<commit_message>
updated catchByEffort and catch_table_summary
</commit_message>
<xml_diff>
--- a/dev/MFA_table_joins.pptx
+++ b/dev/MFA_table_joins.pptx
@@ -7,8 +7,8 @@
   <p:sldIdLst>
     <p:sldId id="256" r:id="rId2"/>
     <p:sldId id="259" r:id="rId3"/>
-    <p:sldId id="257" r:id="rId4"/>
-    <p:sldId id="261" r:id="rId5"/>
+    <p:sldId id="261" r:id="rId4"/>
+    <p:sldId id="263" r:id="rId5"/>
     <p:sldId id="258" r:id="rId6"/>
   </p:sldIdLst>
   <p:sldSz cx="12192000" cy="6858000"/>
@@ -108,20 +108,119 @@
       </a:defRPr>
     </a:lvl9pPr>
   </p:defaultTextStyle>
+  <p:extLst>
+    <p:ext uri="{EFAFB233-063F-42B5-8137-9DF3F51BA10A}">
+      <p15:sldGuideLst xmlns:p15="http://schemas.microsoft.com/office/powerpoint/2012/main"/>
+    </p:ext>
+  </p:extLst>
 </p:presentation>
+</file>
+
+<file path=ppt/revisionInfo.xml><?xml version="1.0" encoding="utf-8"?>
+<p1510:revInfo xmlns:a="http://schemas.openxmlformats.org/drawingml/2006/main" xmlns:r="http://schemas.openxmlformats.org/officeDocument/2006/relationships" xmlns:p1510="http://schemas.microsoft.com/office/powerpoint/2015/10/main">
+  <p1510:revLst>
+    <p1510:client id="{281603EB-896B-47D6-9EA3-975A2DE2B083}" v="15" dt="2026-06-29T20:57:57.397"/>
+  </p1510:revLst>
+</p1510:revInfo>
 </file>
 
 <file path=ppt/changesInfos/changesInfo1.xml><?xml version="1.0" encoding="utf-8"?>
 <pc:chgInfo xmlns:a="http://schemas.openxmlformats.org/drawingml/2006/main" xmlns:r="http://schemas.openxmlformats.org/officeDocument/2006/relationships" xmlns:ac="http://schemas.microsoft.com/office/drawing/2013/main/command" xmlns:pc="http://schemas.microsoft.com/office/powerpoint/2013/main/command">
   <pc:docChgLst>
     <pc:chgData name="Nathan, Lucas (DNR)" userId="96837891-6aae-41c1-b905-2f597761f76b" providerId="ADAL" clId="{F64F8652-B73F-49BC-A105-17EA9971C31A}"/>
-    <pc:docChg chg="modSld">
-      <pc:chgData name="Nathan, Lucas (DNR)" userId="96837891-6aae-41c1-b905-2f597761f76b" providerId="ADAL" clId="{F64F8652-B73F-49BC-A105-17EA9971C31A}" dt="2026-06-25T16:01:30.244" v="13" actId="1076"/>
+    <pc:docChg chg="undo custSel addSld delSld modSld">
+      <pc:chgData name="Nathan, Lucas (DNR)" userId="96837891-6aae-41c1-b905-2f597761f76b" providerId="ADAL" clId="{F64F8652-B73F-49BC-A105-17EA9971C31A}" dt="2026-06-29T20:57:58.912" v="307" actId="1076"/>
       <pc:docMkLst>
         <pc:docMk/>
       </pc:docMkLst>
+      <pc:sldChg chg="addSp delSp modSp mod">
+        <pc:chgData name="Nathan, Lucas (DNR)" userId="96837891-6aae-41c1-b905-2f597761f76b" providerId="ADAL" clId="{F64F8652-B73F-49BC-A105-17EA9971C31A}" dt="2026-06-29T20:41:55.147" v="259" actId="1076"/>
+        <pc:sldMkLst>
+          <pc:docMk/>
+          <pc:sldMk cId="4018073164" sldId="256"/>
+        </pc:sldMkLst>
+        <pc:spChg chg="add mod">
+          <ac:chgData name="Nathan, Lucas (DNR)" userId="96837891-6aae-41c1-b905-2f597761f76b" providerId="ADAL" clId="{F64F8652-B73F-49BC-A105-17EA9971C31A}" dt="2026-06-29T20:41:55.147" v="259" actId="1076"/>
+          <ac:spMkLst>
+            <pc:docMk/>
+            <pc:sldMk cId="4018073164" sldId="256"/>
+            <ac:spMk id="7" creationId="{4FE9BE98-0136-BEEC-A5C5-767111FEA440}"/>
+          </ac:spMkLst>
+        </pc:spChg>
+        <pc:spChg chg="del">
+          <ac:chgData name="Nathan, Lucas (DNR)" userId="96837891-6aae-41c1-b905-2f597761f76b" providerId="ADAL" clId="{F64F8652-B73F-49BC-A105-17EA9971C31A}" dt="2026-06-29T19:32:11.823" v="14" actId="478"/>
+          <ac:spMkLst>
+            <pc:docMk/>
+            <pc:sldMk cId="4018073164" sldId="256"/>
+            <ac:spMk id="116" creationId="{58981A44-2D30-B03A-40AF-B4D55A7E46A4}"/>
+          </ac:spMkLst>
+        </pc:spChg>
+        <pc:spChg chg="del">
+          <ac:chgData name="Nathan, Lucas (DNR)" userId="96837891-6aae-41c1-b905-2f597761f76b" providerId="ADAL" clId="{F64F8652-B73F-49BC-A105-17EA9971C31A}" dt="2026-06-29T19:32:12.841" v="15" actId="478"/>
+          <ac:spMkLst>
+            <pc:docMk/>
+            <pc:sldMk cId="4018073164" sldId="256"/>
+            <ac:spMk id="117" creationId="{26B2E6BC-1735-4EF8-6CF5-FE1B71D9491D}"/>
+          </ac:spMkLst>
+        </pc:spChg>
+        <pc:cxnChg chg="add mod">
+          <ac:chgData name="Nathan, Lucas (DNR)" userId="96837891-6aae-41c1-b905-2f597761f76b" providerId="ADAL" clId="{F64F8652-B73F-49BC-A105-17EA9971C31A}" dt="2026-06-29T20:41:55.147" v="259" actId="1076"/>
+          <ac:cxnSpMkLst>
+            <pc:docMk/>
+            <pc:sldMk cId="4018073164" sldId="256"/>
+            <ac:cxnSpMk id="12" creationId="{81A26EC5-D573-533A-BC0E-C461C4C8848C}"/>
+          </ac:cxnSpMkLst>
+        </pc:cxnChg>
+        <pc:cxnChg chg="mod">
+          <ac:chgData name="Nathan, Lucas (DNR)" userId="96837891-6aae-41c1-b905-2f597761f76b" providerId="ADAL" clId="{F64F8652-B73F-49BC-A105-17EA9971C31A}" dt="2026-06-29T20:41:55.147" v="259" actId="1076"/>
+          <ac:cxnSpMkLst>
+            <pc:docMk/>
+            <pc:sldMk cId="4018073164" sldId="256"/>
+            <ac:cxnSpMk id="119" creationId="{E5FC0A42-AE9F-0B0B-485B-29F8C0298083}"/>
+          </ac:cxnSpMkLst>
+        </pc:cxnChg>
+        <pc:cxnChg chg="del mod">
+          <ac:chgData name="Nathan, Lucas (DNR)" userId="96837891-6aae-41c1-b905-2f597761f76b" providerId="ADAL" clId="{F64F8652-B73F-49BC-A105-17EA9971C31A}" dt="2026-06-29T19:32:14.031" v="16" actId="478"/>
+          <ac:cxnSpMkLst>
+            <pc:docMk/>
+            <pc:sldMk cId="4018073164" sldId="256"/>
+            <ac:cxnSpMk id="124" creationId="{E5109F92-7FEE-64A0-E5A1-96C05482E3D8}"/>
+          </ac:cxnSpMkLst>
+        </pc:cxnChg>
+        <pc:cxnChg chg="mod">
+          <ac:chgData name="Nathan, Lucas (DNR)" userId="96837891-6aae-41c1-b905-2f597761f76b" providerId="ADAL" clId="{F64F8652-B73F-49BC-A105-17EA9971C31A}" dt="2026-06-29T20:41:55.147" v="259" actId="1076"/>
+          <ac:cxnSpMkLst>
+            <pc:docMk/>
+            <pc:sldMk cId="4018073164" sldId="256"/>
+            <ac:cxnSpMk id="127" creationId="{4523B275-7E03-2157-6D4C-DDEFFA1D55B1}"/>
+          </ac:cxnSpMkLst>
+        </pc:cxnChg>
+        <pc:cxnChg chg="mod">
+          <ac:chgData name="Nathan, Lucas (DNR)" userId="96837891-6aae-41c1-b905-2f597761f76b" providerId="ADAL" clId="{F64F8652-B73F-49BC-A105-17EA9971C31A}" dt="2026-06-29T20:41:55.147" v="259" actId="1076"/>
+          <ac:cxnSpMkLst>
+            <pc:docMk/>
+            <pc:sldMk cId="4018073164" sldId="256"/>
+            <ac:cxnSpMk id="137" creationId="{72489654-A647-3A7F-4431-D5E48C7D81F8}"/>
+          </ac:cxnSpMkLst>
+        </pc:cxnChg>
+        <pc:cxnChg chg="mod">
+          <ac:chgData name="Nathan, Lucas (DNR)" userId="96837891-6aae-41c1-b905-2f597761f76b" providerId="ADAL" clId="{F64F8652-B73F-49BC-A105-17EA9971C31A}" dt="2026-06-29T20:41:55.147" v="259" actId="1076"/>
+          <ac:cxnSpMkLst>
+            <pc:docMk/>
+            <pc:sldMk cId="4018073164" sldId="256"/>
+            <ac:cxnSpMk id="143" creationId="{BF46648B-8EDA-6C28-B5D0-4CED0A3094C8}"/>
+          </ac:cxnSpMkLst>
+        </pc:cxnChg>
+      </pc:sldChg>
+      <pc:sldChg chg="del">
+        <pc:chgData name="Nathan, Lucas (DNR)" userId="96837891-6aae-41c1-b905-2f597761f76b" providerId="ADAL" clId="{F64F8652-B73F-49BC-A105-17EA9971C31A}" dt="2026-06-29T19:32:32.280" v="21" actId="47"/>
+        <pc:sldMkLst>
+          <pc:docMk/>
+          <pc:sldMk cId="3617245666" sldId="257"/>
+        </pc:sldMkLst>
+      </pc:sldChg>
       <pc:sldChg chg="modSp mod">
-        <pc:chgData name="Nathan, Lucas (DNR)" userId="96837891-6aae-41c1-b905-2f597761f76b" providerId="ADAL" clId="{F64F8652-B73F-49BC-A105-17EA9971C31A}" dt="2026-06-25T16:01:30.244" v="13" actId="1076"/>
+        <pc:chgData name="Nathan, Lucas (DNR)" userId="96837891-6aae-41c1-b905-2f597761f76b" providerId="ADAL" clId="{F64F8652-B73F-49BC-A105-17EA9971C31A}" dt="2026-06-29T19:37:01.542" v="155" actId="1076"/>
         <pc:sldMkLst>
           <pc:docMk/>
           <pc:sldMk cId="736430854" sldId="259"/>
@@ -143,7 +242,7 @@
           </ac:spMkLst>
         </pc:spChg>
         <pc:spChg chg="mod">
-          <ac:chgData name="Nathan, Lucas (DNR)" userId="96837891-6aae-41c1-b905-2f597761f76b" providerId="ADAL" clId="{F64F8652-B73F-49BC-A105-17EA9971C31A}" dt="2026-06-25T16:01:27.035" v="11" actId="1076"/>
+          <ac:chgData name="Nathan, Lucas (DNR)" userId="96837891-6aae-41c1-b905-2f597761f76b" providerId="ADAL" clId="{F64F8652-B73F-49BC-A105-17EA9971C31A}" dt="2026-06-29T19:37:01.542" v="155" actId="1076"/>
           <ac:spMkLst>
             <pc:docMk/>
             <pc:sldMk cId="736430854" sldId="259"/>
@@ -183,7 +282,7 @@
           </ac:cxnSpMkLst>
         </pc:cxnChg>
         <pc:cxnChg chg="mod">
-          <ac:chgData name="Nathan, Lucas (DNR)" userId="96837891-6aae-41c1-b905-2f597761f76b" providerId="ADAL" clId="{F64F8652-B73F-49BC-A105-17EA9971C31A}" dt="2026-06-25T16:01:27.035" v="11" actId="1076"/>
+          <ac:chgData name="Nathan, Lucas (DNR)" userId="96837891-6aae-41c1-b905-2f597761f76b" providerId="ADAL" clId="{F64F8652-B73F-49BC-A105-17EA9971C31A}" dt="2026-06-29T19:37:01.542" v="155" actId="1076"/>
           <ac:cxnSpMkLst>
             <pc:docMk/>
             <pc:sldMk cId="736430854" sldId="259"/>
@@ -191,7 +290,7 @@
           </ac:cxnSpMkLst>
         </pc:cxnChg>
         <pc:cxnChg chg="mod">
-          <ac:chgData name="Nathan, Lucas (DNR)" userId="96837891-6aae-41c1-b905-2f597761f76b" providerId="ADAL" clId="{F64F8652-B73F-49BC-A105-17EA9971C31A}" dt="2026-06-25T16:01:28.334" v="12" actId="1076"/>
+          <ac:chgData name="Nathan, Lucas (DNR)" userId="96837891-6aae-41c1-b905-2f597761f76b" providerId="ADAL" clId="{F64F8652-B73F-49BC-A105-17EA9971C31A}" dt="2026-06-29T19:37:01.542" v="155" actId="1076"/>
           <ac:cxnSpMkLst>
             <pc:docMk/>
             <pc:sldMk cId="736430854" sldId="259"/>
@@ -204,6 +303,307 @@
             <pc:docMk/>
             <pc:sldMk cId="736430854" sldId="259"/>
             <ac:cxnSpMk id="97" creationId="{F71000F1-93EA-247E-8A84-87318AB40F95}"/>
+          </ac:cxnSpMkLst>
+        </pc:cxnChg>
+      </pc:sldChg>
+      <pc:sldChg chg="addSp delSp modSp mod">
+        <pc:chgData name="Nathan, Lucas (DNR)" userId="96837891-6aae-41c1-b905-2f597761f76b" providerId="ADAL" clId="{F64F8652-B73F-49BC-A105-17EA9971C31A}" dt="2026-06-29T20:57:58.912" v="307" actId="1076"/>
+        <pc:sldMkLst>
+          <pc:docMk/>
+          <pc:sldMk cId="3322492765" sldId="261"/>
+        </pc:sldMkLst>
+        <pc:spChg chg="add del">
+          <ac:chgData name="Nathan, Lucas (DNR)" userId="96837891-6aae-41c1-b905-2f597761f76b" providerId="ADAL" clId="{F64F8652-B73F-49BC-A105-17EA9971C31A}" dt="2026-06-29T19:33:48.409" v="39" actId="478"/>
+          <ac:spMkLst>
+            <pc:docMk/>
+            <pc:sldMk cId="3322492765" sldId="261"/>
+            <ac:spMk id="2" creationId="{9724142F-D601-8CD2-2C17-A9A6925DF763}"/>
+          </ac:spMkLst>
+        </pc:spChg>
+        <pc:spChg chg="mod">
+          <ac:chgData name="Nathan, Lucas (DNR)" userId="96837891-6aae-41c1-b905-2f597761f76b" providerId="ADAL" clId="{F64F8652-B73F-49BC-A105-17EA9971C31A}" dt="2026-06-29T20:39:45.866" v="185" actId="20577"/>
+          <ac:spMkLst>
+            <pc:docMk/>
+            <pc:sldMk cId="3322492765" sldId="261"/>
+            <ac:spMk id="4" creationId="{1BAD97C7-DEBE-62C8-60F1-6A62E416FEB8}"/>
+          </ac:spMkLst>
+        </pc:spChg>
+        <pc:spChg chg="mod">
+          <ac:chgData name="Nathan, Lucas (DNR)" userId="96837891-6aae-41c1-b905-2f597761f76b" providerId="ADAL" clId="{F64F8652-B73F-49BC-A105-17EA9971C31A}" dt="2026-06-29T19:33:44.604" v="33" actId="1076"/>
+          <ac:spMkLst>
+            <pc:docMk/>
+            <pc:sldMk cId="3322492765" sldId="261"/>
+            <ac:spMk id="7" creationId="{3F27521D-007A-864A-7E95-FF49BA411BA1}"/>
+          </ac:spMkLst>
+        </pc:spChg>
+        <pc:spChg chg="add mod">
+          <ac:chgData name="Nathan, Lucas (DNR)" userId="96837891-6aae-41c1-b905-2f597761f76b" providerId="ADAL" clId="{F64F8652-B73F-49BC-A105-17EA9971C31A}" dt="2026-06-29T19:35:35.592" v="147" actId="20577"/>
+          <ac:spMkLst>
+            <pc:docMk/>
+            <pc:sldMk cId="3322492765" sldId="261"/>
+            <ac:spMk id="11" creationId="{874FE0CA-DA94-0BB5-C081-880419EACCCE}"/>
+          </ac:spMkLst>
+        </pc:spChg>
+        <pc:spChg chg="add mod">
+          <ac:chgData name="Nathan, Lucas (DNR)" userId="96837891-6aae-41c1-b905-2f597761f76b" providerId="ADAL" clId="{F64F8652-B73F-49BC-A105-17EA9971C31A}" dt="2026-06-29T20:40:43.330" v="217" actId="11530"/>
+          <ac:spMkLst>
+            <pc:docMk/>
+            <pc:sldMk cId="3322492765" sldId="261"/>
+            <ac:spMk id="12" creationId="{9B493B7F-5FB2-67D1-E903-204D47D7C3BD}"/>
+          </ac:spMkLst>
+        </pc:spChg>
+        <pc:spChg chg="mod">
+          <ac:chgData name="Nathan, Lucas (DNR)" userId="96837891-6aae-41c1-b905-2f597761f76b" providerId="ADAL" clId="{F64F8652-B73F-49BC-A105-17EA9971C31A}" dt="2026-06-29T20:40:22.121" v="212" actId="115"/>
+          <ac:spMkLst>
+            <pc:docMk/>
+            <pc:sldMk cId="3322492765" sldId="261"/>
+            <ac:spMk id="13" creationId="{5FE2401A-BFFA-29AA-CEDE-7C96C5964533}"/>
+          </ac:spMkLst>
+        </pc:spChg>
+        <pc:spChg chg="add mod">
+          <ac:chgData name="Nathan, Lucas (DNR)" userId="96837891-6aae-41c1-b905-2f597761f76b" providerId="ADAL" clId="{F64F8652-B73F-49BC-A105-17EA9971C31A}" dt="2026-06-29T20:41:22.294" v="223" actId="1076"/>
+          <ac:spMkLst>
+            <pc:docMk/>
+            <pc:sldMk cId="3322492765" sldId="261"/>
+            <ac:spMk id="19" creationId="{A88200D1-2FA7-C9BB-C320-3AD2B05F0804}"/>
+          </ac:spMkLst>
+        </pc:spChg>
+        <pc:spChg chg="add mod">
+          <ac:chgData name="Nathan, Lucas (DNR)" userId="96837891-6aae-41c1-b905-2f597761f76b" providerId="ADAL" clId="{F64F8652-B73F-49BC-A105-17EA9971C31A}" dt="2026-06-29T20:57:58.912" v="307" actId="1076"/>
+          <ac:spMkLst>
+            <pc:docMk/>
+            <pc:sldMk cId="3322492765" sldId="261"/>
+            <ac:spMk id="24" creationId="{4745DB2B-329F-010A-51F8-365B963F646F}"/>
+          </ac:spMkLst>
+        </pc:spChg>
+        <pc:spChg chg="del">
+          <ac:chgData name="Nathan, Lucas (DNR)" userId="96837891-6aae-41c1-b905-2f597761f76b" providerId="ADAL" clId="{F64F8652-B73F-49BC-A105-17EA9971C31A}" dt="2026-06-29T19:36:00.892" v="148" actId="478"/>
+          <ac:spMkLst>
+            <pc:docMk/>
+            <pc:sldMk cId="3322492765" sldId="261"/>
+            <ac:spMk id="25" creationId="{3E2605F5-6924-AB68-E547-F0544AEF2C11}"/>
+          </ac:spMkLst>
+        </pc:spChg>
+        <pc:spChg chg="mod">
+          <ac:chgData name="Nathan, Lucas (DNR)" userId="96837891-6aae-41c1-b905-2f597761f76b" providerId="ADAL" clId="{F64F8652-B73F-49BC-A105-17EA9971C31A}" dt="2026-06-29T19:34:44.859" v="41" actId="115"/>
+          <ac:spMkLst>
+            <pc:docMk/>
+            <pc:sldMk cId="3322492765" sldId="261"/>
+            <ac:spMk id="74" creationId="{8794BFCB-0CD3-D62F-28BE-79835CCFE93C}"/>
+          </ac:spMkLst>
+        </pc:spChg>
+        <pc:spChg chg="add del">
+          <ac:chgData name="Nathan, Lucas (DNR)" userId="96837891-6aae-41c1-b905-2f597761f76b" providerId="ADAL" clId="{F64F8652-B73F-49BC-A105-17EA9971C31A}" dt="2026-06-29T19:33:47.881" v="38" actId="478"/>
+          <ac:spMkLst>
+            <pc:docMk/>
+            <pc:sldMk cId="3322492765" sldId="261"/>
+            <ac:spMk id="89" creationId="{EA9AA6C2-F859-B3D3-D675-965CE58843B8}"/>
+          </ac:spMkLst>
+        </pc:spChg>
+        <pc:cxnChg chg="mod">
+          <ac:chgData name="Nathan, Lucas (DNR)" userId="96837891-6aae-41c1-b905-2f597761f76b" providerId="ADAL" clId="{F64F8652-B73F-49BC-A105-17EA9971C31A}" dt="2026-06-29T19:33:44.604" v="33" actId="1076"/>
+          <ac:cxnSpMkLst>
+            <pc:docMk/>
+            <pc:sldMk cId="3322492765" sldId="261"/>
+            <ac:cxnSpMk id="8" creationId="{D76D930F-8B45-04E7-7E3E-4D5961526237}"/>
+          </ac:cxnSpMkLst>
+        </pc:cxnChg>
+        <pc:cxnChg chg="add del mod">
+          <ac:chgData name="Nathan, Lucas (DNR)" userId="96837891-6aae-41c1-b905-2f597761f76b" providerId="ADAL" clId="{F64F8652-B73F-49BC-A105-17EA9971C31A}" dt="2026-06-29T20:57:35.549" v="276"/>
+          <ac:cxnSpMkLst>
+            <pc:docMk/>
+            <pc:sldMk cId="3322492765" sldId="261"/>
+            <ac:cxnSpMk id="14" creationId="{DD218F72-E8C3-F972-2248-BA6FD2FDE5EA}"/>
+          </ac:cxnSpMkLst>
+        </pc:cxnChg>
+        <pc:cxnChg chg="add mod">
+          <ac:chgData name="Nathan, Lucas (DNR)" userId="96837891-6aae-41c1-b905-2f597761f76b" providerId="ADAL" clId="{F64F8652-B73F-49BC-A105-17EA9971C31A}" dt="2026-06-29T20:57:41.062" v="277"/>
+          <ac:cxnSpMkLst>
+            <pc:docMk/>
+            <pc:sldMk cId="3322492765" sldId="261"/>
+            <ac:cxnSpMk id="15" creationId="{53AE46C1-1B8D-7C20-EF65-D20C1F3846E8}"/>
+          </ac:cxnSpMkLst>
+        </pc:cxnChg>
+        <pc:cxnChg chg="add mod">
+          <ac:chgData name="Nathan, Lucas (DNR)" userId="96837891-6aae-41c1-b905-2f597761f76b" providerId="ADAL" clId="{F64F8652-B73F-49BC-A105-17EA9971C31A}" dt="2026-06-29T20:41:22.294" v="223" actId="1076"/>
+          <ac:cxnSpMkLst>
+            <pc:docMk/>
+            <pc:sldMk cId="3322492765" sldId="261"/>
+            <ac:cxnSpMk id="20" creationId="{AC5B9D03-0DB8-6CB3-CA9F-3201452C90FD}"/>
+          </ac:cxnSpMkLst>
+        </pc:cxnChg>
+        <pc:cxnChg chg="del mod">
+          <ac:chgData name="Nathan, Lucas (DNR)" userId="96837891-6aae-41c1-b905-2f597761f76b" providerId="ADAL" clId="{F64F8652-B73F-49BC-A105-17EA9971C31A}" dt="2026-06-29T19:36:01.452" v="149" actId="478"/>
+          <ac:cxnSpMkLst>
+            <pc:docMk/>
+            <pc:sldMk cId="3322492765" sldId="261"/>
+            <ac:cxnSpMk id="26" creationId="{9584F975-E590-4D1D-53B1-AABC90A93150}"/>
+          </ac:cxnSpMkLst>
+        </pc:cxnChg>
+        <pc:cxnChg chg="mod">
+          <ac:chgData name="Nathan, Lucas (DNR)" userId="96837891-6aae-41c1-b905-2f597761f76b" providerId="ADAL" clId="{F64F8652-B73F-49BC-A105-17EA9971C31A}" dt="2026-06-29T19:33:44.604" v="33" actId="1076"/>
+          <ac:cxnSpMkLst>
+            <pc:docMk/>
+            <pc:sldMk cId="3322492765" sldId="261"/>
+            <ac:cxnSpMk id="41" creationId="{A3380EF5-361B-BA11-7E5B-5EC9E6DA518F}"/>
+          </ac:cxnSpMkLst>
+        </pc:cxnChg>
+        <pc:cxnChg chg="add del mod">
+          <ac:chgData name="Nathan, Lucas (DNR)" userId="96837891-6aae-41c1-b905-2f597761f76b" providerId="ADAL" clId="{F64F8652-B73F-49BC-A105-17EA9971C31A}" dt="2026-06-29T19:33:45.455" v="35" actId="478"/>
+          <ac:cxnSpMkLst>
+            <pc:docMk/>
+            <pc:sldMk cId="3322492765" sldId="261"/>
+            <ac:cxnSpMk id="44" creationId="{E696C7E1-B2EC-C3E2-55C6-DBF02B4CAABA}"/>
+          </ac:cxnSpMkLst>
+        </pc:cxnChg>
+        <pc:cxnChg chg="del mod">
+          <ac:chgData name="Nathan, Lucas (DNR)" userId="96837891-6aae-41c1-b905-2f597761f76b" providerId="ADAL" clId="{F64F8652-B73F-49BC-A105-17EA9971C31A}" dt="2026-06-29T19:34:50.011" v="42" actId="478"/>
+          <ac:cxnSpMkLst>
+            <pc:docMk/>
+            <pc:sldMk cId="3322492765" sldId="261"/>
+            <ac:cxnSpMk id="75" creationId="{83B769DA-AD63-C4ED-00AE-45CA1156D7C2}"/>
+          </ac:cxnSpMkLst>
+        </pc:cxnChg>
+        <pc:cxnChg chg="add del mod">
+          <ac:chgData name="Nathan, Lucas (DNR)" userId="96837891-6aae-41c1-b905-2f597761f76b" providerId="ADAL" clId="{F64F8652-B73F-49BC-A105-17EA9971C31A}" dt="2026-06-29T19:34:57.593" v="43" actId="693"/>
+          <ac:cxnSpMkLst>
+            <pc:docMk/>
+            <pc:sldMk cId="3322492765" sldId="261"/>
+            <ac:cxnSpMk id="78" creationId="{A29CBA1D-BDF4-AF4F-A9A7-0A44836FEA7E}"/>
+          </ac:cxnSpMkLst>
+        </pc:cxnChg>
+        <pc:cxnChg chg="mod">
+          <ac:chgData name="Nathan, Lucas (DNR)" userId="96837891-6aae-41c1-b905-2f597761f76b" providerId="ADAL" clId="{F64F8652-B73F-49BC-A105-17EA9971C31A}" dt="2026-06-29T19:33:44.604" v="33" actId="1076"/>
+          <ac:cxnSpMkLst>
+            <pc:docMk/>
+            <pc:sldMk cId="3322492765" sldId="261"/>
+            <ac:cxnSpMk id="93" creationId="{7B20C067-AF4B-1864-B26F-22E4E53C4846}"/>
+          </ac:cxnSpMkLst>
+        </pc:cxnChg>
+      </pc:sldChg>
+      <pc:sldChg chg="modSp add del mod">
+        <pc:chgData name="Nathan, Lucas (DNR)" userId="96837891-6aae-41c1-b905-2f597761f76b" providerId="ADAL" clId="{F64F8652-B73F-49BC-A105-17EA9971C31A}" dt="2026-06-29T20:39:40.247" v="171" actId="47"/>
+        <pc:sldMkLst>
+          <pc:docMk/>
+          <pc:sldMk cId="1516480922" sldId="262"/>
+        </pc:sldMkLst>
+        <pc:spChg chg="mod">
+          <ac:chgData name="Nathan, Lucas (DNR)" userId="96837891-6aae-41c1-b905-2f597761f76b" providerId="ADAL" clId="{F64F8652-B73F-49BC-A105-17EA9971C31A}" dt="2026-06-29T20:39:16.851" v="169" actId="20577"/>
+          <ac:spMkLst>
+            <pc:docMk/>
+            <pc:sldMk cId="1516480922" sldId="262"/>
+            <ac:spMk id="4" creationId="{3C2BF129-49AA-0ABB-F93C-8D1F19B32577}"/>
+          </ac:spMkLst>
+        </pc:spChg>
+      </pc:sldChg>
+      <pc:sldChg chg="addSp delSp modSp add mod">
+        <pc:chgData name="Nathan, Lucas (DNR)" userId="96837891-6aae-41c1-b905-2f597761f76b" providerId="ADAL" clId="{F64F8652-B73F-49BC-A105-17EA9971C31A}" dt="2026-06-29T20:57:54.514" v="305" actId="20577"/>
+        <pc:sldMkLst>
+          <pc:docMk/>
+          <pc:sldMk cId="796165095" sldId="263"/>
+        </pc:sldMkLst>
+        <pc:spChg chg="add mod">
+          <ac:chgData name="Nathan, Lucas (DNR)" userId="96837891-6aae-41c1-b905-2f597761f76b" providerId="ADAL" clId="{F64F8652-B73F-49BC-A105-17EA9971C31A}" dt="2026-06-29T20:42:20.142" v="272" actId="1076"/>
+          <ac:spMkLst>
+            <pc:docMk/>
+            <pc:sldMk cId="796165095" sldId="263"/>
+            <ac:spMk id="2" creationId="{1F05B9EE-2FF8-B44C-370B-8A17D8BF7C4A}"/>
+          </ac:spMkLst>
+        </pc:spChg>
+        <pc:spChg chg="del">
+          <ac:chgData name="Nathan, Lucas (DNR)" userId="96837891-6aae-41c1-b905-2f597761f76b" providerId="ADAL" clId="{F64F8652-B73F-49BC-A105-17EA9971C31A}" dt="2026-06-29T20:42:19.028" v="271" actId="478"/>
+          <ac:spMkLst>
+            <pc:docMk/>
+            <pc:sldMk cId="796165095" sldId="263"/>
+            <ac:spMk id="5" creationId="{862447DF-FF79-EBA8-BB69-DBC724B1EFE1}"/>
+          </ac:spMkLst>
+        </pc:spChg>
+        <pc:spChg chg="del">
+          <ac:chgData name="Nathan, Lucas (DNR)" userId="96837891-6aae-41c1-b905-2f597761f76b" providerId="ADAL" clId="{F64F8652-B73F-49BC-A105-17EA9971C31A}" dt="2026-06-29T20:42:13.716" v="262" actId="478"/>
+          <ac:spMkLst>
+            <pc:docMk/>
+            <pc:sldMk cId="796165095" sldId="263"/>
+            <ac:spMk id="7" creationId="{A38F1692-CB86-E338-BD4B-A824A177F077}"/>
+          </ac:spMkLst>
+        </pc:spChg>
+        <pc:spChg chg="add del mod">
+          <ac:chgData name="Nathan, Lucas (DNR)" userId="96837891-6aae-41c1-b905-2f597761f76b" providerId="ADAL" clId="{F64F8652-B73F-49BC-A105-17EA9971C31A}" dt="2026-06-29T20:57:54.514" v="305" actId="20577"/>
+          <ac:spMkLst>
+            <pc:docMk/>
+            <pc:sldMk cId="796165095" sldId="263"/>
+            <ac:spMk id="11" creationId="{B3D0F06D-DB70-E021-E141-F59AF8C8AB58}"/>
+          </ac:spMkLst>
+        </pc:spChg>
+        <pc:spChg chg="del">
+          <ac:chgData name="Nathan, Lucas (DNR)" userId="96837891-6aae-41c1-b905-2f597761f76b" providerId="ADAL" clId="{F64F8652-B73F-49BC-A105-17EA9971C31A}" dt="2026-06-29T20:42:13.008" v="261" actId="478"/>
+          <ac:spMkLst>
+            <pc:docMk/>
+            <pc:sldMk cId="796165095" sldId="263"/>
+            <ac:spMk id="13" creationId="{DF12DC8C-54A8-4EC7-4CDC-D6891FCF3CA1}"/>
+          </ac:spMkLst>
+        </pc:spChg>
+        <pc:spChg chg="del mod">
+          <ac:chgData name="Nathan, Lucas (DNR)" userId="96837891-6aae-41c1-b905-2f597761f76b" providerId="ADAL" clId="{F64F8652-B73F-49BC-A105-17EA9971C31A}" dt="2026-06-29T20:42:18.246" v="270" actId="478"/>
+          <ac:spMkLst>
+            <pc:docMk/>
+            <pc:sldMk cId="796165095" sldId="263"/>
+            <ac:spMk id="38" creationId="{5F4B0D02-1FD5-185C-F86D-624F0F4D9249}"/>
+          </ac:spMkLst>
+        </pc:spChg>
+        <pc:spChg chg="del">
+          <ac:chgData name="Nathan, Lucas (DNR)" userId="96837891-6aae-41c1-b905-2f597761f76b" providerId="ADAL" clId="{F64F8652-B73F-49BC-A105-17EA9971C31A}" dt="2026-06-29T20:42:17.640" v="269" actId="478"/>
+          <ac:spMkLst>
+            <pc:docMk/>
+            <pc:sldMk cId="796165095" sldId="263"/>
+            <ac:spMk id="74" creationId="{598F55DA-9160-6855-00D7-1140E63A13DA}"/>
+          </ac:spMkLst>
+        </pc:spChg>
+        <pc:cxnChg chg="del mod">
+          <ac:chgData name="Nathan, Lucas (DNR)" userId="96837891-6aae-41c1-b905-2f597761f76b" providerId="ADAL" clId="{F64F8652-B73F-49BC-A105-17EA9971C31A}" dt="2026-06-29T20:42:14.211" v="263" actId="478"/>
+          <ac:cxnSpMkLst>
+            <pc:docMk/>
+            <pc:sldMk cId="796165095" sldId="263"/>
+            <ac:cxnSpMk id="8" creationId="{C1441D0A-BCC5-4FCB-F8E1-8F9558DFE42B}"/>
+          </ac:cxnSpMkLst>
+        </pc:cxnChg>
+        <pc:cxnChg chg="mod">
+          <ac:chgData name="Nathan, Lucas (DNR)" userId="96837891-6aae-41c1-b905-2f597761f76b" providerId="ADAL" clId="{F64F8652-B73F-49BC-A105-17EA9971C31A}" dt="2026-06-29T20:42:42.853" v="274" actId="14100"/>
+          <ac:cxnSpMkLst>
+            <pc:docMk/>
+            <pc:sldMk cId="796165095" sldId="263"/>
+            <ac:cxnSpMk id="14" creationId="{9373E434-CB22-6DAD-802E-93462B042E39}"/>
+          </ac:cxnSpMkLst>
+        </pc:cxnChg>
+        <pc:cxnChg chg="del mod">
+          <ac:chgData name="Nathan, Lucas (DNR)" userId="96837891-6aae-41c1-b905-2f597761f76b" providerId="ADAL" clId="{F64F8652-B73F-49BC-A105-17EA9971C31A}" dt="2026-06-29T20:42:14.546" v="264" actId="478"/>
+          <ac:cxnSpMkLst>
+            <pc:docMk/>
+            <pc:sldMk cId="796165095" sldId="263"/>
+            <ac:cxnSpMk id="41" creationId="{CBDD80CF-1F35-F10C-D379-AA35FB7CD344}"/>
+          </ac:cxnSpMkLst>
+        </pc:cxnChg>
+        <pc:cxnChg chg="del mod">
+          <ac:chgData name="Nathan, Lucas (DNR)" userId="96837891-6aae-41c1-b905-2f597761f76b" providerId="ADAL" clId="{F64F8652-B73F-49BC-A105-17EA9971C31A}" dt="2026-06-29T20:42:16.120" v="267" actId="478"/>
+          <ac:cxnSpMkLst>
+            <pc:docMk/>
+            <pc:sldMk cId="796165095" sldId="263"/>
+            <ac:cxnSpMk id="44" creationId="{D741B401-09ED-34DB-9430-B5DE562B112A}"/>
+          </ac:cxnSpMkLst>
+        </pc:cxnChg>
+        <pc:cxnChg chg="del mod">
+          <ac:chgData name="Nathan, Lucas (DNR)" userId="96837891-6aae-41c1-b905-2f597761f76b" providerId="ADAL" clId="{F64F8652-B73F-49BC-A105-17EA9971C31A}" dt="2026-06-29T20:42:14.970" v="265" actId="478"/>
+          <ac:cxnSpMkLst>
+            <pc:docMk/>
+            <pc:sldMk cId="796165095" sldId="263"/>
+            <ac:cxnSpMk id="78" creationId="{E9708ED6-F01B-E46D-DFF0-2E000C8CD1F6}"/>
+          </ac:cxnSpMkLst>
+        </pc:cxnChg>
+        <pc:cxnChg chg="del mod">
+          <ac:chgData name="Nathan, Lucas (DNR)" userId="96837891-6aae-41c1-b905-2f597761f76b" providerId="ADAL" clId="{F64F8652-B73F-49BC-A105-17EA9971C31A}" dt="2026-06-29T20:42:15.586" v="266" actId="478"/>
+          <ac:cxnSpMkLst>
+            <pc:docMk/>
+            <pc:sldMk cId="796165095" sldId="263"/>
+            <ac:cxnSpMk id="93" creationId="{589C798D-2A0D-9997-ED7A-C4D27CE1EE88}"/>
           </ac:cxnSpMkLst>
         </pc:cxnChg>
       </pc:sldChg>
@@ -359,7 +759,7 @@
           <a:p>
             <a:fld id="{179C5205-C240-4C15-BC7A-8B28C81B6976}" type="datetimeFigureOut">
               <a:rPr lang="en-US" smtClean="0"/>
-              <a:t>06/25/2026</a:t>
+              <a:t>06/29/2026</a:t>
             </a:fld>
             <a:endParaRPr lang="en-US"/>
           </a:p>
@@ -557,7 +957,7 @@
           <a:p>
             <a:fld id="{179C5205-C240-4C15-BC7A-8B28C81B6976}" type="datetimeFigureOut">
               <a:rPr lang="en-US" smtClean="0"/>
-              <a:t>06/25/2026</a:t>
+              <a:t>06/29/2026</a:t>
             </a:fld>
             <a:endParaRPr lang="en-US"/>
           </a:p>
@@ -765,7 +1165,7 @@
           <a:p>
             <a:fld id="{179C5205-C240-4C15-BC7A-8B28C81B6976}" type="datetimeFigureOut">
               <a:rPr lang="en-US" smtClean="0"/>
-              <a:t>06/25/2026</a:t>
+              <a:t>06/29/2026</a:t>
             </a:fld>
             <a:endParaRPr lang="en-US"/>
           </a:p>
@@ -963,7 +1363,7 @@
           <a:p>
             <a:fld id="{179C5205-C240-4C15-BC7A-8B28C81B6976}" type="datetimeFigureOut">
               <a:rPr lang="en-US" smtClean="0"/>
-              <a:t>06/25/2026</a:t>
+              <a:t>06/29/2026</a:t>
             </a:fld>
             <a:endParaRPr lang="en-US"/>
           </a:p>
@@ -1238,7 +1638,7 @@
           <a:p>
             <a:fld id="{179C5205-C240-4C15-BC7A-8B28C81B6976}" type="datetimeFigureOut">
               <a:rPr lang="en-US" smtClean="0"/>
-              <a:t>06/25/2026</a:t>
+              <a:t>06/29/2026</a:t>
             </a:fld>
             <a:endParaRPr lang="en-US"/>
           </a:p>
@@ -1503,7 +1903,7 @@
           <a:p>
             <a:fld id="{179C5205-C240-4C15-BC7A-8B28C81B6976}" type="datetimeFigureOut">
               <a:rPr lang="en-US" smtClean="0"/>
-              <a:t>06/25/2026</a:t>
+              <a:t>06/29/2026</a:t>
             </a:fld>
             <a:endParaRPr lang="en-US"/>
           </a:p>
@@ -1915,7 +2315,7 @@
           <a:p>
             <a:fld id="{179C5205-C240-4C15-BC7A-8B28C81B6976}" type="datetimeFigureOut">
               <a:rPr lang="en-US" smtClean="0"/>
-              <a:t>06/25/2026</a:t>
+              <a:t>06/29/2026</a:t>
             </a:fld>
             <a:endParaRPr lang="en-US"/>
           </a:p>
@@ -2056,7 +2456,7 @@
           <a:p>
             <a:fld id="{179C5205-C240-4C15-BC7A-8B28C81B6976}" type="datetimeFigureOut">
               <a:rPr lang="en-US" smtClean="0"/>
-              <a:t>06/25/2026</a:t>
+              <a:t>06/29/2026</a:t>
             </a:fld>
             <a:endParaRPr lang="en-US"/>
           </a:p>
@@ -2169,7 +2569,7 @@
           <a:p>
             <a:fld id="{179C5205-C240-4C15-BC7A-8B28C81B6976}" type="datetimeFigureOut">
               <a:rPr lang="en-US" smtClean="0"/>
-              <a:t>06/25/2026</a:t>
+              <a:t>06/29/2026</a:t>
             </a:fld>
             <a:endParaRPr lang="en-US"/>
           </a:p>
@@ -2480,7 +2880,7 @@
           <a:p>
             <a:fld id="{179C5205-C240-4C15-BC7A-8B28C81B6976}" type="datetimeFigureOut">
               <a:rPr lang="en-US" smtClean="0"/>
-              <a:t>06/25/2026</a:t>
+              <a:t>06/29/2026</a:t>
             </a:fld>
             <a:endParaRPr lang="en-US"/>
           </a:p>
@@ -2768,7 +3168,7 @@
           <a:p>
             <a:fld id="{179C5205-C240-4C15-BC7A-8B28C81B6976}" type="datetimeFigureOut">
               <a:rPr lang="en-US" smtClean="0"/>
-              <a:t>06/25/2026</a:t>
+              <a:t>06/29/2026</a:t>
             </a:fld>
             <a:endParaRPr lang="en-US"/>
           </a:p>
@@ -3009,7 +3409,7 @@
           <a:p>
             <a:fld id="{179C5205-C240-4C15-BC7A-8B28C81B6976}" type="datetimeFigureOut">
               <a:rPr lang="en-US" smtClean="0"/>
-              <a:t>06/25/2026</a:t>
+              <a:t>06/29/2026</a:t>
             </a:fld>
             <a:endParaRPr lang="en-US"/>
           </a:p>
@@ -3666,130 +4066,6 @@
           </a:p>
         </p:txBody>
       </p:sp>
-      <p:sp>
-        <p:nvSpPr>
-          <p:cNvPr id="116" name="Oval 1">
-            <a:extLst>
-              <a:ext uri="{FF2B5EF4-FFF2-40B4-BE49-F238E27FC236}">
-                <a16:creationId xmlns:a16="http://schemas.microsoft.com/office/drawing/2014/main" id="{58981A44-2D30-B03A-40AF-B4D55A7E46A4}"/>
-              </a:ext>
-            </a:extLst>
-          </p:cNvPr>
-          <p:cNvSpPr/>
-          <p:nvPr/>
-        </p:nvSpPr>
-        <p:spPr>
-          <a:xfrm>
-            <a:off x="1201733" y="3062790"/>
-            <a:ext cx="2532065" cy="1179512"/>
-          </a:xfrm>
-          <a:prstGeom prst="ellipse">
-            <a:avLst/>
-          </a:prstGeom>
-          <a:solidFill>
-            <a:srgbClr val="92D050"/>
-          </a:solidFill>
-        </p:spPr>
-        <p:style>
-          <a:lnRef idx="2">
-            <a:schemeClr val="accent1">
-              <a:shade val="15000"/>
-            </a:schemeClr>
-          </a:lnRef>
-          <a:fillRef idx="1">
-            <a:schemeClr val="accent1"/>
-          </a:fillRef>
-          <a:effectRef idx="0">
-            <a:schemeClr val="accent1"/>
-          </a:effectRef>
-          <a:fontRef idx="minor">
-            <a:schemeClr val="lt1"/>
-          </a:fontRef>
-        </p:style>
-        <p:txBody>
-          <a:bodyPr rot="0" spcFirstLastPara="0" vert="horz" wrap="square" lIns="91440" tIns="45720" rIns="91440" bIns="45720" numCol="1" spcCol="0" rtlCol="0" fromWordArt="0" anchor="ctr" anchorCtr="0" forceAA="0" compatLnSpc="1">
-            <a:prstTxWarp prst="textNoShape">
-              <a:avLst/>
-            </a:prstTxWarp>
-            <a:noAutofit/>
-          </a:bodyPr>
-          <a:lstStyle/>
-          <a:p>
-            <a:pPr algn="ctr"/>
-            <a:r>
-              <a:rPr lang="en-US" sz="1200" b="1" u="sng" kern="100" dirty="0" err="1">
-                <a:solidFill>
-                  <a:srgbClr val="000000"/>
-                </a:solidFill>
-                <a:ea typeface="Aptos" panose="020B0004020202020204" pitchFamily="34" charset="0"/>
-                <a:cs typeface="Times New Roman" panose="02020603050405020304" pitchFamily="18" charset="0"/>
-              </a:rPr>
-              <a:t>catchByEffort</a:t>
-            </a:r>
-            <a:endParaRPr lang="en-US" sz="1200" u="sng" kern="100" dirty="0">
-              <a:effectLst/>
-              <a:ea typeface="Aptos" panose="020B0004020202020204" pitchFamily="34" charset="0"/>
-              <a:cs typeface="Times New Roman" panose="02020603050405020304" pitchFamily="18" charset="0"/>
-            </a:endParaRPr>
-          </a:p>
-        </p:txBody>
-      </p:sp>
-      <p:sp>
-        <p:nvSpPr>
-          <p:cNvPr id="117" name="TextBox 116">
-            <a:extLst>
-              <a:ext uri="{FF2B5EF4-FFF2-40B4-BE49-F238E27FC236}">
-                <a16:creationId xmlns:a16="http://schemas.microsoft.com/office/drawing/2014/main" id="{26B2E6BC-1735-4EF8-6CF5-FE1B71D9491D}"/>
-              </a:ext>
-            </a:extLst>
-          </p:cNvPr>
-          <p:cNvSpPr txBox="1"/>
-          <p:nvPr/>
-        </p:nvSpPr>
-        <p:spPr>
-          <a:xfrm>
-            <a:off x="4013199" y="3365500"/>
-            <a:ext cx="3809999" cy="461665"/>
-          </a:xfrm>
-          <a:prstGeom prst="rect">
-            <a:avLst/>
-          </a:prstGeom>
-          <a:noFill/>
-          <a:ln>
-            <a:solidFill>
-              <a:schemeClr val="tx1"/>
-            </a:solidFill>
-          </a:ln>
-        </p:spPr>
-        <p:txBody>
-          <a:bodyPr wrap="square" rtlCol="0">
-            <a:spAutoFit/>
-          </a:bodyPr>
-          <a:lstStyle/>
-          <a:p>
-            <a:r>
-              <a:rPr lang="en-US" sz="1200" dirty="0"/>
-              <a:t>Queries catch data by efforts in </a:t>
-            </a:r>
-            <a:r>
-              <a:rPr lang="en-US" sz="1200" dirty="0" err="1"/>
-              <a:t>FISH_query</a:t>
-            </a:r>
-            <a:endParaRPr lang="en-US" sz="1200" dirty="0"/>
-          </a:p>
-          <a:p>
-            <a:r>
-              <a:rPr lang="en-US" sz="1200" dirty="0"/>
-              <a:t>Output: joins catch data to </a:t>
-            </a:r>
-            <a:r>
-              <a:rPr lang="en-US" sz="1200" dirty="0" err="1"/>
-              <a:t>FISH_query</a:t>
-            </a:r>
-            <a:endParaRPr lang="en-US" sz="1200" dirty="0"/>
-          </a:p>
-        </p:txBody>
-      </p:sp>
       <p:cxnSp>
         <p:nvCxnSpPr>
           <p:cNvPr id="119" name="Straight Arrow Connector 118">
@@ -3801,58 +4077,15 @@
           </p:cNvPr>
           <p:cNvCxnSpPr>
             <a:cxnSpLocks/>
-            <a:stCxn id="116" idx="4"/>
+            <a:stCxn id="7" idx="4"/>
             <a:endCxn id="115" idx="0"/>
           </p:cNvCxnSpPr>
           <p:nvPr/>
         </p:nvCxnSpPr>
         <p:spPr>
           <a:xfrm flipH="1">
-            <a:off x="1413665" y="4242302"/>
-            <a:ext cx="1054101" cy="510291"/>
-          </a:xfrm>
-          <a:prstGeom prst="straightConnector1">
-            <a:avLst/>
-          </a:prstGeom>
-          <a:ln>
-            <a:tailEnd type="triangle"/>
-          </a:ln>
-        </p:spPr>
-        <p:style>
-          <a:lnRef idx="2">
-            <a:schemeClr val="dk1"/>
-          </a:lnRef>
-          <a:fillRef idx="0">
-            <a:schemeClr val="dk1"/>
-          </a:fillRef>
-          <a:effectRef idx="1">
-            <a:schemeClr val="dk1"/>
-          </a:effectRef>
-          <a:fontRef idx="minor">
-            <a:schemeClr val="tx1"/>
-          </a:fontRef>
-        </p:style>
-      </p:cxnSp>
-      <p:cxnSp>
-        <p:nvCxnSpPr>
-          <p:cNvPr id="124" name="Straight Arrow Connector 123">
-            <a:extLst>
-              <a:ext uri="{FF2B5EF4-FFF2-40B4-BE49-F238E27FC236}">
-                <a16:creationId xmlns:a16="http://schemas.microsoft.com/office/drawing/2014/main" id="{E5109F92-7FEE-64A0-E5A1-96C05482E3D8}"/>
-              </a:ext>
-            </a:extLst>
-          </p:cNvPr>
-          <p:cNvCxnSpPr>
-            <a:cxnSpLocks/>
-            <a:stCxn id="114" idx="4"/>
-            <a:endCxn id="116" idx="0"/>
-          </p:cNvCxnSpPr>
-          <p:nvPr/>
-        </p:nvCxnSpPr>
-        <p:spPr>
-          <a:xfrm flipH="1">
-            <a:off x="2467766" y="2726756"/>
-            <a:ext cx="1" cy="336034"/>
+            <a:off x="1413665" y="4131245"/>
+            <a:ext cx="1054101" cy="621348"/>
           </a:xfrm>
           <a:prstGeom prst="straightConnector1">
             <a:avLst/>
@@ -3887,15 +4120,15 @@
           </p:cNvPr>
           <p:cNvCxnSpPr>
             <a:cxnSpLocks/>
-            <a:stCxn id="116" idx="4"/>
+            <a:stCxn id="7" idx="4"/>
             <a:endCxn id="131" idx="0"/>
           </p:cNvCxnSpPr>
           <p:nvPr/>
         </p:nvCxnSpPr>
         <p:spPr>
           <a:xfrm>
-            <a:off x="2467766" y="4242302"/>
-            <a:ext cx="1642267" cy="589756"/>
+            <a:off x="2467766" y="4131245"/>
+            <a:ext cx="1642267" cy="700813"/>
           </a:xfrm>
           <a:prstGeom prst="straightConnector1">
             <a:avLst/>
@@ -4066,15 +4299,15 @@
           </p:cNvPr>
           <p:cNvCxnSpPr>
             <a:cxnSpLocks/>
-            <a:stCxn id="116" idx="4"/>
+            <a:stCxn id="7" idx="4"/>
             <a:endCxn id="134" idx="0"/>
           </p:cNvCxnSpPr>
           <p:nvPr/>
         </p:nvCxnSpPr>
         <p:spPr>
           <a:xfrm>
-            <a:off x="2467766" y="4242302"/>
-            <a:ext cx="4348171" cy="589756"/>
+            <a:off x="2467766" y="4131245"/>
+            <a:ext cx="4348171" cy="700813"/>
           </a:xfrm>
           <a:prstGeom prst="straightConnector1">
             <a:avLst/>
@@ -4109,15 +4342,15 @@
           </p:cNvPr>
           <p:cNvCxnSpPr>
             <a:cxnSpLocks/>
-            <a:stCxn id="116" idx="4"/>
+            <a:stCxn id="7" idx="4"/>
             <a:endCxn id="146" idx="0"/>
           </p:cNvCxnSpPr>
           <p:nvPr/>
         </p:nvCxnSpPr>
         <p:spPr>
           <a:xfrm>
-            <a:off x="2467766" y="4242302"/>
-            <a:ext cx="7044537" cy="510291"/>
+            <a:off x="2467766" y="4131245"/>
+            <a:ext cx="7044537" cy="621348"/>
           </a:xfrm>
           <a:prstGeom prst="straightConnector1">
             <a:avLst/>
@@ -4209,6 +4442,119 @@
           </a:p>
         </p:txBody>
       </p:sp>
+      <p:sp>
+        <p:nvSpPr>
+          <p:cNvPr id="7" name="Oval 1">
+            <a:extLst>
+              <a:ext uri="{FF2B5EF4-FFF2-40B4-BE49-F238E27FC236}">
+                <a16:creationId xmlns:a16="http://schemas.microsoft.com/office/drawing/2014/main" id="{4FE9BE98-0136-BEEC-A5C5-767111FEA440}"/>
+              </a:ext>
+            </a:extLst>
+          </p:cNvPr>
+          <p:cNvSpPr/>
+          <p:nvPr/>
+        </p:nvSpPr>
+        <p:spPr>
+          <a:xfrm>
+            <a:off x="1646633" y="2951733"/>
+            <a:ext cx="1642266" cy="1179512"/>
+          </a:xfrm>
+          <a:prstGeom prst="ellipse">
+            <a:avLst/>
+          </a:prstGeom>
+          <a:solidFill>
+            <a:srgbClr val="92D050"/>
+          </a:solidFill>
+        </p:spPr>
+        <p:style>
+          <a:lnRef idx="2">
+            <a:schemeClr val="accent1">
+              <a:shade val="15000"/>
+            </a:schemeClr>
+          </a:lnRef>
+          <a:fillRef idx="1">
+            <a:schemeClr val="accent1"/>
+          </a:fillRef>
+          <a:effectRef idx="0">
+            <a:schemeClr val="accent1"/>
+          </a:effectRef>
+          <a:fontRef idx="minor">
+            <a:schemeClr val="lt1"/>
+          </a:fontRef>
+        </p:style>
+        <p:txBody>
+          <a:bodyPr rot="0" spcFirstLastPara="0" vert="horz" wrap="square" lIns="91440" tIns="45720" rIns="91440" bIns="45720" numCol="1" spcCol="0" rtlCol="0" fromWordArt="0" anchor="ctr" anchorCtr="0" forceAA="0" compatLnSpc="1">
+            <a:prstTxWarp prst="textNoShape">
+              <a:avLst/>
+            </a:prstTxWarp>
+            <a:noAutofit/>
+          </a:bodyPr>
+          <a:lstStyle/>
+          <a:p>
+            <a:pPr algn="ctr"/>
+            <a:r>
+              <a:rPr lang="en-US" sz="1200" b="1" kern="100" dirty="0" err="1">
+                <a:solidFill>
+                  <a:srgbClr val="000000"/>
+                </a:solidFill>
+                <a:ea typeface="Aptos" panose="020B0004020202020204" pitchFamily="34" charset="0"/>
+                <a:cs typeface="Times New Roman" panose="02020603050405020304" pitchFamily="18" charset="0"/>
+              </a:rPr>
+              <a:t>catchByEffort</a:t>
+            </a:r>
+            <a:endParaRPr lang="en-US" sz="1200" b="1" kern="100" dirty="0">
+              <a:solidFill>
+                <a:srgbClr val="000000"/>
+              </a:solidFill>
+              <a:ea typeface="Aptos" panose="020B0004020202020204" pitchFamily="34" charset="0"/>
+              <a:cs typeface="Times New Roman" panose="02020603050405020304" pitchFamily="18" charset="0"/>
+            </a:endParaRPr>
+          </a:p>
+        </p:txBody>
+      </p:sp>
+      <p:cxnSp>
+        <p:nvCxnSpPr>
+          <p:cNvPr id="12" name="Straight Arrow Connector 11">
+            <a:extLst>
+              <a:ext uri="{FF2B5EF4-FFF2-40B4-BE49-F238E27FC236}">
+                <a16:creationId xmlns:a16="http://schemas.microsoft.com/office/drawing/2014/main" id="{81A26EC5-D573-533A-BC0E-C461C4C8848C}"/>
+              </a:ext>
+            </a:extLst>
+          </p:cNvPr>
+          <p:cNvCxnSpPr>
+            <a:cxnSpLocks/>
+            <a:stCxn id="114" idx="4"/>
+            <a:endCxn id="7" idx="0"/>
+          </p:cNvCxnSpPr>
+          <p:nvPr/>
+        </p:nvCxnSpPr>
+        <p:spPr>
+          <a:xfrm flipH="1">
+            <a:off x="2467766" y="2726756"/>
+            <a:ext cx="1" cy="224977"/>
+          </a:xfrm>
+          <a:prstGeom prst="straightConnector1">
+            <a:avLst/>
+          </a:prstGeom>
+          <a:ln>
+            <a:tailEnd type="triangle"/>
+          </a:ln>
+        </p:spPr>
+        <p:style>
+          <a:lnRef idx="2">
+            <a:schemeClr val="dk1"/>
+          </a:lnRef>
+          <a:fillRef idx="0">
+            <a:schemeClr val="dk1"/>
+          </a:fillRef>
+          <a:effectRef idx="1">
+            <a:schemeClr val="dk1"/>
+          </a:effectRef>
+          <a:fontRef idx="minor">
+            <a:schemeClr val="tx1"/>
+          </a:fontRef>
+        </p:style>
+      </p:cxnSp>
     </p:spTree>
     <p:extLst>
       <p:ext uri="{BB962C8B-B14F-4D97-AF65-F5344CB8AC3E}">
@@ -5003,8 +5349,8 @@
         </p:nvSpPr>
         <p:spPr>
           <a:xfrm>
-            <a:off x="3637755" y="2953939"/>
-            <a:ext cx="2695692" cy="2234407"/>
+            <a:off x="4028280" y="3591716"/>
+            <a:ext cx="1600991" cy="958851"/>
           </a:xfrm>
           <a:prstGeom prst="rect">
             <a:avLst/>
@@ -5131,135 +5477,7 @@
                 <a:ea typeface="Aptos" panose="020B0004020202020204" pitchFamily="34" charset="0"/>
                 <a:cs typeface="Times New Roman" panose="02020603050405020304" pitchFamily="18" charset="0"/>
               </a:rPr>
-              <a:t>GearTypeId</a:t>
-            </a:r>
-            <a:endParaRPr lang="en-US" sz="1200" kern="100" dirty="0">
-              <a:solidFill>
-                <a:srgbClr val="000000"/>
-              </a:solidFill>
-              <a:ea typeface="Aptos" panose="020B0004020202020204" pitchFamily="34" charset="0"/>
-              <a:cs typeface="Times New Roman" panose="02020603050405020304" pitchFamily="18" charset="0"/>
-            </a:endParaRPr>
-          </a:p>
-          <a:p>
-            <a:pPr algn="ctr"/>
-            <a:r>
-              <a:rPr lang="en-US" sz="1200" kern="100" dirty="0" err="1">
-                <a:solidFill>
-                  <a:srgbClr val="000000"/>
-                </a:solidFill>
-                <a:effectLst/>
-                <a:ea typeface="Aptos" panose="020B0004020202020204" pitchFamily="34" charset="0"/>
-                <a:cs typeface="Times New Roman" panose="02020603050405020304" pitchFamily="18" charset="0"/>
-              </a:rPr>
               <a:t>ModuleId</a:t>
-            </a:r>
-            <a:r>
-              <a:rPr lang="en-US" sz="1200" kern="100" dirty="0">
-                <a:solidFill>
-                  <a:srgbClr val="000000"/>
-                </a:solidFill>
-                <a:effectLst/>
-                <a:ea typeface="Aptos" panose="020B0004020202020204" pitchFamily="34" charset="0"/>
-                <a:cs typeface="Times New Roman" panose="02020603050405020304" pitchFamily="18" charset="0"/>
-              </a:rPr>
-              <a:t>       </a:t>
-            </a:r>
-            <a:r>
-              <a:rPr lang="en-US" sz="1200" kern="100" dirty="0" err="1">
-                <a:solidFill>
-                  <a:srgbClr val="000000"/>
-                </a:solidFill>
-                <a:effectLst/>
-                <a:ea typeface="Aptos" panose="020B0004020202020204" pitchFamily="34" charset="0"/>
-                <a:cs typeface="Times New Roman" panose="02020603050405020304" pitchFamily="18" charset="0"/>
-              </a:rPr>
-              <a:t>EffortNumberofGearUsed</a:t>
-            </a:r>
-            <a:endParaRPr lang="en-US" sz="1200" kern="100" dirty="0">
-              <a:solidFill>
-                <a:srgbClr val="000000"/>
-              </a:solidFill>
-              <a:effectLst/>
-              <a:ea typeface="Aptos" panose="020B0004020202020204" pitchFamily="34" charset="0"/>
-              <a:cs typeface="Times New Roman" panose="02020603050405020304" pitchFamily="18" charset="0"/>
-            </a:endParaRPr>
-          </a:p>
-          <a:p>
-            <a:pPr algn="ctr"/>
-            <a:r>
-              <a:rPr lang="en-US" sz="1200" kern="100" dirty="0" err="1">
-                <a:solidFill>
-                  <a:srgbClr val="000000"/>
-                </a:solidFill>
-                <a:effectLst/>
-                <a:ea typeface="Aptos" panose="020B0004020202020204" pitchFamily="34" charset="0"/>
-                <a:cs typeface="Times New Roman" panose="02020603050405020304" pitchFamily="18" charset="0"/>
-              </a:rPr>
-              <a:t>EffortMeasurement</a:t>
-            </a:r>
-            <a:endParaRPr lang="en-US" sz="1200" kern="100" dirty="0">
-              <a:solidFill>
-                <a:srgbClr val="000000"/>
-              </a:solidFill>
-              <a:ea typeface="Aptos" panose="020B0004020202020204" pitchFamily="34" charset="0"/>
-              <a:cs typeface="Times New Roman" panose="02020603050405020304" pitchFamily="18" charset="0"/>
-            </a:endParaRPr>
-          </a:p>
-          <a:p>
-            <a:pPr algn="ctr"/>
-            <a:r>
-              <a:rPr lang="en-US" sz="1200" kern="100" dirty="0" err="1">
-                <a:solidFill>
-                  <a:srgbClr val="000000"/>
-                </a:solidFill>
-                <a:effectLst/>
-                <a:ea typeface="Aptos" panose="020B0004020202020204" pitchFamily="34" charset="0"/>
-                <a:cs typeface="Times New Roman" panose="02020603050405020304" pitchFamily="18" charset="0"/>
-              </a:rPr>
-              <a:t>EffortQuantity</a:t>
-            </a:r>
-            <a:endParaRPr lang="en-US" sz="1200" kern="100" dirty="0">
-              <a:solidFill>
-                <a:srgbClr val="000000"/>
-              </a:solidFill>
-              <a:ea typeface="Aptos" panose="020B0004020202020204" pitchFamily="34" charset="0"/>
-              <a:cs typeface="Times New Roman" panose="02020603050405020304" pitchFamily="18" charset="0"/>
-            </a:endParaRPr>
-          </a:p>
-          <a:p>
-            <a:pPr algn="ctr"/>
-            <a:r>
-              <a:rPr lang="en-US" sz="1200" kern="100" dirty="0">
-                <a:solidFill>
-                  <a:srgbClr val="000000"/>
-                </a:solidFill>
-                <a:effectLst/>
-                <a:ea typeface="Aptos" panose="020B0004020202020204" pitchFamily="34" charset="0"/>
-                <a:cs typeface="Times New Roman" panose="02020603050405020304" pitchFamily="18" charset="0"/>
-              </a:rPr>
-              <a:t>EffortMeasurement2</a:t>
-            </a:r>
-            <a:endParaRPr lang="en-US" sz="1200" kern="100" dirty="0">
-              <a:solidFill>
-                <a:srgbClr val="000000"/>
-              </a:solidFill>
-              <a:ea typeface="Aptos" panose="020B0004020202020204" pitchFamily="34" charset="0"/>
-              <a:cs typeface="Times New Roman" panose="02020603050405020304" pitchFamily="18" charset="0"/>
-            </a:endParaRPr>
-          </a:p>
-          <a:p>
-            <a:pPr algn="ctr"/>
-            <a:r>
-              <a:rPr lang="en-US" sz="1200" kern="100" dirty="0">
-                <a:solidFill>
-                  <a:srgbClr val="000000"/>
-                </a:solidFill>
-                <a:effectLst/>
-                <a:ea typeface="Aptos" panose="020B0004020202020204" pitchFamily="34" charset="0"/>
-                <a:cs typeface="Times New Roman" panose="02020603050405020304" pitchFamily="18" charset="0"/>
-              </a:rPr>
-              <a:t>EffortQuantity2</a:t>
             </a:r>
             <a:endParaRPr lang="en-US" sz="1200" kern="100" dirty="0">
               <a:effectLst/>
@@ -5655,9 +5873,9 @@
           <p:nvPr/>
         </p:nvCxnSpPr>
         <p:spPr>
-          <a:xfrm>
-            <a:off x="2362675" y="4071143"/>
-            <a:ext cx="1275080" cy="0"/>
+          <a:xfrm flipV="1">
+            <a:off x="2362675" y="4071142"/>
+            <a:ext cx="1665605" cy="1"/>
           </a:xfrm>
           <a:prstGeom prst="straightConnector1">
             <a:avLst/>
@@ -5698,9 +5916,9 @@
           <p:nvPr/>
         </p:nvCxnSpPr>
         <p:spPr>
-          <a:xfrm flipV="1">
-            <a:off x="6333447" y="4071142"/>
-            <a:ext cx="513499" cy="1"/>
+          <a:xfrm>
+            <a:off x="5629271" y="4071142"/>
+            <a:ext cx="1217675" cy="0"/>
           </a:xfrm>
           <a:prstGeom prst="straightConnector1">
             <a:avLst/>
@@ -5788,7 +6006,7 @@
         <p:cNvPr id="1" name="">
           <a:extLst>
             <a:ext uri="{FF2B5EF4-FFF2-40B4-BE49-F238E27FC236}">
-              <a16:creationId xmlns:a16="http://schemas.microsoft.com/office/drawing/2014/main" id="{0ABC13E6-4B29-D95B-7563-D4E3C8D714FD}"/>
+              <a16:creationId xmlns:a16="http://schemas.microsoft.com/office/drawing/2014/main" id="{BB7C6E82-3B56-7367-7ACF-69D6C3486CB2}"/>
             </a:ext>
           </a:extLst>
         </p:cNvPr>
@@ -5808,7 +6026,7 @@
           <p:cNvPr id="4" name="Title 3">
             <a:extLst>
               <a:ext uri="{FF2B5EF4-FFF2-40B4-BE49-F238E27FC236}">
-                <a16:creationId xmlns:a16="http://schemas.microsoft.com/office/drawing/2014/main" id="{418CDC6C-8A45-B20A-B223-49B2497AE55D}"/>
+                <a16:creationId xmlns:a16="http://schemas.microsoft.com/office/drawing/2014/main" id="{1BAD97C7-DEBE-62C8-60F1-6A62E416FEB8}"/>
               </a:ext>
             </a:extLst>
           </p:cNvPr>
@@ -5837,7 +6055,7 @@
           <p:cNvPr id="5" name="Oval 1">
             <a:extLst>
               <a:ext uri="{FF2B5EF4-FFF2-40B4-BE49-F238E27FC236}">
-                <a16:creationId xmlns:a16="http://schemas.microsoft.com/office/drawing/2014/main" id="{3195C522-2030-D15A-FE62-C290E35B62D0}"/>
+                <a16:creationId xmlns:a16="http://schemas.microsoft.com/office/drawing/2014/main" id="{63D1010D-187C-CBCE-D8EF-07F5C49E6297}"/>
               </a:ext>
             </a:extLst>
           </p:cNvPr>
@@ -6039,7 +6257,7 @@
           <p:cNvPr id="7" name="Oval 1">
             <a:extLst>
               <a:ext uri="{FF2B5EF4-FFF2-40B4-BE49-F238E27FC236}">
-                <a16:creationId xmlns:a16="http://schemas.microsoft.com/office/drawing/2014/main" id="{0D3B8EBA-C2BB-D4C2-DD7A-5B18DB01E86E}"/>
+                <a16:creationId xmlns:a16="http://schemas.microsoft.com/office/drawing/2014/main" id="{3F27521D-007A-864A-7E95-FF49BA411BA1}"/>
               </a:ext>
             </a:extLst>
           </p:cNvPr>
@@ -6150,7 +6368,7 @@
           <p:cNvPr id="8" name="Straight Arrow Connector 7">
             <a:extLst>
               <a:ext uri="{FF2B5EF4-FFF2-40B4-BE49-F238E27FC236}">
-                <a16:creationId xmlns:a16="http://schemas.microsoft.com/office/drawing/2014/main" id="{1E0FED9E-27E2-752B-BCB2-A111E66BAD5B}"/>
+                <a16:creationId xmlns:a16="http://schemas.microsoft.com/office/drawing/2014/main" id="{D76D930F-8B45-04E7-7E3E-4D5961526237}"/>
               </a:ext>
             </a:extLst>
           </p:cNvPr>
@@ -6193,7 +6411,7 @@
           <p:cNvPr id="13" name="Oval 1">
             <a:extLst>
               <a:ext uri="{FF2B5EF4-FFF2-40B4-BE49-F238E27FC236}">
-                <a16:creationId xmlns:a16="http://schemas.microsoft.com/office/drawing/2014/main" id="{7E0A5844-1058-2A3D-9C61-CD7CE7543CD5}"/>
+                <a16:creationId xmlns:a16="http://schemas.microsoft.com/office/drawing/2014/main" id="{5FE2401A-BFFA-29AA-CEDE-7C96C5964533}"/>
               </a:ext>
             </a:extLst>
           </p:cNvPr>
@@ -6281,7 +6499,7 @@
           <a:p>
             <a:pPr algn="ctr"/>
             <a:r>
-              <a:rPr lang="en-US" sz="1200" kern="100" dirty="0">
+              <a:rPr lang="en-US" sz="1200" u="sng" kern="100" dirty="0">
                 <a:solidFill>
                   <a:srgbClr val="000000"/>
                 </a:solidFill>
@@ -6321,7 +6539,7 @@
           <p:cNvPr id="14" name="Straight Arrow Connector 13">
             <a:extLst>
               <a:ext uri="{FF2B5EF4-FFF2-40B4-BE49-F238E27FC236}">
-                <a16:creationId xmlns:a16="http://schemas.microsoft.com/office/drawing/2014/main" id="{888C8E5B-2D36-6F28-C728-560CE454A79C}"/>
+                <a16:creationId xmlns:a16="http://schemas.microsoft.com/office/drawing/2014/main" id="{DD218F72-E8C3-F972-2248-BA6FD2FDE5EA}"/>
               </a:ext>
             </a:extLst>
           </p:cNvPr>
@@ -6361,165 +6579,10 @@
       </p:cxnSp>
       <p:sp>
         <p:nvSpPr>
-          <p:cNvPr id="25" name="Oval 1">
-            <a:extLst>
-              <a:ext uri="{FF2B5EF4-FFF2-40B4-BE49-F238E27FC236}">
-                <a16:creationId xmlns:a16="http://schemas.microsoft.com/office/drawing/2014/main" id="{02C815BB-1E92-8AD5-1141-2435BE9E3FB7}"/>
-              </a:ext>
-            </a:extLst>
-          </p:cNvPr>
-          <p:cNvSpPr/>
-          <p:nvPr/>
-        </p:nvSpPr>
-        <p:spPr>
-          <a:xfrm>
-            <a:off x="7043735" y="5290143"/>
-            <a:ext cx="1516063" cy="1179512"/>
-          </a:xfrm>
-          <a:prstGeom prst="ellipse">
-            <a:avLst/>
-          </a:prstGeom>
-          <a:solidFill>
-            <a:srgbClr val="92D050"/>
-          </a:solidFill>
-        </p:spPr>
-        <p:style>
-          <a:lnRef idx="2">
-            <a:schemeClr val="accent1">
-              <a:shade val="15000"/>
-            </a:schemeClr>
-          </a:lnRef>
-          <a:fillRef idx="1">
-            <a:schemeClr val="accent1"/>
-          </a:fillRef>
-          <a:effectRef idx="0">
-            <a:schemeClr val="accent1"/>
-          </a:effectRef>
-          <a:fontRef idx="minor">
-            <a:schemeClr val="lt1"/>
-          </a:fontRef>
-        </p:style>
-        <p:txBody>
-          <a:bodyPr rot="0" spcFirstLastPara="0" vert="horz" wrap="square" lIns="91440" tIns="45720" rIns="91440" bIns="45720" numCol="1" spcCol="0" rtlCol="0" fromWordArt="0" anchor="ctr" anchorCtr="0" forceAA="0" compatLnSpc="1">
-            <a:prstTxWarp prst="textNoShape">
-              <a:avLst/>
-            </a:prstTxWarp>
-            <a:noAutofit/>
-          </a:bodyPr>
-          <a:lstStyle/>
-          <a:p>
-            <a:pPr algn="ctr"/>
-            <a:r>
-              <a:rPr lang="en-US" sz="1200" b="1" kern="100" dirty="0" err="1">
-                <a:solidFill>
-                  <a:srgbClr val="000000"/>
-                </a:solidFill>
-                <a:effectLst/>
-                <a:ea typeface="Aptos" panose="020B0004020202020204" pitchFamily="34" charset="0"/>
-                <a:cs typeface="Times New Roman" panose="02020603050405020304" pitchFamily="18" charset="0"/>
-              </a:rPr>
-              <a:t>FISH_query</a:t>
-            </a:r>
-            <a:endParaRPr lang="en-US" sz="1200" b="1" kern="100" dirty="0">
-              <a:solidFill>
-                <a:srgbClr val="000000"/>
-              </a:solidFill>
-              <a:ea typeface="Aptos" panose="020B0004020202020204" pitchFamily="34" charset="0"/>
-              <a:cs typeface="Times New Roman" panose="02020603050405020304" pitchFamily="18" charset="0"/>
-            </a:endParaRPr>
-          </a:p>
-          <a:p>
-            <a:pPr algn="ctr"/>
-            <a:r>
-              <a:rPr lang="en-US" sz="1200" u="sng" kern="100" dirty="0" err="1">
-                <a:solidFill>
-                  <a:srgbClr val="000000"/>
-                </a:solidFill>
-                <a:effectLst/>
-                <a:ea typeface="Aptos" panose="020B0004020202020204" pitchFamily="34" charset="0"/>
-                <a:cs typeface="Times New Roman" panose="02020603050405020304" pitchFamily="18" charset="0"/>
-              </a:rPr>
-              <a:t>ModuleId</a:t>
-            </a:r>
-            <a:endParaRPr lang="en-US" sz="1200" u="sng" kern="100" dirty="0">
-              <a:solidFill>
-                <a:srgbClr val="000000"/>
-              </a:solidFill>
-              <a:effectLst/>
-              <a:ea typeface="Aptos" panose="020B0004020202020204" pitchFamily="34" charset="0"/>
-              <a:cs typeface="Times New Roman" panose="02020603050405020304" pitchFamily="18" charset="0"/>
-            </a:endParaRPr>
-          </a:p>
-          <a:p>
-            <a:pPr algn="ctr"/>
-            <a:r>
-              <a:rPr lang="en-US" sz="1200" u="sng" kern="100" dirty="0" err="1">
-                <a:solidFill>
-                  <a:srgbClr val="000000"/>
-                </a:solidFill>
-                <a:effectLst/>
-                <a:ea typeface="Aptos" panose="020B0004020202020204" pitchFamily="34" charset="0"/>
-                <a:cs typeface="Times New Roman" panose="02020603050405020304" pitchFamily="18" charset="0"/>
-              </a:rPr>
-              <a:t>SurveyId</a:t>
-            </a:r>
-            <a:endParaRPr lang="en-US" sz="1200" u="sng" kern="100" dirty="0">
-              <a:effectLst/>
-              <a:ea typeface="Aptos" panose="020B0004020202020204" pitchFamily="34" charset="0"/>
-              <a:cs typeface="Times New Roman" panose="02020603050405020304" pitchFamily="18" charset="0"/>
-            </a:endParaRPr>
-          </a:p>
-        </p:txBody>
-      </p:sp>
-      <p:cxnSp>
-        <p:nvCxnSpPr>
-          <p:cNvPr id="26" name="Straight Arrow Connector 25">
-            <a:extLst>
-              <a:ext uri="{FF2B5EF4-FFF2-40B4-BE49-F238E27FC236}">
-                <a16:creationId xmlns:a16="http://schemas.microsoft.com/office/drawing/2014/main" id="{60A5B798-2013-6B89-CBB8-3B8D09108AA9}"/>
-              </a:ext>
-            </a:extLst>
-          </p:cNvPr>
-          <p:cNvCxnSpPr>
-            <a:cxnSpLocks/>
-            <a:stCxn id="25" idx="0"/>
-            <a:endCxn id="7" idx="2"/>
-          </p:cNvCxnSpPr>
-          <p:nvPr/>
-        </p:nvCxnSpPr>
-        <p:spPr>
-          <a:xfrm flipH="1" flipV="1">
-            <a:off x="6468268" y="4879855"/>
-            <a:ext cx="1333499" cy="410288"/>
-          </a:xfrm>
-          <a:prstGeom prst="straightConnector1">
-            <a:avLst/>
-          </a:prstGeom>
-          <a:ln>
-            <a:tailEnd type="triangle"/>
-          </a:ln>
-        </p:spPr>
-        <p:style>
-          <a:lnRef idx="2">
-            <a:schemeClr val="dk1"/>
-          </a:lnRef>
-          <a:fillRef idx="0">
-            <a:schemeClr val="dk1"/>
-          </a:fillRef>
-          <a:effectRef idx="1">
-            <a:schemeClr val="dk1"/>
-          </a:effectRef>
-          <a:fontRef idx="minor">
-            <a:schemeClr val="tx1"/>
-          </a:fontRef>
-        </p:style>
-      </p:cxnSp>
-      <p:sp>
-        <p:nvSpPr>
           <p:cNvPr id="38" name="Oval 1">
             <a:extLst>
               <a:ext uri="{FF2B5EF4-FFF2-40B4-BE49-F238E27FC236}">
-                <a16:creationId xmlns:a16="http://schemas.microsoft.com/office/drawing/2014/main" id="{7BA59096-1338-2259-37D1-D16DC768901E}"/>
+                <a16:creationId xmlns:a16="http://schemas.microsoft.com/office/drawing/2014/main" id="{F0E000B8-5F45-04EE-B264-811ED14C2A21}"/>
               </a:ext>
             </a:extLst>
           </p:cNvPr>
@@ -6691,7 +6754,7 @@
           <p:cNvPr id="41" name="Straight Arrow Connector 40">
             <a:extLst>
               <a:ext uri="{FF2B5EF4-FFF2-40B4-BE49-F238E27FC236}">
-                <a16:creationId xmlns:a16="http://schemas.microsoft.com/office/drawing/2014/main" id="{7F6A3D3A-B93F-9101-E540-6EB9F73A284B}"/>
+                <a16:creationId xmlns:a16="http://schemas.microsoft.com/office/drawing/2014/main" id="{A3380EF5-361B-BA11-7E5B-5EC9E6DA518F}"/>
               </a:ext>
             </a:extLst>
           </p:cNvPr>
@@ -6734,7 +6797,7 @@
           <p:cNvPr id="44" name="Straight Arrow Connector 43">
             <a:extLst>
               <a:ext uri="{FF2B5EF4-FFF2-40B4-BE49-F238E27FC236}">
-                <a16:creationId xmlns:a16="http://schemas.microsoft.com/office/drawing/2014/main" id="{A824664D-C8E5-132F-1392-324C006577E6}"/>
+                <a16:creationId xmlns:a16="http://schemas.microsoft.com/office/drawing/2014/main" id="{E696C7E1-B2EC-C3E2-55C6-DBF02B4CAABA}"/>
               </a:ext>
             </a:extLst>
           </p:cNvPr>
@@ -6777,7 +6840,7 @@
           <p:cNvPr id="74" name="Oval 1">
             <a:extLst>
               <a:ext uri="{FF2B5EF4-FFF2-40B4-BE49-F238E27FC236}">
-                <a16:creationId xmlns:a16="http://schemas.microsoft.com/office/drawing/2014/main" id="{46F5C7CC-6925-F2A6-9406-632497A09E9C}"/>
+                <a16:creationId xmlns:a16="http://schemas.microsoft.com/office/drawing/2014/main" id="{8794BFCB-0CD3-D62F-28BE-79835CCFE93C}"/>
               </a:ext>
             </a:extLst>
           </p:cNvPr>
@@ -6843,6 +6906,28 @@
           <a:p>
             <a:pPr algn="ctr"/>
             <a:r>
+              <a:rPr lang="en-US" sz="1200" kern="100" dirty="0" err="1">
+                <a:solidFill>
+                  <a:srgbClr val="000000"/>
+                </a:solidFill>
+                <a:effectLst/>
+                <a:ea typeface="Aptos" panose="020B0004020202020204" pitchFamily="34" charset="0"/>
+                <a:cs typeface="Times New Roman" panose="02020603050405020304" pitchFamily="18" charset="0"/>
+              </a:rPr>
+              <a:t>SurveyId</a:t>
+            </a:r>
+            <a:endParaRPr lang="en-US" sz="1200" kern="100" dirty="0">
+              <a:solidFill>
+                <a:srgbClr val="000000"/>
+              </a:solidFill>
+              <a:effectLst/>
+              <a:ea typeface="Aptos" panose="020B0004020202020204" pitchFamily="34" charset="0"/>
+              <a:cs typeface="Times New Roman" panose="02020603050405020304" pitchFamily="18" charset="0"/>
+            </a:endParaRPr>
+          </a:p>
+          <a:p>
+            <a:pPr algn="ctr"/>
+            <a:r>
               <a:rPr lang="en-US" sz="1200" u="sng" kern="100" dirty="0" err="1">
                 <a:solidFill>
                   <a:srgbClr val="000000"/>
@@ -6851,7 +6936,7 @@
                 <a:ea typeface="Aptos" panose="020B0004020202020204" pitchFamily="34" charset="0"/>
                 <a:cs typeface="Times New Roman" panose="02020603050405020304" pitchFamily="18" charset="0"/>
               </a:rPr>
-              <a:t>SurveyId</a:t>
+              <a:t>ModuleDataId</a:t>
             </a:r>
             <a:endParaRPr lang="en-US" sz="1200" u="sng" kern="100" dirty="0">
               <a:solidFill>
@@ -6873,7 +6958,7 @@
                 <a:ea typeface="Aptos" panose="020B0004020202020204" pitchFamily="34" charset="0"/>
                 <a:cs typeface="Times New Roman" panose="02020603050405020304" pitchFamily="18" charset="0"/>
               </a:rPr>
-              <a:t>ModuleDataId</a:t>
+              <a:t>EnvelopeSerialNumber</a:t>
             </a:r>
             <a:endParaRPr lang="en-US" sz="1200" kern="100" dirty="0">
               <a:solidFill>
@@ -6887,28 +6972,6 @@
           <a:p>
             <a:pPr algn="ctr"/>
             <a:r>
-              <a:rPr lang="en-US" sz="1200" kern="100" dirty="0" err="1">
-                <a:solidFill>
-                  <a:srgbClr val="000000"/>
-                </a:solidFill>
-                <a:effectLst/>
-                <a:ea typeface="Aptos" panose="020B0004020202020204" pitchFamily="34" charset="0"/>
-                <a:cs typeface="Times New Roman" panose="02020603050405020304" pitchFamily="18" charset="0"/>
-              </a:rPr>
-              <a:t>EnvelopeSerialNumber</a:t>
-            </a:r>
-            <a:endParaRPr lang="en-US" sz="1200" kern="100" dirty="0">
-              <a:solidFill>
-                <a:srgbClr val="000000"/>
-              </a:solidFill>
-              <a:effectLst/>
-              <a:ea typeface="Aptos" panose="020B0004020202020204" pitchFamily="34" charset="0"/>
-              <a:cs typeface="Times New Roman" panose="02020603050405020304" pitchFamily="18" charset="0"/>
-            </a:endParaRPr>
-          </a:p>
-          <a:p>
-            <a:pPr algn="ctr"/>
-            <a:r>
               <a:rPr lang="en-US" sz="1200" u="sng" kern="100" dirty="0" err="1">
                 <a:solidFill>
                   <a:srgbClr val="000000"/>
@@ -6951,24 +7014,24 @@
       </p:sp>
       <p:cxnSp>
         <p:nvCxnSpPr>
-          <p:cNvPr id="75" name="Straight Arrow Connector 74">
-            <a:extLst>
-              <a:ext uri="{FF2B5EF4-FFF2-40B4-BE49-F238E27FC236}">
-                <a16:creationId xmlns:a16="http://schemas.microsoft.com/office/drawing/2014/main" id="{7373FC20-4DB9-0EBF-B26C-406748F7C46D}"/>
+          <p:cNvPr id="78" name="Straight Arrow Connector 77">
+            <a:extLst>
+              <a:ext uri="{FF2B5EF4-FFF2-40B4-BE49-F238E27FC236}">
+                <a16:creationId xmlns:a16="http://schemas.microsoft.com/office/drawing/2014/main" id="{A29CBA1D-BDF4-AF4F-A9A7-0A44836FEA7E}"/>
               </a:ext>
             </a:extLst>
           </p:cNvPr>
           <p:cNvCxnSpPr>
             <a:cxnSpLocks/>
             <a:stCxn id="74" idx="2"/>
-            <a:endCxn id="25" idx="0"/>
+            <a:endCxn id="13" idx="0"/>
           </p:cNvCxnSpPr>
           <p:nvPr/>
         </p:nvCxnSpPr>
         <p:spPr>
           <a:xfrm flipH="1">
-            <a:off x="7801767" y="3087092"/>
-            <a:ext cx="285752" cy="2203051"/>
+            <a:off x="2757884" y="3087092"/>
+            <a:ext cx="5329635" cy="1024850"/>
           </a:xfrm>
           <a:prstGeom prst="straightConnector1">
             <a:avLst/>
@@ -6995,102 +7058,10 @@
       </p:cxnSp>
       <p:cxnSp>
         <p:nvCxnSpPr>
-          <p:cNvPr id="78" name="Straight Arrow Connector 77">
-            <a:extLst>
-              <a:ext uri="{FF2B5EF4-FFF2-40B4-BE49-F238E27FC236}">
-                <a16:creationId xmlns:a16="http://schemas.microsoft.com/office/drawing/2014/main" id="{611CF0E8-E529-CC42-9A90-AE3BD15DBC2B}"/>
-              </a:ext>
-            </a:extLst>
-          </p:cNvPr>
-          <p:cNvCxnSpPr>
-            <a:cxnSpLocks/>
-            <a:stCxn id="74" idx="2"/>
-            <a:endCxn id="13" idx="0"/>
-          </p:cNvCxnSpPr>
-          <p:nvPr/>
-        </p:nvCxnSpPr>
-        <p:spPr>
-          <a:xfrm flipH="1">
-            <a:off x="2757884" y="3087092"/>
-            <a:ext cx="5329635" cy="1024850"/>
-          </a:xfrm>
-          <a:prstGeom prst="straightConnector1">
-            <a:avLst/>
-          </a:prstGeom>
-          <a:ln>
-            <a:tailEnd type="triangle"/>
-          </a:ln>
-        </p:spPr>
-        <p:style>
-          <a:lnRef idx="2">
-            <a:schemeClr val="dk1"/>
-          </a:lnRef>
-          <a:fillRef idx="0">
-            <a:schemeClr val="dk1"/>
-          </a:fillRef>
-          <a:effectRef idx="1">
-            <a:schemeClr val="dk1"/>
-          </a:effectRef>
-          <a:fontRef idx="minor">
-            <a:schemeClr val="tx1"/>
-          </a:fontRef>
-        </p:style>
-      </p:cxnSp>
-      <p:sp>
-        <p:nvSpPr>
-          <p:cNvPr id="89" name="Explosion: 8 Points 88">
-            <a:extLst>
-              <a:ext uri="{FF2B5EF4-FFF2-40B4-BE49-F238E27FC236}">
-                <a16:creationId xmlns:a16="http://schemas.microsoft.com/office/drawing/2014/main" id="{616E293E-E6D5-C468-BCA9-F358D3A56DDD}"/>
-              </a:ext>
-            </a:extLst>
-          </p:cNvPr>
-          <p:cNvSpPr/>
-          <p:nvPr/>
-        </p:nvSpPr>
-        <p:spPr>
-          <a:xfrm>
-            <a:off x="8281987" y="3263900"/>
-            <a:ext cx="3474246" cy="2746873"/>
-          </a:xfrm>
-          <a:prstGeom prst="irregularSeal1">
-            <a:avLst/>
-          </a:prstGeom>
-        </p:spPr>
-        <p:style>
-          <a:lnRef idx="2">
-            <a:schemeClr val="accent1">
-              <a:shade val="15000"/>
-            </a:schemeClr>
-          </a:lnRef>
-          <a:fillRef idx="1">
-            <a:schemeClr val="accent1"/>
-          </a:fillRef>
-          <a:effectRef idx="0">
-            <a:schemeClr val="accent1"/>
-          </a:effectRef>
-          <a:fontRef idx="minor">
-            <a:schemeClr val="lt1"/>
-          </a:fontRef>
-        </p:style>
-        <p:txBody>
-          <a:bodyPr rtlCol="0" anchor="ctr"/>
-          <a:lstStyle/>
-          <a:p>
-            <a:pPr algn="ctr"/>
-            <a:r>
-              <a:rPr lang="en-US" dirty="0"/>
-              <a:t>How should scale envelope be joined??</a:t>
-            </a:r>
-          </a:p>
-        </p:txBody>
-      </p:sp>
-      <p:cxnSp>
-        <p:nvCxnSpPr>
           <p:cNvPr id="93" name="Straight Arrow Connector 92">
             <a:extLst>
               <a:ext uri="{FF2B5EF4-FFF2-40B4-BE49-F238E27FC236}">
-                <a16:creationId xmlns:a16="http://schemas.microsoft.com/office/drawing/2014/main" id="{994C8DB8-0F48-876A-B588-45D8C4D02632}"/>
+                <a16:creationId xmlns:a16="http://schemas.microsoft.com/office/drawing/2014/main" id="{7B20C067-AF4B-1864-B26F-22E4E53C4846}"/>
               </a:ext>
             </a:extLst>
           </p:cNvPr>
@@ -7129,77 +7100,12 @@
           </a:fontRef>
         </p:style>
       </p:cxnSp>
-    </p:spTree>
-    <p:extLst>
-      <p:ext uri="{BB962C8B-B14F-4D97-AF65-F5344CB8AC3E}">
-        <p14:creationId xmlns:p14="http://schemas.microsoft.com/office/powerpoint/2010/main" val="3617245666"/>
-      </p:ext>
-    </p:extLst>
-  </p:cSld>
-  <p:clrMapOvr>
-    <a:masterClrMapping/>
-  </p:clrMapOvr>
-</p:sld>
-</file>
-
-<file path=ppt/slides/slide4.xml><?xml version="1.0" encoding="utf-8"?>
-<p:sld xmlns:a="http://schemas.openxmlformats.org/drawingml/2006/main" xmlns:r="http://schemas.openxmlformats.org/officeDocument/2006/relationships" xmlns:p="http://schemas.openxmlformats.org/presentationml/2006/main">
-  <p:cSld>
-    <p:spTree>
-      <p:nvGrpSpPr>
-        <p:cNvPr id="1" name="">
-          <a:extLst>
-            <a:ext uri="{FF2B5EF4-FFF2-40B4-BE49-F238E27FC236}">
-              <a16:creationId xmlns:a16="http://schemas.microsoft.com/office/drawing/2014/main" id="{BB7C6E82-3B56-7367-7ACF-69D6C3486CB2}"/>
-            </a:ext>
-          </a:extLst>
-        </p:cNvPr>
-        <p:cNvGrpSpPr/>
-        <p:nvPr/>
-      </p:nvGrpSpPr>
-      <p:grpSpPr>
-        <a:xfrm>
-          <a:off x="0" y="0"/>
-          <a:ext cx="0" cy="0"/>
-          <a:chOff x="0" y="0"/>
-          <a:chExt cx="0" cy="0"/>
-        </a:xfrm>
-      </p:grpSpPr>
-      <p:sp>
-        <p:nvSpPr>
-          <p:cNvPr id="4" name="Title 3">
-            <a:extLst>
-              <a:ext uri="{FF2B5EF4-FFF2-40B4-BE49-F238E27FC236}">
-                <a16:creationId xmlns:a16="http://schemas.microsoft.com/office/drawing/2014/main" id="{1BAD97C7-DEBE-62C8-60F1-6A62E416FEB8}"/>
-              </a:ext>
-            </a:extLst>
-          </p:cNvPr>
-          <p:cNvSpPr>
-            <a:spLocks noGrp="1"/>
-          </p:cNvSpPr>
-          <p:nvPr>
-            <p:ph type="title"/>
-          </p:nvPr>
-        </p:nvSpPr>
-        <p:spPr/>
-        <p:txBody>
-          <a:bodyPr/>
-          <a:lstStyle/>
-          <a:p>
-            <a:r>
-              <a:rPr lang="en-US" dirty="0" err="1"/>
-              <a:t>catch_summary_table</a:t>
-            </a:r>
-            <a:endParaRPr lang="en-US" dirty="0"/>
-          </a:p>
-        </p:txBody>
-      </p:sp>
-      <p:sp>
-        <p:nvSpPr>
-          <p:cNvPr id="5" name="Oval 1">
-            <a:extLst>
-              <a:ext uri="{FF2B5EF4-FFF2-40B4-BE49-F238E27FC236}">
-                <a16:creationId xmlns:a16="http://schemas.microsoft.com/office/drawing/2014/main" id="{63D1010D-187C-CBCE-D8EF-07F5C49E6297}"/>
+      <p:sp>
+        <p:nvSpPr>
+          <p:cNvPr id="11" name="Explosion: 8 Points 10">
+            <a:extLst>
+              <a:ext uri="{FF2B5EF4-FFF2-40B4-BE49-F238E27FC236}">
+                <a16:creationId xmlns:a16="http://schemas.microsoft.com/office/drawing/2014/main" id="{874FE0CA-DA94-0BB5-C081-880419EACCCE}"/>
               </a:ext>
             </a:extLst>
           </p:cNvPr>
@@ -7208,10 +7114,59 @@
         </p:nvSpPr>
         <p:spPr>
           <a:xfrm>
-            <a:off x="592137" y="1842690"/>
-            <a:ext cx="2239961" cy="1421210"/>
+            <a:off x="7801766" y="3280489"/>
+            <a:ext cx="2266950" cy="1703029"/>
           </a:xfrm>
-          <a:prstGeom prst="rect">
+          <a:prstGeom prst="irregularSeal1">
+            <a:avLst/>
+          </a:prstGeom>
+        </p:spPr>
+        <p:style>
+          <a:lnRef idx="2">
+            <a:schemeClr val="accent1">
+              <a:shade val="15000"/>
+            </a:schemeClr>
+          </a:lnRef>
+          <a:fillRef idx="1">
+            <a:schemeClr val="accent1"/>
+          </a:fillRef>
+          <a:effectRef idx="0">
+            <a:schemeClr val="accent1"/>
+          </a:effectRef>
+          <a:fontRef idx="minor">
+            <a:schemeClr val="lt1"/>
+          </a:fontRef>
+        </p:style>
+        <p:txBody>
+          <a:bodyPr rtlCol="0" anchor="ctr"/>
+          <a:lstStyle/>
+          <a:p>
+            <a:pPr algn="ctr"/>
+            <a:r>
+              <a:rPr lang="en-US" sz="1100" dirty="0"/>
+              <a:t>Need to confirm these joins once we have new data entered</a:t>
+            </a:r>
+          </a:p>
+        </p:txBody>
+      </p:sp>
+      <p:sp>
+        <p:nvSpPr>
+          <p:cNvPr id="12" name="Oval 1">
+            <a:extLst>
+              <a:ext uri="{FF2B5EF4-FFF2-40B4-BE49-F238E27FC236}">
+                <a16:creationId xmlns:a16="http://schemas.microsoft.com/office/drawing/2014/main" id="{9B493B7F-5FB2-67D1-E903-204D47D7C3BD}"/>
+              </a:ext>
+            </a:extLst>
+          </p:cNvPr>
+          <p:cNvSpPr/>
+          <p:nvPr/>
+        </p:nvSpPr>
+        <p:spPr>
+          <a:xfrm>
+            <a:off x="2082401" y="5291455"/>
+            <a:ext cx="1350963" cy="792719"/>
+          </a:xfrm>
+          <a:prstGeom prst="hexagon">
             <a:avLst/>
           </a:prstGeom>
           <a:noFill/>
@@ -7251,26 +7206,7 @@
                 <a:ea typeface="Aptos" panose="020B0004020202020204" pitchFamily="34" charset="0"/>
                 <a:cs typeface="Times New Roman" panose="02020603050405020304" pitchFamily="18" charset="0"/>
               </a:rPr>
-              <a:t>ModuleDataCatchBySpecies</a:t>
-            </a:r>
-            <a:endParaRPr lang="en-US" sz="1200" kern="100" dirty="0">
-              <a:effectLst/>
-              <a:ea typeface="Aptos" panose="020B0004020202020204" pitchFamily="34" charset="0"/>
-              <a:cs typeface="Times New Roman" panose="02020603050405020304" pitchFamily="18" charset="0"/>
-            </a:endParaRPr>
-          </a:p>
-          <a:p>
-            <a:pPr algn="ctr"/>
-            <a:r>
-              <a:rPr lang="en-US" sz="1200" u="sng" kern="100" dirty="0" err="1">
-                <a:solidFill>
-                  <a:srgbClr val="000000"/>
-                </a:solidFill>
-                <a:effectLst/>
-                <a:ea typeface="Aptos" panose="020B0004020202020204" pitchFamily="34" charset="0"/>
-                <a:cs typeface="Times New Roman" panose="02020603050405020304" pitchFamily="18" charset="0"/>
-              </a:rPr>
-              <a:t>ModuleDataId</a:t>
+              <a:t>LegalSizes</a:t>
             </a:r>
             <a:endParaRPr lang="en-US" sz="1200" u="sng" kern="100" dirty="0">
               <a:solidFill>
@@ -7284,7 +7220,7 @@
           <a:p>
             <a:pPr algn="ctr"/>
             <a:r>
-              <a:rPr lang="en-US" sz="1200" u="sng" kern="100" dirty="0" err="1">
+              <a:rPr lang="en-US" sz="1200" u="sng" kern="100" dirty="0">
                 <a:solidFill>
                   <a:srgbClr val="000000"/>
                 </a:solidFill>
@@ -7292,15 +7228,8 @@
                 <a:ea typeface="Aptos" panose="020B0004020202020204" pitchFamily="34" charset="0"/>
                 <a:cs typeface="Times New Roman" panose="02020603050405020304" pitchFamily="18" charset="0"/>
               </a:rPr>
-              <a:t>SpeciesStrainId</a:t>
-            </a:r>
-            <a:endParaRPr lang="en-US" sz="1200" u="sng" kern="100" dirty="0">
-              <a:solidFill>
-                <a:srgbClr val="000000"/>
-              </a:solidFill>
-              <a:ea typeface="Aptos" panose="020B0004020202020204" pitchFamily="34" charset="0"/>
-              <a:cs typeface="Times New Roman" panose="02020603050405020304" pitchFamily="18" charset="0"/>
-            </a:endParaRPr>
+              <a:t>Species</a:t>
+            </a:r>
           </a:p>
           <a:p>
             <a:pPr algn="ctr"/>
@@ -7313,188 +7242,7 @@
                 <a:ea typeface="Aptos" panose="020B0004020202020204" pitchFamily="34" charset="0"/>
                 <a:cs typeface="Times New Roman" panose="02020603050405020304" pitchFamily="18" charset="0"/>
               </a:rPr>
-              <a:t>TotalNumberCaugh</a:t>
-            </a:r>
-            <a:r>
-              <a:rPr lang="en-US" sz="1200" kern="100" dirty="0" err="1">
-                <a:solidFill>
-                  <a:srgbClr val="000000"/>
-                </a:solidFill>
-                <a:ea typeface="Aptos" panose="020B0004020202020204" pitchFamily="34" charset="0"/>
-                <a:cs typeface="Times New Roman" panose="02020603050405020304" pitchFamily="18" charset="0"/>
-              </a:rPr>
-              <a:t>t</a:t>
-            </a:r>
-            <a:endParaRPr lang="en-US" sz="1200" kern="100" dirty="0">
-              <a:solidFill>
-                <a:srgbClr val="000000"/>
-              </a:solidFill>
-              <a:ea typeface="Aptos" panose="020B0004020202020204" pitchFamily="34" charset="0"/>
-              <a:cs typeface="Times New Roman" panose="02020603050405020304" pitchFamily="18" charset="0"/>
-            </a:endParaRPr>
-          </a:p>
-          <a:p>
-            <a:pPr algn="ctr"/>
-            <a:r>
-              <a:rPr lang="en-US" sz="1200" kern="100" dirty="0" err="1">
-                <a:solidFill>
-                  <a:srgbClr val="000000"/>
-                </a:solidFill>
-                <a:effectLst/>
-                <a:ea typeface="Aptos" panose="020B0004020202020204" pitchFamily="34" charset="0"/>
-                <a:cs typeface="Times New Roman" panose="02020603050405020304" pitchFamily="18" charset="0"/>
-              </a:rPr>
-              <a:t>LengthAverage</a:t>
-            </a:r>
-            <a:endParaRPr lang="en-US" sz="1200" kern="100" dirty="0">
-              <a:solidFill>
-                <a:srgbClr val="000000"/>
-              </a:solidFill>
-              <a:ea typeface="Aptos" panose="020B0004020202020204" pitchFamily="34" charset="0"/>
-              <a:cs typeface="Times New Roman" panose="02020603050405020304" pitchFamily="18" charset="0"/>
-            </a:endParaRPr>
-          </a:p>
-          <a:p>
-            <a:pPr algn="ctr"/>
-            <a:r>
-              <a:rPr lang="en-US" sz="1200" kern="100" dirty="0" err="1">
-                <a:solidFill>
-                  <a:srgbClr val="000000"/>
-                </a:solidFill>
-                <a:effectLst/>
-                <a:ea typeface="Aptos" panose="020B0004020202020204" pitchFamily="34" charset="0"/>
-                <a:cs typeface="Times New Roman" panose="02020603050405020304" pitchFamily="18" charset="0"/>
-              </a:rPr>
-              <a:t>LengthMaximum</a:t>
-            </a:r>
-            <a:endParaRPr lang="en-US" sz="1200" kern="100" dirty="0">
-              <a:solidFill>
-                <a:srgbClr val="000000"/>
-              </a:solidFill>
-              <a:ea typeface="Aptos" panose="020B0004020202020204" pitchFamily="34" charset="0"/>
-              <a:cs typeface="Times New Roman" panose="02020603050405020304" pitchFamily="18" charset="0"/>
-            </a:endParaRPr>
-          </a:p>
-          <a:p>
-            <a:pPr algn="ctr"/>
-            <a:r>
-              <a:rPr lang="en-US" sz="1200" kern="100" dirty="0" err="1">
-                <a:solidFill>
-                  <a:srgbClr val="000000"/>
-                </a:solidFill>
-                <a:effectLst/>
-                <a:ea typeface="Aptos" panose="020B0004020202020204" pitchFamily="34" charset="0"/>
-                <a:cs typeface="Times New Roman" panose="02020603050405020304" pitchFamily="18" charset="0"/>
-              </a:rPr>
-              <a:t>LengthMinimum</a:t>
-            </a:r>
-            <a:endParaRPr lang="en-US" sz="1200" kern="100" dirty="0">
-              <a:effectLst/>
-              <a:ea typeface="Aptos" panose="020B0004020202020204" pitchFamily="34" charset="0"/>
-              <a:cs typeface="Times New Roman" panose="02020603050405020304" pitchFamily="18" charset="0"/>
-            </a:endParaRPr>
-          </a:p>
-        </p:txBody>
-      </p:sp>
-      <p:sp>
-        <p:nvSpPr>
-          <p:cNvPr id="7" name="Oval 1">
-            <a:extLst>
-              <a:ext uri="{FF2B5EF4-FFF2-40B4-BE49-F238E27FC236}">
-                <a16:creationId xmlns:a16="http://schemas.microsoft.com/office/drawing/2014/main" id="{3F27521D-007A-864A-7E95-FF49BA411BA1}"/>
-              </a:ext>
-            </a:extLst>
-          </p:cNvPr>
-          <p:cNvSpPr/>
-          <p:nvPr/>
-        </p:nvSpPr>
-        <p:spPr>
-          <a:xfrm>
-            <a:off x="5792786" y="4087136"/>
-            <a:ext cx="1350963" cy="792719"/>
-          </a:xfrm>
-          <a:prstGeom prst="rect">
-            <a:avLst/>
-          </a:prstGeom>
-          <a:noFill/>
-        </p:spPr>
-        <p:style>
-          <a:lnRef idx="2">
-            <a:schemeClr val="accent1">
-              <a:shade val="15000"/>
-            </a:schemeClr>
-          </a:lnRef>
-          <a:fillRef idx="1">
-            <a:schemeClr val="accent1"/>
-          </a:fillRef>
-          <a:effectRef idx="0">
-            <a:schemeClr val="accent1"/>
-          </a:effectRef>
-          <a:fontRef idx="minor">
-            <a:schemeClr val="lt1"/>
-          </a:fontRef>
-        </p:style>
-        <p:txBody>
-          <a:bodyPr rot="0" spcFirstLastPara="0" vert="horz" wrap="square" lIns="91440" tIns="45720" rIns="91440" bIns="45720" numCol="1" spcCol="0" rtlCol="0" fromWordArt="0" anchor="ctr" anchorCtr="0" forceAA="0" compatLnSpc="1">
-            <a:prstTxWarp prst="textNoShape">
-              <a:avLst/>
-            </a:prstTxWarp>
-            <a:noAutofit/>
-          </a:bodyPr>
-          <a:lstStyle/>
-          <a:p>
-            <a:pPr algn="ctr"/>
-            <a:r>
-              <a:rPr lang="en-US" sz="1200" b="1" kern="100" dirty="0" err="1">
-                <a:solidFill>
-                  <a:srgbClr val="000000"/>
-                </a:solidFill>
-                <a:effectLst/>
-                <a:ea typeface="Aptos" panose="020B0004020202020204" pitchFamily="34" charset="0"/>
-                <a:cs typeface="Times New Roman" panose="02020603050405020304" pitchFamily="18" charset="0"/>
-              </a:rPr>
-              <a:t>ModuleData</a:t>
-            </a:r>
-            <a:endParaRPr lang="en-US" sz="1200" b="1" kern="100" dirty="0">
-              <a:solidFill>
-                <a:srgbClr val="000000"/>
-              </a:solidFill>
-              <a:effectLst/>
-              <a:ea typeface="Aptos" panose="020B0004020202020204" pitchFamily="34" charset="0"/>
-              <a:cs typeface="Times New Roman" panose="02020603050405020304" pitchFamily="18" charset="0"/>
-            </a:endParaRPr>
-          </a:p>
-          <a:p>
-            <a:pPr algn="ctr"/>
-            <a:r>
-              <a:rPr lang="en-US" sz="1200" u="sng" kern="100" dirty="0" err="1">
-                <a:solidFill>
-                  <a:srgbClr val="000000"/>
-                </a:solidFill>
-                <a:effectLst/>
-                <a:ea typeface="Aptos" panose="020B0004020202020204" pitchFamily="34" charset="0"/>
-                <a:cs typeface="Times New Roman" panose="02020603050405020304" pitchFamily="18" charset="0"/>
-              </a:rPr>
-              <a:t>ModuleId</a:t>
-            </a:r>
-            <a:endParaRPr lang="en-US" sz="1200" u="sng" kern="100" dirty="0">
-              <a:effectLst/>
-              <a:ea typeface="Aptos" panose="020B0004020202020204" pitchFamily="34" charset="0"/>
-              <a:cs typeface="Times New Roman" panose="02020603050405020304" pitchFamily="18" charset="0"/>
-            </a:endParaRPr>
-          </a:p>
-          <a:p>
-            <a:pPr algn="ctr"/>
-            <a:r>
-              <a:rPr lang="en-US" sz="1200" u="sng" kern="100" dirty="0" err="1">
-                <a:solidFill>
-                  <a:srgbClr val="000000"/>
-                </a:solidFill>
-                <a:effectLst/>
-                <a:ea typeface="Aptos" panose="020B0004020202020204" pitchFamily="34" charset="0"/>
-                <a:cs typeface="Times New Roman" panose="02020603050405020304" pitchFamily="18" charset="0"/>
-              </a:rPr>
-              <a:t>ModuleDataId</a:t>
+              <a:t>LegalSize</a:t>
             </a:r>
             <a:endParaRPr lang="en-US" sz="1200" u="sng" kern="100" dirty="0">
               <a:solidFill>
@@ -7509,24 +7257,23 @@
       </p:sp>
       <p:cxnSp>
         <p:nvCxnSpPr>
-          <p:cNvPr id="8" name="Straight Arrow Connector 7">
-            <a:extLst>
-              <a:ext uri="{FF2B5EF4-FFF2-40B4-BE49-F238E27FC236}">
-                <a16:creationId xmlns:a16="http://schemas.microsoft.com/office/drawing/2014/main" id="{D76D930F-8B45-04E7-7E3E-4D5961526237}"/>
+          <p:cNvPr id="15" name="Straight Arrow Connector 14">
+            <a:extLst>
+              <a:ext uri="{FF2B5EF4-FFF2-40B4-BE49-F238E27FC236}">
+                <a16:creationId xmlns:a16="http://schemas.microsoft.com/office/drawing/2014/main" id="{53AE46C1-1B8D-7C20-EF65-D20C1F3846E8}"/>
               </a:ext>
             </a:extLst>
           </p:cNvPr>
           <p:cNvCxnSpPr>
             <a:cxnSpLocks/>
-            <a:stCxn id="5" idx="2"/>
-            <a:endCxn id="7" idx="0"/>
+            <a:endCxn id="13" idx="2"/>
           </p:cNvCxnSpPr>
           <p:nvPr/>
         </p:nvCxnSpPr>
         <p:spPr>
-          <a:xfrm>
-            <a:off x="1712118" y="3263900"/>
-            <a:ext cx="4756150" cy="823236"/>
+          <a:xfrm flipV="1">
+            <a:off x="2757883" y="4904661"/>
+            <a:ext cx="1" cy="386794"/>
           </a:xfrm>
           <a:prstGeom prst="straightConnector1">
             <a:avLst/>
@@ -7552,10 +7299,10 @@
       </p:cxnSp>
       <p:sp>
         <p:nvSpPr>
-          <p:cNvPr id="13" name="Oval 1">
-            <a:extLst>
-              <a:ext uri="{FF2B5EF4-FFF2-40B4-BE49-F238E27FC236}">
-                <a16:creationId xmlns:a16="http://schemas.microsoft.com/office/drawing/2014/main" id="{5FE2401A-BFFA-29AA-CEDE-7C96C5964533}"/>
+          <p:cNvPr id="19" name="Oval 1">
+            <a:extLst>
+              <a:ext uri="{FF2B5EF4-FFF2-40B4-BE49-F238E27FC236}">
+                <a16:creationId xmlns:a16="http://schemas.microsoft.com/office/drawing/2014/main" id="{A88200D1-2FA7-C9BB-C320-3AD2B05F0804}"/>
               </a:ext>
             </a:extLst>
           </p:cNvPr>
@@ -7564,178 +7311,7 @@
         </p:nvSpPr>
         <p:spPr>
           <a:xfrm>
-            <a:off x="2082402" y="4111942"/>
-            <a:ext cx="1350963" cy="792719"/>
-          </a:xfrm>
-          <a:prstGeom prst="rect">
-            <a:avLst/>
-          </a:prstGeom>
-          <a:noFill/>
-        </p:spPr>
-        <p:style>
-          <a:lnRef idx="2">
-            <a:schemeClr val="accent1">
-              <a:shade val="15000"/>
-            </a:schemeClr>
-          </a:lnRef>
-          <a:fillRef idx="1">
-            <a:schemeClr val="accent1"/>
-          </a:fillRef>
-          <a:effectRef idx="0">
-            <a:schemeClr val="accent1"/>
-          </a:effectRef>
-          <a:fontRef idx="minor">
-            <a:schemeClr val="lt1"/>
-          </a:fontRef>
-        </p:style>
-        <p:txBody>
-          <a:bodyPr rot="0" spcFirstLastPara="0" vert="horz" wrap="square" lIns="91440" tIns="45720" rIns="91440" bIns="45720" numCol="1" spcCol="0" rtlCol="0" fromWordArt="0" anchor="ctr" anchorCtr="0" forceAA="0" compatLnSpc="1">
-            <a:prstTxWarp prst="textNoShape">
-              <a:avLst/>
-            </a:prstTxWarp>
-            <a:noAutofit/>
-          </a:bodyPr>
-          <a:lstStyle/>
-          <a:p>
-            <a:pPr algn="ctr"/>
-            <a:r>
-              <a:rPr lang="en-US" sz="1200" b="1" kern="100" dirty="0" err="1">
-                <a:solidFill>
-                  <a:srgbClr val="000000"/>
-                </a:solidFill>
-                <a:effectLst/>
-                <a:ea typeface="Aptos" panose="020B0004020202020204" pitchFamily="34" charset="0"/>
-                <a:cs typeface="Times New Roman" panose="02020603050405020304" pitchFamily="18" charset="0"/>
-              </a:rPr>
-              <a:t>SpeciesStrain</a:t>
-            </a:r>
-            <a:endParaRPr lang="en-US" sz="1200" b="1" kern="100" dirty="0">
-              <a:solidFill>
-                <a:srgbClr val="000000"/>
-              </a:solidFill>
-              <a:effectLst/>
-              <a:ea typeface="Aptos" panose="020B0004020202020204" pitchFamily="34" charset="0"/>
-              <a:cs typeface="Times New Roman" panose="02020603050405020304" pitchFamily="18" charset="0"/>
-            </a:endParaRPr>
-          </a:p>
-          <a:p>
-            <a:pPr algn="ctr"/>
-            <a:r>
-              <a:rPr lang="en-US" sz="1200" u="sng" kern="100" dirty="0" err="1">
-                <a:solidFill>
-                  <a:srgbClr val="000000"/>
-                </a:solidFill>
-                <a:effectLst/>
-                <a:ea typeface="Aptos" panose="020B0004020202020204" pitchFamily="34" charset="0"/>
-                <a:cs typeface="Times New Roman" panose="02020603050405020304" pitchFamily="18" charset="0"/>
-              </a:rPr>
-              <a:t>SpeciesStrainId</a:t>
-            </a:r>
-            <a:endParaRPr lang="en-US" sz="1200" u="sng" kern="100" dirty="0">
-              <a:solidFill>
-                <a:srgbClr val="000000"/>
-              </a:solidFill>
-              <a:effectLst/>
-              <a:ea typeface="Aptos" panose="020B0004020202020204" pitchFamily="34" charset="0"/>
-              <a:cs typeface="Times New Roman" panose="02020603050405020304" pitchFamily="18" charset="0"/>
-            </a:endParaRPr>
-          </a:p>
-          <a:p>
-            <a:pPr algn="ctr"/>
-            <a:r>
-              <a:rPr lang="en-US" sz="1200" kern="100" dirty="0">
-                <a:solidFill>
-                  <a:srgbClr val="000000"/>
-                </a:solidFill>
-                <a:effectLst/>
-                <a:ea typeface="Aptos" panose="020B0004020202020204" pitchFamily="34" charset="0"/>
-                <a:cs typeface="Times New Roman" panose="02020603050405020304" pitchFamily="18" charset="0"/>
-              </a:rPr>
-              <a:t>Species</a:t>
-            </a:r>
-          </a:p>
-          <a:p>
-            <a:pPr algn="ctr"/>
-            <a:r>
-              <a:rPr lang="en-US" sz="1200" kern="100" dirty="0">
-                <a:solidFill>
-                  <a:srgbClr val="000000"/>
-                </a:solidFill>
-                <a:effectLst/>
-                <a:ea typeface="Aptos" panose="020B0004020202020204" pitchFamily="34" charset="0"/>
-                <a:cs typeface="Times New Roman" panose="02020603050405020304" pitchFamily="18" charset="0"/>
-              </a:rPr>
-              <a:t>Strain</a:t>
-            </a:r>
-            <a:endParaRPr lang="en-US" sz="1200" u="sng" kern="100" dirty="0">
-              <a:solidFill>
-                <a:srgbClr val="000000"/>
-              </a:solidFill>
-              <a:effectLst/>
-              <a:ea typeface="Aptos" panose="020B0004020202020204" pitchFamily="34" charset="0"/>
-              <a:cs typeface="Times New Roman" panose="02020603050405020304" pitchFamily="18" charset="0"/>
-            </a:endParaRPr>
-          </a:p>
-        </p:txBody>
-      </p:sp>
-      <p:cxnSp>
-        <p:nvCxnSpPr>
-          <p:cNvPr id="14" name="Straight Arrow Connector 13">
-            <a:extLst>
-              <a:ext uri="{FF2B5EF4-FFF2-40B4-BE49-F238E27FC236}">
-                <a16:creationId xmlns:a16="http://schemas.microsoft.com/office/drawing/2014/main" id="{DD218F72-E8C3-F972-2248-BA6FD2FDE5EA}"/>
-              </a:ext>
-            </a:extLst>
-          </p:cNvPr>
-          <p:cNvCxnSpPr>
-            <a:cxnSpLocks/>
-            <a:stCxn id="5" idx="2"/>
-            <a:endCxn id="13" idx="0"/>
-          </p:cNvCxnSpPr>
-          <p:nvPr/>
-        </p:nvCxnSpPr>
-        <p:spPr>
-          <a:xfrm>
-            <a:off x="1712118" y="3263900"/>
-            <a:ext cx="1045766" cy="848042"/>
-          </a:xfrm>
-          <a:prstGeom prst="straightConnector1">
-            <a:avLst/>
-          </a:prstGeom>
-          <a:ln>
-            <a:tailEnd type="triangle"/>
-          </a:ln>
-        </p:spPr>
-        <p:style>
-          <a:lnRef idx="2">
-            <a:schemeClr val="dk1"/>
-          </a:lnRef>
-          <a:fillRef idx="0">
-            <a:schemeClr val="dk1"/>
-          </a:fillRef>
-          <a:effectRef idx="1">
-            <a:schemeClr val="dk1"/>
-          </a:effectRef>
-          <a:fontRef idx="minor">
-            <a:schemeClr val="tx1"/>
-          </a:fontRef>
-        </p:style>
-      </p:cxnSp>
-      <p:sp>
-        <p:nvSpPr>
-          <p:cNvPr id="25" name="Oval 1">
-            <a:extLst>
-              <a:ext uri="{FF2B5EF4-FFF2-40B4-BE49-F238E27FC236}">
-                <a16:creationId xmlns:a16="http://schemas.microsoft.com/office/drawing/2014/main" id="{3E2605F5-6924-AB68-E547-F0544AEF2C11}"/>
-              </a:ext>
-            </a:extLst>
-          </p:cNvPr>
-          <p:cNvSpPr/>
-          <p:nvPr/>
-        </p:nvSpPr>
-        <p:spPr>
-          <a:xfrm>
-            <a:off x="7043735" y="5290143"/>
+            <a:off x="5710235" y="5331538"/>
             <a:ext cx="1516063" cy="1179512"/>
           </a:xfrm>
           <a:prstGeom prst="ellipse">
@@ -7790,69 +7366,28 @@
               <a:cs typeface="Times New Roman" panose="02020603050405020304" pitchFamily="18" charset="0"/>
             </a:endParaRPr>
           </a:p>
-          <a:p>
-            <a:pPr algn="ctr"/>
-            <a:r>
-              <a:rPr lang="en-US" sz="1200" u="sng" kern="100" dirty="0" err="1">
-                <a:solidFill>
-                  <a:srgbClr val="000000"/>
-                </a:solidFill>
-                <a:effectLst/>
-                <a:ea typeface="Aptos" panose="020B0004020202020204" pitchFamily="34" charset="0"/>
-                <a:cs typeface="Times New Roman" panose="02020603050405020304" pitchFamily="18" charset="0"/>
-              </a:rPr>
-              <a:t>ModuleId</a:t>
-            </a:r>
-            <a:endParaRPr lang="en-US" sz="1200" u="sng" kern="100" dirty="0">
-              <a:solidFill>
-                <a:srgbClr val="000000"/>
-              </a:solidFill>
-              <a:effectLst/>
-              <a:ea typeface="Aptos" panose="020B0004020202020204" pitchFamily="34" charset="0"/>
-              <a:cs typeface="Times New Roman" panose="02020603050405020304" pitchFamily="18" charset="0"/>
-            </a:endParaRPr>
-          </a:p>
-          <a:p>
-            <a:pPr algn="ctr"/>
-            <a:r>
-              <a:rPr lang="en-US" sz="1200" u="sng" kern="100" dirty="0" err="1">
-                <a:solidFill>
-                  <a:srgbClr val="000000"/>
-                </a:solidFill>
-                <a:effectLst/>
-                <a:ea typeface="Aptos" panose="020B0004020202020204" pitchFamily="34" charset="0"/>
-                <a:cs typeface="Times New Roman" panose="02020603050405020304" pitchFamily="18" charset="0"/>
-              </a:rPr>
-              <a:t>SurveyId</a:t>
-            </a:r>
-            <a:endParaRPr lang="en-US" sz="1200" u="sng" kern="100" dirty="0">
-              <a:effectLst/>
-              <a:ea typeface="Aptos" panose="020B0004020202020204" pitchFamily="34" charset="0"/>
-              <a:cs typeface="Times New Roman" panose="02020603050405020304" pitchFamily="18" charset="0"/>
-            </a:endParaRPr>
-          </a:p>
         </p:txBody>
       </p:sp>
       <p:cxnSp>
         <p:nvCxnSpPr>
-          <p:cNvPr id="26" name="Straight Arrow Connector 25">
-            <a:extLst>
-              <a:ext uri="{FF2B5EF4-FFF2-40B4-BE49-F238E27FC236}">
-                <a16:creationId xmlns:a16="http://schemas.microsoft.com/office/drawing/2014/main" id="{9584F975-E590-4D1D-53B1-AABC90A93150}"/>
+          <p:cNvPr id="20" name="Straight Arrow Connector 19">
+            <a:extLst>
+              <a:ext uri="{FF2B5EF4-FFF2-40B4-BE49-F238E27FC236}">
+                <a16:creationId xmlns:a16="http://schemas.microsoft.com/office/drawing/2014/main" id="{AC5B9D03-0DB8-6CB3-CA9F-3201452C90FD}"/>
               </a:ext>
             </a:extLst>
           </p:cNvPr>
           <p:cNvCxnSpPr>
             <a:cxnSpLocks/>
-            <a:stCxn id="25" idx="0"/>
+            <a:stCxn id="19" idx="0"/>
             <a:endCxn id="7" idx="2"/>
           </p:cNvCxnSpPr>
           <p:nvPr/>
         </p:nvCxnSpPr>
         <p:spPr>
-          <a:xfrm flipH="1" flipV="1">
-            <a:off x="6468268" y="4879855"/>
-            <a:ext cx="1333499" cy="410288"/>
+          <a:xfrm flipV="1">
+            <a:off x="6468267" y="4879855"/>
+            <a:ext cx="1" cy="451683"/>
           </a:xfrm>
           <a:prstGeom prst="straightConnector1">
             <a:avLst/>
@@ -7878,10 +7413,10 @@
       </p:cxnSp>
       <p:sp>
         <p:nvSpPr>
-          <p:cNvPr id="38" name="Oval 1">
-            <a:extLst>
-              <a:ext uri="{FF2B5EF4-FFF2-40B4-BE49-F238E27FC236}">
-                <a16:creationId xmlns:a16="http://schemas.microsoft.com/office/drawing/2014/main" id="{F0E000B8-5F45-04EE-B264-811ED14C2A21}"/>
+          <p:cNvPr id="24" name="Explosion: 8 Points 23">
+            <a:extLst>
+              <a:ext uri="{FF2B5EF4-FFF2-40B4-BE49-F238E27FC236}">
+                <a16:creationId xmlns:a16="http://schemas.microsoft.com/office/drawing/2014/main" id="{4745DB2B-329F-010A-51F8-365B963F646F}"/>
               </a:ext>
             </a:extLst>
           </p:cNvPr>
@@ -7890,13 +7425,12 @@
         </p:nvSpPr>
         <p:spPr>
           <a:xfrm>
-            <a:off x="3322637" y="1907579"/>
-            <a:ext cx="2951163" cy="1179513"/>
+            <a:off x="8935241" y="4983518"/>
+            <a:ext cx="2266950" cy="1703029"/>
           </a:xfrm>
-          <a:prstGeom prst="rect">
+          <a:prstGeom prst="irregularSeal1">
             <a:avLst/>
           </a:prstGeom>
-          <a:noFill/>
         </p:spPr>
         <p:style>
           <a:lnRef idx="2">
@@ -7915,159 +7449,101 @@
           </a:fontRef>
         </p:style>
         <p:txBody>
-          <a:bodyPr rot="0" spcFirstLastPara="0" vert="horz" wrap="square" lIns="91440" tIns="45720" rIns="91440" bIns="45720" numCol="1" spcCol="0" rtlCol="0" fromWordArt="0" anchor="ctr" anchorCtr="0" forceAA="0" compatLnSpc="1">
-            <a:prstTxWarp prst="textNoShape">
-              <a:avLst/>
-            </a:prstTxWarp>
-            <a:noAutofit/>
-          </a:bodyPr>
+          <a:bodyPr rtlCol="0" anchor="ctr"/>
           <a:lstStyle/>
           <a:p>
             <a:pPr algn="ctr"/>
             <a:r>
-              <a:rPr lang="en-US" sz="1200" b="1" kern="100" dirty="0" err="1">
-                <a:solidFill>
-                  <a:srgbClr val="000000"/>
-                </a:solidFill>
-                <a:effectLst/>
-                <a:ea typeface="Aptos" panose="020B0004020202020204" pitchFamily="34" charset="0"/>
-                <a:cs typeface="Times New Roman" panose="02020603050405020304" pitchFamily="18" charset="0"/>
-              </a:rPr>
-              <a:t>ModuleDataCatchSampleByInchGroup</a:t>
-            </a:r>
-            <a:endParaRPr lang="en-US" sz="1200" kern="100" dirty="0">
-              <a:effectLst/>
-              <a:ea typeface="Aptos" panose="020B0004020202020204" pitchFamily="34" charset="0"/>
-              <a:cs typeface="Times New Roman" panose="02020603050405020304" pitchFamily="18" charset="0"/>
-            </a:endParaRPr>
-          </a:p>
-          <a:p>
-            <a:pPr algn="ctr"/>
-            <a:r>
-              <a:rPr lang="en-US" sz="1200" u="sng" kern="100" dirty="0" err="1">
-                <a:solidFill>
-                  <a:srgbClr val="000000"/>
-                </a:solidFill>
-                <a:effectLst/>
-                <a:ea typeface="Aptos" panose="020B0004020202020204" pitchFamily="34" charset="0"/>
-                <a:cs typeface="Times New Roman" panose="02020603050405020304" pitchFamily="18" charset="0"/>
-              </a:rPr>
-              <a:t>ModuleDataId</a:t>
-            </a:r>
-            <a:endParaRPr lang="en-US" sz="1200" u="sng" kern="100" dirty="0">
-              <a:solidFill>
-                <a:srgbClr val="000000"/>
-              </a:solidFill>
-              <a:effectLst/>
-              <a:ea typeface="Aptos" panose="020B0004020202020204" pitchFamily="34" charset="0"/>
-              <a:cs typeface="Times New Roman" panose="02020603050405020304" pitchFamily="18" charset="0"/>
-            </a:endParaRPr>
-          </a:p>
-          <a:p>
-            <a:pPr algn="ctr"/>
-            <a:r>
-              <a:rPr lang="en-US" sz="1200" u="sng" kern="100" dirty="0" err="1">
-                <a:solidFill>
-                  <a:srgbClr val="000000"/>
-                </a:solidFill>
-                <a:effectLst/>
-                <a:ea typeface="Aptos" panose="020B0004020202020204" pitchFamily="34" charset="0"/>
-                <a:cs typeface="Times New Roman" panose="02020603050405020304" pitchFamily="18" charset="0"/>
-              </a:rPr>
-              <a:t>SpeciesStrainId</a:t>
-            </a:r>
-            <a:endParaRPr lang="en-US" sz="1200" u="sng" kern="100" dirty="0">
-              <a:solidFill>
-                <a:srgbClr val="000000"/>
-              </a:solidFill>
-              <a:effectLst/>
-              <a:ea typeface="Aptos" panose="020B0004020202020204" pitchFamily="34" charset="0"/>
-              <a:cs typeface="Times New Roman" panose="02020603050405020304" pitchFamily="18" charset="0"/>
-            </a:endParaRPr>
-          </a:p>
-          <a:p>
-            <a:pPr algn="ctr"/>
-            <a:r>
-              <a:rPr lang="en-US" sz="1200" kern="100" dirty="0" err="1">
-                <a:solidFill>
-                  <a:srgbClr val="000000"/>
-                </a:solidFill>
-                <a:effectLst/>
-                <a:ea typeface="Aptos" panose="020B0004020202020204" pitchFamily="34" charset="0"/>
-                <a:cs typeface="Times New Roman" panose="02020603050405020304" pitchFamily="18" charset="0"/>
-              </a:rPr>
-              <a:t>InchGroup</a:t>
-            </a:r>
-            <a:endParaRPr lang="en-US" sz="1200" kern="100" dirty="0">
-              <a:solidFill>
-                <a:srgbClr val="000000"/>
-              </a:solidFill>
-              <a:ea typeface="Aptos" panose="020B0004020202020204" pitchFamily="34" charset="0"/>
-              <a:cs typeface="Times New Roman" panose="02020603050405020304" pitchFamily="18" charset="0"/>
-            </a:endParaRPr>
-          </a:p>
-          <a:p>
-            <a:pPr algn="ctr"/>
-            <a:r>
-              <a:rPr lang="en-US" sz="1200" kern="100" dirty="0" err="1">
-                <a:solidFill>
-                  <a:srgbClr val="000000"/>
-                </a:solidFill>
-                <a:effectLst/>
-                <a:ea typeface="Aptos" panose="020B0004020202020204" pitchFamily="34" charset="0"/>
-                <a:cs typeface="Times New Roman" panose="02020603050405020304" pitchFamily="18" charset="0"/>
-              </a:rPr>
-              <a:t>NumberCaughtUnmarked</a:t>
-            </a:r>
-            <a:endParaRPr lang="en-US" sz="1200" kern="100" dirty="0">
-              <a:solidFill>
-                <a:srgbClr val="000000"/>
-              </a:solidFill>
-              <a:ea typeface="Aptos" panose="020B0004020202020204" pitchFamily="34" charset="0"/>
-              <a:cs typeface="Times New Roman" panose="02020603050405020304" pitchFamily="18" charset="0"/>
-            </a:endParaRPr>
-          </a:p>
-          <a:p>
-            <a:pPr algn="ctr"/>
-            <a:r>
-              <a:rPr lang="en-US" sz="1200" kern="100" dirty="0" err="1">
-                <a:solidFill>
-                  <a:srgbClr val="000000"/>
-                </a:solidFill>
-                <a:effectLst/>
-                <a:ea typeface="Aptos" panose="020B0004020202020204" pitchFamily="34" charset="0"/>
-                <a:cs typeface="Times New Roman" panose="02020603050405020304" pitchFamily="18" charset="0"/>
-              </a:rPr>
-              <a:t>NumberCaughtMarked</a:t>
-            </a:r>
-            <a:endParaRPr lang="en-US" sz="1200" kern="100" dirty="0">
-              <a:effectLst/>
-              <a:ea typeface="Aptos" panose="020B0004020202020204" pitchFamily="34" charset="0"/>
-              <a:cs typeface="Times New Roman" panose="02020603050405020304" pitchFamily="18" charset="0"/>
-            </a:endParaRPr>
+              <a:rPr lang="en-US" sz="1100" dirty="0"/>
+              <a:t>Add info on summaries?</a:t>
+            </a:r>
+          </a:p>
+        </p:txBody>
+      </p:sp>
+    </p:spTree>
+    <p:extLst>
+      <p:ext uri="{BB962C8B-B14F-4D97-AF65-F5344CB8AC3E}">
+        <p14:creationId xmlns:p14="http://schemas.microsoft.com/office/powerpoint/2010/main" val="3322492765"/>
+      </p:ext>
+    </p:extLst>
+  </p:cSld>
+  <p:clrMapOvr>
+    <a:masterClrMapping/>
+  </p:clrMapOvr>
+</p:sld>
+</file>
+
+<file path=ppt/slides/slide4.xml><?xml version="1.0" encoding="utf-8"?>
+<p:sld xmlns:a="http://schemas.openxmlformats.org/drawingml/2006/main" xmlns:r="http://schemas.openxmlformats.org/officeDocument/2006/relationships" xmlns:p="http://schemas.openxmlformats.org/presentationml/2006/main">
+  <p:cSld>
+    <p:spTree>
+      <p:nvGrpSpPr>
+        <p:cNvPr id="1" name="">
+          <a:extLst>
+            <a:ext uri="{FF2B5EF4-FFF2-40B4-BE49-F238E27FC236}">
+              <a16:creationId xmlns:a16="http://schemas.microsoft.com/office/drawing/2014/main" id="{6A5C681D-C28B-2DA5-BE7C-DB42CBE3D718}"/>
+            </a:ext>
+          </a:extLst>
+        </p:cNvPr>
+        <p:cNvGrpSpPr/>
+        <p:nvPr/>
+      </p:nvGrpSpPr>
+      <p:grpSpPr>
+        <a:xfrm>
+          <a:off x="0" y="0"/>
+          <a:ext cx="0" cy="0"/>
+          <a:chOff x="0" y="0"/>
+          <a:chExt cx="0" cy="0"/>
+        </a:xfrm>
+      </p:grpSpPr>
+      <p:sp>
+        <p:nvSpPr>
+          <p:cNvPr id="4" name="Title 3">
+            <a:extLst>
+              <a:ext uri="{FF2B5EF4-FFF2-40B4-BE49-F238E27FC236}">
+                <a16:creationId xmlns:a16="http://schemas.microsoft.com/office/drawing/2014/main" id="{0466993E-22CC-8960-30E3-1161330698C7}"/>
+              </a:ext>
+            </a:extLst>
+          </p:cNvPr>
+          <p:cNvSpPr>
+            <a:spLocks noGrp="1"/>
+          </p:cNvSpPr>
+          <p:nvPr>
+            <p:ph type="title"/>
+          </p:nvPr>
+        </p:nvSpPr>
+        <p:spPr/>
+        <p:txBody>
+          <a:bodyPr/>
+          <a:lstStyle/>
+          <a:p>
+            <a:r>
+              <a:rPr lang="en-US" dirty="0" err="1"/>
+              <a:t>catch_summary_table</a:t>
+            </a:r>
+            <a:endParaRPr lang="en-US" dirty="0"/>
           </a:p>
         </p:txBody>
       </p:sp>
       <p:cxnSp>
         <p:nvCxnSpPr>
-          <p:cNvPr id="41" name="Straight Arrow Connector 40">
-            <a:extLst>
-              <a:ext uri="{FF2B5EF4-FFF2-40B4-BE49-F238E27FC236}">
-                <a16:creationId xmlns:a16="http://schemas.microsoft.com/office/drawing/2014/main" id="{A3380EF5-361B-BA11-7E5B-5EC9E6DA518F}"/>
+          <p:cNvPr id="14" name="Straight Arrow Connector 13">
+            <a:extLst>
+              <a:ext uri="{FF2B5EF4-FFF2-40B4-BE49-F238E27FC236}">
+                <a16:creationId xmlns:a16="http://schemas.microsoft.com/office/drawing/2014/main" id="{9373E434-CB22-6DAD-802E-93462B042E39}"/>
               </a:ext>
             </a:extLst>
           </p:cNvPr>
           <p:cNvCxnSpPr>
             <a:cxnSpLocks/>
-            <a:stCxn id="38" idx="2"/>
-            <a:endCxn id="7" idx="0"/>
+            <a:stCxn id="2" idx="4"/>
           </p:cNvCxnSpPr>
           <p:nvPr/>
         </p:nvCxnSpPr>
         <p:spPr>
           <a:xfrm>
-            <a:off x="4798219" y="3087092"/>
-            <a:ext cx="1670049" cy="1000044"/>
+            <a:off x="2235001" y="3004264"/>
+            <a:ext cx="0" cy="849473"/>
           </a:xfrm>
           <a:prstGeom prst="straightConnector1">
             <a:avLst/>
@@ -8091,55 +7567,12 @@
           </a:fontRef>
         </p:style>
       </p:cxnSp>
-      <p:cxnSp>
-        <p:nvCxnSpPr>
-          <p:cNvPr id="44" name="Straight Arrow Connector 43">
-            <a:extLst>
-              <a:ext uri="{FF2B5EF4-FFF2-40B4-BE49-F238E27FC236}">
-                <a16:creationId xmlns:a16="http://schemas.microsoft.com/office/drawing/2014/main" id="{E696C7E1-B2EC-C3E2-55C6-DBF02B4CAABA}"/>
-              </a:ext>
-            </a:extLst>
-          </p:cNvPr>
-          <p:cNvCxnSpPr>
-            <a:cxnSpLocks/>
-            <a:stCxn id="38" idx="2"/>
-            <a:endCxn id="13" idx="0"/>
-          </p:cNvCxnSpPr>
-          <p:nvPr/>
-        </p:nvCxnSpPr>
-        <p:spPr>
-          <a:xfrm flipH="1">
-            <a:off x="2757884" y="3087092"/>
-            <a:ext cx="2040335" cy="1024850"/>
-          </a:xfrm>
-          <a:prstGeom prst="straightConnector1">
-            <a:avLst/>
-          </a:prstGeom>
-          <a:ln>
-            <a:tailEnd type="triangle"/>
-          </a:ln>
-        </p:spPr>
-        <p:style>
-          <a:lnRef idx="2">
-            <a:schemeClr val="dk1"/>
-          </a:lnRef>
-          <a:fillRef idx="0">
-            <a:schemeClr val="dk1"/>
-          </a:fillRef>
-          <a:effectRef idx="1">
-            <a:schemeClr val="dk1"/>
-          </a:effectRef>
-          <a:fontRef idx="minor">
-            <a:schemeClr val="tx1"/>
-          </a:fontRef>
-        </p:style>
-      </p:cxnSp>
-      <p:sp>
-        <p:nvSpPr>
-          <p:cNvPr id="74" name="Oval 1">
-            <a:extLst>
-              <a:ext uri="{FF2B5EF4-FFF2-40B4-BE49-F238E27FC236}">
-                <a16:creationId xmlns:a16="http://schemas.microsoft.com/office/drawing/2014/main" id="{8794BFCB-0CD3-D62F-28BE-79835CCFE93C}"/>
+      <p:sp>
+        <p:nvSpPr>
+          <p:cNvPr id="11" name="Explosion: 8 Points 10">
+            <a:extLst>
+              <a:ext uri="{FF2B5EF4-FFF2-40B4-BE49-F238E27FC236}">
+                <a16:creationId xmlns:a16="http://schemas.microsoft.com/office/drawing/2014/main" id="{B3D0F06D-DB70-E021-E141-F59AF8C8AB58}"/>
               </a:ext>
             </a:extLst>
           </p:cNvPr>
@@ -8148,272 +7581,8 @@
         </p:nvSpPr>
         <p:spPr>
           <a:xfrm>
-            <a:off x="6611937" y="1907579"/>
-            <a:ext cx="2951163" cy="1179513"/>
-          </a:xfrm>
-          <a:prstGeom prst="rect">
-            <a:avLst/>
-          </a:prstGeom>
-          <a:noFill/>
-        </p:spPr>
-        <p:style>
-          <a:lnRef idx="2">
-            <a:schemeClr val="accent1">
-              <a:shade val="15000"/>
-            </a:schemeClr>
-          </a:lnRef>
-          <a:fillRef idx="1">
-            <a:schemeClr val="accent1"/>
-          </a:fillRef>
-          <a:effectRef idx="0">
-            <a:schemeClr val="accent1"/>
-          </a:effectRef>
-          <a:fontRef idx="minor">
-            <a:schemeClr val="lt1"/>
-          </a:fontRef>
-        </p:style>
-        <p:txBody>
-          <a:bodyPr rot="0" spcFirstLastPara="0" vert="horz" wrap="square" lIns="91440" tIns="45720" rIns="91440" bIns="45720" numCol="1" spcCol="0" rtlCol="0" fromWordArt="0" anchor="ctr" anchorCtr="0" forceAA="0" compatLnSpc="1">
-            <a:prstTxWarp prst="textNoShape">
-              <a:avLst/>
-            </a:prstTxWarp>
-            <a:noAutofit/>
-          </a:bodyPr>
-          <a:lstStyle/>
-          <a:p>
-            <a:pPr algn="ctr"/>
-            <a:r>
-              <a:rPr lang="en-US" sz="1200" b="1" kern="100" dirty="0" err="1">
-                <a:solidFill>
-                  <a:srgbClr val="000000"/>
-                </a:solidFill>
-                <a:effectLst/>
-                <a:ea typeface="Aptos" panose="020B0004020202020204" pitchFamily="34" charset="0"/>
-                <a:cs typeface="Times New Roman" panose="02020603050405020304" pitchFamily="18" charset="0"/>
-              </a:rPr>
-              <a:t>ModuleDataScaleEnvelope</a:t>
-            </a:r>
-            <a:endParaRPr lang="en-US" sz="1200" b="1" kern="100" dirty="0">
-              <a:solidFill>
-                <a:srgbClr val="000000"/>
-              </a:solidFill>
-              <a:effectLst/>
-              <a:ea typeface="Aptos" panose="020B0004020202020204" pitchFamily="34" charset="0"/>
-              <a:cs typeface="Times New Roman" panose="02020603050405020304" pitchFamily="18" charset="0"/>
-            </a:endParaRPr>
-          </a:p>
-          <a:p>
-            <a:pPr algn="ctr"/>
-            <a:r>
-              <a:rPr lang="en-US" sz="1200" u="sng" kern="100" dirty="0" err="1">
-                <a:solidFill>
-                  <a:srgbClr val="000000"/>
-                </a:solidFill>
-                <a:effectLst/>
-                <a:ea typeface="Aptos" panose="020B0004020202020204" pitchFamily="34" charset="0"/>
-                <a:cs typeface="Times New Roman" panose="02020603050405020304" pitchFamily="18" charset="0"/>
-              </a:rPr>
-              <a:t>SurveyId</a:t>
-            </a:r>
-            <a:endParaRPr lang="en-US" sz="1200" u="sng" kern="100" dirty="0">
-              <a:solidFill>
-                <a:srgbClr val="000000"/>
-              </a:solidFill>
-              <a:effectLst/>
-              <a:ea typeface="Aptos" panose="020B0004020202020204" pitchFamily="34" charset="0"/>
-              <a:cs typeface="Times New Roman" panose="02020603050405020304" pitchFamily="18" charset="0"/>
-            </a:endParaRPr>
-          </a:p>
-          <a:p>
-            <a:pPr algn="ctr"/>
-            <a:r>
-              <a:rPr lang="en-US" sz="1200" kern="100" dirty="0" err="1">
-                <a:solidFill>
-                  <a:srgbClr val="000000"/>
-                </a:solidFill>
-                <a:effectLst/>
-                <a:ea typeface="Aptos" panose="020B0004020202020204" pitchFamily="34" charset="0"/>
-                <a:cs typeface="Times New Roman" panose="02020603050405020304" pitchFamily="18" charset="0"/>
-              </a:rPr>
-              <a:t>ModuleDataId</a:t>
-            </a:r>
-            <a:endParaRPr lang="en-US" sz="1200" kern="100" dirty="0">
-              <a:solidFill>
-                <a:srgbClr val="000000"/>
-              </a:solidFill>
-              <a:effectLst/>
-              <a:ea typeface="Aptos" panose="020B0004020202020204" pitchFamily="34" charset="0"/>
-              <a:cs typeface="Times New Roman" panose="02020603050405020304" pitchFamily="18" charset="0"/>
-            </a:endParaRPr>
-          </a:p>
-          <a:p>
-            <a:pPr algn="ctr"/>
-            <a:r>
-              <a:rPr lang="en-US" sz="1200" kern="100" dirty="0" err="1">
-                <a:solidFill>
-                  <a:srgbClr val="000000"/>
-                </a:solidFill>
-                <a:effectLst/>
-                <a:ea typeface="Aptos" panose="020B0004020202020204" pitchFamily="34" charset="0"/>
-                <a:cs typeface="Times New Roman" panose="02020603050405020304" pitchFamily="18" charset="0"/>
-              </a:rPr>
-              <a:t>EnvelopeSerialNumber</a:t>
-            </a:r>
-            <a:endParaRPr lang="en-US" sz="1200" kern="100" dirty="0">
-              <a:solidFill>
-                <a:srgbClr val="000000"/>
-              </a:solidFill>
-              <a:effectLst/>
-              <a:ea typeface="Aptos" panose="020B0004020202020204" pitchFamily="34" charset="0"/>
-              <a:cs typeface="Times New Roman" panose="02020603050405020304" pitchFamily="18" charset="0"/>
-            </a:endParaRPr>
-          </a:p>
-          <a:p>
-            <a:pPr algn="ctr"/>
-            <a:r>
-              <a:rPr lang="en-US" sz="1200" u="sng" kern="100" dirty="0" err="1">
-                <a:solidFill>
-                  <a:srgbClr val="000000"/>
-                </a:solidFill>
-                <a:effectLst/>
-                <a:ea typeface="Aptos" panose="020B0004020202020204" pitchFamily="34" charset="0"/>
-                <a:cs typeface="Times New Roman" panose="02020603050405020304" pitchFamily="18" charset="0"/>
-              </a:rPr>
-              <a:t>SpeciesStrainId</a:t>
-            </a:r>
-            <a:endParaRPr lang="en-US" sz="1200" u="sng" kern="100" dirty="0">
-              <a:solidFill>
-                <a:srgbClr val="000000"/>
-              </a:solidFill>
-              <a:effectLst/>
-              <a:ea typeface="Aptos" panose="020B0004020202020204" pitchFamily="34" charset="0"/>
-              <a:cs typeface="Times New Roman" panose="02020603050405020304" pitchFamily="18" charset="0"/>
-            </a:endParaRPr>
-          </a:p>
-          <a:p>
-            <a:pPr algn="ctr"/>
-            <a:r>
-              <a:rPr lang="en-US" sz="1200" kern="100" dirty="0" err="1">
-                <a:solidFill>
-                  <a:srgbClr val="000000"/>
-                </a:solidFill>
-                <a:effectLst/>
-                <a:ea typeface="Aptos" panose="020B0004020202020204" pitchFamily="34" charset="0"/>
-                <a:cs typeface="Times New Roman" panose="02020603050405020304" pitchFamily="18" charset="0"/>
-              </a:rPr>
-              <a:t>TotalLengthEntered</a:t>
-            </a:r>
-            <a:endParaRPr lang="en-US" sz="1200" kern="100" dirty="0">
-              <a:effectLst/>
-              <a:ea typeface="Aptos" panose="020B0004020202020204" pitchFamily="34" charset="0"/>
-              <a:cs typeface="Times New Roman" panose="02020603050405020304" pitchFamily="18" charset="0"/>
-            </a:endParaRPr>
-          </a:p>
-        </p:txBody>
-      </p:sp>
-      <p:cxnSp>
-        <p:nvCxnSpPr>
-          <p:cNvPr id="75" name="Straight Arrow Connector 74">
-            <a:extLst>
-              <a:ext uri="{FF2B5EF4-FFF2-40B4-BE49-F238E27FC236}">
-                <a16:creationId xmlns:a16="http://schemas.microsoft.com/office/drawing/2014/main" id="{83B769DA-AD63-C4ED-00AE-45CA1156D7C2}"/>
-              </a:ext>
-            </a:extLst>
-          </p:cNvPr>
-          <p:cNvCxnSpPr>
-            <a:cxnSpLocks/>
-            <a:stCxn id="74" idx="2"/>
-            <a:endCxn id="25" idx="0"/>
-          </p:cNvCxnSpPr>
-          <p:nvPr/>
-        </p:nvCxnSpPr>
-        <p:spPr>
-          <a:xfrm flipH="1">
-            <a:off x="7801767" y="3087092"/>
-            <a:ext cx="285752" cy="2203051"/>
-          </a:xfrm>
-          <a:prstGeom prst="straightConnector1">
-            <a:avLst/>
-          </a:prstGeom>
-          <a:ln>
-            <a:prstDash val="sysDash"/>
-            <a:tailEnd type="triangle"/>
-          </a:ln>
-        </p:spPr>
-        <p:style>
-          <a:lnRef idx="2">
-            <a:schemeClr val="dk1"/>
-          </a:lnRef>
-          <a:fillRef idx="0">
-            <a:schemeClr val="dk1"/>
-          </a:fillRef>
-          <a:effectRef idx="1">
-            <a:schemeClr val="dk1"/>
-          </a:effectRef>
-          <a:fontRef idx="minor">
-            <a:schemeClr val="tx1"/>
-          </a:fontRef>
-        </p:style>
-      </p:cxnSp>
-      <p:cxnSp>
-        <p:nvCxnSpPr>
-          <p:cNvPr id="78" name="Straight Arrow Connector 77">
-            <a:extLst>
-              <a:ext uri="{FF2B5EF4-FFF2-40B4-BE49-F238E27FC236}">
-                <a16:creationId xmlns:a16="http://schemas.microsoft.com/office/drawing/2014/main" id="{A29CBA1D-BDF4-AF4F-A9A7-0A44836FEA7E}"/>
-              </a:ext>
-            </a:extLst>
-          </p:cNvPr>
-          <p:cNvCxnSpPr>
-            <a:cxnSpLocks/>
-            <a:stCxn id="74" idx="2"/>
-            <a:endCxn id="13" idx="0"/>
-          </p:cNvCxnSpPr>
-          <p:nvPr/>
-        </p:nvCxnSpPr>
-        <p:spPr>
-          <a:xfrm flipH="1">
-            <a:off x="2757884" y="3087092"/>
-            <a:ext cx="5329635" cy="1024850"/>
-          </a:xfrm>
-          <a:prstGeom prst="straightConnector1">
-            <a:avLst/>
-          </a:prstGeom>
-          <a:ln>
-            <a:tailEnd type="triangle"/>
-          </a:ln>
-        </p:spPr>
-        <p:style>
-          <a:lnRef idx="2">
-            <a:schemeClr val="dk1"/>
-          </a:lnRef>
-          <a:fillRef idx="0">
-            <a:schemeClr val="dk1"/>
-          </a:fillRef>
-          <a:effectRef idx="1">
-            <a:schemeClr val="dk1"/>
-          </a:effectRef>
-          <a:fontRef idx="minor">
-            <a:schemeClr val="tx1"/>
-          </a:fontRef>
-        </p:style>
-      </p:cxnSp>
-      <p:sp>
-        <p:nvSpPr>
-          <p:cNvPr id="89" name="Explosion: 8 Points 88">
-            <a:extLst>
-              <a:ext uri="{FF2B5EF4-FFF2-40B4-BE49-F238E27FC236}">
-                <a16:creationId xmlns:a16="http://schemas.microsoft.com/office/drawing/2014/main" id="{EA9AA6C2-F859-B3D3-D675-965CE58843B8}"/>
-              </a:ext>
-            </a:extLst>
-          </p:cNvPr>
-          <p:cNvSpPr/>
-          <p:nvPr/>
-        </p:nvSpPr>
-        <p:spPr>
-          <a:xfrm>
-            <a:off x="8281987" y="3263900"/>
-            <a:ext cx="3474246" cy="2746873"/>
+            <a:off x="7801766" y="3280489"/>
+            <a:ext cx="2266950" cy="1703029"/>
           </a:xfrm>
           <a:prstGeom prst="irregularSeal1">
             <a:avLst/>
@@ -8441,76 +7610,35 @@
           <a:p>
             <a:pPr algn="ctr"/>
             <a:r>
-              <a:rPr lang="en-US" dirty="0"/>
-              <a:t>How should scale envelope be joined??</a:t>
-            </a:r>
-          </a:p>
-        </p:txBody>
-      </p:sp>
-      <p:cxnSp>
-        <p:nvCxnSpPr>
-          <p:cNvPr id="93" name="Straight Arrow Connector 92">
-            <a:extLst>
-              <a:ext uri="{FF2B5EF4-FFF2-40B4-BE49-F238E27FC236}">
-                <a16:creationId xmlns:a16="http://schemas.microsoft.com/office/drawing/2014/main" id="{7B20C067-AF4B-1864-B26F-22E4E53C4846}"/>
-              </a:ext>
-            </a:extLst>
-          </p:cNvPr>
-          <p:cNvCxnSpPr>
-            <a:cxnSpLocks/>
-            <a:stCxn id="74" idx="2"/>
-            <a:endCxn id="7" idx="0"/>
-          </p:cNvCxnSpPr>
+              <a:rPr lang="en-US" sz="1100" dirty="0"/>
+              <a:t>Add info on summaries?</a:t>
+            </a:r>
+          </a:p>
+        </p:txBody>
+      </p:sp>
+      <p:sp>
+        <p:nvSpPr>
+          <p:cNvPr id="2" name="Oval 1">
+            <a:extLst>
+              <a:ext uri="{FF2B5EF4-FFF2-40B4-BE49-F238E27FC236}">
+                <a16:creationId xmlns:a16="http://schemas.microsoft.com/office/drawing/2014/main" id="{1F05B9EE-2FF8-B44C-370B-8A17D8BF7C4A}"/>
+              </a:ext>
+            </a:extLst>
+          </p:cNvPr>
+          <p:cNvSpPr/>
           <p:nvPr/>
-        </p:nvCxnSpPr>
+        </p:nvSpPr>
         <p:spPr>
-          <a:xfrm flipH="1">
-            <a:off x="6468268" y="3087092"/>
-            <a:ext cx="1619251" cy="1000044"/>
+          <a:xfrm>
+            <a:off x="1413868" y="1824752"/>
+            <a:ext cx="1642266" cy="1179512"/>
           </a:xfrm>
-          <a:prstGeom prst="straightConnector1">
+          <a:prstGeom prst="ellipse">
             <a:avLst/>
           </a:prstGeom>
-          <a:ln>
-            <a:prstDash val="sysDash"/>
-            <a:tailEnd type="triangle"/>
-          </a:ln>
-        </p:spPr>
-        <p:style>
-          <a:lnRef idx="2">
-            <a:schemeClr val="dk1"/>
-          </a:lnRef>
-          <a:fillRef idx="0">
-            <a:schemeClr val="dk1"/>
-          </a:fillRef>
-          <a:effectRef idx="1">
-            <a:schemeClr val="dk1"/>
-          </a:effectRef>
-          <a:fontRef idx="minor">
-            <a:schemeClr val="tx1"/>
-          </a:fontRef>
-        </p:style>
-      </p:cxnSp>
-      <p:sp>
-        <p:nvSpPr>
-          <p:cNvPr id="2" name="Explosion: 8 Points 1">
-            <a:extLst>
-              <a:ext uri="{FF2B5EF4-FFF2-40B4-BE49-F238E27FC236}">
-                <a16:creationId xmlns:a16="http://schemas.microsoft.com/office/drawing/2014/main" id="{9724142F-D601-8CD2-2C17-A9A6925DF763}"/>
-              </a:ext>
-            </a:extLst>
-          </p:cNvPr>
-          <p:cNvSpPr/>
-          <p:nvPr/>
-        </p:nvSpPr>
-        <p:spPr>
-          <a:xfrm>
-            <a:off x="5633243" y="0"/>
-            <a:ext cx="3474246" cy="2746873"/>
-          </a:xfrm>
-          <a:prstGeom prst="irregularSeal1">
-            <a:avLst/>
-          </a:prstGeom>
+          <a:solidFill>
+            <a:srgbClr val="92D050"/>
+          </a:solidFill>
         </p:spPr>
         <p:style>
           <a:lnRef idx="2">
@@ -8529,26 +7657,39 @@
           </a:fontRef>
         </p:style>
         <p:txBody>
-          <a:bodyPr rtlCol="0" anchor="ctr"/>
+          <a:bodyPr rot="0" spcFirstLastPara="0" vert="horz" wrap="square" lIns="91440" tIns="45720" rIns="91440" bIns="45720" numCol="1" spcCol="0" rtlCol="0" fromWordArt="0" anchor="ctr" anchorCtr="0" forceAA="0" compatLnSpc="1">
+            <a:prstTxWarp prst="textNoShape">
+              <a:avLst/>
+            </a:prstTxWarp>
+            <a:noAutofit/>
+          </a:bodyPr>
           <a:lstStyle/>
           <a:p>
             <a:pPr algn="ctr"/>
             <a:r>
-              <a:rPr lang="en-US" dirty="0"/>
-              <a:t>Update this after finishing </a:t>
-            </a:r>
-            <a:r>
-              <a:rPr lang="en-US" dirty="0" err="1"/>
+              <a:rPr lang="en-US" sz="1200" b="1" kern="100" dirty="0" err="1">
+                <a:solidFill>
+                  <a:srgbClr val="000000"/>
+                </a:solidFill>
+                <a:ea typeface="Aptos" panose="020B0004020202020204" pitchFamily="34" charset="0"/>
+                <a:cs typeface="Times New Roman" panose="02020603050405020304" pitchFamily="18" charset="0"/>
+              </a:rPr>
               <a:t>catchByEffort</a:t>
             </a:r>
-            <a:endParaRPr lang="en-US" dirty="0"/>
+            <a:endParaRPr lang="en-US" sz="1200" b="1" kern="100" dirty="0">
+              <a:solidFill>
+                <a:srgbClr val="000000"/>
+              </a:solidFill>
+              <a:ea typeface="Aptos" panose="020B0004020202020204" pitchFamily="34" charset="0"/>
+              <a:cs typeface="Times New Roman" panose="02020603050405020304" pitchFamily="18" charset="0"/>
+            </a:endParaRPr>
           </a:p>
         </p:txBody>
       </p:sp>
     </p:spTree>
     <p:extLst>
       <p:ext uri="{BB962C8B-B14F-4D97-AF65-F5344CB8AC3E}">
-        <p14:creationId xmlns:p14="http://schemas.microsoft.com/office/powerpoint/2010/main" val="3322492765"/>
+        <p14:creationId xmlns:p14="http://schemas.microsoft.com/office/powerpoint/2010/main" val="796165095"/>
       </p:ext>
     </p:extLst>
   </p:cSld>

</xml_diff>

<commit_message>
updated after query modification
</commit_message>
<xml_diff>
--- a/dev/MFA_table_joins.pptx
+++ b/dev/MFA_table_joins.pptx
@@ -119,7 +119,7 @@
 <file path=ppt/revisionInfo.xml><?xml version="1.0" encoding="utf-8"?>
 <p1510:revInfo xmlns:a="http://schemas.openxmlformats.org/drawingml/2006/main" xmlns:r="http://schemas.openxmlformats.org/officeDocument/2006/relationships" xmlns:p1510="http://schemas.microsoft.com/office/powerpoint/2015/10/main">
   <p1510:revLst>
-    <p1510:client id="{281603EB-896B-47D6-9EA3-975A2DE2B083}" v="15" dt="2026-06-29T20:57:57.397"/>
+    <p1510:client id="{281603EB-896B-47D6-9EA3-975A2DE2B083}" v="18" dt="2026-06-30T15:01:45.268"/>
   </p1510:revLst>
 </p1510:revInfo>
 </file>
@@ -129,7 +129,7 @@
   <pc:docChgLst>
     <pc:chgData name="Nathan, Lucas (DNR)" userId="96837891-6aae-41c1-b905-2f597761f76b" providerId="ADAL" clId="{F64F8652-B73F-49BC-A105-17EA9971C31A}"/>
     <pc:docChg chg="undo custSel addSld delSld modSld">
-      <pc:chgData name="Nathan, Lucas (DNR)" userId="96837891-6aae-41c1-b905-2f597761f76b" providerId="ADAL" clId="{F64F8652-B73F-49BC-A105-17EA9971C31A}" dt="2026-06-29T20:57:58.912" v="307" actId="1076"/>
+      <pc:chgData name="Nathan, Lucas (DNR)" userId="96837891-6aae-41c1-b905-2f597761f76b" providerId="ADAL" clId="{F64F8652-B73F-49BC-A105-17EA9971C31A}" dt="2026-06-30T15:05:41.794" v="536" actId="1076"/>
       <pc:docMkLst>
         <pc:docMk/>
       </pc:docMkLst>
@@ -219,8 +219,8 @@
           <pc:sldMk cId="3617245666" sldId="257"/>
         </pc:sldMkLst>
       </pc:sldChg>
-      <pc:sldChg chg="modSp mod">
-        <pc:chgData name="Nathan, Lucas (DNR)" userId="96837891-6aae-41c1-b905-2f597761f76b" providerId="ADAL" clId="{F64F8652-B73F-49BC-A105-17EA9971C31A}" dt="2026-06-29T19:37:01.542" v="155" actId="1076"/>
+      <pc:sldChg chg="addSp delSp modSp mod">
+        <pc:chgData name="Nathan, Lucas (DNR)" userId="96837891-6aae-41c1-b905-2f597761f76b" providerId="ADAL" clId="{F64F8652-B73F-49BC-A105-17EA9971C31A}" dt="2026-06-30T15:03:23.791" v="532" actId="478"/>
         <pc:sldMkLst>
           <pc:docMk/>
           <pc:sldMk cId="736430854" sldId="259"/>
@@ -233,6 +233,22 @@
             <ac:spMk id="9" creationId="{4DE46BED-CCB7-ED12-76E6-987DDCF23BB5}"/>
           </ac:spMkLst>
         </pc:spChg>
+        <pc:spChg chg="add mod">
+          <ac:chgData name="Nathan, Lucas (DNR)" userId="96837891-6aae-41c1-b905-2f597761f76b" providerId="ADAL" clId="{F64F8652-B73F-49BC-A105-17EA9971C31A}" dt="2026-06-30T15:00:50.293" v="321" actId="1076"/>
+          <ac:spMkLst>
+            <pc:docMk/>
+            <pc:sldMk cId="736430854" sldId="259"/>
+            <ac:spMk id="22" creationId="{94A251C3-E18A-1F32-94AA-9C10E78A9CC8}"/>
+          </ac:spMkLst>
+        </pc:spChg>
+        <pc:spChg chg="add del mod">
+          <ac:chgData name="Nathan, Lucas (DNR)" userId="96837891-6aae-41c1-b905-2f597761f76b" providerId="ADAL" clId="{F64F8652-B73F-49BC-A105-17EA9971C31A}" dt="2026-06-30T15:03:23.791" v="532" actId="478"/>
+          <ac:spMkLst>
+            <pc:docMk/>
+            <pc:sldMk cId="736430854" sldId="259"/>
+            <ac:spMk id="26" creationId="{02F666D8-2D64-87AF-F713-CF297F963AE6}"/>
+          </ac:spMkLst>
+        </pc:spChg>
         <pc:spChg chg="mod">
           <ac:chgData name="Nathan, Lucas (DNR)" userId="96837891-6aae-41c1-b905-2f597761f76b" providerId="ADAL" clId="{F64F8652-B73F-49BC-A105-17EA9971C31A}" dt="2026-06-25T16:01:23.717" v="9" actId="1076"/>
           <ac:spMkLst>
@@ -242,7 +258,7 @@
           </ac:spMkLst>
         </pc:spChg>
         <pc:spChg chg="mod">
-          <ac:chgData name="Nathan, Lucas (DNR)" userId="96837891-6aae-41c1-b905-2f597761f76b" providerId="ADAL" clId="{F64F8652-B73F-49BC-A105-17EA9971C31A}" dt="2026-06-29T19:37:01.542" v="155" actId="1076"/>
+          <ac:chgData name="Nathan, Lucas (DNR)" userId="96837891-6aae-41c1-b905-2f597761f76b" providerId="ADAL" clId="{F64F8652-B73F-49BC-A105-17EA9971C31A}" dt="2026-06-30T15:00:13.943" v="316" actId="1076"/>
           <ac:spMkLst>
             <pc:docMk/>
             <pc:sldMk cId="736430854" sldId="259"/>
@@ -250,7 +266,7 @@
           </ac:spMkLst>
         </pc:spChg>
         <pc:spChg chg="mod">
-          <ac:chgData name="Nathan, Lucas (DNR)" userId="96837891-6aae-41c1-b905-2f597761f76b" providerId="ADAL" clId="{F64F8652-B73F-49BC-A105-17EA9971C31A}" dt="2026-06-25T16:01:28.334" v="12" actId="1076"/>
+          <ac:chgData name="Nathan, Lucas (DNR)" userId="96837891-6aae-41c1-b905-2f597761f76b" providerId="ADAL" clId="{F64F8652-B73F-49BC-A105-17EA9971C31A}" dt="2026-06-30T15:00:15.453" v="317" actId="1076"/>
           <ac:spMkLst>
             <pc:docMk/>
             <pc:sldMk cId="736430854" sldId="259"/>
@@ -258,13 +274,21 @@
           </ac:spMkLst>
         </pc:spChg>
         <pc:spChg chg="mod">
-          <ac:chgData name="Nathan, Lucas (DNR)" userId="96837891-6aae-41c1-b905-2f597761f76b" providerId="ADAL" clId="{F64F8652-B73F-49BC-A105-17EA9971C31A}" dt="2026-06-25T16:01:30.244" v="13" actId="1076"/>
+          <ac:chgData name="Nathan, Lucas (DNR)" userId="96837891-6aae-41c1-b905-2f597761f76b" providerId="ADAL" clId="{F64F8652-B73F-49BC-A105-17EA9971C31A}" dt="2026-06-30T15:00:19.360" v="319" actId="1076"/>
           <ac:spMkLst>
             <pc:docMk/>
             <pc:sldMk cId="736430854" sldId="259"/>
             <ac:spMk id="57" creationId="{9E41CA45-5A62-0DC2-D3E3-DB5565A92737}"/>
           </ac:spMkLst>
         </pc:spChg>
+        <pc:cxnChg chg="add mod">
+          <ac:chgData name="Nathan, Lucas (DNR)" userId="96837891-6aae-41c1-b905-2f597761f76b" providerId="ADAL" clId="{F64F8652-B73F-49BC-A105-17EA9971C31A}" dt="2026-06-30T15:00:56.981" v="324" actId="14100"/>
+          <ac:cxnSpMkLst>
+            <pc:docMk/>
+            <pc:sldMk cId="736430854" sldId="259"/>
+            <ac:cxnSpMk id="23" creationId="{8B2C970B-DFB2-ABD9-17B5-8C09DD3A1C63}"/>
+          </ac:cxnSpMkLst>
+        </pc:cxnChg>
         <pc:cxnChg chg="mod">
           <ac:chgData name="Nathan, Lucas (DNR)" userId="96837891-6aae-41c1-b905-2f597761f76b" providerId="ADAL" clId="{F64F8652-B73F-49BC-A105-17EA9971C31A}" dt="2026-06-25T16:01:23.717" v="9" actId="1076"/>
           <ac:cxnSpMkLst>
@@ -282,7 +306,7 @@
           </ac:cxnSpMkLst>
         </pc:cxnChg>
         <pc:cxnChg chg="mod">
-          <ac:chgData name="Nathan, Lucas (DNR)" userId="96837891-6aae-41c1-b905-2f597761f76b" providerId="ADAL" clId="{F64F8652-B73F-49BC-A105-17EA9971C31A}" dt="2026-06-29T19:37:01.542" v="155" actId="1076"/>
+          <ac:chgData name="Nathan, Lucas (DNR)" userId="96837891-6aae-41c1-b905-2f597761f76b" providerId="ADAL" clId="{F64F8652-B73F-49BC-A105-17EA9971C31A}" dt="2026-06-30T15:00:13.943" v="316" actId="1076"/>
           <ac:cxnSpMkLst>
             <pc:docMk/>
             <pc:sldMk cId="736430854" sldId="259"/>
@@ -290,7 +314,7 @@
           </ac:cxnSpMkLst>
         </pc:cxnChg>
         <pc:cxnChg chg="mod">
-          <ac:chgData name="Nathan, Lucas (DNR)" userId="96837891-6aae-41c1-b905-2f597761f76b" providerId="ADAL" clId="{F64F8652-B73F-49BC-A105-17EA9971C31A}" dt="2026-06-29T19:37:01.542" v="155" actId="1076"/>
+          <ac:chgData name="Nathan, Lucas (DNR)" userId="96837891-6aae-41c1-b905-2f597761f76b" providerId="ADAL" clId="{F64F8652-B73F-49BC-A105-17EA9971C31A}" dt="2026-06-30T15:00:15.453" v="317" actId="1076"/>
           <ac:cxnSpMkLst>
             <pc:docMk/>
             <pc:sldMk cId="736430854" sldId="259"/>
@@ -298,7 +322,7 @@
           </ac:cxnSpMkLst>
         </pc:cxnChg>
         <pc:cxnChg chg="mod">
-          <ac:chgData name="Nathan, Lucas (DNR)" userId="96837891-6aae-41c1-b905-2f597761f76b" providerId="ADAL" clId="{F64F8652-B73F-49BC-A105-17EA9971C31A}" dt="2026-06-25T16:01:30.244" v="13" actId="1076"/>
+          <ac:chgData name="Nathan, Lucas (DNR)" userId="96837891-6aae-41c1-b905-2f597761f76b" providerId="ADAL" clId="{F64F8652-B73F-49BC-A105-17EA9971C31A}" dt="2026-06-30T15:00:19.360" v="319" actId="1076"/>
           <ac:cxnSpMkLst>
             <pc:docMk/>
             <pc:sldMk cId="736430854" sldId="259"/>
@@ -307,7 +331,7 @@
         </pc:cxnChg>
       </pc:sldChg>
       <pc:sldChg chg="addSp delSp modSp mod">
-        <pc:chgData name="Nathan, Lucas (DNR)" userId="96837891-6aae-41c1-b905-2f597761f76b" providerId="ADAL" clId="{F64F8652-B73F-49BC-A105-17EA9971C31A}" dt="2026-06-29T20:57:58.912" v="307" actId="1076"/>
+        <pc:chgData name="Nathan, Lucas (DNR)" userId="96837891-6aae-41c1-b905-2f597761f76b" providerId="ADAL" clId="{F64F8652-B73F-49BC-A105-17EA9971C31A}" dt="2026-06-30T15:05:28.855" v="533" actId="478"/>
         <pc:sldMkLst>
           <pc:docMk/>
           <pc:sldMk cId="3322492765" sldId="261"/>
@@ -368,8 +392,8 @@
             <ac:spMk id="19" creationId="{A88200D1-2FA7-C9BB-C320-3AD2B05F0804}"/>
           </ac:spMkLst>
         </pc:spChg>
-        <pc:spChg chg="add mod">
-          <ac:chgData name="Nathan, Lucas (DNR)" userId="96837891-6aae-41c1-b905-2f597761f76b" providerId="ADAL" clId="{F64F8652-B73F-49BC-A105-17EA9971C31A}" dt="2026-06-29T20:57:58.912" v="307" actId="1076"/>
+        <pc:spChg chg="add del mod">
+          <ac:chgData name="Nathan, Lucas (DNR)" userId="96837891-6aae-41c1-b905-2f597761f76b" providerId="ADAL" clId="{F64F8652-B73F-49BC-A105-17EA9971C31A}" dt="2026-06-30T15:05:28.855" v="533" actId="478"/>
           <ac:spMkLst>
             <pc:docMk/>
             <pc:sldMk cId="3322492765" sldId="261"/>
@@ -497,13 +521,13 @@
         </pc:spChg>
       </pc:sldChg>
       <pc:sldChg chg="addSp delSp modSp add mod">
-        <pc:chgData name="Nathan, Lucas (DNR)" userId="96837891-6aae-41c1-b905-2f597761f76b" providerId="ADAL" clId="{F64F8652-B73F-49BC-A105-17EA9971C31A}" dt="2026-06-29T20:57:54.514" v="305" actId="20577"/>
+        <pc:chgData name="Nathan, Lucas (DNR)" userId="96837891-6aae-41c1-b905-2f597761f76b" providerId="ADAL" clId="{F64F8652-B73F-49BC-A105-17EA9971C31A}" dt="2026-06-30T15:05:41.794" v="536" actId="1076"/>
         <pc:sldMkLst>
           <pc:docMk/>
           <pc:sldMk cId="796165095" sldId="263"/>
         </pc:sldMkLst>
         <pc:spChg chg="add mod">
-          <ac:chgData name="Nathan, Lucas (DNR)" userId="96837891-6aae-41c1-b905-2f597761f76b" providerId="ADAL" clId="{F64F8652-B73F-49BC-A105-17EA9971C31A}" dt="2026-06-29T20:42:20.142" v="272" actId="1076"/>
+          <ac:chgData name="Nathan, Lucas (DNR)" userId="96837891-6aae-41c1-b905-2f597761f76b" providerId="ADAL" clId="{F64F8652-B73F-49BC-A105-17EA9971C31A}" dt="2026-06-30T15:05:41.794" v="536" actId="1076"/>
           <ac:spMkLst>
             <pc:docMk/>
             <pc:sldMk cId="796165095" sldId="263"/>
@@ -527,7 +551,7 @@
           </ac:spMkLst>
         </pc:spChg>
         <pc:spChg chg="add del mod">
-          <ac:chgData name="Nathan, Lucas (DNR)" userId="96837891-6aae-41c1-b905-2f597761f76b" providerId="ADAL" clId="{F64F8652-B73F-49BC-A105-17EA9971C31A}" dt="2026-06-29T20:57:54.514" v="305" actId="20577"/>
+          <ac:chgData name="Nathan, Lucas (DNR)" userId="96837891-6aae-41c1-b905-2f597761f76b" providerId="ADAL" clId="{F64F8652-B73F-49BC-A105-17EA9971C31A}" dt="2026-06-30T15:05:38.396" v="534" actId="478"/>
           <ac:spMkLst>
             <pc:docMk/>
             <pc:sldMk cId="796165095" sldId="263"/>
@@ -566,8 +590,8 @@
             <ac:cxnSpMk id="8" creationId="{C1441D0A-BCC5-4FCB-F8E1-8F9558DFE42B}"/>
           </ac:cxnSpMkLst>
         </pc:cxnChg>
-        <pc:cxnChg chg="mod">
-          <ac:chgData name="Nathan, Lucas (DNR)" userId="96837891-6aae-41c1-b905-2f597761f76b" providerId="ADAL" clId="{F64F8652-B73F-49BC-A105-17EA9971C31A}" dt="2026-06-29T20:42:42.853" v="274" actId="14100"/>
+        <pc:cxnChg chg="del mod">
+          <ac:chgData name="Nathan, Lucas (DNR)" userId="96837891-6aae-41c1-b905-2f597761f76b" providerId="ADAL" clId="{F64F8652-B73F-49BC-A105-17EA9971C31A}" dt="2026-06-30T15:05:39.431" v="535" actId="478"/>
           <ac:cxnSpMkLst>
             <pc:docMk/>
             <pc:sldMk cId="796165095" sldId="263"/>
@@ -759,7 +783,7 @@
           <a:p>
             <a:fld id="{179C5205-C240-4C15-BC7A-8B28C81B6976}" type="datetimeFigureOut">
               <a:rPr lang="en-US" smtClean="0"/>
-              <a:t>06/29/2026</a:t>
+              <a:t>06/30/2026</a:t>
             </a:fld>
             <a:endParaRPr lang="en-US"/>
           </a:p>
@@ -957,7 +981,7 @@
           <a:p>
             <a:fld id="{179C5205-C240-4C15-BC7A-8B28C81B6976}" type="datetimeFigureOut">
               <a:rPr lang="en-US" smtClean="0"/>
-              <a:t>06/29/2026</a:t>
+              <a:t>06/30/2026</a:t>
             </a:fld>
             <a:endParaRPr lang="en-US"/>
           </a:p>
@@ -1165,7 +1189,7 @@
           <a:p>
             <a:fld id="{179C5205-C240-4C15-BC7A-8B28C81B6976}" type="datetimeFigureOut">
               <a:rPr lang="en-US" smtClean="0"/>
-              <a:t>06/29/2026</a:t>
+              <a:t>06/30/2026</a:t>
             </a:fld>
             <a:endParaRPr lang="en-US"/>
           </a:p>
@@ -1363,7 +1387,7 @@
           <a:p>
             <a:fld id="{179C5205-C240-4C15-BC7A-8B28C81B6976}" type="datetimeFigureOut">
               <a:rPr lang="en-US" smtClean="0"/>
-              <a:t>06/29/2026</a:t>
+              <a:t>06/30/2026</a:t>
             </a:fld>
             <a:endParaRPr lang="en-US"/>
           </a:p>
@@ -1638,7 +1662,7 @@
           <a:p>
             <a:fld id="{179C5205-C240-4C15-BC7A-8B28C81B6976}" type="datetimeFigureOut">
               <a:rPr lang="en-US" smtClean="0"/>
-              <a:t>06/29/2026</a:t>
+              <a:t>06/30/2026</a:t>
             </a:fld>
             <a:endParaRPr lang="en-US"/>
           </a:p>
@@ -1903,7 +1927,7 @@
           <a:p>
             <a:fld id="{179C5205-C240-4C15-BC7A-8B28C81B6976}" type="datetimeFigureOut">
               <a:rPr lang="en-US" smtClean="0"/>
-              <a:t>06/29/2026</a:t>
+              <a:t>06/30/2026</a:t>
             </a:fld>
             <a:endParaRPr lang="en-US"/>
           </a:p>
@@ -2315,7 +2339,7 @@
           <a:p>
             <a:fld id="{179C5205-C240-4C15-BC7A-8B28C81B6976}" type="datetimeFigureOut">
               <a:rPr lang="en-US" smtClean="0"/>
-              <a:t>06/29/2026</a:t>
+              <a:t>06/30/2026</a:t>
             </a:fld>
             <a:endParaRPr lang="en-US"/>
           </a:p>
@@ -2456,7 +2480,7 @@
           <a:p>
             <a:fld id="{179C5205-C240-4C15-BC7A-8B28C81B6976}" type="datetimeFigureOut">
               <a:rPr lang="en-US" smtClean="0"/>
-              <a:t>06/29/2026</a:t>
+              <a:t>06/30/2026</a:t>
             </a:fld>
             <a:endParaRPr lang="en-US"/>
           </a:p>
@@ -2569,7 +2593,7 @@
           <a:p>
             <a:fld id="{179C5205-C240-4C15-BC7A-8B28C81B6976}" type="datetimeFigureOut">
               <a:rPr lang="en-US" smtClean="0"/>
-              <a:t>06/29/2026</a:t>
+              <a:t>06/30/2026</a:t>
             </a:fld>
             <a:endParaRPr lang="en-US"/>
           </a:p>
@@ -2880,7 +2904,7 @@
           <a:p>
             <a:fld id="{179C5205-C240-4C15-BC7A-8B28C81B6976}" type="datetimeFigureOut">
               <a:rPr lang="en-US" smtClean="0"/>
-              <a:t>06/29/2026</a:t>
+              <a:t>06/30/2026</a:t>
             </a:fld>
             <a:endParaRPr lang="en-US"/>
           </a:p>
@@ -3168,7 +3192,7 @@
           <a:p>
             <a:fld id="{179C5205-C240-4C15-BC7A-8B28C81B6976}" type="datetimeFigureOut">
               <a:rPr lang="en-US" smtClean="0"/>
-              <a:t>06/29/2026</a:t>
+              <a:t>06/30/2026</a:t>
             </a:fld>
             <a:endParaRPr lang="en-US"/>
           </a:p>
@@ -3409,7 +3433,7 @@
           <a:p>
             <a:fld id="{179C5205-C240-4C15-BC7A-8B28C81B6976}" type="datetimeFigureOut">
               <a:rPr lang="en-US" smtClean="0"/>
-              <a:t>06/29/2026</a:t>
+              <a:t>06/30/2026</a:t>
             </a:fld>
             <a:endParaRPr lang="en-US"/>
           </a:p>
@@ -5349,7 +5373,7 @@
         </p:nvSpPr>
         <p:spPr>
           <a:xfrm>
-            <a:off x="4028280" y="3591716"/>
+            <a:off x="5131595" y="1856255"/>
             <a:ext cx="1600991" cy="958851"/>
           </a:xfrm>
           <a:prstGeom prst="rect">
@@ -5501,7 +5525,7 @@
         </p:nvSpPr>
         <p:spPr>
           <a:xfrm>
-            <a:off x="6846946" y="2953938"/>
+            <a:off x="4584245" y="3186732"/>
             <a:ext cx="2695692" cy="2234407"/>
           </a:xfrm>
           <a:prstGeom prst="rect">
@@ -5763,7 +5787,7 @@
         </p:nvSpPr>
         <p:spPr>
           <a:xfrm>
-            <a:off x="10056137" y="3729828"/>
+            <a:off x="5425326" y="6129337"/>
             <a:ext cx="1013527" cy="682625"/>
           </a:xfrm>
           <a:prstGeom prst="rect">
@@ -5874,8 +5898,8 @@
         </p:nvCxnSpPr>
         <p:spPr>
           <a:xfrm flipV="1">
-            <a:off x="2362675" y="4071142"/>
-            <a:ext cx="1665605" cy="1"/>
+            <a:off x="2362675" y="2335681"/>
+            <a:ext cx="2768920" cy="1735462"/>
           </a:xfrm>
           <a:prstGeom prst="straightConnector1">
             <a:avLst/>
@@ -5910,15 +5934,15 @@
           </p:cNvPr>
           <p:cNvCxnSpPr>
             <a:cxnSpLocks/>
-            <a:stCxn id="55" idx="3"/>
-            <a:endCxn id="56" idx="1"/>
+            <a:stCxn id="55" idx="2"/>
+            <a:endCxn id="56" idx="0"/>
           </p:cNvCxnSpPr>
           <p:nvPr/>
         </p:nvCxnSpPr>
         <p:spPr>
           <a:xfrm>
-            <a:off x="5629271" y="4071142"/>
-            <a:ext cx="1217675" cy="0"/>
+            <a:off x="5932091" y="2815106"/>
+            <a:ext cx="0" cy="371626"/>
           </a:xfrm>
           <a:prstGeom prst="straightConnector1">
             <a:avLst/>
@@ -5953,15 +5977,128 @@
           </p:cNvPr>
           <p:cNvCxnSpPr>
             <a:cxnSpLocks/>
-            <a:stCxn id="56" idx="3"/>
-            <a:endCxn id="57" idx="1"/>
+            <a:stCxn id="56" idx="2"/>
+            <a:endCxn id="57" idx="0"/>
           </p:cNvCxnSpPr>
           <p:nvPr/>
         </p:nvCxnSpPr>
         <p:spPr>
-          <a:xfrm flipV="1">
-            <a:off x="9542638" y="4071141"/>
-            <a:ext cx="513499" cy="1"/>
+          <a:xfrm flipH="1">
+            <a:off x="5932090" y="5421139"/>
+            <a:ext cx="1" cy="708198"/>
+          </a:xfrm>
+          <a:prstGeom prst="straightConnector1">
+            <a:avLst/>
+          </a:prstGeom>
+          <a:ln>
+            <a:tailEnd type="triangle"/>
+          </a:ln>
+        </p:spPr>
+        <p:style>
+          <a:lnRef idx="2">
+            <a:schemeClr val="dk1"/>
+          </a:lnRef>
+          <a:fillRef idx="0">
+            <a:schemeClr val="dk1"/>
+          </a:fillRef>
+          <a:effectRef idx="1">
+            <a:schemeClr val="dk1"/>
+          </a:effectRef>
+          <a:fontRef idx="minor">
+            <a:schemeClr val="tx1"/>
+          </a:fontRef>
+        </p:style>
+      </p:cxnSp>
+      <p:sp>
+        <p:nvSpPr>
+          <p:cNvPr id="22" name="Oval 1">
+            <a:extLst>
+              <a:ext uri="{FF2B5EF4-FFF2-40B4-BE49-F238E27FC236}">
+                <a16:creationId xmlns:a16="http://schemas.microsoft.com/office/drawing/2014/main" id="{94A251C3-E18A-1F32-94AA-9C10E78A9CC8}"/>
+              </a:ext>
+            </a:extLst>
+          </p:cNvPr>
+          <p:cNvSpPr/>
+          <p:nvPr/>
+        </p:nvSpPr>
+        <p:spPr>
+          <a:xfrm>
+            <a:off x="9104073" y="1767919"/>
+            <a:ext cx="1642266" cy="1179512"/>
+          </a:xfrm>
+          <a:prstGeom prst="ellipse">
+            <a:avLst/>
+          </a:prstGeom>
+          <a:solidFill>
+            <a:srgbClr val="92D050"/>
+          </a:solidFill>
+        </p:spPr>
+        <p:style>
+          <a:lnRef idx="2">
+            <a:schemeClr val="accent1">
+              <a:shade val="15000"/>
+            </a:schemeClr>
+          </a:lnRef>
+          <a:fillRef idx="1">
+            <a:schemeClr val="accent1"/>
+          </a:fillRef>
+          <a:effectRef idx="0">
+            <a:schemeClr val="accent1"/>
+          </a:effectRef>
+          <a:fontRef idx="minor">
+            <a:schemeClr val="lt1"/>
+          </a:fontRef>
+        </p:style>
+        <p:txBody>
+          <a:bodyPr rot="0" spcFirstLastPara="0" vert="horz" wrap="square" lIns="91440" tIns="45720" rIns="91440" bIns="45720" numCol="1" spcCol="0" rtlCol="0" fromWordArt="0" anchor="ctr" anchorCtr="0" forceAA="0" compatLnSpc="1">
+            <a:prstTxWarp prst="textNoShape">
+              <a:avLst/>
+            </a:prstTxWarp>
+            <a:noAutofit/>
+          </a:bodyPr>
+          <a:lstStyle/>
+          <a:p>
+            <a:pPr algn="ctr"/>
+            <a:r>
+              <a:rPr lang="en-US" sz="1200" b="1" kern="100" dirty="0" err="1">
+                <a:solidFill>
+                  <a:srgbClr val="000000"/>
+                </a:solidFill>
+                <a:ea typeface="Aptos" panose="020B0004020202020204" pitchFamily="34" charset="0"/>
+                <a:cs typeface="Times New Roman" panose="02020603050405020304" pitchFamily="18" charset="0"/>
+              </a:rPr>
+              <a:t>catchByEffort</a:t>
+            </a:r>
+            <a:endParaRPr lang="en-US" sz="1200" b="1" kern="100" dirty="0">
+              <a:solidFill>
+                <a:srgbClr val="000000"/>
+              </a:solidFill>
+              <a:ea typeface="Aptos" panose="020B0004020202020204" pitchFamily="34" charset="0"/>
+              <a:cs typeface="Times New Roman" panose="02020603050405020304" pitchFamily="18" charset="0"/>
+            </a:endParaRPr>
+          </a:p>
+        </p:txBody>
+      </p:sp>
+      <p:cxnSp>
+        <p:nvCxnSpPr>
+          <p:cNvPr id="23" name="Straight Arrow Connector 22">
+            <a:extLst>
+              <a:ext uri="{FF2B5EF4-FFF2-40B4-BE49-F238E27FC236}">
+                <a16:creationId xmlns:a16="http://schemas.microsoft.com/office/drawing/2014/main" id="{8B2C970B-DFB2-ABD9-17B5-8C09DD3A1C63}"/>
+              </a:ext>
+            </a:extLst>
+          </p:cNvPr>
+          <p:cNvCxnSpPr>
+            <a:cxnSpLocks/>
+            <a:stCxn id="55" idx="3"/>
+            <a:endCxn id="22" idx="2"/>
+          </p:cNvCxnSpPr>
+          <p:nvPr/>
+        </p:nvCxnSpPr>
+        <p:spPr>
+          <a:xfrm>
+            <a:off x="6732586" y="2335681"/>
+            <a:ext cx="2371487" cy="21994"/>
           </a:xfrm>
           <a:prstGeom prst="straightConnector1">
             <a:avLst/>
@@ -7411,55 +7548,6 @@
           </a:fontRef>
         </p:style>
       </p:cxnSp>
-      <p:sp>
-        <p:nvSpPr>
-          <p:cNvPr id="24" name="Explosion: 8 Points 23">
-            <a:extLst>
-              <a:ext uri="{FF2B5EF4-FFF2-40B4-BE49-F238E27FC236}">
-                <a16:creationId xmlns:a16="http://schemas.microsoft.com/office/drawing/2014/main" id="{4745DB2B-329F-010A-51F8-365B963F646F}"/>
-              </a:ext>
-            </a:extLst>
-          </p:cNvPr>
-          <p:cNvSpPr/>
-          <p:nvPr/>
-        </p:nvSpPr>
-        <p:spPr>
-          <a:xfrm>
-            <a:off x="8935241" y="4983518"/>
-            <a:ext cx="2266950" cy="1703029"/>
-          </a:xfrm>
-          <a:prstGeom prst="irregularSeal1">
-            <a:avLst/>
-          </a:prstGeom>
-        </p:spPr>
-        <p:style>
-          <a:lnRef idx="2">
-            <a:schemeClr val="accent1">
-              <a:shade val="15000"/>
-            </a:schemeClr>
-          </a:lnRef>
-          <a:fillRef idx="1">
-            <a:schemeClr val="accent1"/>
-          </a:fillRef>
-          <a:effectRef idx="0">
-            <a:schemeClr val="accent1"/>
-          </a:effectRef>
-          <a:fontRef idx="minor">
-            <a:schemeClr val="lt1"/>
-          </a:fontRef>
-        </p:style>
-        <p:txBody>
-          <a:bodyPr rtlCol="0" anchor="ctr"/>
-          <a:lstStyle/>
-          <a:p>
-            <a:pPr algn="ctr"/>
-            <a:r>
-              <a:rPr lang="en-US" sz="1100" dirty="0"/>
-              <a:t>Add info on summaries?</a:t>
-            </a:r>
-          </a:p>
-        </p:txBody>
-      </p:sp>
     </p:spTree>
     <p:extLst>
       <p:ext uri="{BB962C8B-B14F-4D97-AF65-F5344CB8AC3E}">
@@ -7525,112 +7613,21 @@
           </a:p>
         </p:txBody>
       </p:sp>
-      <p:cxnSp>
-        <p:nvCxnSpPr>
-          <p:cNvPr id="14" name="Straight Arrow Connector 13">
-            <a:extLst>
-              <a:ext uri="{FF2B5EF4-FFF2-40B4-BE49-F238E27FC236}">
-                <a16:creationId xmlns:a16="http://schemas.microsoft.com/office/drawing/2014/main" id="{9373E434-CB22-6DAD-802E-93462B042E39}"/>
-              </a:ext>
-            </a:extLst>
-          </p:cNvPr>
-          <p:cNvCxnSpPr>
-            <a:cxnSpLocks/>
-            <a:stCxn id="2" idx="4"/>
-          </p:cNvCxnSpPr>
+      <p:sp>
+        <p:nvSpPr>
+          <p:cNvPr id="2" name="Oval 1">
+            <a:extLst>
+              <a:ext uri="{FF2B5EF4-FFF2-40B4-BE49-F238E27FC236}">
+                <a16:creationId xmlns:a16="http://schemas.microsoft.com/office/drawing/2014/main" id="{1F05B9EE-2FF8-B44C-370B-8A17D8BF7C4A}"/>
+              </a:ext>
+            </a:extLst>
+          </p:cNvPr>
+          <p:cNvSpPr/>
           <p:nvPr/>
-        </p:nvCxnSpPr>
+        </p:nvSpPr>
         <p:spPr>
           <a:xfrm>
-            <a:off x="2235001" y="3004264"/>
-            <a:ext cx="0" cy="849473"/>
-          </a:xfrm>
-          <a:prstGeom prst="straightConnector1">
-            <a:avLst/>
-          </a:prstGeom>
-          <a:ln>
-            <a:tailEnd type="triangle"/>
-          </a:ln>
-        </p:spPr>
-        <p:style>
-          <a:lnRef idx="2">
-            <a:schemeClr val="dk1"/>
-          </a:lnRef>
-          <a:fillRef idx="0">
-            <a:schemeClr val="dk1"/>
-          </a:fillRef>
-          <a:effectRef idx="1">
-            <a:schemeClr val="dk1"/>
-          </a:effectRef>
-          <a:fontRef idx="minor">
-            <a:schemeClr val="tx1"/>
-          </a:fontRef>
-        </p:style>
-      </p:cxnSp>
-      <p:sp>
-        <p:nvSpPr>
-          <p:cNvPr id="11" name="Explosion: 8 Points 10">
-            <a:extLst>
-              <a:ext uri="{FF2B5EF4-FFF2-40B4-BE49-F238E27FC236}">
-                <a16:creationId xmlns:a16="http://schemas.microsoft.com/office/drawing/2014/main" id="{B3D0F06D-DB70-E021-E141-F59AF8C8AB58}"/>
-              </a:ext>
-            </a:extLst>
-          </p:cNvPr>
-          <p:cNvSpPr/>
-          <p:nvPr/>
-        </p:nvSpPr>
-        <p:spPr>
-          <a:xfrm>
-            <a:off x="7801766" y="3280489"/>
-            <a:ext cx="2266950" cy="1703029"/>
-          </a:xfrm>
-          <a:prstGeom prst="irregularSeal1">
-            <a:avLst/>
-          </a:prstGeom>
-        </p:spPr>
-        <p:style>
-          <a:lnRef idx="2">
-            <a:schemeClr val="accent1">
-              <a:shade val="15000"/>
-            </a:schemeClr>
-          </a:lnRef>
-          <a:fillRef idx="1">
-            <a:schemeClr val="accent1"/>
-          </a:fillRef>
-          <a:effectRef idx="0">
-            <a:schemeClr val="accent1"/>
-          </a:effectRef>
-          <a:fontRef idx="minor">
-            <a:schemeClr val="lt1"/>
-          </a:fontRef>
-        </p:style>
-        <p:txBody>
-          <a:bodyPr rtlCol="0" anchor="ctr"/>
-          <a:lstStyle/>
-          <a:p>
-            <a:pPr algn="ctr"/>
-            <a:r>
-              <a:rPr lang="en-US" sz="1100" dirty="0"/>
-              <a:t>Add info on summaries?</a:t>
-            </a:r>
-          </a:p>
-        </p:txBody>
-      </p:sp>
-      <p:sp>
-        <p:nvSpPr>
-          <p:cNvPr id="2" name="Oval 1">
-            <a:extLst>
-              <a:ext uri="{FF2B5EF4-FFF2-40B4-BE49-F238E27FC236}">
-                <a16:creationId xmlns:a16="http://schemas.microsoft.com/office/drawing/2014/main" id="{1F05B9EE-2FF8-B44C-370B-8A17D8BF7C4A}"/>
-              </a:ext>
-            </a:extLst>
-          </p:cNvPr>
-          <p:cNvSpPr/>
-          <p:nvPr/>
-        </p:nvSpPr>
-        <p:spPr>
-          <a:xfrm>
-            <a:off x="1413868" y="1824752"/>
+            <a:off x="1424028" y="2007632"/>
             <a:ext cx="1642266" cy="1179512"/>
           </a:xfrm>
           <a:prstGeom prst="ellipse">

</xml_diff>

<commit_message>
updated after adding lengthFreqByEffort function
</commit_message>
<xml_diff>
--- a/dev/MFA_table_joins.pptx
+++ b/dev/MFA_table_joins.pptx
@@ -11,6 +11,7 @@
     <p:sldId id="263" r:id="rId5"/>
     <p:sldId id="258" r:id="rId6"/>
     <p:sldId id="264" r:id="rId7"/>
+    <p:sldId id="267" r:id="rId8"/>
   </p:sldIdLst>
   <p:sldSz cx="12192000" cy="6858000"/>
   <p:notesSz cx="6858000" cy="9144000"/>
@@ -120,7 +121,7 @@
 <file path=ppt/revisionInfo.xml><?xml version="1.0" encoding="utf-8"?>
 <p1510:revInfo xmlns:a="http://schemas.openxmlformats.org/drawingml/2006/main" xmlns:r="http://schemas.openxmlformats.org/officeDocument/2006/relationships" xmlns:p1510="http://schemas.microsoft.com/office/powerpoint/2015/10/main">
   <p1510:revLst>
-    <p1510:client id="{281603EB-896B-47D6-9EA3-975A2DE2B083}" v="24" dt="2026-06-30T21:08:31.147"/>
+    <p1510:client id="{EEFF3537-259B-4121-BEBA-A217C3B649A0}" v="10" dt="2026-08-20T18:59:17.783"/>
   </p1510:revLst>
 </p1510:revInfo>
 </file>
@@ -130,98 +131,34 @@
   <pc:docChgLst>
     <pc:chgData name="Nathan, Lucas (DNR)" userId="96837891-6aae-41c1-b905-2f597761f76b" providerId="ADAL" clId="{F64F8652-B73F-49BC-A105-17EA9971C31A}"/>
     <pc:docChg chg="undo custSel addSld delSld modSld">
-      <pc:chgData name="Nathan, Lucas (DNR)" userId="96837891-6aae-41c1-b905-2f597761f76b" providerId="ADAL" clId="{F64F8652-B73F-49BC-A105-17EA9971C31A}" dt="2026-06-30T21:09:57.280" v="590" actId="1076"/>
+      <pc:chgData name="Nathan, Lucas (DNR)" userId="96837891-6aae-41c1-b905-2f597761f76b" providerId="ADAL" clId="{F64F8652-B73F-49BC-A105-17EA9971C31A}" dt="2026-08-20T18:59:51.633" v="655" actId="20577"/>
       <pc:docMkLst>
         <pc:docMk/>
       </pc:docMkLst>
       <pc:sldChg chg="addSp delSp modSp mod">
-        <pc:chgData name="Nathan, Lucas (DNR)" userId="96837891-6aae-41c1-b905-2f597761f76b" providerId="ADAL" clId="{F64F8652-B73F-49BC-A105-17EA9971C31A}" dt="2026-06-30T21:09:57.280" v="590" actId="1076"/>
+        <pc:chgData name="Nathan, Lucas (DNR)" userId="96837891-6aae-41c1-b905-2f597761f76b" providerId="ADAL" clId="{F64F8652-B73F-49BC-A105-17EA9971C31A}" dt="2026-08-20T18:57:28.513" v="618" actId="20577"/>
         <pc:sldMkLst>
           <pc:docMk/>
           <pc:sldMk cId="4018073164" sldId="256"/>
         </pc:sldMkLst>
         <pc:spChg chg="add mod">
-          <ac:chgData name="Nathan, Lucas (DNR)" userId="96837891-6aae-41c1-b905-2f597761f76b" providerId="ADAL" clId="{F64F8652-B73F-49BC-A105-17EA9971C31A}" dt="2026-06-30T21:09:46.431" v="588" actId="1076"/>
+          <ac:chgData name="Nathan, Lucas (DNR)" userId="96837891-6aae-41c1-b905-2f597761f76b" providerId="ADAL" clId="{F64F8652-B73F-49BC-A105-17EA9971C31A}" dt="2026-08-20T18:57:28.513" v="618" actId="20577"/>
           <ac:spMkLst>
             <pc:docMk/>
             <pc:sldMk cId="4018073164" sldId="256"/>
-            <ac:spMk id="7" creationId="{4FE9BE98-0136-BEEC-A5C5-767111FEA440}"/>
-          </ac:spMkLst>
-        </pc:spChg>
-        <pc:spChg chg="mod">
-          <ac:chgData name="Nathan, Lucas (DNR)" userId="96837891-6aae-41c1-b905-2f597761f76b" providerId="ADAL" clId="{F64F8652-B73F-49BC-A105-17EA9971C31A}" dt="2026-06-30T21:09:55.328" v="589" actId="1076"/>
-          <ac:spMkLst>
-            <pc:docMk/>
-            <pc:sldMk cId="4018073164" sldId="256"/>
-            <ac:spMk id="113" creationId="{E4F7837C-465A-CE42-65C5-756BC6581BBA}"/>
-          </ac:spMkLst>
-        </pc:spChg>
-        <pc:spChg chg="mod">
-          <ac:chgData name="Nathan, Lucas (DNR)" userId="96837891-6aae-41c1-b905-2f597761f76b" providerId="ADAL" clId="{F64F8652-B73F-49BC-A105-17EA9971C31A}" dt="2026-06-30T21:09:57.280" v="590" actId="1076"/>
-          <ac:spMkLst>
-            <pc:docMk/>
-            <pc:sldMk cId="4018073164" sldId="256"/>
-            <ac:spMk id="114" creationId="{22A466D5-AAD0-3071-6965-5C1B6750E217}"/>
-          </ac:spMkLst>
-        </pc:spChg>
-        <pc:spChg chg="del">
-          <ac:chgData name="Nathan, Lucas (DNR)" userId="96837891-6aae-41c1-b905-2f597761f76b" providerId="ADAL" clId="{F64F8652-B73F-49BC-A105-17EA9971C31A}" dt="2026-06-29T19:32:11.823" v="14" actId="478"/>
-          <ac:spMkLst>
-            <pc:docMk/>
-            <pc:sldMk cId="4018073164" sldId="256"/>
-            <ac:spMk id="116" creationId="{58981A44-2D30-B03A-40AF-B4D55A7E46A4}"/>
-          </ac:spMkLst>
-        </pc:spChg>
-        <pc:spChg chg="del">
-          <ac:chgData name="Nathan, Lucas (DNR)" userId="96837891-6aae-41c1-b905-2f597761f76b" providerId="ADAL" clId="{F64F8652-B73F-49BC-A105-17EA9971C31A}" dt="2026-06-29T19:32:12.841" v="15" actId="478"/>
-          <ac:spMkLst>
-            <pc:docMk/>
-            <pc:sldMk cId="4018073164" sldId="256"/>
-            <ac:spMk id="117" creationId="{26B2E6BC-1735-4EF8-6CF5-FE1B71D9491D}"/>
+            <ac:spMk id="3" creationId="{C83F8609-4D7A-AA38-F086-9E85B47A8159}"/>
           </ac:spMkLst>
         </pc:spChg>
         <pc:cxnChg chg="add mod">
-          <ac:chgData name="Nathan, Lucas (DNR)" userId="96837891-6aae-41c1-b905-2f597761f76b" providerId="ADAL" clId="{F64F8652-B73F-49BC-A105-17EA9971C31A}" dt="2026-06-30T21:09:57.280" v="590" actId="1076"/>
+          <ac:chgData name="Nathan, Lucas (DNR)" userId="96837891-6aae-41c1-b905-2f597761f76b" providerId="ADAL" clId="{F64F8652-B73F-49BC-A105-17EA9971C31A}" dt="2026-08-20T18:57:20.486" v="596" actId="14100"/>
           <ac:cxnSpMkLst>
             <pc:docMk/>
             <pc:sldMk cId="4018073164" sldId="256"/>
-            <ac:cxnSpMk id="12" creationId="{81A26EC5-D573-533A-BC0E-C461C4C8848C}"/>
+            <ac:cxnSpMk id="6" creationId="{6E5E4102-F999-0B05-BBF4-9FFA54A5074E}"/>
           </ac:cxnSpMkLst>
         </pc:cxnChg>
         <pc:cxnChg chg="mod">
-          <ac:chgData name="Nathan, Lucas (DNR)" userId="96837891-6aae-41c1-b905-2f597761f76b" providerId="ADAL" clId="{F64F8652-B73F-49BC-A105-17EA9971C31A}" dt="2026-06-30T21:09:46.431" v="588" actId="1076"/>
-          <ac:cxnSpMkLst>
-            <pc:docMk/>
-            <pc:sldMk cId="4018073164" sldId="256"/>
-            <ac:cxnSpMk id="119" creationId="{E5FC0A42-AE9F-0B0B-485B-29F8C0298083}"/>
-          </ac:cxnSpMkLst>
-        </pc:cxnChg>
-        <pc:cxnChg chg="del mod">
-          <ac:chgData name="Nathan, Lucas (DNR)" userId="96837891-6aae-41c1-b905-2f597761f76b" providerId="ADAL" clId="{F64F8652-B73F-49BC-A105-17EA9971C31A}" dt="2026-06-29T19:32:14.031" v="16" actId="478"/>
-          <ac:cxnSpMkLst>
-            <pc:docMk/>
-            <pc:sldMk cId="4018073164" sldId="256"/>
-            <ac:cxnSpMk id="124" creationId="{E5109F92-7FEE-64A0-E5A1-96C05482E3D8}"/>
-          </ac:cxnSpMkLst>
-        </pc:cxnChg>
-        <pc:cxnChg chg="mod">
-          <ac:chgData name="Nathan, Lucas (DNR)" userId="96837891-6aae-41c1-b905-2f597761f76b" providerId="ADAL" clId="{F64F8652-B73F-49BC-A105-17EA9971C31A}" dt="2026-06-30T21:09:57.280" v="590" actId="1076"/>
-          <ac:cxnSpMkLst>
-            <pc:docMk/>
-            <pc:sldMk cId="4018073164" sldId="256"/>
-            <ac:cxnSpMk id="127" creationId="{4523B275-7E03-2157-6D4C-DDEFFA1D55B1}"/>
-          </ac:cxnSpMkLst>
-        </pc:cxnChg>
-        <pc:cxnChg chg="mod">
-          <ac:chgData name="Nathan, Lucas (DNR)" userId="96837891-6aae-41c1-b905-2f597761f76b" providerId="ADAL" clId="{F64F8652-B73F-49BC-A105-17EA9971C31A}" dt="2026-06-30T21:09:57.280" v="590" actId="1076"/>
-          <ac:cxnSpMkLst>
-            <pc:docMk/>
-            <pc:sldMk cId="4018073164" sldId="256"/>
-            <ac:cxnSpMk id="137" creationId="{72489654-A647-3A7F-4431-D5E48C7D81F8}"/>
-          </ac:cxnSpMkLst>
-        </pc:cxnChg>
-        <pc:cxnChg chg="mod">
-          <ac:chgData name="Nathan, Lucas (DNR)" userId="96837891-6aae-41c1-b905-2f597761f76b" providerId="ADAL" clId="{F64F8652-B73F-49BC-A105-17EA9971C31A}" dt="2026-06-30T21:09:57.280" v="590" actId="1076"/>
+          <ac:chgData name="Nathan, Lucas (DNR)" userId="96837891-6aae-41c1-b905-2f597761f76b" providerId="ADAL" clId="{F64F8652-B73F-49BC-A105-17EA9971C31A}" dt="2026-08-20T18:57:14.805" v="593" actId="14100"/>
           <ac:cxnSpMkLst>
             <pc:docMk/>
             <pc:sldMk cId="4018073164" sldId="256"/>
@@ -229,612 +166,118 @@
           </ac:cxnSpMkLst>
         </pc:cxnChg>
       </pc:sldChg>
-      <pc:sldChg chg="del">
-        <pc:chgData name="Nathan, Lucas (DNR)" userId="96837891-6aae-41c1-b905-2f597761f76b" providerId="ADAL" clId="{F64F8652-B73F-49BC-A105-17EA9971C31A}" dt="2026-06-29T19:32:32.280" v="21" actId="47"/>
-        <pc:sldMkLst>
-          <pc:docMk/>
-          <pc:sldMk cId="3617245666" sldId="257"/>
-        </pc:sldMkLst>
-      </pc:sldChg>
-      <pc:sldChg chg="addSp delSp modSp mod">
-        <pc:chgData name="Nathan, Lucas (DNR)" userId="96837891-6aae-41c1-b905-2f597761f76b" providerId="ADAL" clId="{F64F8652-B73F-49BC-A105-17EA9971C31A}" dt="2026-06-30T21:08:28.867" v="556"/>
+      <pc:sldChg chg="modSp">
+        <pc:chgData name="Nathan, Lucas (DNR)" userId="96837891-6aae-41c1-b905-2f597761f76b" providerId="ADAL" clId="{F64F8652-B73F-49BC-A105-17EA9971C31A}" dt="2026-08-20T18:59:17.783" v="653"/>
         <pc:sldMkLst>
           <pc:docMk/>
           <pc:sldMk cId="3824178543" sldId="258"/>
         </pc:sldMkLst>
         <pc:spChg chg="mod">
-          <ac:chgData name="Nathan, Lucas (DNR)" userId="96837891-6aae-41c1-b905-2f597761f76b" providerId="ADAL" clId="{F64F8652-B73F-49BC-A105-17EA9971C31A}" dt="2026-06-30T21:06:53.492" v="539" actId="1076"/>
+          <ac:chgData name="Nathan, Lucas (DNR)" userId="96837891-6aae-41c1-b905-2f597761f76b" providerId="ADAL" clId="{F64F8652-B73F-49BC-A105-17EA9971C31A}" dt="2026-08-20T18:59:17.783" v="653"/>
           <ac:spMkLst>
             <pc:docMk/>
             <pc:sldMk cId="3824178543" sldId="258"/>
-            <ac:spMk id="7" creationId="{738DB486-0B48-9129-FA57-EE80E82478D3}"/>
+            <ac:spMk id="2" creationId="{1036EC3D-1D78-C254-2687-3311AA086CE2}"/>
           </ac:spMkLst>
         </pc:spChg>
-        <pc:spChg chg="add mod">
-          <ac:chgData name="Nathan, Lucas (DNR)" userId="96837891-6aae-41c1-b905-2f597761f76b" providerId="ADAL" clId="{F64F8652-B73F-49BC-A105-17EA9971C31A}" dt="2026-06-30T21:07:41.806" v="545" actId="1076"/>
-          <ac:spMkLst>
-            <pc:docMk/>
-            <pc:sldMk cId="3824178543" sldId="258"/>
-            <ac:spMk id="11" creationId="{3B9536FD-AA33-FD98-4295-D67D0C0CA61A}"/>
-          </ac:spMkLst>
-        </pc:spChg>
-        <pc:spChg chg="mod">
-          <ac:chgData name="Nathan, Lucas (DNR)" userId="96837891-6aae-41c1-b905-2f597761f76b" providerId="ADAL" clId="{F64F8652-B73F-49BC-A105-17EA9971C31A}" dt="2026-06-30T21:07:11.467" v="542" actId="1076"/>
-          <ac:spMkLst>
-            <pc:docMk/>
-            <pc:sldMk cId="3824178543" sldId="258"/>
-            <ac:spMk id="25" creationId="{2B178FF1-30AE-DFFC-19AF-E9CF6A50FC41}"/>
-          </ac:spMkLst>
-        </pc:spChg>
-        <pc:cxnChg chg="add mod">
-          <ac:chgData name="Nathan, Lucas (DNR)" userId="96837891-6aae-41c1-b905-2f597761f76b" providerId="ADAL" clId="{F64F8652-B73F-49BC-A105-17EA9971C31A}" dt="2026-06-30T21:07:55.766" v="550" actId="14100"/>
-          <ac:cxnSpMkLst>
-            <pc:docMk/>
-            <pc:sldMk cId="3824178543" sldId="258"/>
-            <ac:cxnSpMk id="12" creationId="{C9DB5F63-3404-5507-1BB5-58E79FE00B0A}"/>
-          </ac:cxnSpMkLst>
-        </pc:cxnChg>
-        <pc:cxnChg chg="add mod">
-          <ac:chgData name="Nathan, Lucas (DNR)" userId="96837891-6aae-41c1-b905-2f597761f76b" providerId="ADAL" clId="{F64F8652-B73F-49BC-A105-17EA9971C31A}" dt="2026-06-30T21:08:07.119" v="555" actId="14100"/>
-          <ac:cxnSpMkLst>
-            <pc:docMk/>
-            <pc:sldMk cId="3824178543" sldId="258"/>
-            <ac:cxnSpMk id="17" creationId="{88DF40E1-B77B-B4EE-4069-0D3CE97B51F1}"/>
-          </ac:cxnSpMkLst>
-        </pc:cxnChg>
-        <pc:cxnChg chg="add mod">
-          <ac:chgData name="Nathan, Lucas (DNR)" userId="96837891-6aae-41c1-b905-2f597761f76b" providerId="ADAL" clId="{F64F8652-B73F-49BC-A105-17EA9971C31A}" dt="2026-06-30T21:08:28.867" v="556"/>
-          <ac:cxnSpMkLst>
-            <pc:docMk/>
-            <pc:sldMk cId="3824178543" sldId="258"/>
-            <ac:cxnSpMk id="22" creationId="{9E4C5AF1-BAF3-4C51-05A7-DFC08269082B}"/>
-          </ac:cxnSpMkLst>
-        </pc:cxnChg>
-        <pc:cxnChg chg="mod">
-          <ac:chgData name="Nathan, Lucas (DNR)" userId="96837891-6aae-41c1-b905-2f597761f76b" providerId="ADAL" clId="{F64F8652-B73F-49BC-A105-17EA9971C31A}" dt="2026-06-30T21:07:11.467" v="542" actId="1076"/>
-          <ac:cxnSpMkLst>
-            <pc:docMk/>
-            <pc:sldMk cId="3824178543" sldId="258"/>
-            <ac:cxnSpMk id="26" creationId="{A30920DD-6278-7159-0D80-291D8AE9D9B4}"/>
-          </ac:cxnSpMkLst>
-        </pc:cxnChg>
-        <pc:cxnChg chg="del mod">
-          <ac:chgData name="Nathan, Lucas (DNR)" userId="96837891-6aae-41c1-b905-2f597761f76b" providerId="ADAL" clId="{F64F8652-B73F-49BC-A105-17EA9971C31A}" dt="2026-06-30T21:07:12.990" v="543" actId="478"/>
-          <ac:cxnSpMkLst>
-            <pc:docMk/>
-            <pc:sldMk cId="3824178543" sldId="258"/>
-            <ac:cxnSpMk id="75" creationId="{810FB7AB-C868-17B9-B8D5-568B70158A7B}"/>
-          </ac:cxnSpMkLst>
-        </pc:cxnChg>
-        <pc:cxnChg chg="mod">
-          <ac:chgData name="Nathan, Lucas (DNR)" userId="96837891-6aae-41c1-b905-2f597761f76b" providerId="ADAL" clId="{F64F8652-B73F-49BC-A105-17EA9971C31A}" dt="2026-06-30T21:07:50.911" v="547" actId="1076"/>
-          <ac:cxnSpMkLst>
-            <pc:docMk/>
-            <pc:sldMk cId="3824178543" sldId="258"/>
-            <ac:cxnSpMk id="93" creationId="{BC67D152-E33D-B84F-C18B-FB954C82EA71}"/>
-          </ac:cxnSpMkLst>
-        </pc:cxnChg>
       </pc:sldChg>
-      <pc:sldChg chg="addSp delSp modSp mod">
-        <pc:chgData name="Nathan, Lucas (DNR)" userId="96837891-6aae-41c1-b905-2f597761f76b" providerId="ADAL" clId="{F64F8652-B73F-49BC-A105-17EA9971C31A}" dt="2026-06-30T15:03:23.791" v="532" actId="478"/>
-        <pc:sldMkLst>
-          <pc:docMk/>
-          <pc:sldMk cId="736430854" sldId="259"/>
-        </pc:sldMkLst>
-        <pc:spChg chg="mod">
-          <ac:chgData name="Nathan, Lucas (DNR)" userId="96837891-6aae-41c1-b905-2f597761f76b" providerId="ADAL" clId="{F64F8652-B73F-49BC-A105-17EA9971C31A}" dt="2026-06-25T16:01:18.150" v="6" actId="1076"/>
-          <ac:spMkLst>
-            <pc:docMk/>
-            <pc:sldMk cId="736430854" sldId="259"/>
-            <ac:spMk id="9" creationId="{4DE46BED-CCB7-ED12-76E6-987DDCF23BB5}"/>
-          </ac:spMkLst>
-        </pc:spChg>
-        <pc:spChg chg="add mod">
-          <ac:chgData name="Nathan, Lucas (DNR)" userId="96837891-6aae-41c1-b905-2f597761f76b" providerId="ADAL" clId="{F64F8652-B73F-49BC-A105-17EA9971C31A}" dt="2026-06-30T15:00:50.293" v="321" actId="1076"/>
-          <ac:spMkLst>
-            <pc:docMk/>
-            <pc:sldMk cId="736430854" sldId="259"/>
-            <ac:spMk id="22" creationId="{94A251C3-E18A-1F32-94AA-9C10E78A9CC8}"/>
-          </ac:spMkLst>
-        </pc:spChg>
-        <pc:spChg chg="add del mod">
-          <ac:chgData name="Nathan, Lucas (DNR)" userId="96837891-6aae-41c1-b905-2f597761f76b" providerId="ADAL" clId="{F64F8652-B73F-49BC-A105-17EA9971C31A}" dt="2026-06-30T15:03:23.791" v="532" actId="478"/>
-          <ac:spMkLst>
-            <pc:docMk/>
-            <pc:sldMk cId="736430854" sldId="259"/>
-            <ac:spMk id="26" creationId="{02F666D8-2D64-87AF-F713-CF297F963AE6}"/>
-          </ac:spMkLst>
-        </pc:spChg>
-        <pc:spChg chg="mod">
-          <ac:chgData name="Nathan, Lucas (DNR)" userId="96837891-6aae-41c1-b905-2f597761f76b" providerId="ADAL" clId="{F64F8652-B73F-49BC-A105-17EA9971C31A}" dt="2026-06-25T16:01:23.717" v="9" actId="1076"/>
-          <ac:spMkLst>
-            <pc:docMk/>
-            <pc:sldMk cId="736430854" sldId="259"/>
-            <ac:spMk id="36" creationId="{F232C6D4-D313-5CF3-FB0F-E1501BDC93CD}"/>
-          </ac:spMkLst>
-        </pc:spChg>
-        <pc:spChg chg="mod">
-          <ac:chgData name="Nathan, Lucas (DNR)" userId="96837891-6aae-41c1-b905-2f597761f76b" providerId="ADAL" clId="{F64F8652-B73F-49BC-A105-17EA9971C31A}" dt="2026-06-30T15:00:13.943" v="316" actId="1076"/>
-          <ac:spMkLst>
-            <pc:docMk/>
-            <pc:sldMk cId="736430854" sldId="259"/>
-            <ac:spMk id="55" creationId="{E5F2DEB9-D5FF-822A-EC32-801F1E718A91}"/>
-          </ac:spMkLst>
-        </pc:spChg>
-        <pc:spChg chg="mod">
-          <ac:chgData name="Nathan, Lucas (DNR)" userId="96837891-6aae-41c1-b905-2f597761f76b" providerId="ADAL" clId="{F64F8652-B73F-49BC-A105-17EA9971C31A}" dt="2026-06-30T15:00:15.453" v="317" actId="1076"/>
-          <ac:spMkLst>
-            <pc:docMk/>
-            <pc:sldMk cId="736430854" sldId="259"/>
-            <ac:spMk id="56" creationId="{804BC60D-A7DB-B0DC-873E-C88966E8B6E5}"/>
-          </ac:spMkLst>
-        </pc:spChg>
-        <pc:spChg chg="mod">
-          <ac:chgData name="Nathan, Lucas (DNR)" userId="96837891-6aae-41c1-b905-2f597761f76b" providerId="ADAL" clId="{F64F8652-B73F-49BC-A105-17EA9971C31A}" dt="2026-06-30T15:00:19.360" v="319" actId="1076"/>
-          <ac:spMkLst>
-            <pc:docMk/>
-            <pc:sldMk cId="736430854" sldId="259"/>
-            <ac:spMk id="57" creationId="{9E41CA45-5A62-0DC2-D3E3-DB5565A92737}"/>
-          </ac:spMkLst>
-        </pc:spChg>
-        <pc:cxnChg chg="add mod">
-          <ac:chgData name="Nathan, Lucas (DNR)" userId="96837891-6aae-41c1-b905-2f597761f76b" providerId="ADAL" clId="{F64F8652-B73F-49BC-A105-17EA9971C31A}" dt="2026-06-30T15:00:56.981" v="324" actId="14100"/>
-          <ac:cxnSpMkLst>
-            <pc:docMk/>
-            <pc:sldMk cId="736430854" sldId="259"/>
-            <ac:cxnSpMk id="23" creationId="{8B2C970B-DFB2-ABD9-17B5-8C09DD3A1C63}"/>
-          </ac:cxnSpMkLst>
-        </pc:cxnChg>
-        <pc:cxnChg chg="mod">
-          <ac:chgData name="Nathan, Lucas (DNR)" userId="96837891-6aae-41c1-b905-2f597761f76b" providerId="ADAL" clId="{F64F8652-B73F-49BC-A105-17EA9971C31A}" dt="2026-06-25T16:01:23.717" v="9" actId="1076"/>
-          <ac:cxnSpMkLst>
-            <pc:docMk/>
-            <pc:sldMk cId="736430854" sldId="259"/>
-            <ac:cxnSpMk id="33" creationId="{5ACF0083-16C2-F0F9-A827-FF66098563B1}"/>
-          </ac:cxnSpMkLst>
-        </pc:cxnChg>
-        <pc:cxnChg chg="mod">
-          <ac:chgData name="Nathan, Lucas (DNR)" userId="96837891-6aae-41c1-b905-2f597761f76b" providerId="ADAL" clId="{F64F8652-B73F-49BC-A105-17EA9971C31A}" dt="2026-06-25T16:01:18.150" v="6" actId="1076"/>
-          <ac:cxnSpMkLst>
-            <pc:docMk/>
-            <pc:sldMk cId="736430854" sldId="259"/>
-            <ac:cxnSpMk id="47" creationId="{C469FA14-2E55-6586-C5EF-5368C0DF10FC}"/>
-          </ac:cxnSpMkLst>
-        </pc:cxnChg>
-        <pc:cxnChg chg="mod">
-          <ac:chgData name="Nathan, Lucas (DNR)" userId="96837891-6aae-41c1-b905-2f597761f76b" providerId="ADAL" clId="{F64F8652-B73F-49BC-A105-17EA9971C31A}" dt="2026-06-30T15:00:13.943" v="316" actId="1076"/>
-          <ac:cxnSpMkLst>
-            <pc:docMk/>
-            <pc:sldMk cId="736430854" sldId="259"/>
-            <ac:cxnSpMk id="60" creationId="{1AEE35A2-74F7-EC18-C0F9-6FA2948E2BD5}"/>
-          </ac:cxnSpMkLst>
-        </pc:cxnChg>
-        <pc:cxnChg chg="mod">
-          <ac:chgData name="Nathan, Lucas (DNR)" userId="96837891-6aae-41c1-b905-2f597761f76b" providerId="ADAL" clId="{F64F8652-B73F-49BC-A105-17EA9971C31A}" dt="2026-06-30T15:00:15.453" v="317" actId="1076"/>
-          <ac:cxnSpMkLst>
-            <pc:docMk/>
-            <pc:sldMk cId="736430854" sldId="259"/>
-            <ac:cxnSpMk id="64" creationId="{1DFF9741-0F70-B9A9-9AEB-498E31BECBF6}"/>
-          </ac:cxnSpMkLst>
-        </pc:cxnChg>
-        <pc:cxnChg chg="mod">
-          <ac:chgData name="Nathan, Lucas (DNR)" userId="96837891-6aae-41c1-b905-2f597761f76b" providerId="ADAL" clId="{F64F8652-B73F-49BC-A105-17EA9971C31A}" dt="2026-06-30T15:00:19.360" v="319" actId="1076"/>
-          <ac:cxnSpMkLst>
-            <pc:docMk/>
-            <pc:sldMk cId="736430854" sldId="259"/>
-            <ac:cxnSpMk id="97" creationId="{F71000F1-93EA-247E-8A84-87318AB40F95}"/>
-          </ac:cxnSpMkLst>
-        </pc:cxnChg>
-      </pc:sldChg>
-      <pc:sldChg chg="addSp delSp modSp mod">
-        <pc:chgData name="Nathan, Lucas (DNR)" userId="96837891-6aae-41c1-b905-2f597761f76b" providerId="ADAL" clId="{F64F8652-B73F-49BC-A105-17EA9971C31A}" dt="2026-06-30T15:05:28.855" v="533" actId="478"/>
+      <pc:sldChg chg="modSp">
+        <pc:chgData name="Nathan, Lucas (DNR)" userId="96837891-6aae-41c1-b905-2f597761f76b" providerId="ADAL" clId="{F64F8652-B73F-49BC-A105-17EA9971C31A}" dt="2026-08-20T18:59:01.779" v="651"/>
         <pc:sldMkLst>
           <pc:docMk/>
           <pc:sldMk cId="3322492765" sldId="261"/>
         </pc:sldMkLst>
-        <pc:spChg chg="add del">
-          <ac:chgData name="Nathan, Lucas (DNR)" userId="96837891-6aae-41c1-b905-2f597761f76b" providerId="ADAL" clId="{F64F8652-B73F-49BC-A105-17EA9971C31A}" dt="2026-06-29T19:33:48.409" v="39" actId="478"/>
-          <ac:spMkLst>
-            <pc:docMk/>
-            <pc:sldMk cId="3322492765" sldId="261"/>
-            <ac:spMk id="2" creationId="{9724142F-D601-8CD2-2C17-A9A6925DF763}"/>
-          </ac:spMkLst>
-        </pc:spChg>
         <pc:spChg chg="mod">
-          <ac:chgData name="Nathan, Lucas (DNR)" userId="96837891-6aae-41c1-b905-2f597761f76b" providerId="ADAL" clId="{F64F8652-B73F-49BC-A105-17EA9971C31A}" dt="2026-06-29T20:39:45.866" v="185" actId="20577"/>
-          <ac:spMkLst>
-            <pc:docMk/>
-            <pc:sldMk cId="3322492765" sldId="261"/>
-            <ac:spMk id="4" creationId="{1BAD97C7-DEBE-62C8-60F1-6A62E416FEB8}"/>
-          </ac:spMkLst>
-        </pc:spChg>
-        <pc:spChg chg="mod">
-          <ac:chgData name="Nathan, Lucas (DNR)" userId="96837891-6aae-41c1-b905-2f597761f76b" providerId="ADAL" clId="{F64F8652-B73F-49BC-A105-17EA9971C31A}" dt="2026-06-29T19:33:44.604" v="33" actId="1076"/>
-          <ac:spMkLst>
-            <pc:docMk/>
-            <pc:sldMk cId="3322492765" sldId="261"/>
-            <ac:spMk id="7" creationId="{3F27521D-007A-864A-7E95-FF49BA411BA1}"/>
-          </ac:spMkLst>
-        </pc:spChg>
-        <pc:spChg chg="add mod">
-          <ac:chgData name="Nathan, Lucas (DNR)" userId="96837891-6aae-41c1-b905-2f597761f76b" providerId="ADAL" clId="{F64F8652-B73F-49BC-A105-17EA9971C31A}" dt="2026-06-29T19:35:35.592" v="147" actId="20577"/>
-          <ac:spMkLst>
-            <pc:docMk/>
-            <pc:sldMk cId="3322492765" sldId="261"/>
-            <ac:spMk id="11" creationId="{874FE0CA-DA94-0BB5-C081-880419EACCCE}"/>
-          </ac:spMkLst>
-        </pc:spChg>
-        <pc:spChg chg="add mod">
-          <ac:chgData name="Nathan, Lucas (DNR)" userId="96837891-6aae-41c1-b905-2f597761f76b" providerId="ADAL" clId="{F64F8652-B73F-49BC-A105-17EA9971C31A}" dt="2026-06-29T20:40:43.330" v="217" actId="11530"/>
-          <ac:spMkLst>
-            <pc:docMk/>
-            <pc:sldMk cId="3322492765" sldId="261"/>
-            <ac:spMk id="12" creationId="{9B493B7F-5FB2-67D1-E903-204D47D7C3BD}"/>
-          </ac:spMkLst>
-        </pc:spChg>
-        <pc:spChg chg="mod">
-          <ac:chgData name="Nathan, Lucas (DNR)" userId="96837891-6aae-41c1-b905-2f597761f76b" providerId="ADAL" clId="{F64F8652-B73F-49BC-A105-17EA9971C31A}" dt="2026-06-29T20:40:22.121" v="212" actId="115"/>
-          <ac:spMkLst>
-            <pc:docMk/>
-            <pc:sldMk cId="3322492765" sldId="261"/>
-            <ac:spMk id="13" creationId="{5FE2401A-BFFA-29AA-CEDE-7C96C5964533}"/>
-          </ac:spMkLst>
-        </pc:spChg>
-        <pc:spChg chg="add mod">
-          <ac:chgData name="Nathan, Lucas (DNR)" userId="96837891-6aae-41c1-b905-2f597761f76b" providerId="ADAL" clId="{F64F8652-B73F-49BC-A105-17EA9971C31A}" dt="2026-06-29T20:41:22.294" v="223" actId="1076"/>
-          <ac:spMkLst>
-            <pc:docMk/>
-            <pc:sldMk cId="3322492765" sldId="261"/>
-            <ac:spMk id="19" creationId="{A88200D1-2FA7-C9BB-C320-3AD2B05F0804}"/>
-          </ac:spMkLst>
-        </pc:spChg>
-        <pc:spChg chg="add del mod">
-          <ac:chgData name="Nathan, Lucas (DNR)" userId="96837891-6aae-41c1-b905-2f597761f76b" providerId="ADAL" clId="{F64F8652-B73F-49BC-A105-17EA9971C31A}" dt="2026-06-30T15:05:28.855" v="533" actId="478"/>
-          <ac:spMkLst>
-            <pc:docMk/>
-            <pc:sldMk cId="3322492765" sldId="261"/>
-            <ac:spMk id="24" creationId="{4745DB2B-329F-010A-51F8-365B963F646F}"/>
-          </ac:spMkLst>
-        </pc:spChg>
-        <pc:spChg chg="del">
-          <ac:chgData name="Nathan, Lucas (DNR)" userId="96837891-6aae-41c1-b905-2f597761f76b" providerId="ADAL" clId="{F64F8652-B73F-49BC-A105-17EA9971C31A}" dt="2026-06-29T19:36:00.892" v="148" actId="478"/>
-          <ac:spMkLst>
-            <pc:docMk/>
-            <pc:sldMk cId="3322492765" sldId="261"/>
-            <ac:spMk id="25" creationId="{3E2605F5-6924-AB68-E547-F0544AEF2C11}"/>
-          </ac:spMkLst>
-        </pc:spChg>
-        <pc:spChg chg="mod">
-          <ac:chgData name="Nathan, Lucas (DNR)" userId="96837891-6aae-41c1-b905-2f597761f76b" providerId="ADAL" clId="{F64F8652-B73F-49BC-A105-17EA9971C31A}" dt="2026-06-29T19:34:44.859" v="41" actId="115"/>
+          <ac:chgData name="Nathan, Lucas (DNR)" userId="96837891-6aae-41c1-b905-2f597761f76b" providerId="ADAL" clId="{F64F8652-B73F-49BC-A105-17EA9971C31A}" dt="2026-08-20T18:59:01.779" v="651"/>
           <ac:spMkLst>
             <pc:docMk/>
             <pc:sldMk cId="3322492765" sldId="261"/>
             <ac:spMk id="74" creationId="{8794BFCB-0CD3-D62F-28BE-79835CCFE93C}"/>
           </ac:spMkLst>
         </pc:spChg>
-        <pc:spChg chg="add del">
-          <ac:chgData name="Nathan, Lucas (DNR)" userId="96837891-6aae-41c1-b905-2f597761f76b" providerId="ADAL" clId="{F64F8652-B73F-49BC-A105-17EA9971C31A}" dt="2026-06-29T19:33:47.881" v="38" actId="478"/>
+      </pc:sldChg>
+      <pc:sldChg chg="new del">
+        <pc:chgData name="Nathan, Lucas (DNR)" userId="96837891-6aae-41c1-b905-2f597761f76b" providerId="ADAL" clId="{F64F8652-B73F-49BC-A105-17EA9971C31A}" dt="2026-08-20T18:57:47.114" v="621" actId="47"/>
+        <pc:sldMkLst>
+          <pc:docMk/>
+          <pc:sldMk cId="1830833992" sldId="265"/>
+        </pc:sldMkLst>
+      </pc:sldChg>
+      <pc:sldChg chg="modSp add del mod">
+        <pc:chgData name="Nathan, Lucas (DNR)" userId="96837891-6aae-41c1-b905-2f597761f76b" providerId="ADAL" clId="{F64F8652-B73F-49BC-A105-17EA9971C31A}" dt="2026-08-20T18:58:25.079" v="644" actId="47"/>
+        <pc:sldMkLst>
+          <pc:docMk/>
+          <pc:sldMk cId="3682069085" sldId="266"/>
+        </pc:sldMkLst>
+        <pc:spChg chg="mod">
+          <ac:chgData name="Nathan, Lucas (DNR)" userId="96837891-6aae-41c1-b905-2f597761f76b" providerId="ADAL" clId="{F64F8652-B73F-49BC-A105-17EA9971C31A}" dt="2026-08-20T18:57:57.334" v="641" actId="20577"/>
           <ac:spMkLst>
             <pc:docMk/>
-            <pc:sldMk cId="3322492765" sldId="261"/>
-            <ac:spMk id="89" creationId="{EA9AA6C2-F859-B3D3-D675-965CE58843B8}"/>
+            <pc:sldMk cId="3682069085" sldId="266"/>
+            <ac:spMk id="4" creationId="{08866912-E5BA-9807-9452-B225735480EE}"/>
           </ac:spMkLst>
         </pc:spChg>
-        <pc:cxnChg chg="mod">
-          <ac:chgData name="Nathan, Lucas (DNR)" userId="96837891-6aae-41c1-b905-2f597761f76b" providerId="ADAL" clId="{F64F8652-B73F-49BC-A105-17EA9971C31A}" dt="2026-06-29T19:33:44.604" v="33" actId="1076"/>
+      </pc:sldChg>
+      <pc:sldChg chg="delSp modSp add mod">
+        <pc:chgData name="Nathan, Lucas (DNR)" userId="96837891-6aae-41c1-b905-2f597761f76b" providerId="ADAL" clId="{F64F8652-B73F-49BC-A105-17EA9971C31A}" dt="2026-08-20T18:59:51.633" v="655" actId="20577"/>
+        <pc:sldMkLst>
+          <pc:docMk/>
+          <pc:sldMk cId="1454144528" sldId="267"/>
+        </pc:sldMkLst>
+        <pc:spChg chg="mod">
+          <ac:chgData name="Nathan, Lucas (DNR)" userId="96837891-6aae-41c1-b905-2f597761f76b" providerId="ADAL" clId="{F64F8652-B73F-49BC-A105-17EA9971C31A}" dt="2026-08-20T18:59:51.633" v="655" actId="20577"/>
+          <ac:spMkLst>
+            <pc:docMk/>
+            <pc:sldMk cId="1454144528" sldId="267"/>
+            <ac:spMk id="4" creationId="{94F933C4-A647-0DA0-5236-83D00C7AC93A}"/>
+          </ac:spMkLst>
+        </pc:spChg>
+        <pc:spChg chg="del">
+          <ac:chgData name="Nathan, Lucas (DNR)" userId="96837891-6aae-41c1-b905-2f597761f76b" providerId="ADAL" clId="{F64F8652-B73F-49BC-A105-17EA9971C31A}" dt="2026-08-20T18:58:26.814" v="645" actId="478"/>
+          <ac:spMkLst>
+            <pc:docMk/>
+            <pc:sldMk cId="1454144528" sldId="267"/>
+            <ac:spMk id="5" creationId="{6A356268-4562-647A-FBBC-74631ADD2549}"/>
+          </ac:spMkLst>
+        </pc:spChg>
+        <pc:spChg chg="del">
+          <ac:chgData name="Nathan, Lucas (DNR)" userId="96837891-6aae-41c1-b905-2f597761f76b" providerId="ADAL" clId="{F64F8652-B73F-49BC-A105-17EA9971C31A}" dt="2026-08-20T18:58:29.974" v="648" actId="478"/>
+          <ac:spMkLst>
+            <pc:docMk/>
+            <pc:sldMk cId="1454144528" sldId="267"/>
+            <ac:spMk id="12" creationId="{D1C4419D-EE87-1A4A-6F47-B3A5BF0A523B}"/>
+          </ac:spMkLst>
+        </pc:spChg>
+        <pc:spChg chg="mod">
+          <ac:chgData name="Nathan, Lucas (DNR)" userId="96837891-6aae-41c1-b905-2f597761f76b" providerId="ADAL" clId="{F64F8652-B73F-49BC-A105-17EA9971C31A}" dt="2026-08-20T18:58:57.064" v="650"/>
+          <ac:spMkLst>
+            <pc:docMk/>
+            <pc:sldMk cId="1454144528" sldId="267"/>
+            <ac:spMk id="74" creationId="{2FA0CD76-DB46-C196-D4C5-340484EE2E9D}"/>
+          </ac:spMkLst>
+        </pc:spChg>
+        <pc:cxnChg chg="del mod">
+          <ac:chgData name="Nathan, Lucas (DNR)" userId="96837891-6aae-41c1-b905-2f597761f76b" providerId="ADAL" clId="{F64F8652-B73F-49BC-A105-17EA9971C31A}" dt="2026-08-20T18:58:27.734" v="646" actId="478"/>
           <ac:cxnSpMkLst>
             <pc:docMk/>
-            <pc:sldMk cId="3322492765" sldId="261"/>
-            <ac:cxnSpMk id="8" creationId="{D76D930F-8B45-04E7-7E3E-4D5961526237}"/>
-          </ac:cxnSpMkLst>
-        </pc:cxnChg>
-        <pc:cxnChg chg="add del mod">
-          <ac:chgData name="Nathan, Lucas (DNR)" userId="96837891-6aae-41c1-b905-2f597761f76b" providerId="ADAL" clId="{F64F8652-B73F-49BC-A105-17EA9971C31A}" dt="2026-06-29T20:57:35.549" v="276"/>
-          <ac:cxnSpMkLst>
-            <pc:docMk/>
-            <pc:sldMk cId="3322492765" sldId="261"/>
-            <ac:cxnSpMk id="14" creationId="{DD218F72-E8C3-F972-2248-BA6FD2FDE5EA}"/>
-          </ac:cxnSpMkLst>
-        </pc:cxnChg>
-        <pc:cxnChg chg="add mod">
-          <ac:chgData name="Nathan, Lucas (DNR)" userId="96837891-6aae-41c1-b905-2f597761f76b" providerId="ADAL" clId="{F64F8652-B73F-49BC-A105-17EA9971C31A}" dt="2026-06-29T20:57:41.062" v="277"/>
-          <ac:cxnSpMkLst>
-            <pc:docMk/>
-            <pc:sldMk cId="3322492765" sldId="261"/>
-            <ac:cxnSpMk id="15" creationId="{53AE46C1-1B8D-7C20-EF65-D20C1F3846E8}"/>
-          </ac:cxnSpMkLst>
-        </pc:cxnChg>
-        <pc:cxnChg chg="add mod">
-          <ac:chgData name="Nathan, Lucas (DNR)" userId="96837891-6aae-41c1-b905-2f597761f76b" providerId="ADAL" clId="{F64F8652-B73F-49BC-A105-17EA9971C31A}" dt="2026-06-29T20:41:22.294" v="223" actId="1076"/>
-          <ac:cxnSpMkLst>
-            <pc:docMk/>
-            <pc:sldMk cId="3322492765" sldId="261"/>
-            <ac:cxnSpMk id="20" creationId="{AC5B9D03-0DB8-6CB3-CA9F-3201452C90FD}"/>
+            <pc:sldMk cId="1454144528" sldId="267"/>
+            <ac:cxnSpMk id="8" creationId="{3830FE5E-72A3-EF3A-2CD6-3F4A83B03528}"/>
           </ac:cxnSpMkLst>
         </pc:cxnChg>
         <pc:cxnChg chg="del mod">
-          <ac:chgData name="Nathan, Lucas (DNR)" userId="96837891-6aae-41c1-b905-2f597761f76b" providerId="ADAL" clId="{F64F8652-B73F-49BC-A105-17EA9971C31A}" dt="2026-06-29T19:36:01.452" v="149" actId="478"/>
+          <ac:chgData name="Nathan, Lucas (DNR)" userId="96837891-6aae-41c1-b905-2f597761f76b" providerId="ADAL" clId="{F64F8652-B73F-49BC-A105-17EA9971C31A}" dt="2026-08-20T18:58:28.324" v="647" actId="478"/>
           <ac:cxnSpMkLst>
             <pc:docMk/>
-            <pc:sldMk cId="3322492765" sldId="261"/>
-            <ac:cxnSpMk id="26" creationId="{9584F975-E590-4D1D-53B1-AABC90A93150}"/>
-          </ac:cxnSpMkLst>
-        </pc:cxnChg>
-        <pc:cxnChg chg="mod">
-          <ac:chgData name="Nathan, Lucas (DNR)" userId="96837891-6aae-41c1-b905-2f597761f76b" providerId="ADAL" clId="{F64F8652-B73F-49BC-A105-17EA9971C31A}" dt="2026-06-29T19:33:44.604" v="33" actId="1076"/>
-          <ac:cxnSpMkLst>
-            <pc:docMk/>
-            <pc:sldMk cId="3322492765" sldId="261"/>
-            <ac:cxnSpMk id="41" creationId="{A3380EF5-361B-BA11-7E5B-5EC9E6DA518F}"/>
-          </ac:cxnSpMkLst>
-        </pc:cxnChg>
-        <pc:cxnChg chg="add del mod">
-          <ac:chgData name="Nathan, Lucas (DNR)" userId="96837891-6aae-41c1-b905-2f597761f76b" providerId="ADAL" clId="{F64F8652-B73F-49BC-A105-17EA9971C31A}" dt="2026-06-29T19:33:45.455" v="35" actId="478"/>
-          <ac:cxnSpMkLst>
-            <pc:docMk/>
-            <pc:sldMk cId="3322492765" sldId="261"/>
-            <ac:cxnSpMk id="44" creationId="{E696C7E1-B2EC-C3E2-55C6-DBF02B4CAABA}"/>
+            <pc:sldMk cId="1454144528" sldId="267"/>
+            <ac:cxnSpMk id="14" creationId="{1D86613C-B5CD-789F-B350-CB022CFB9AAC}"/>
           </ac:cxnSpMkLst>
         </pc:cxnChg>
         <pc:cxnChg chg="del mod">
-          <ac:chgData name="Nathan, Lucas (DNR)" userId="96837891-6aae-41c1-b905-2f597761f76b" providerId="ADAL" clId="{F64F8652-B73F-49BC-A105-17EA9971C31A}" dt="2026-06-29T19:34:50.011" v="42" actId="478"/>
+          <ac:chgData name="Nathan, Lucas (DNR)" userId="96837891-6aae-41c1-b905-2f597761f76b" providerId="ADAL" clId="{F64F8652-B73F-49BC-A105-17EA9971C31A}" dt="2026-08-20T18:58:30.574" v="649" actId="478"/>
           <ac:cxnSpMkLst>
             <pc:docMk/>
-            <pc:sldMk cId="3322492765" sldId="261"/>
-            <ac:cxnSpMk id="75" creationId="{83B769DA-AD63-C4ED-00AE-45CA1156D7C2}"/>
-          </ac:cxnSpMkLst>
-        </pc:cxnChg>
-        <pc:cxnChg chg="add del mod">
-          <ac:chgData name="Nathan, Lucas (DNR)" userId="96837891-6aae-41c1-b905-2f597761f76b" providerId="ADAL" clId="{F64F8652-B73F-49BC-A105-17EA9971C31A}" dt="2026-06-29T19:34:57.593" v="43" actId="693"/>
-          <ac:cxnSpMkLst>
-            <pc:docMk/>
-            <pc:sldMk cId="3322492765" sldId="261"/>
-            <ac:cxnSpMk id="78" creationId="{A29CBA1D-BDF4-AF4F-A9A7-0A44836FEA7E}"/>
-          </ac:cxnSpMkLst>
-        </pc:cxnChg>
-        <pc:cxnChg chg="mod">
-          <ac:chgData name="Nathan, Lucas (DNR)" userId="96837891-6aae-41c1-b905-2f597761f76b" providerId="ADAL" clId="{F64F8652-B73F-49BC-A105-17EA9971C31A}" dt="2026-06-29T19:33:44.604" v="33" actId="1076"/>
-          <ac:cxnSpMkLst>
-            <pc:docMk/>
-            <pc:sldMk cId="3322492765" sldId="261"/>
-            <ac:cxnSpMk id="93" creationId="{7B20C067-AF4B-1864-B26F-22E4E53C4846}"/>
-          </ac:cxnSpMkLst>
-        </pc:cxnChg>
-      </pc:sldChg>
-      <pc:sldChg chg="modSp add del mod">
-        <pc:chgData name="Nathan, Lucas (DNR)" userId="96837891-6aae-41c1-b905-2f597761f76b" providerId="ADAL" clId="{F64F8652-B73F-49BC-A105-17EA9971C31A}" dt="2026-06-29T20:39:40.247" v="171" actId="47"/>
-        <pc:sldMkLst>
-          <pc:docMk/>
-          <pc:sldMk cId="1516480922" sldId="262"/>
-        </pc:sldMkLst>
-        <pc:spChg chg="mod">
-          <ac:chgData name="Nathan, Lucas (DNR)" userId="96837891-6aae-41c1-b905-2f597761f76b" providerId="ADAL" clId="{F64F8652-B73F-49BC-A105-17EA9971C31A}" dt="2026-06-29T20:39:16.851" v="169" actId="20577"/>
-          <ac:spMkLst>
-            <pc:docMk/>
-            <pc:sldMk cId="1516480922" sldId="262"/>
-            <ac:spMk id="4" creationId="{3C2BF129-49AA-0ABB-F93C-8D1F19B32577}"/>
-          </ac:spMkLst>
-        </pc:spChg>
-      </pc:sldChg>
-      <pc:sldChg chg="addSp delSp modSp add mod">
-        <pc:chgData name="Nathan, Lucas (DNR)" userId="96837891-6aae-41c1-b905-2f597761f76b" providerId="ADAL" clId="{F64F8652-B73F-49BC-A105-17EA9971C31A}" dt="2026-06-30T21:06:06.377" v="537" actId="1076"/>
-        <pc:sldMkLst>
-          <pc:docMk/>
-          <pc:sldMk cId="796165095" sldId="263"/>
-        </pc:sldMkLst>
-        <pc:spChg chg="add mod">
-          <ac:chgData name="Nathan, Lucas (DNR)" userId="96837891-6aae-41c1-b905-2f597761f76b" providerId="ADAL" clId="{F64F8652-B73F-49BC-A105-17EA9971C31A}" dt="2026-06-30T15:05:41.794" v="536" actId="1076"/>
-          <ac:spMkLst>
-            <pc:docMk/>
-            <pc:sldMk cId="796165095" sldId="263"/>
-            <ac:spMk id="2" creationId="{1F05B9EE-2FF8-B44C-370B-8A17D8BF7C4A}"/>
-          </ac:spMkLst>
-        </pc:spChg>
-        <pc:spChg chg="mod">
-          <ac:chgData name="Nathan, Lucas (DNR)" userId="96837891-6aae-41c1-b905-2f597761f76b" providerId="ADAL" clId="{F64F8652-B73F-49BC-A105-17EA9971C31A}" dt="2026-06-30T21:06:06.377" v="537" actId="1076"/>
-          <ac:spMkLst>
-            <pc:docMk/>
-            <pc:sldMk cId="796165095" sldId="263"/>
-            <ac:spMk id="4" creationId="{0466993E-22CC-8960-30E3-1161330698C7}"/>
-          </ac:spMkLst>
-        </pc:spChg>
-        <pc:spChg chg="del">
-          <ac:chgData name="Nathan, Lucas (DNR)" userId="96837891-6aae-41c1-b905-2f597761f76b" providerId="ADAL" clId="{F64F8652-B73F-49BC-A105-17EA9971C31A}" dt="2026-06-29T20:42:19.028" v="271" actId="478"/>
-          <ac:spMkLst>
-            <pc:docMk/>
-            <pc:sldMk cId="796165095" sldId="263"/>
-            <ac:spMk id="5" creationId="{862447DF-FF79-EBA8-BB69-DBC724B1EFE1}"/>
-          </ac:spMkLst>
-        </pc:spChg>
-        <pc:spChg chg="del">
-          <ac:chgData name="Nathan, Lucas (DNR)" userId="96837891-6aae-41c1-b905-2f597761f76b" providerId="ADAL" clId="{F64F8652-B73F-49BC-A105-17EA9971C31A}" dt="2026-06-29T20:42:13.716" v="262" actId="478"/>
-          <ac:spMkLst>
-            <pc:docMk/>
-            <pc:sldMk cId="796165095" sldId="263"/>
-            <ac:spMk id="7" creationId="{A38F1692-CB86-E338-BD4B-A824A177F077}"/>
-          </ac:spMkLst>
-        </pc:spChg>
-        <pc:spChg chg="add del mod">
-          <ac:chgData name="Nathan, Lucas (DNR)" userId="96837891-6aae-41c1-b905-2f597761f76b" providerId="ADAL" clId="{F64F8652-B73F-49BC-A105-17EA9971C31A}" dt="2026-06-30T15:05:38.396" v="534" actId="478"/>
-          <ac:spMkLst>
-            <pc:docMk/>
-            <pc:sldMk cId="796165095" sldId="263"/>
-            <ac:spMk id="11" creationId="{B3D0F06D-DB70-E021-E141-F59AF8C8AB58}"/>
-          </ac:spMkLst>
-        </pc:spChg>
-        <pc:spChg chg="del">
-          <ac:chgData name="Nathan, Lucas (DNR)" userId="96837891-6aae-41c1-b905-2f597761f76b" providerId="ADAL" clId="{F64F8652-B73F-49BC-A105-17EA9971C31A}" dt="2026-06-29T20:42:13.008" v="261" actId="478"/>
-          <ac:spMkLst>
-            <pc:docMk/>
-            <pc:sldMk cId="796165095" sldId="263"/>
-            <ac:spMk id="13" creationId="{DF12DC8C-54A8-4EC7-4CDC-D6891FCF3CA1}"/>
-          </ac:spMkLst>
-        </pc:spChg>
-        <pc:spChg chg="del mod">
-          <ac:chgData name="Nathan, Lucas (DNR)" userId="96837891-6aae-41c1-b905-2f597761f76b" providerId="ADAL" clId="{F64F8652-B73F-49BC-A105-17EA9971C31A}" dt="2026-06-29T20:42:18.246" v="270" actId="478"/>
-          <ac:spMkLst>
-            <pc:docMk/>
-            <pc:sldMk cId="796165095" sldId="263"/>
-            <ac:spMk id="38" creationId="{5F4B0D02-1FD5-185C-F86D-624F0F4D9249}"/>
-          </ac:spMkLst>
-        </pc:spChg>
-        <pc:spChg chg="del">
-          <ac:chgData name="Nathan, Lucas (DNR)" userId="96837891-6aae-41c1-b905-2f597761f76b" providerId="ADAL" clId="{F64F8652-B73F-49BC-A105-17EA9971C31A}" dt="2026-06-29T20:42:17.640" v="269" actId="478"/>
-          <ac:spMkLst>
-            <pc:docMk/>
-            <pc:sldMk cId="796165095" sldId="263"/>
-            <ac:spMk id="74" creationId="{598F55DA-9160-6855-00D7-1140E63A13DA}"/>
-          </ac:spMkLst>
-        </pc:spChg>
-        <pc:cxnChg chg="del mod">
-          <ac:chgData name="Nathan, Lucas (DNR)" userId="96837891-6aae-41c1-b905-2f597761f76b" providerId="ADAL" clId="{F64F8652-B73F-49BC-A105-17EA9971C31A}" dt="2026-06-29T20:42:14.211" v="263" actId="478"/>
-          <ac:cxnSpMkLst>
-            <pc:docMk/>
-            <pc:sldMk cId="796165095" sldId="263"/>
-            <ac:cxnSpMk id="8" creationId="{C1441D0A-BCC5-4FCB-F8E1-8F9558DFE42B}"/>
-          </ac:cxnSpMkLst>
-        </pc:cxnChg>
-        <pc:cxnChg chg="del mod">
-          <ac:chgData name="Nathan, Lucas (DNR)" userId="96837891-6aae-41c1-b905-2f597761f76b" providerId="ADAL" clId="{F64F8652-B73F-49BC-A105-17EA9971C31A}" dt="2026-06-30T15:05:39.431" v="535" actId="478"/>
-          <ac:cxnSpMkLst>
-            <pc:docMk/>
-            <pc:sldMk cId="796165095" sldId="263"/>
-            <ac:cxnSpMk id="14" creationId="{9373E434-CB22-6DAD-802E-93462B042E39}"/>
-          </ac:cxnSpMkLst>
-        </pc:cxnChg>
-        <pc:cxnChg chg="del mod">
-          <ac:chgData name="Nathan, Lucas (DNR)" userId="96837891-6aae-41c1-b905-2f597761f76b" providerId="ADAL" clId="{F64F8652-B73F-49BC-A105-17EA9971C31A}" dt="2026-06-29T20:42:14.546" v="264" actId="478"/>
-          <ac:cxnSpMkLst>
-            <pc:docMk/>
-            <pc:sldMk cId="796165095" sldId="263"/>
-            <ac:cxnSpMk id="41" creationId="{CBDD80CF-1F35-F10C-D379-AA35FB7CD344}"/>
-          </ac:cxnSpMkLst>
-        </pc:cxnChg>
-        <pc:cxnChg chg="del mod">
-          <ac:chgData name="Nathan, Lucas (DNR)" userId="96837891-6aae-41c1-b905-2f597761f76b" providerId="ADAL" clId="{F64F8652-B73F-49BC-A105-17EA9971C31A}" dt="2026-06-29T20:42:16.120" v="267" actId="478"/>
-          <ac:cxnSpMkLst>
-            <pc:docMk/>
-            <pc:sldMk cId="796165095" sldId="263"/>
-            <ac:cxnSpMk id="44" creationId="{D741B401-09ED-34DB-9430-B5DE562B112A}"/>
-          </ac:cxnSpMkLst>
-        </pc:cxnChg>
-        <pc:cxnChg chg="del mod">
-          <ac:chgData name="Nathan, Lucas (DNR)" userId="96837891-6aae-41c1-b905-2f597761f76b" providerId="ADAL" clId="{F64F8652-B73F-49BC-A105-17EA9971C31A}" dt="2026-06-29T20:42:14.970" v="265" actId="478"/>
-          <ac:cxnSpMkLst>
-            <pc:docMk/>
-            <pc:sldMk cId="796165095" sldId="263"/>
-            <ac:cxnSpMk id="78" creationId="{E9708ED6-F01B-E46D-DFF0-2E000C8CD1F6}"/>
-          </ac:cxnSpMkLst>
-        </pc:cxnChg>
-        <pc:cxnChg chg="del mod">
-          <ac:chgData name="Nathan, Lucas (DNR)" userId="96837891-6aae-41c1-b905-2f597761f76b" providerId="ADAL" clId="{F64F8652-B73F-49BC-A105-17EA9971C31A}" dt="2026-06-29T20:42:15.586" v="266" actId="478"/>
-          <ac:cxnSpMkLst>
-            <pc:docMk/>
-            <pc:sldMk cId="796165095" sldId="263"/>
-            <ac:cxnSpMk id="93" creationId="{589C798D-2A0D-9997-ED7A-C4D27CE1EE88}"/>
-          </ac:cxnSpMkLst>
-        </pc:cxnChg>
-      </pc:sldChg>
-      <pc:sldChg chg="delSp modSp add mod">
-        <pc:chgData name="Nathan, Lucas (DNR)" userId="96837891-6aae-41c1-b905-2f597761f76b" providerId="ADAL" clId="{F64F8652-B73F-49BC-A105-17EA9971C31A}" dt="2026-06-30T21:08:55.874" v="583" actId="1076"/>
-        <pc:sldMkLst>
-          <pc:docMk/>
-          <pc:sldMk cId="26251068" sldId="264"/>
-        </pc:sldMkLst>
-        <pc:spChg chg="del">
-          <ac:chgData name="Nathan, Lucas (DNR)" userId="96837891-6aae-41c1-b905-2f597761f76b" providerId="ADAL" clId="{F64F8652-B73F-49BC-A105-17EA9971C31A}" dt="2026-06-30T21:08:53.515" v="581" actId="478"/>
-          <ac:spMkLst>
-            <pc:docMk/>
-            <pc:sldMk cId="26251068" sldId="264"/>
-            <ac:spMk id="2" creationId="{43379F5E-1077-C99E-3702-E17ADC33195C}"/>
-          </ac:spMkLst>
-        </pc:spChg>
-        <pc:spChg chg="del">
-          <ac:chgData name="Nathan, Lucas (DNR)" userId="96837891-6aae-41c1-b905-2f597761f76b" providerId="ADAL" clId="{F64F8652-B73F-49BC-A105-17EA9971C31A}" dt="2026-06-30T21:08:53.515" v="581" actId="478"/>
-          <ac:spMkLst>
-            <pc:docMk/>
-            <pc:sldMk cId="26251068" sldId="264"/>
-            <ac:spMk id="3" creationId="{E6D89344-6E6A-071F-F6A7-6B15686BD5EA}"/>
-          </ac:spMkLst>
-        </pc:spChg>
-        <pc:spChg chg="mod">
-          <ac:chgData name="Nathan, Lucas (DNR)" userId="96837891-6aae-41c1-b905-2f597761f76b" providerId="ADAL" clId="{F64F8652-B73F-49BC-A105-17EA9971C31A}" dt="2026-06-30T21:08:37.973" v="580" actId="20577"/>
-          <ac:spMkLst>
-            <pc:docMk/>
-            <pc:sldMk cId="26251068" sldId="264"/>
-            <ac:spMk id="4" creationId="{4E7DA2EE-1A40-BB29-E385-9956E79B6ED5}"/>
-          </ac:spMkLst>
-        </pc:spChg>
-        <pc:spChg chg="del">
-          <ac:chgData name="Nathan, Lucas (DNR)" userId="96837891-6aae-41c1-b905-2f597761f76b" providerId="ADAL" clId="{F64F8652-B73F-49BC-A105-17EA9971C31A}" dt="2026-06-30T21:08:53.515" v="581" actId="478"/>
-          <ac:spMkLst>
-            <pc:docMk/>
-            <pc:sldMk cId="26251068" sldId="264"/>
-            <ac:spMk id="7" creationId="{691C86FC-7D83-3A31-005E-B0ACFA396674}"/>
-          </ac:spMkLst>
-        </pc:spChg>
-        <pc:spChg chg="del">
-          <ac:chgData name="Nathan, Lucas (DNR)" userId="96837891-6aae-41c1-b905-2f597761f76b" providerId="ADAL" clId="{F64F8652-B73F-49BC-A105-17EA9971C31A}" dt="2026-06-30T21:08:53.515" v="581" actId="478"/>
-          <ac:spMkLst>
-            <pc:docMk/>
-            <pc:sldMk cId="26251068" sldId="264"/>
-            <ac:spMk id="11" creationId="{3C27B9C5-2F7C-5797-063C-8975C6A68BDA}"/>
-          </ac:spMkLst>
-        </pc:spChg>
-        <pc:spChg chg="del">
-          <ac:chgData name="Nathan, Lucas (DNR)" userId="96837891-6aae-41c1-b905-2f597761f76b" providerId="ADAL" clId="{F64F8652-B73F-49BC-A105-17EA9971C31A}" dt="2026-06-30T21:08:53.515" v="581" actId="478"/>
-          <ac:spMkLst>
-            <pc:docMk/>
-            <pc:sldMk cId="26251068" sldId="264"/>
-            <ac:spMk id="13" creationId="{9ECD3942-471D-EF16-6BFE-73DEC536788B}"/>
-          </ac:spMkLst>
-        </pc:spChg>
-        <pc:spChg chg="mod">
-          <ac:chgData name="Nathan, Lucas (DNR)" userId="96837891-6aae-41c1-b905-2f597761f76b" providerId="ADAL" clId="{F64F8652-B73F-49BC-A105-17EA9971C31A}" dt="2026-06-30T21:08:55.874" v="583" actId="1076"/>
-          <ac:spMkLst>
-            <pc:docMk/>
-            <pc:sldMk cId="26251068" sldId="264"/>
-            <ac:spMk id="25" creationId="{4463CFD1-F4F7-05F3-6093-DE85CE964EDE}"/>
-          </ac:spMkLst>
-        </pc:spChg>
-        <pc:cxnChg chg="del mod">
-          <ac:chgData name="Nathan, Lucas (DNR)" userId="96837891-6aae-41c1-b905-2f597761f76b" providerId="ADAL" clId="{F64F8652-B73F-49BC-A105-17EA9971C31A}" dt="2026-06-30T21:08:53.515" v="581" actId="478"/>
-          <ac:cxnSpMkLst>
-            <pc:docMk/>
-            <pc:sldMk cId="26251068" sldId="264"/>
-            <ac:cxnSpMk id="6" creationId="{B1CC3DF4-6519-3AFA-A13F-DF8F6D7C7D0C}"/>
-          </ac:cxnSpMkLst>
-        </pc:cxnChg>
-        <pc:cxnChg chg="del mod">
-          <ac:chgData name="Nathan, Lucas (DNR)" userId="96837891-6aae-41c1-b905-2f597761f76b" providerId="ADAL" clId="{F64F8652-B73F-49BC-A105-17EA9971C31A}" dt="2026-06-30T21:08:53.515" v="581" actId="478"/>
-          <ac:cxnSpMkLst>
-            <pc:docMk/>
-            <pc:sldMk cId="26251068" sldId="264"/>
-            <ac:cxnSpMk id="14" creationId="{B5600E23-9C1E-BD89-9BAE-5C3484AA0137}"/>
-          </ac:cxnSpMkLst>
-        </pc:cxnChg>
-        <pc:cxnChg chg="del mod">
-          <ac:chgData name="Nathan, Lucas (DNR)" userId="96837891-6aae-41c1-b905-2f597761f76b" providerId="ADAL" clId="{F64F8652-B73F-49BC-A105-17EA9971C31A}" dt="2026-06-30T21:08:53.515" v="581" actId="478"/>
-          <ac:cxnSpMkLst>
-            <pc:docMk/>
-            <pc:sldMk cId="26251068" sldId="264"/>
-            <ac:cxnSpMk id="17" creationId="{C99355AE-F1C9-E160-D225-31351C68E2BA}"/>
-          </ac:cxnSpMkLst>
-        </pc:cxnChg>
-        <pc:cxnChg chg="del mod">
-          <ac:chgData name="Nathan, Lucas (DNR)" userId="96837891-6aae-41c1-b905-2f597761f76b" providerId="ADAL" clId="{F64F8652-B73F-49BC-A105-17EA9971C31A}" dt="2026-06-30T21:08:54.694" v="582" actId="478"/>
-          <ac:cxnSpMkLst>
-            <pc:docMk/>
-            <pc:sldMk cId="26251068" sldId="264"/>
-            <ac:cxnSpMk id="26" creationId="{E99F1CFE-EDA1-600D-5B1B-1796D95FEE49}"/>
-          </ac:cxnSpMkLst>
-        </pc:cxnChg>
-        <pc:cxnChg chg="del mod">
-          <ac:chgData name="Nathan, Lucas (DNR)" userId="96837891-6aae-41c1-b905-2f597761f76b" providerId="ADAL" clId="{F64F8652-B73F-49BC-A105-17EA9971C31A}" dt="2026-06-30T21:08:53.515" v="581" actId="478"/>
-          <ac:cxnSpMkLst>
-            <pc:docMk/>
-            <pc:sldMk cId="26251068" sldId="264"/>
-            <ac:cxnSpMk id="93" creationId="{DFE904C2-B43C-8529-DE21-804DFE952AF0}"/>
+            <pc:sldMk cId="1454144528" sldId="267"/>
+            <ac:cxnSpMk id="15" creationId="{7F29F53F-61B8-09AC-0D51-C9865DE4FD46}"/>
           </ac:cxnSpMkLst>
         </pc:cxnChg>
       </pc:sldChg>
@@ -990,7 +433,7 @@
           <a:p>
             <a:fld id="{179C5205-C240-4C15-BC7A-8B28C81B6976}" type="datetimeFigureOut">
               <a:rPr lang="en-US" smtClean="0"/>
-              <a:t>06/30/2026</a:t>
+              <a:t>08/20/2026</a:t>
             </a:fld>
             <a:endParaRPr lang="en-US"/>
           </a:p>
@@ -1188,7 +631,7 @@
           <a:p>
             <a:fld id="{179C5205-C240-4C15-BC7A-8B28C81B6976}" type="datetimeFigureOut">
               <a:rPr lang="en-US" smtClean="0"/>
-              <a:t>06/30/2026</a:t>
+              <a:t>08/20/2026</a:t>
             </a:fld>
             <a:endParaRPr lang="en-US"/>
           </a:p>
@@ -1396,7 +839,7 @@
           <a:p>
             <a:fld id="{179C5205-C240-4C15-BC7A-8B28C81B6976}" type="datetimeFigureOut">
               <a:rPr lang="en-US" smtClean="0"/>
-              <a:t>06/30/2026</a:t>
+              <a:t>08/20/2026</a:t>
             </a:fld>
             <a:endParaRPr lang="en-US"/>
           </a:p>
@@ -1594,7 +1037,7 @@
           <a:p>
             <a:fld id="{179C5205-C240-4C15-BC7A-8B28C81B6976}" type="datetimeFigureOut">
               <a:rPr lang="en-US" smtClean="0"/>
-              <a:t>06/30/2026</a:t>
+              <a:t>08/20/2026</a:t>
             </a:fld>
             <a:endParaRPr lang="en-US"/>
           </a:p>
@@ -1869,7 +1312,7 @@
           <a:p>
             <a:fld id="{179C5205-C240-4C15-BC7A-8B28C81B6976}" type="datetimeFigureOut">
               <a:rPr lang="en-US" smtClean="0"/>
-              <a:t>06/30/2026</a:t>
+              <a:t>08/20/2026</a:t>
             </a:fld>
             <a:endParaRPr lang="en-US"/>
           </a:p>
@@ -2134,7 +1577,7 @@
           <a:p>
             <a:fld id="{179C5205-C240-4C15-BC7A-8B28C81B6976}" type="datetimeFigureOut">
               <a:rPr lang="en-US" smtClean="0"/>
-              <a:t>06/30/2026</a:t>
+              <a:t>08/20/2026</a:t>
             </a:fld>
             <a:endParaRPr lang="en-US"/>
           </a:p>
@@ -2546,7 +1989,7 @@
           <a:p>
             <a:fld id="{179C5205-C240-4C15-BC7A-8B28C81B6976}" type="datetimeFigureOut">
               <a:rPr lang="en-US" smtClean="0"/>
-              <a:t>06/30/2026</a:t>
+              <a:t>08/20/2026</a:t>
             </a:fld>
             <a:endParaRPr lang="en-US"/>
           </a:p>
@@ -2687,7 +2130,7 @@
           <a:p>
             <a:fld id="{179C5205-C240-4C15-BC7A-8B28C81B6976}" type="datetimeFigureOut">
               <a:rPr lang="en-US" smtClean="0"/>
-              <a:t>06/30/2026</a:t>
+              <a:t>08/20/2026</a:t>
             </a:fld>
             <a:endParaRPr lang="en-US"/>
           </a:p>
@@ -2800,7 +2243,7 @@
           <a:p>
             <a:fld id="{179C5205-C240-4C15-BC7A-8B28C81B6976}" type="datetimeFigureOut">
               <a:rPr lang="en-US" smtClean="0"/>
-              <a:t>06/30/2026</a:t>
+              <a:t>08/20/2026</a:t>
             </a:fld>
             <a:endParaRPr lang="en-US"/>
           </a:p>
@@ -3111,7 +2554,7 @@
           <a:p>
             <a:fld id="{179C5205-C240-4C15-BC7A-8B28C81B6976}" type="datetimeFigureOut">
               <a:rPr lang="en-US" smtClean="0"/>
-              <a:t>06/30/2026</a:t>
+              <a:t>08/20/2026</a:t>
             </a:fld>
             <a:endParaRPr lang="en-US"/>
           </a:p>
@@ -3399,7 +2842,7 @@
           <a:p>
             <a:fld id="{179C5205-C240-4C15-BC7A-8B28C81B6976}" type="datetimeFigureOut">
               <a:rPr lang="en-US" smtClean="0"/>
-              <a:t>06/30/2026</a:t>
+              <a:t>08/20/2026</a:t>
             </a:fld>
             <a:endParaRPr lang="en-US"/>
           </a:p>
@@ -3640,7 +3083,7 @@
           <a:p>
             <a:fld id="{179C5205-C240-4C15-BC7A-8B28C81B6976}" type="datetimeFigureOut">
               <a:rPr lang="en-US" smtClean="0"/>
-              <a:t>06/30/2026</a:t>
+              <a:t>08/20/2026</a:t>
             </a:fld>
             <a:endParaRPr lang="en-US"/>
           </a:p>
@@ -4574,14 +4017,14 @@
           <p:cNvCxnSpPr>
             <a:cxnSpLocks/>
             <a:stCxn id="114" idx="4"/>
-            <a:endCxn id="146" idx="0"/>
+            <a:endCxn id="3" idx="1"/>
           </p:cNvCxnSpPr>
           <p:nvPr/>
         </p:nvCxnSpPr>
         <p:spPr>
           <a:xfrm>
             <a:off x="5337969" y="3047462"/>
-            <a:ext cx="4174334" cy="1705131"/>
+            <a:ext cx="2125275" cy="349998"/>
           </a:xfrm>
           <a:prstGeom prst="straightConnector1">
             <a:avLst/>
@@ -4763,6 +4206,119 @@
           <a:xfrm flipH="1">
             <a:off x="1551540" y="3047462"/>
             <a:ext cx="3786429" cy="79307"/>
+          </a:xfrm>
+          <a:prstGeom prst="straightConnector1">
+            <a:avLst/>
+          </a:prstGeom>
+          <a:ln>
+            <a:tailEnd type="triangle"/>
+          </a:ln>
+        </p:spPr>
+        <p:style>
+          <a:lnRef idx="2">
+            <a:schemeClr val="dk1"/>
+          </a:lnRef>
+          <a:fillRef idx="0">
+            <a:schemeClr val="dk1"/>
+          </a:fillRef>
+          <a:effectRef idx="1">
+            <a:schemeClr val="dk1"/>
+          </a:effectRef>
+          <a:fontRef idx="minor">
+            <a:schemeClr val="tx1"/>
+          </a:fontRef>
+        </p:style>
+      </p:cxnSp>
+      <p:sp>
+        <p:nvSpPr>
+          <p:cNvPr id="3" name="Oval 1">
+            <a:extLst>
+              <a:ext uri="{FF2B5EF4-FFF2-40B4-BE49-F238E27FC236}">
+                <a16:creationId xmlns:a16="http://schemas.microsoft.com/office/drawing/2014/main" id="{C83F8609-4D7A-AA38-F086-9E85B47A8159}"/>
+              </a:ext>
+            </a:extLst>
+          </p:cNvPr>
+          <p:cNvSpPr/>
+          <p:nvPr/>
+        </p:nvSpPr>
+        <p:spPr>
+          <a:xfrm>
+            <a:off x="7222740" y="3224724"/>
+            <a:ext cx="1642266" cy="1179512"/>
+          </a:xfrm>
+          <a:prstGeom prst="ellipse">
+            <a:avLst/>
+          </a:prstGeom>
+          <a:solidFill>
+            <a:srgbClr val="92D050"/>
+          </a:solidFill>
+        </p:spPr>
+        <p:style>
+          <a:lnRef idx="2">
+            <a:schemeClr val="accent1">
+              <a:shade val="15000"/>
+            </a:schemeClr>
+          </a:lnRef>
+          <a:fillRef idx="1">
+            <a:schemeClr val="accent1"/>
+          </a:fillRef>
+          <a:effectRef idx="0">
+            <a:schemeClr val="accent1"/>
+          </a:effectRef>
+          <a:fontRef idx="minor">
+            <a:schemeClr val="lt1"/>
+          </a:fontRef>
+        </p:style>
+        <p:txBody>
+          <a:bodyPr rot="0" spcFirstLastPara="0" vert="horz" wrap="square" lIns="91440" tIns="45720" rIns="91440" bIns="45720" numCol="1" spcCol="0" rtlCol="0" fromWordArt="0" anchor="ctr" anchorCtr="0" forceAA="0" compatLnSpc="1">
+            <a:prstTxWarp prst="textNoShape">
+              <a:avLst/>
+            </a:prstTxWarp>
+            <a:noAutofit/>
+          </a:bodyPr>
+          <a:lstStyle/>
+          <a:p>
+            <a:pPr algn="ctr"/>
+            <a:r>
+              <a:rPr lang="en-US" sz="1200" b="1" kern="100" dirty="0" err="1">
+                <a:solidFill>
+                  <a:srgbClr val="000000"/>
+                </a:solidFill>
+                <a:ea typeface="Aptos" panose="020B0004020202020204" pitchFamily="34" charset="0"/>
+                <a:cs typeface="Times New Roman" panose="02020603050405020304" pitchFamily="18" charset="0"/>
+              </a:rPr>
+              <a:t>lengthFreqByEffort</a:t>
+            </a:r>
+            <a:endParaRPr lang="en-US" sz="1200" b="1" kern="100" dirty="0">
+              <a:solidFill>
+                <a:srgbClr val="000000"/>
+              </a:solidFill>
+              <a:ea typeface="Aptos" panose="020B0004020202020204" pitchFamily="34" charset="0"/>
+              <a:cs typeface="Times New Roman" panose="02020603050405020304" pitchFamily="18" charset="0"/>
+            </a:endParaRPr>
+          </a:p>
+        </p:txBody>
+      </p:sp>
+      <p:cxnSp>
+        <p:nvCxnSpPr>
+          <p:cNvPr id="6" name="Straight Arrow Connector 5">
+            <a:extLst>
+              <a:ext uri="{FF2B5EF4-FFF2-40B4-BE49-F238E27FC236}">
+                <a16:creationId xmlns:a16="http://schemas.microsoft.com/office/drawing/2014/main" id="{6E5E4102-F999-0B05-BBF4-9FFA54A5074E}"/>
+              </a:ext>
+            </a:extLst>
+          </p:cNvPr>
+          <p:cNvCxnSpPr>
+            <a:cxnSpLocks/>
+            <a:stCxn id="3" idx="5"/>
+            <a:endCxn id="146" idx="0"/>
+          </p:cNvCxnSpPr>
+          <p:nvPr/>
+        </p:nvCxnSpPr>
+        <p:spPr>
+          <a:xfrm>
+            <a:off x="8624502" y="4231500"/>
+            <a:ext cx="887801" cy="521093"/>
           </a:xfrm>
           <a:prstGeom prst="straightConnector1">
             <a:avLst/>
@@ -8597,23 +8153,15 @@
           <a:p>
             <a:pPr algn="ctr"/>
             <a:r>
-              <a:rPr lang="en-US" sz="1200" kern="100" dirty="0" err="1">
-                <a:solidFill>
-                  <a:srgbClr val="000000"/>
-                </a:solidFill>
-                <a:effectLst/>
-                <a:ea typeface="Aptos" panose="020B0004020202020204" pitchFamily="34" charset="0"/>
-                <a:cs typeface="Times New Roman" panose="02020603050405020304" pitchFamily="18" charset="0"/>
-              </a:rPr>
-              <a:t>TotalLengthEntered</a:t>
-            </a:r>
-            <a:endParaRPr lang="en-US" sz="1200" kern="100" dirty="0">
-              <a:solidFill>
-                <a:srgbClr val="000000"/>
-              </a:solidFill>
-              <a:ea typeface="Aptos" panose="020B0004020202020204" pitchFamily="34" charset="0"/>
-              <a:cs typeface="Times New Roman" panose="02020603050405020304" pitchFamily="18" charset="0"/>
-            </a:endParaRPr>
+              <a:rPr lang="en-US" sz="1200" kern="100" dirty="0">
+                <a:solidFill>
+                  <a:srgbClr val="000000"/>
+                </a:solidFill>
+                <a:ea typeface="Aptos" panose="020B0004020202020204" pitchFamily="34" charset="0"/>
+                <a:cs typeface="Times New Roman" panose="02020603050405020304" pitchFamily="18" charset="0"/>
+              </a:rPr>
+              <a:t>TotalLengthInInches</a:t>
+            </a:r>
           </a:p>
           <a:p>
             <a:pPr algn="ctr"/>
@@ -9224,6 +8772,995 @@
     <p:extLst>
       <p:ext uri="{BB962C8B-B14F-4D97-AF65-F5344CB8AC3E}">
         <p14:creationId xmlns:p14="http://schemas.microsoft.com/office/powerpoint/2010/main" val="26251068"/>
+      </p:ext>
+    </p:extLst>
+  </p:cSld>
+  <p:clrMapOvr>
+    <a:masterClrMapping/>
+  </p:clrMapOvr>
+</p:sld>
+</file>
+
+<file path=ppt/slides/slide7.xml><?xml version="1.0" encoding="utf-8"?>
+<p:sld xmlns:a="http://schemas.openxmlformats.org/drawingml/2006/main" xmlns:r="http://schemas.openxmlformats.org/officeDocument/2006/relationships" xmlns:p="http://schemas.openxmlformats.org/presentationml/2006/main">
+  <p:cSld>
+    <p:spTree>
+      <p:nvGrpSpPr>
+        <p:cNvPr id="1" name="">
+          <a:extLst>
+            <a:ext uri="{FF2B5EF4-FFF2-40B4-BE49-F238E27FC236}">
+              <a16:creationId xmlns:a16="http://schemas.microsoft.com/office/drawing/2014/main" id="{4701EA61-8E07-EF03-43A0-1AB404972CF5}"/>
+            </a:ext>
+          </a:extLst>
+        </p:cNvPr>
+        <p:cNvGrpSpPr/>
+        <p:nvPr/>
+      </p:nvGrpSpPr>
+      <p:grpSpPr>
+        <a:xfrm>
+          <a:off x="0" y="0"/>
+          <a:ext cx="0" cy="0"/>
+          <a:chOff x="0" y="0"/>
+          <a:chExt cx="0" cy="0"/>
+        </a:xfrm>
+      </p:grpSpPr>
+      <p:sp>
+        <p:nvSpPr>
+          <p:cNvPr id="4" name="Title 3">
+            <a:extLst>
+              <a:ext uri="{FF2B5EF4-FFF2-40B4-BE49-F238E27FC236}">
+                <a16:creationId xmlns:a16="http://schemas.microsoft.com/office/drawing/2014/main" id="{94F933C4-A647-0DA0-5236-83D00C7AC93A}"/>
+              </a:ext>
+            </a:extLst>
+          </p:cNvPr>
+          <p:cNvSpPr>
+            <a:spLocks noGrp="1"/>
+          </p:cNvSpPr>
+          <p:nvPr>
+            <p:ph type="title"/>
+          </p:nvPr>
+        </p:nvSpPr>
+        <p:spPr/>
+        <p:txBody>
+          <a:bodyPr/>
+          <a:lstStyle/>
+          <a:p>
+            <a:r>
+              <a:rPr lang="en-US" dirty="0" err="1"/>
+              <a:t>lengthFreqByEffort</a:t>
+            </a:r>
+            <a:endParaRPr lang="en-US" dirty="0"/>
+          </a:p>
+        </p:txBody>
+      </p:sp>
+      <p:sp>
+        <p:nvSpPr>
+          <p:cNvPr id="7" name="Oval 1">
+            <a:extLst>
+              <a:ext uri="{FF2B5EF4-FFF2-40B4-BE49-F238E27FC236}">
+                <a16:creationId xmlns:a16="http://schemas.microsoft.com/office/drawing/2014/main" id="{2E343D64-34F6-9150-4CEB-C31B05E8638A}"/>
+              </a:ext>
+            </a:extLst>
+          </p:cNvPr>
+          <p:cNvSpPr/>
+          <p:nvPr/>
+        </p:nvSpPr>
+        <p:spPr>
+          <a:xfrm>
+            <a:off x="5792786" y="4087136"/>
+            <a:ext cx="1350963" cy="792719"/>
+          </a:xfrm>
+          <a:prstGeom prst="rect">
+            <a:avLst/>
+          </a:prstGeom>
+          <a:noFill/>
+        </p:spPr>
+        <p:style>
+          <a:lnRef idx="2">
+            <a:schemeClr val="accent1">
+              <a:shade val="15000"/>
+            </a:schemeClr>
+          </a:lnRef>
+          <a:fillRef idx="1">
+            <a:schemeClr val="accent1"/>
+          </a:fillRef>
+          <a:effectRef idx="0">
+            <a:schemeClr val="accent1"/>
+          </a:effectRef>
+          <a:fontRef idx="minor">
+            <a:schemeClr val="lt1"/>
+          </a:fontRef>
+        </p:style>
+        <p:txBody>
+          <a:bodyPr rot="0" spcFirstLastPara="0" vert="horz" wrap="square" lIns="91440" tIns="45720" rIns="91440" bIns="45720" numCol="1" spcCol="0" rtlCol="0" fromWordArt="0" anchor="ctr" anchorCtr="0" forceAA="0" compatLnSpc="1">
+            <a:prstTxWarp prst="textNoShape">
+              <a:avLst/>
+            </a:prstTxWarp>
+            <a:noAutofit/>
+          </a:bodyPr>
+          <a:lstStyle/>
+          <a:p>
+            <a:pPr algn="ctr"/>
+            <a:r>
+              <a:rPr lang="en-US" sz="1200" b="1" kern="100" dirty="0" err="1">
+                <a:solidFill>
+                  <a:srgbClr val="000000"/>
+                </a:solidFill>
+                <a:effectLst/>
+                <a:ea typeface="Aptos" panose="020B0004020202020204" pitchFamily="34" charset="0"/>
+                <a:cs typeface="Times New Roman" panose="02020603050405020304" pitchFamily="18" charset="0"/>
+              </a:rPr>
+              <a:t>ModuleData</a:t>
+            </a:r>
+            <a:endParaRPr lang="en-US" sz="1200" b="1" kern="100" dirty="0">
+              <a:solidFill>
+                <a:srgbClr val="000000"/>
+              </a:solidFill>
+              <a:effectLst/>
+              <a:ea typeface="Aptos" panose="020B0004020202020204" pitchFamily="34" charset="0"/>
+              <a:cs typeface="Times New Roman" panose="02020603050405020304" pitchFamily="18" charset="0"/>
+            </a:endParaRPr>
+          </a:p>
+          <a:p>
+            <a:pPr algn="ctr"/>
+            <a:r>
+              <a:rPr lang="en-US" sz="1200" u="sng" kern="100" dirty="0" err="1">
+                <a:solidFill>
+                  <a:srgbClr val="000000"/>
+                </a:solidFill>
+                <a:effectLst/>
+                <a:ea typeface="Aptos" panose="020B0004020202020204" pitchFamily="34" charset="0"/>
+                <a:cs typeface="Times New Roman" panose="02020603050405020304" pitchFamily="18" charset="0"/>
+              </a:rPr>
+              <a:t>ModuleId</a:t>
+            </a:r>
+            <a:endParaRPr lang="en-US" sz="1200" u="sng" kern="100" dirty="0">
+              <a:effectLst/>
+              <a:ea typeface="Aptos" panose="020B0004020202020204" pitchFamily="34" charset="0"/>
+              <a:cs typeface="Times New Roman" panose="02020603050405020304" pitchFamily="18" charset="0"/>
+            </a:endParaRPr>
+          </a:p>
+          <a:p>
+            <a:pPr algn="ctr"/>
+            <a:r>
+              <a:rPr lang="en-US" sz="1200" u="sng" kern="100" dirty="0" err="1">
+                <a:solidFill>
+                  <a:srgbClr val="000000"/>
+                </a:solidFill>
+                <a:effectLst/>
+                <a:ea typeface="Aptos" panose="020B0004020202020204" pitchFamily="34" charset="0"/>
+                <a:cs typeface="Times New Roman" panose="02020603050405020304" pitchFamily="18" charset="0"/>
+              </a:rPr>
+              <a:t>ModuleDataId</a:t>
+            </a:r>
+            <a:endParaRPr lang="en-US" sz="1200" u="sng" kern="100" dirty="0">
+              <a:solidFill>
+                <a:srgbClr val="000000"/>
+              </a:solidFill>
+              <a:effectLst/>
+              <a:ea typeface="Aptos" panose="020B0004020202020204" pitchFamily="34" charset="0"/>
+              <a:cs typeface="Times New Roman" panose="02020603050405020304" pitchFamily="18" charset="0"/>
+            </a:endParaRPr>
+          </a:p>
+        </p:txBody>
+      </p:sp>
+      <p:sp>
+        <p:nvSpPr>
+          <p:cNvPr id="13" name="Oval 1">
+            <a:extLst>
+              <a:ext uri="{FF2B5EF4-FFF2-40B4-BE49-F238E27FC236}">
+                <a16:creationId xmlns:a16="http://schemas.microsoft.com/office/drawing/2014/main" id="{5739946C-9A4D-7611-F89B-0C4B17EA0446}"/>
+              </a:ext>
+            </a:extLst>
+          </p:cNvPr>
+          <p:cNvSpPr/>
+          <p:nvPr/>
+        </p:nvSpPr>
+        <p:spPr>
+          <a:xfrm>
+            <a:off x="2082402" y="4111942"/>
+            <a:ext cx="1350963" cy="792719"/>
+          </a:xfrm>
+          <a:prstGeom prst="rect">
+            <a:avLst/>
+          </a:prstGeom>
+          <a:noFill/>
+        </p:spPr>
+        <p:style>
+          <a:lnRef idx="2">
+            <a:schemeClr val="accent1">
+              <a:shade val="15000"/>
+            </a:schemeClr>
+          </a:lnRef>
+          <a:fillRef idx="1">
+            <a:schemeClr val="accent1"/>
+          </a:fillRef>
+          <a:effectRef idx="0">
+            <a:schemeClr val="accent1"/>
+          </a:effectRef>
+          <a:fontRef idx="minor">
+            <a:schemeClr val="lt1"/>
+          </a:fontRef>
+        </p:style>
+        <p:txBody>
+          <a:bodyPr rot="0" spcFirstLastPara="0" vert="horz" wrap="square" lIns="91440" tIns="45720" rIns="91440" bIns="45720" numCol="1" spcCol="0" rtlCol="0" fromWordArt="0" anchor="ctr" anchorCtr="0" forceAA="0" compatLnSpc="1">
+            <a:prstTxWarp prst="textNoShape">
+              <a:avLst/>
+            </a:prstTxWarp>
+            <a:noAutofit/>
+          </a:bodyPr>
+          <a:lstStyle/>
+          <a:p>
+            <a:pPr algn="ctr"/>
+            <a:r>
+              <a:rPr lang="en-US" sz="1200" b="1" kern="100" dirty="0" err="1">
+                <a:solidFill>
+                  <a:srgbClr val="000000"/>
+                </a:solidFill>
+                <a:effectLst/>
+                <a:ea typeface="Aptos" panose="020B0004020202020204" pitchFamily="34" charset="0"/>
+                <a:cs typeface="Times New Roman" panose="02020603050405020304" pitchFamily="18" charset="0"/>
+              </a:rPr>
+              <a:t>SpeciesStrain</a:t>
+            </a:r>
+            <a:endParaRPr lang="en-US" sz="1200" b="1" kern="100" dirty="0">
+              <a:solidFill>
+                <a:srgbClr val="000000"/>
+              </a:solidFill>
+              <a:effectLst/>
+              <a:ea typeface="Aptos" panose="020B0004020202020204" pitchFamily="34" charset="0"/>
+              <a:cs typeface="Times New Roman" panose="02020603050405020304" pitchFamily="18" charset="0"/>
+            </a:endParaRPr>
+          </a:p>
+          <a:p>
+            <a:pPr algn="ctr"/>
+            <a:r>
+              <a:rPr lang="en-US" sz="1200" u="sng" kern="100" dirty="0" err="1">
+                <a:solidFill>
+                  <a:srgbClr val="000000"/>
+                </a:solidFill>
+                <a:effectLst/>
+                <a:ea typeface="Aptos" panose="020B0004020202020204" pitchFamily="34" charset="0"/>
+                <a:cs typeface="Times New Roman" panose="02020603050405020304" pitchFamily="18" charset="0"/>
+              </a:rPr>
+              <a:t>SpeciesStrainId</a:t>
+            </a:r>
+            <a:endParaRPr lang="en-US" sz="1200" u="sng" kern="100" dirty="0">
+              <a:solidFill>
+                <a:srgbClr val="000000"/>
+              </a:solidFill>
+              <a:effectLst/>
+              <a:ea typeface="Aptos" panose="020B0004020202020204" pitchFamily="34" charset="0"/>
+              <a:cs typeface="Times New Roman" panose="02020603050405020304" pitchFamily="18" charset="0"/>
+            </a:endParaRPr>
+          </a:p>
+          <a:p>
+            <a:pPr algn="ctr"/>
+            <a:r>
+              <a:rPr lang="en-US" sz="1200" u="sng" kern="100" dirty="0">
+                <a:solidFill>
+                  <a:srgbClr val="000000"/>
+                </a:solidFill>
+                <a:effectLst/>
+                <a:ea typeface="Aptos" panose="020B0004020202020204" pitchFamily="34" charset="0"/>
+                <a:cs typeface="Times New Roman" panose="02020603050405020304" pitchFamily="18" charset="0"/>
+              </a:rPr>
+              <a:t>Species</a:t>
+            </a:r>
+          </a:p>
+          <a:p>
+            <a:pPr algn="ctr"/>
+            <a:r>
+              <a:rPr lang="en-US" sz="1200" kern="100" dirty="0">
+                <a:solidFill>
+                  <a:srgbClr val="000000"/>
+                </a:solidFill>
+                <a:effectLst/>
+                <a:ea typeface="Aptos" panose="020B0004020202020204" pitchFamily="34" charset="0"/>
+                <a:cs typeface="Times New Roman" panose="02020603050405020304" pitchFamily="18" charset="0"/>
+              </a:rPr>
+              <a:t>Strain</a:t>
+            </a:r>
+            <a:endParaRPr lang="en-US" sz="1200" u="sng" kern="100" dirty="0">
+              <a:solidFill>
+                <a:srgbClr val="000000"/>
+              </a:solidFill>
+              <a:effectLst/>
+              <a:ea typeface="Aptos" panose="020B0004020202020204" pitchFamily="34" charset="0"/>
+              <a:cs typeface="Times New Roman" panose="02020603050405020304" pitchFamily="18" charset="0"/>
+            </a:endParaRPr>
+          </a:p>
+        </p:txBody>
+      </p:sp>
+      <p:sp>
+        <p:nvSpPr>
+          <p:cNvPr id="38" name="Oval 1">
+            <a:extLst>
+              <a:ext uri="{FF2B5EF4-FFF2-40B4-BE49-F238E27FC236}">
+                <a16:creationId xmlns:a16="http://schemas.microsoft.com/office/drawing/2014/main" id="{A6BF9572-7A97-DD4E-7750-47DDCEC66EDD}"/>
+              </a:ext>
+            </a:extLst>
+          </p:cNvPr>
+          <p:cNvSpPr/>
+          <p:nvPr/>
+        </p:nvSpPr>
+        <p:spPr>
+          <a:xfrm>
+            <a:off x="3322637" y="1907579"/>
+            <a:ext cx="2951163" cy="1179513"/>
+          </a:xfrm>
+          <a:prstGeom prst="rect">
+            <a:avLst/>
+          </a:prstGeom>
+          <a:noFill/>
+        </p:spPr>
+        <p:style>
+          <a:lnRef idx="2">
+            <a:schemeClr val="accent1">
+              <a:shade val="15000"/>
+            </a:schemeClr>
+          </a:lnRef>
+          <a:fillRef idx="1">
+            <a:schemeClr val="accent1"/>
+          </a:fillRef>
+          <a:effectRef idx="0">
+            <a:schemeClr val="accent1"/>
+          </a:effectRef>
+          <a:fontRef idx="minor">
+            <a:schemeClr val="lt1"/>
+          </a:fontRef>
+        </p:style>
+        <p:txBody>
+          <a:bodyPr rot="0" spcFirstLastPara="0" vert="horz" wrap="square" lIns="91440" tIns="45720" rIns="91440" bIns="45720" numCol="1" spcCol="0" rtlCol="0" fromWordArt="0" anchor="ctr" anchorCtr="0" forceAA="0" compatLnSpc="1">
+            <a:prstTxWarp prst="textNoShape">
+              <a:avLst/>
+            </a:prstTxWarp>
+            <a:noAutofit/>
+          </a:bodyPr>
+          <a:lstStyle/>
+          <a:p>
+            <a:pPr algn="ctr"/>
+            <a:r>
+              <a:rPr lang="en-US" sz="1200" b="1" kern="100" dirty="0" err="1">
+                <a:solidFill>
+                  <a:srgbClr val="000000"/>
+                </a:solidFill>
+                <a:effectLst/>
+                <a:ea typeface="Aptos" panose="020B0004020202020204" pitchFamily="34" charset="0"/>
+                <a:cs typeface="Times New Roman" panose="02020603050405020304" pitchFamily="18" charset="0"/>
+              </a:rPr>
+              <a:t>ModuleDataCatchSampleByInchGroup</a:t>
+            </a:r>
+            <a:endParaRPr lang="en-US" sz="1200" kern="100" dirty="0">
+              <a:effectLst/>
+              <a:ea typeface="Aptos" panose="020B0004020202020204" pitchFamily="34" charset="0"/>
+              <a:cs typeface="Times New Roman" panose="02020603050405020304" pitchFamily="18" charset="0"/>
+            </a:endParaRPr>
+          </a:p>
+          <a:p>
+            <a:pPr algn="ctr"/>
+            <a:r>
+              <a:rPr lang="en-US" sz="1200" u="sng" kern="100" dirty="0" err="1">
+                <a:solidFill>
+                  <a:srgbClr val="000000"/>
+                </a:solidFill>
+                <a:effectLst/>
+                <a:ea typeface="Aptos" panose="020B0004020202020204" pitchFamily="34" charset="0"/>
+                <a:cs typeface="Times New Roman" panose="02020603050405020304" pitchFamily="18" charset="0"/>
+              </a:rPr>
+              <a:t>ModuleDataId</a:t>
+            </a:r>
+            <a:endParaRPr lang="en-US" sz="1200" u="sng" kern="100" dirty="0">
+              <a:solidFill>
+                <a:srgbClr val="000000"/>
+              </a:solidFill>
+              <a:effectLst/>
+              <a:ea typeface="Aptos" panose="020B0004020202020204" pitchFamily="34" charset="0"/>
+              <a:cs typeface="Times New Roman" panose="02020603050405020304" pitchFamily="18" charset="0"/>
+            </a:endParaRPr>
+          </a:p>
+          <a:p>
+            <a:pPr algn="ctr"/>
+            <a:r>
+              <a:rPr lang="en-US" sz="1200" u="sng" kern="100" dirty="0" err="1">
+                <a:solidFill>
+                  <a:srgbClr val="000000"/>
+                </a:solidFill>
+                <a:effectLst/>
+                <a:ea typeface="Aptos" panose="020B0004020202020204" pitchFamily="34" charset="0"/>
+                <a:cs typeface="Times New Roman" panose="02020603050405020304" pitchFamily="18" charset="0"/>
+              </a:rPr>
+              <a:t>SpeciesStrainId</a:t>
+            </a:r>
+            <a:endParaRPr lang="en-US" sz="1200" u="sng" kern="100" dirty="0">
+              <a:solidFill>
+                <a:srgbClr val="000000"/>
+              </a:solidFill>
+              <a:effectLst/>
+              <a:ea typeface="Aptos" panose="020B0004020202020204" pitchFamily="34" charset="0"/>
+              <a:cs typeface="Times New Roman" panose="02020603050405020304" pitchFamily="18" charset="0"/>
+            </a:endParaRPr>
+          </a:p>
+          <a:p>
+            <a:pPr algn="ctr"/>
+            <a:r>
+              <a:rPr lang="en-US" sz="1200" kern="100" dirty="0" err="1">
+                <a:solidFill>
+                  <a:srgbClr val="000000"/>
+                </a:solidFill>
+                <a:effectLst/>
+                <a:ea typeface="Aptos" panose="020B0004020202020204" pitchFamily="34" charset="0"/>
+                <a:cs typeface="Times New Roman" panose="02020603050405020304" pitchFamily="18" charset="0"/>
+              </a:rPr>
+              <a:t>InchGroup</a:t>
+            </a:r>
+            <a:endParaRPr lang="en-US" sz="1200" kern="100" dirty="0">
+              <a:solidFill>
+                <a:srgbClr val="000000"/>
+              </a:solidFill>
+              <a:ea typeface="Aptos" panose="020B0004020202020204" pitchFamily="34" charset="0"/>
+              <a:cs typeface="Times New Roman" panose="02020603050405020304" pitchFamily="18" charset="0"/>
+            </a:endParaRPr>
+          </a:p>
+          <a:p>
+            <a:pPr algn="ctr"/>
+            <a:r>
+              <a:rPr lang="en-US" sz="1200" kern="100" dirty="0" err="1">
+                <a:solidFill>
+                  <a:srgbClr val="000000"/>
+                </a:solidFill>
+                <a:effectLst/>
+                <a:ea typeface="Aptos" panose="020B0004020202020204" pitchFamily="34" charset="0"/>
+                <a:cs typeface="Times New Roman" panose="02020603050405020304" pitchFamily="18" charset="0"/>
+              </a:rPr>
+              <a:t>NumberCaughtUnmarked</a:t>
+            </a:r>
+            <a:endParaRPr lang="en-US" sz="1200" kern="100" dirty="0">
+              <a:solidFill>
+                <a:srgbClr val="000000"/>
+              </a:solidFill>
+              <a:ea typeface="Aptos" panose="020B0004020202020204" pitchFamily="34" charset="0"/>
+              <a:cs typeface="Times New Roman" panose="02020603050405020304" pitchFamily="18" charset="0"/>
+            </a:endParaRPr>
+          </a:p>
+          <a:p>
+            <a:pPr algn="ctr"/>
+            <a:r>
+              <a:rPr lang="en-US" sz="1200" kern="100" dirty="0" err="1">
+                <a:solidFill>
+                  <a:srgbClr val="000000"/>
+                </a:solidFill>
+                <a:effectLst/>
+                <a:ea typeface="Aptos" panose="020B0004020202020204" pitchFamily="34" charset="0"/>
+                <a:cs typeface="Times New Roman" panose="02020603050405020304" pitchFamily="18" charset="0"/>
+              </a:rPr>
+              <a:t>NumberCaughtMarked</a:t>
+            </a:r>
+            <a:endParaRPr lang="en-US" sz="1200" kern="100" dirty="0">
+              <a:effectLst/>
+              <a:ea typeface="Aptos" panose="020B0004020202020204" pitchFamily="34" charset="0"/>
+              <a:cs typeface="Times New Roman" panose="02020603050405020304" pitchFamily="18" charset="0"/>
+            </a:endParaRPr>
+          </a:p>
+        </p:txBody>
+      </p:sp>
+      <p:cxnSp>
+        <p:nvCxnSpPr>
+          <p:cNvPr id="41" name="Straight Arrow Connector 40">
+            <a:extLst>
+              <a:ext uri="{FF2B5EF4-FFF2-40B4-BE49-F238E27FC236}">
+                <a16:creationId xmlns:a16="http://schemas.microsoft.com/office/drawing/2014/main" id="{023E9AB1-0A30-2655-9645-9FC486FFAA54}"/>
+              </a:ext>
+            </a:extLst>
+          </p:cNvPr>
+          <p:cNvCxnSpPr>
+            <a:cxnSpLocks/>
+            <a:stCxn id="38" idx="2"/>
+            <a:endCxn id="7" idx="0"/>
+          </p:cNvCxnSpPr>
+          <p:nvPr/>
+        </p:nvCxnSpPr>
+        <p:spPr>
+          <a:xfrm>
+            <a:off x="4798219" y="3087092"/>
+            <a:ext cx="1670049" cy="1000044"/>
+          </a:xfrm>
+          <a:prstGeom prst="straightConnector1">
+            <a:avLst/>
+          </a:prstGeom>
+          <a:ln>
+            <a:tailEnd type="triangle"/>
+          </a:ln>
+        </p:spPr>
+        <p:style>
+          <a:lnRef idx="2">
+            <a:schemeClr val="dk1"/>
+          </a:lnRef>
+          <a:fillRef idx="0">
+            <a:schemeClr val="dk1"/>
+          </a:fillRef>
+          <a:effectRef idx="1">
+            <a:schemeClr val="dk1"/>
+          </a:effectRef>
+          <a:fontRef idx="minor">
+            <a:schemeClr val="tx1"/>
+          </a:fontRef>
+        </p:style>
+      </p:cxnSp>
+      <p:cxnSp>
+        <p:nvCxnSpPr>
+          <p:cNvPr id="44" name="Straight Arrow Connector 43">
+            <a:extLst>
+              <a:ext uri="{FF2B5EF4-FFF2-40B4-BE49-F238E27FC236}">
+                <a16:creationId xmlns:a16="http://schemas.microsoft.com/office/drawing/2014/main" id="{3977D6A6-3A5F-6947-00CC-52BFA252B90A}"/>
+              </a:ext>
+            </a:extLst>
+          </p:cNvPr>
+          <p:cNvCxnSpPr>
+            <a:cxnSpLocks/>
+            <a:stCxn id="38" idx="2"/>
+            <a:endCxn id="13" idx="0"/>
+          </p:cNvCxnSpPr>
+          <p:nvPr/>
+        </p:nvCxnSpPr>
+        <p:spPr>
+          <a:xfrm flipH="1">
+            <a:off x="2757884" y="3087092"/>
+            <a:ext cx="2040335" cy="1024850"/>
+          </a:xfrm>
+          <a:prstGeom prst="straightConnector1">
+            <a:avLst/>
+          </a:prstGeom>
+          <a:ln>
+            <a:tailEnd type="triangle"/>
+          </a:ln>
+        </p:spPr>
+        <p:style>
+          <a:lnRef idx="2">
+            <a:schemeClr val="dk1"/>
+          </a:lnRef>
+          <a:fillRef idx="0">
+            <a:schemeClr val="dk1"/>
+          </a:fillRef>
+          <a:effectRef idx="1">
+            <a:schemeClr val="dk1"/>
+          </a:effectRef>
+          <a:fontRef idx="minor">
+            <a:schemeClr val="tx1"/>
+          </a:fontRef>
+        </p:style>
+      </p:cxnSp>
+      <p:sp>
+        <p:nvSpPr>
+          <p:cNvPr id="74" name="Oval 1">
+            <a:extLst>
+              <a:ext uri="{FF2B5EF4-FFF2-40B4-BE49-F238E27FC236}">
+                <a16:creationId xmlns:a16="http://schemas.microsoft.com/office/drawing/2014/main" id="{2FA0CD76-DB46-C196-D4C5-340484EE2E9D}"/>
+              </a:ext>
+            </a:extLst>
+          </p:cNvPr>
+          <p:cNvSpPr/>
+          <p:nvPr/>
+        </p:nvSpPr>
+        <p:spPr>
+          <a:xfrm>
+            <a:off x="6611937" y="1907579"/>
+            <a:ext cx="2951163" cy="1179513"/>
+          </a:xfrm>
+          <a:prstGeom prst="rect">
+            <a:avLst/>
+          </a:prstGeom>
+          <a:noFill/>
+        </p:spPr>
+        <p:style>
+          <a:lnRef idx="2">
+            <a:schemeClr val="accent1">
+              <a:shade val="15000"/>
+            </a:schemeClr>
+          </a:lnRef>
+          <a:fillRef idx="1">
+            <a:schemeClr val="accent1"/>
+          </a:fillRef>
+          <a:effectRef idx="0">
+            <a:schemeClr val="accent1"/>
+          </a:effectRef>
+          <a:fontRef idx="minor">
+            <a:schemeClr val="lt1"/>
+          </a:fontRef>
+        </p:style>
+        <p:txBody>
+          <a:bodyPr rot="0" spcFirstLastPara="0" vert="horz" wrap="square" lIns="91440" tIns="45720" rIns="91440" bIns="45720" numCol="1" spcCol="0" rtlCol="0" fromWordArt="0" anchor="ctr" anchorCtr="0" forceAA="0" compatLnSpc="1">
+            <a:prstTxWarp prst="textNoShape">
+              <a:avLst/>
+            </a:prstTxWarp>
+            <a:noAutofit/>
+          </a:bodyPr>
+          <a:lstStyle/>
+          <a:p>
+            <a:pPr algn="ctr"/>
+            <a:r>
+              <a:rPr lang="en-US" sz="1200" b="1" kern="100" dirty="0" err="1">
+                <a:solidFill>
+                  <a:srgbClr val="000000"/>
+                </a:solidFill>
+                <a:effectLst/>
+                <a:ea typeface="Aptos" panose="020B0004020202020204" pitchFamily="34" charset="0"/>
+                <a:cs typeface="Times New Roman" panose="02020603050405020304" pitchFamily="18" charset="0"/>
+              </a:rPr>
+              <a:t>ModuleDataScaleEnvelope</a:t>
+            </a:r>
+            <a:endParaRPr lang="en-US" sz="1200" b="1" kern="100" dirty="0">
+              <a:solidFill>
+                <a:srgbClr val="000000"/>
+              </a:solidFill>
+              <a:effectLst/>
+              <a:ea typeface="Aptos" panose="020B0004020202020204" pitchFamily="34" charset="0"/>
+              <a:cs typeface="Times New Roman" panose="02020603050405020304" pitchFamily="18" charset="0"/>
+            </a:endParaRPr>
+          </a:p>
+          <a:p>
+            <a:pPr algn="ctr"/>
+            <a:r>
+              <a:rPr lang="en-US" sz="1200" kern="100" dirty="0" err="1">
+                <a:solidFill>
+                  <a:srgbClr val="000000"/>
+                </a:solidFill>
+                <a:effectLst/>
+                <a:ea typeface="Aptos" panose="020B0004020202020204" pitchFamily="34" charset="0"/>
+                <a:cs typeface="Times New Roman" panose="02020603050405020304" pitchFamily="18" charset="0"/>
+              </a:rPr>
+              <a:t>SurveyId</a:t>
+            </a:r>
+            <a:endParaRPr lang="en-US" sz="1200" kern="100" dirty="0">
+              <a:solidFill>
+                <a:srgbClr val="000000"/>
+              </a:solidFill>
+              <a:effectLst/>
+              <a:ea typeface="Aptos" panose="020B0004020202020204" pitchFamily="34" charset="0"/>
+              <a:cs typeface="Times New Roman" panose="02020603050405020304" pitchFamily="18" charset="0"/>
+            </a:endParaRPr>
+          </a:p>
+          <a:p>
+            <a:pPr algn="ctr"/>
+            <a:r>
+              <a:rPr lang="en-US" sz="1200" u="sng" kern="100" dirty="0" err="1">
+                <a:solidFill>
+                  <a:srgbClr val="000000"/>
+                </a:solidFill>
+                <a:effectLst/>
+                <a:ea typeface="Aptos" panose="020B0004020202020204" pitchFamily="34" charset="0"/>
+                <a:cs typeface="Times New Roman" panose="02020603050405020304" pitchFamily="18" charset="0"/>
+              </a:rPr>
+              <a:t>ModuleDataId</a:t>
+            </a:r>
+            <a:endParaRPr lang="en-US" sz="1200" u="sng" kern="100" dirty="0">
+              <a:solidFill>
+                <a:srgbClr val="000000"/>
+              </a:solidFill>
+              <a:effectLst/>
+              <a:ea typeface="Aptos" panose="020B0004020202020204" pitchFamily="34" charset="0"/>
+              <a:cs typeface="Times New Roman" panose="02020603050405020304" pitchFamily="18" charset="0"/>
+            </a:endParaRPr>
+          </a:p>
+          <a:p>
+            <a:pPr algn="ctr"/>
+            <a:r>
+              <a:rPr lang="en-US" sz="1200" kern="100" dirty="0" err="1">
+                <a:solidFill>
+                  <a:srgbClr val="000000"/>
+                </a:solidFill>
+                <a:effectLst/>
+                <a:ea typeface="Aptos" panose="020B0004020202020204" pitchFamily="34" charset="0"/>
+                <a:cs typeface="Times New Roman" panose="02020603050405020304" pitchFamily="18" charset="0"/>
+              </a:rPr>
+              <a:t>EnvelopeSerialNumber</a:t>
+            </a:r>
+            <a:endParaRPr lang="en-US" sz="1200" kern="100" dirty="0">
+              <a:solidFill>
+                <a:srgbClr val="000000"/>
+              </a:solidFill>
+              <a:effectLst/>
+              <a:ea typeface="Aptos" panose="020B0004020202020204" pitchFamily="34" charset="0"/>
+              <a:cs typeface="Times New Roman" panose="02020603050405020304" pitchFamily="18" charset="0"/>
+            </a:endParaRPr>
+          </a:p>
+          <a:p>
+            <a:pPr algn="ctr"/>
+            <a:r>
+              <a:rPr lang="en-US" sz="1200" u="sng" kern="100" dirty="0" err="1">
+                <a:solidFill>
+                  <a:srgbClr val="000000"/>
+                </a:solidFill>
+                <a:effectLst/>
+                <a:ea typeface="Aptos" panose="020B0004020202020204" pitchFamily="34" charset="0"/>
+                <a:cs typeface="Times New Roman" panose="02020603050405020304" pitchFamily="18" charset="0"/>
+              </a:rPr>
+              <a:t>SpeciesStrainId</a:t>
+            </a:r>
+            <a:endParaRPr lang="en-US" sz="1200" u="sng" kern="100" dirty="0">
+              <a:solidFill>
+                <a:srgbClr val="000000"/>
+              </a:solidFill>
+              <a:effectLst/>
+              <a:ea typeface="Aptos" panose="020B0004020202020204" pitchFamily="34" charset="0"/>
+              <a:cs typeface="Times New Roman" panose="02020603050405020304" pitchFamily="18" charset="0"/>
+            </a:endParaRPr>
+          </a:p>
+          <a:p>
+            <a:pPr algn="ctr"/>
+            <a:r>
+              <a:rPr lang="en-US" sz="1200" kern="100" dirty="0">
+                <a:solidFill>
+                  <a:srgbClr val="000000"/>
+                </a:solidFill>
+                <a:ea typeface="Aptos" panose="020B0004020202020204" pitchFamily="34" charset="0"/>
+                <a:cs typeface="Times New Roman" panose="02020603050405020304" pitchFamily="18" charset="0"/>
+              </a:rPr>
+              <a:t>TotalLengthInInches</a:t>
+            </a:r>
+            <a:endParaRPr lang="en-US" sz="1200" kern="100" dirty="0">
+              <a:effectLst/>
+              <a:ea typeface="Aptos" panose="020B0004020202020204" pitchFamily="34" charset="0"/>
+              <a:cs typeface="Times New Roman" panose="02020603050405020304" pitchFamily="18" charset="0"/>
+            </a:endParaRPr>
+          </a:p>
+        </p:txBody>
+      </p:sp>
+      <p:cxnSp>
+        <p:nvCxnSpPr>
+          <p:cNvPr id="78" name="Straight Arrow Connector 77">
+            <a:extLst>
+              <a:ext uri="{FF2B5EF4-FFF2-40B4-BE49-F238E27FC236}">
+                <a16:creationId xmlns:a16="http://schemas.microsoft.com/office/drawing/2014/main" id="{D3330A2B-926D-C6D3-0F2F-289098FEFD85}"/>
+              </a:ext>
+            </a:extLst>
+          </p:cNvPr>
+          <p:cNvCxnSpPr>
+            <a:cxnSpLocks/>
+            <a:stCxn id="74" idx="2"/>
+            <a:endCxn id="13" idx="0"/>
+          </p:cNvCxnSpPr>
+          <p:nvPr/>
+        </p:nvCxnSpPr>
+        <p:spPr>
+          <a:xfrm flipH="1">
+            <a:off x="2757884" y="3087092"/>
+            <a:ext cx="5329635" cy="1024850"/>
+          </a:xfrm>
+          <a:prstGeom prst="straightConnector1">
+            <a:avLst/>
+          </a:prstGeom>
+          <a:ln>
+            <a:prstDash val="sysDash"/>
+            <a:tailEnd type="triangle"/>
+          </a:ln>
+        </p:spPr>
+        <p:style>
+          <a:lnRef idx="2">
+            <a:schemeClr val="dk1"/>
+          </a:lnRef>
+          <a:fillRef idx="0">
+            <a:schemeClr val="dk1"/>
+          </a:fillRef>
+          <a:effectRef idx="1">
+            <a:schemeClr val="dk1"/>
+          </a:effectRef>
+          <a:fontRef idx="minor">
+            <a:schemeClr val="tx1"/>
+          </a:fontRef>
+        </p:style>
+      </p:cxnSp>
+      <p:cxnSp>
+        <p:nvCxnSpPr>
+          <p:cNvPr id="93" name="Straight Arrow Connector 92">
+            <a:extLst>
+              <a:ext uri="{FF2B5EF4-FFF2-40B4-BE49-F238E27FC236}">
+                <a16:creationId xmlns:a16="http://schemas.microsoft.com/office/drawing/2014/main" id="{314E1EE5-B8F4-0384-53D7-9F6889886BBE}"/>
+              </a:ext>
+            </a:extLst>
+          </p:cNvPr>
+          <p:cNvCxnSpPr>
+            <a:cxnSpLocks/>
+            <a:stCxn id="74" idx="2"/>
+            <a:endCxn id="7" idx="0"/>
+          </p:cNvCxnSpPr>
+          <p:nvPr/>
+        </p:nvCxnSpPr>
+        <p:spPr>
+          <a:xfrm flipH="1">
+            <a:off x="6468268" y="3087092"/>
+            <a:ext cx="1619251" cy="1000044"/>
+          </a:xfrm>
+          <a:prstGeom prst="straightConnector1">
+            <a:avLst/>
+          </a:prstGeom>
+          <a:ln>
+            <a:prstDash val="sysDash"/>
+            <a:tailEnd type="triangle"/>
+          </a:ln>
+        </p:spPr>
+        <p:style>
+          <a:lnRef idx="2">
+            <a:schemeClr val="dk1"/>
+          </a:lnRef>
+          <a:fillRef idx="0">
+            <a:schemeClr val="dk1"/>
+          </a:fillRef>
+          <a:effectRef idx="1">
+            <a:schemeClr val="dk1"/>
+          </a:effectRef>
+          <a:fontRef idx="minor">
+            <a:schemeClr val="tx1"/>
+          </a:fontRef>
+        </p:style>
+      </p:cxnSp>
+      <p:sp>
+        <p:nvSpPr>
+          <p:cNvPr id="11" name="Explosion: 8 Points 10">
+            <a:extLst>
+              <a:ext uri="{FF2B5EF4-FFF2-40B4-BE49-F238E27FC236}">
+                <a16:creationId xmlns:a16="http://schemas.microsoft.com/office/drawing/2014/main" id="{D98E4A45-0018-5F03-5065-F0A923C330A4}"/>
+              </a:ext>
+            </a:extLst>
+          </p:cNvPr>
+          <p:cNvSpPr/>
+          <p:nvPr/>
+        </p:nvSpPr>
+        <p:spPr>
+          <a:xfrm>
+            <a:off x="7801766" y="3280489"/>
+            <a:ext cx="2266950" cy="1703029"/>
+          </a:xfrm>
+          <a:prstGeom prst="irregularSeal1">
+            <a:avLst/>
+          </a:prstGeom>
+        </p:spPr>
+        <p:style>
+          <a:lnRef idx="2">
+            <a:schemeClr val="accent1">
+              <a:shade val="15000"/>
+            </a:schemeClr>
+          </a:lnRef>
+          <a:fillRef idx="1">
+            <a:schemeClr val="accent1"/>
+          </a:fillRef>
+          <a:effectRef idx="0">
+            <a:schemeClr val="accent1"/>
+          </a:effectRef>
+          <a:fontRef idx="minor">
+            <a:schemeClr val="lt1"/>
+          </a:fontRef>
+        </p:style>
+        <p:txBody>
+          <a:bodyPr rtlCol="0" anchor="ctr"/>
+          <a:lstStyle/>
+          <a:p>
+            <a:pPr algn="ctr"/>
+            <a:r>
+              <a:rPr lang="en-US" sz="1100" dirty="0"/>
+              <a:t>Need to confirm these joins once we have new data entered</a:t>
+            </a:r>
+          </a:p>
+        </p:txBody>
+      </p:sp>
+      <p:sp>
+        <p:nvSpPr>
+          <p:cNvPr id="19" name="Oval 1">
+            <a:extLst>
+              <a:ext uri="{FF2B5EF4-FFF2-40B4-BE49-F238E27FC236}">
+                <a16:creationId xmlns:a16="http://schemas.microsoft.com/office/drawing/2014/main" id="{FBA945CC-AEDD-0620-C24B-67113119B74E}"/>
+              </a:ext>
+            </a:extLst>
+          </p:cNvPr>
+          <p:cNvSpPr/>
+          <p:nvPr/>
+        </p:nvSpPr>
+        <p:spPr>
+          <a:xfrm>
+            <a:off x="5710235" y="5331538"/>
+            <a:ext cx="1516063" cy="1179512"/>
+          </a:xfrm>
+          <a:prstGeom prst="ellipse">
+            <a:avLst/>
+          </a:prstGeom>
+          <a:solidFill>
+            <a:srgbClr val="92D050"/>
+          </a:solidFill>
+        </p:spPr>
+        <p:style>
+          <a:lnRef idx="2">
+            <a:schemeClr val="accent1">
+              <a:shade val="15000"/>
+            </a:schemeClr>
+          </a:lnRef>
+          <a:fillRef idx="1">
+            <a:schemeClr val="accent1"/>
+          </a:fillRef>
+          <a:effectRef idx="0">
+            <a:schemeClr val="accent1"/>
+          </a:effectRef>
+          <a:fontRef idx="minor">
+            <a:schemeClr val="lt1"/>
+          </a:fontRef>
+        </p:style>
+        <p:txBody>
+          <a:bodyPr rot="0" spcFirstLastPara="0" vert="horz" wrap="square" lIns="91440" tIns="45720" rIns="91440" bIns="45720" numCol="1" spcCol="0" rtlCol="0" fromWordArt="0" anchor="ctr" anchorCtr="0" forceAA="0" compatLnSpc="1">
+            <a:prstTxWarp prst="textNoShape">
+              <a:avLst/>
+            </a:prstTxWarp>
+            <a:noAutofit/>
+          </a:bodyPr>
+          <a:lstStyle/>
+          <a:p>
+            <a:pPr algn="ctr"/>
+            <a:r>
+              <a:rPr lang="en-US" sz="1200" b="1" kern="100" dirty="0" err="1">
+                <a:solidFill>
+                  <a:srgbClr val="000000"/>
+                </a:solidFill>
+                <a:effectLst/>
+                <a:ea typeface="Aptos" panose="020B0004020202020204" pitchFamily="34" charset="0"/>
+                <a:cs typeface="Times New Roman" panose="02020603050405020304" pitchFamily="18" charset="0"/>
+              </a:rPr>
+              <a:t>FISH_query</a:t>
+            </a:r>
+            <a:endParaRPr lang="en-US" sz="1200" b="1" kern="100" dirty="0">
+              <a:solidFill>
+                <a:srgbClr val="000000"/>
+              </a:solidFill>
+              <a:ea typeface="Aptos" panose="020B0004020202020204" pitchFamily="34" charset="0"/>
+              <a:cs typeface="Times New Roman" panose="02020603050405020304" pitchFamily="18" charset="0"/>
+            </a:endParaRPr>
+          </a:p>
+        </p:txBody>
+      </p:sp>
+      <p:cxnSp>
+        <p:nvCxnSpPr>
+          <p:cNvPr id="20" name="Straight Arrow Connector 19">
+            <a:extLst>
+              <a:ext uri="{FF2B5EF4-FFF2-40B4-BE49-F238E27FC236}">
+                <a16:creationId xmlns:a16="http://schemas.microsoft.com/office/drawing/2014/main" id="{D935B0AB-F975-EC12-028C-C8C4073DD8AA}"/>
+              </a:ext>
+            </a:extLst>
+          </p:cNvPr>
+          <p:cNvCxnSpPr>
+            <a:cxnSpLocks/>
+            <a:stCxn id="19" idx="0"/>
+            <a:endCxn id="7" idx="2"/>
+          </p:cNvCxnSpPr>
+          <p:nvPr/>
+        </p:nvCxnSpPr>
+        <p:spPr>
+          <a:xfrm flipV="1">
+            <a:off x="6468267" y="4879855"/>
+            <a:ext cx="1" cy="451683"/>
+          </a:xfrm>
+          <a:prstGeom prst="straightConnector1">
+            <a:avLst/>
+          </a:prstGeom>
+          <a:ln>
+            <a:tailEnd type="triangle"/>
+          </a:ln>
+        </p:spPr>
+        <p:style>
+          <a:lnRef idx="2">
+            <a:schemeClr val="dk1"/>
+          </a:lnRef>
+          <a:fillRef idx="0">
+            <a:schemeClr val="dk1"/>
+          </a:fillRef>
+          <a:effectRef idx="1">
+            <a:schemeClr val="dk1"/>
+          </a:effectRef>
+          <a:fontRef idx="minor">
+            <a:schemeClr val="tx1"/>
+          </a:fontRef>
+        </p:style>
+      </p:cxnSp>
+    </p:spTree>
+    <p:extLst>
+      <p:ext uri="{BB962C8B-B14F-4D97-AF65-F5344CB8AC3E}">
+        <p14:creationId xmlns:p14="http://schemas.microsoft.com/office/powerpoint/2010/main" val="1454144528"/>
       </p:ext>
     </p:extLst>
   </p:cSld>

</xml_diff>

<commit_message>
added detectionByYear and updated names
</commit_message>
<xml_diff>
--- a/dev/MFA_table_joins.pptx
+++ b/dev/MFA_table_joins.pptx
@@ -120,7 +120,7 @@
 <file path=ppt/revisionInfo.xml><?xml version="1.0" encoding="utf-8"?>
 <p1510:revInfo xmlns:a="http://schemas.openxmlformats.org/drawingml/2006/main" xmlns:r="http://schemas.openxmlformats.org/officeDocument/2006/relationships" xmlns:p1510="http://schemas.microsoft.com/office/powerpoint/2015/10/main">
   <p1510:revLst>
-    <p1510:client id="{EEFF3537-259B-4121-BEBA-A217C3B649A0}" v="18" dt="2026-08-21T19:41:26.489"/>
+    <p1510:client id="{EEFF3537-259B-4121-BEBA-A217C3B649A0}" v="2" dt="2026-08-24T20:22:37.767"/>
   </p1510:revLst>
 </p1510:revInfo>
 </file>
@@ -130,12 +130,12 @@
   <pc:docChgLst>
     <pc:chgData name="Nathan, Lucas (DNR)" userId="96837891-6aae-41c1-b905-2f597761f76b" providerId="ADAL" clId="{F64F8652-B73F-49BC-A105-17EA9971C31A}"/>
     <pc:docChg chg="undo custSel addSld delSld modSld sldOrd">
-      <pc:chgData name="Nathan, Lucas (DNR)" userId="96837891-6aae-41c1-b905-2f597761f76b" providerId="ADAL" clId="{F64F8652-B73F-49BC-A105-17EA9971C31A}" dt="2026-08-21T19:41:26.489" v="1027"/>
+      <pc:chgData name="Nathan, Lucas (DNR)" userId="96837891-6aae-41c1-b905-2f597761f76b" providerId="ADAL" clId="{F64F8652-B73F-49BC-A105-17EA9971C31A}" dt="2026-08-24T20:23:14.881" v="1070" actId="20577"/>
       <pc:docMkLst>
         <pc:docMk/>
       </pc:docMkLst>
       <pc:sldChg chg="addSp delSp modSp mod">
-        <pc:chgData name="Nathan, Lucas (DNR)" userId="96837891-6aae-41c1-b905-2f597761f76b" providerId="ADAL" clId="{F64F8652-B73F-49BC-A105-17EA9971C31A}" dt="2026-08-21T19:41:26.489" v="1027"/>
+        <pc:chgData name="Nathan, Lucas (DNR)" userId="96837891-6aae-41c1-b905-2f597761f76b" providerId="ADAL" clId="{F64F8652-B73F-49BC-A105-17EA9971C31A}" dt="2026-08-24T20:23:01.755" v="1062" actId="20577"/>
         <pc:sldMkLst>
           <pc:docMk/>
           <pc:sldMk cId="4018073164" sldId="256"/>
@@ -148,12 +148,12 @@
             <ac:spMk id="3" creationId="{C83F8609-4D7A-AA38-F086-9E85B47A8159}"/>
           </ac:spMkLst>
         </pc:spChg>
-        <pc:spChg chg="add del mod">
-          <ac:chgData name="Nathan, Lucas (DNR)" userId="96837891-6aae-41c1-b905-2f597761f76b" providerId="ADAL" clId="{F64F8652-B73F-49BC-A105-17EA9971C31A}" dt="2026-08-21T19:11:18.196" v="877" actId="478"/>
+        <pc:spChg chg="add mod">
+          <ac:chgData name="Nathan, Lucas (DNR)" userId="96837891-6aae-41c1-b905-2f597761f76b" providerId="ADAL" clId="{F64F8652-B73F-49BC-A105-17EA9971C31A}" dt="2026-08-24T20:22:42.600" v="1054" actId="1076"/>
           <ac:spMkLst>
             <pc:docMk/>
             <pc:sldMk cId="4018073164" sldId="256"/>
-            <ac:spMk id="5" creationId="{D890C036-07EA-D474-9F02-C984D969ADEB}"/>
+            <ac:spMk id="5" creationId="{5CB56F00-E8BD-EC94-645A-FEECDB529A91}"/>
           </ac:spMkLst>
         </pc:spChg>
         <pc:spChg chg="mod">
@@ -180,14 +180,6 @@
             <ac:spMk id="37" creationId="{4F3D3F9A-BD58-A8B4-D609-BC9D6BE92DE4}"/>
           </ac:spMkLst>
         </pc:spChg>
-        <pc:spChg chg="del">
-          <ac:chgData name="Nathan, Lucas (DNR)" userId="96837891-6aae-41c1-b905-2f597761f76b" providerId="ADAL" clId="{F64F8652-B73F-49BC-A105-17EA9971C31A}" dt="2026-08-21T19:16:45.677" v="948" actId="478"/>
-          <ac:spMkLst>
-            <pc:docMk/>
-            <pc:sldMk cId="4018073164" sldId="256"/>
-            <ac:spMk id="113" creationId="{E4F7837C-465A-CE42-65C5-756BC6581BBA}"/>
-          </ac:spMkLst>
-        </pc:spChg>
         <pc:spChg chg="mod">
           <ac:chgData name="Nathan, Lucas (DNR)" userId="96837891-6aae-41c1-b905-2f597761f76b" providerId="ADAL" clId="{F64F8652-B73F-49BC-A105-17EA9971C31A}" dt="2026-08-21T19:12:36.084" v="879" actId="1076"/>
           <ac:spMkLst>
@@ -205,7 +197,7 @@
           </ac:spMkLst>
         </pc:spChg>
         <pc:spChg chg="mod">
-          <ac:chgData name="Nathan, Lucas (DNR)" userId="96837891-6aae-41c1-b905-2f597761f76b" providerId="ADAL" clId="{F64F8652-B73F-49BC-A105-17EA9971C31A}" dt="2026-08-21T19:14:31.176" v="894" actId="207"/>
+          <ac:chgData name="Nathan, Lucas (DNR)" userId="96837891-6aae-41c1-b905-2f597761f76b" providerId="ADAL" clId="{F64F8652-B73F-49BC-A105-17EA9971C31A}" dt="2026-08-24T20:22:20.847" v="1030"/>
           <ac:spMkLst>
             <pc:docMk/>
             <pc:sldMk cId="4018073164" sldId="256"/>
@@ -213,7 +205,7 @@
           </ac:spMkLst>
         </pc:spChg>
         <pc:spChg chg="mod">
-          <ac:chgData name="Nathan, Lucas (DNR)" userId="96837891-6aae-41c1-b905-2f597761f76b" providerId="ADAL" clId="{F64F8652-B73F-49BC-A105-17EA9971C31A}" dt="2026-08-21T19:13:04.405" v="892" actId="1076"/>
+          <ac:chgData name="Nathan, Lucas (DNR)" userId="96837891-6aae-41c1-b905-2f597761f76b" providerId="ADAL" clId="{F64F8652-B73F-49BC-A105-17EA9971C31A}" dt="2026-08-24T20:23:01.755" v="1062" actId="20577"/>
           <ac:spMkLst>
             <pc:docMk/>
             <pc:sldMk cId="4018073164" sldId="256"/>
@@ -234,6 +226,14 @@
             <pc:docMk/>
             <pc:sldMk cId="4018073164" sldId="256"/>
             <ac:cxnSpMk id="6" creationId="{6E5E4102-F999-0B05-BBF4-9FFA54A5074E}"/>
+          </ac:cxnSpMkLst>
+        </pc:cxnChg>
+        <pc:cxnChg chg="add mod">
+          <ac:chgData name="Nathan, Lucas (DNR)" userId="96837891-6aae-41c1-b905-2f597761f76b" providerId="ADAL" clId="{F64F8652-B73F-49BC-A105-17EA9971C31A}" dt="2026-08-24T20:22:42.600" v="1054" actId="1076"/>
+          <ac:cxnSpMkLst>
+            <pc:docMk/>
+            <pc:sldMk cId="4018073164" sldId="256"/>
+            <ac:cxnSpMk id="8" creationId="{CE6E467D-E8AF-C9DD-AC7F-04E2A3F21B8F}"/>
           </ac:cxnSpMkLst>
         </pc:cxnChg>
         <pc:cxnChg chg="mod">
@@ -277,8 +277,8 @@
           </ac:cxnSpMkLst>
         </pc:cxnChg>
       </pc:sldChg>
-      <pc:sldChg chg="modSp">
-        <pc:chgData name="Nathan, Lucas (DNR)" userId="96837891-6aae-41c1-b905-2f597761f76b" providerId="ADAL" clId="{F64F8652-B73F-49BC-A105-17EA9971C31A}" dt="2026-08-20T18:59:17.783" v="653"/>
+      <pc:sldChg chg="modSp mod">
+        <pc:chgData name="Nathan, Lucas (DNR)" userId="96837891-6aae-41c1-b905-2f597761f76b" providerId="ADAL" clId="{F64F8652-B73F-49BC-A105-17EA9971C31A}" dt="2026-08-24T20:23:14.881" v="1070" actId="20577"/>
         <pc:sldMkLst>
           <pc:docMk/>
           <pc:sldMk cId="3824178543" sldId="258"/>
@@ -291,6 +291,14 @@
             <ac:spMk id="2" creationId="{1036EC3D-1D78-C254-2687-3311AA086CE2}"/>
           </ac:spMkLst>
         </pc:spChg>
+        <pc:spChg chg="mod">
+          <ac:chgData name="Nathan, Lucas (DNR)" userId="96837891-6aae-41c1-b905-2f597761f76b" providerId="ADAL" clId="{F64F8652-B73F-49BC-A105-17EA9971C31A}" dt="2026-08-24T20:23:14.881" v="1070" actId="20577"/>
+          <ac:spMkLst>
+            <pc:docMk/>
+            <pc:sldMk cId="3824178543" sldId="258"/>
+            <ac:spMk id="4" creationId="{254CB11E-5E2E-302D-3DB2-2779B0D21CF0}"/>
+          </ac:spMkLst>
+        </pc:spChg>
       </pc:sldChg>
       <pc:sldChg chg="addSp delSp modSp mod">
         <pc:chgData name="Nathan, Lucas (DNR)" userId="96837891-6aae-41c1-b905-2f597761f76b" providerId="ADAL" clId="{F64F8652-B73F-49BC-A105-17EA9971C31A}" dt="2026-08-21T19:17:42.158" v="1025" actId="478"/>
@@ -298,72 +306,12 @@
           <pc:docMk/>
           <pc:sldMk cId="3322492765" sldId="261"/>
         </pc:sldMkLst>
-        <pc:spChg chg="add del mod">
-          <ac:chgData name="Nathan, Lucas (DNR)" userId="96837891-6aae-41c1-b905-2f597761f76b" providerId="ADAL" clId="{F64F8652-B73F-49BC-A105-17EA9971C31A}" dt="2026-08-21T19:17:42.158" v="1025" actId="478"/>
-          <ac:spMkLst>
-            <pc:docMk/>
-            <pc:sldMk cId="3322492765" sldId="261"/>
-            <ac:spMk id="2" creationId="{C800D204-BF40-0237-82EF-BAE3D1902204}"/>
-          </ac:spMkLst>
-        </pc:spChg>
         <pc:spChg chg="mod">
           <ac:chgData name="Nathan, Lucas (DNR)" userId="96837891-6aae-41c1-b905-2f597761f76b" providerId="ADAL" clId="{F64F8652-B73F-49BC-A105-17EA9971C31A}" dt="2026-08-20T18:59:01.779" v="651"/>
           <ac:spMkLst>
             <pc:docMk/>
             <pc:sldMk cId="3322492765" sldId="261"/>
             <ac:spMk id="74" creationId="{8794BFCB-0CD3-D62F-28BE-79835CCFE93C}"/>
-          </ac:spMkLst>
-        </pc:spChg>
-      </pc:sldChg>
-      <pc:sldChg chg="addSp del mod">
-        <pc:chgData name="Nathan, Lucas (DNR)" userId="96837891-6aae-41c1-b905-2f597761f76b" providerId="ADAL" clId="{F64F8652-B73F-49BC-A105-17EA9971C31A}" dt="2026-08-21T19:14:47.895" v="897" actId="47"/>
-        <pc:sldMkLst>
-          <pc:docMk/>
-          <pc:sldMk cId="796165095" sldId="263"/>
-        </pc:sldMkLst>
-        <pc:spChg chg="add">
-          <ac:chgData name="Nathan, Lucas (DNR)" userId="96837891-6aae-41c1-b905-2f597761f76b" providerId="ADAL" clId="{F64F8652-B73F-49BC-A105-17EA9971C31A}" dt="2026-08-21T19:08:28.523" v="874" actId="22"/>
-          <ac:spMkLst>
-            <pc:docMk/>
-            <pc:sldMk cId="796165095" sldId="263"/>
-            <ac:spMk id="5" creationId="{0FF9D8AB-0F3E-D9FB-8109-515448EB5A73}"/>
-          </ac:spMkLst>
-        </pc:spChg>
-      </pc:sldChg>
-      <pc:sldChg chg="addSp del mod">
-        <pc:chgData name="Nathan, Lucas (DNR)" userId="96837891-6aae-41c1-b905-2f597761f76b" providerId="ADAL" clId="{F64F8652-B73F-49BC-A105-17EA9971C31A}" dt="2026-08-21T19:14:45.887" v="895" actId="47"/>
-        <pc:sldMkLst>
-          <pc:docMk/>
-          <pc:sldMk cId="26251068" sldId="264"/>
-        </pc:sldMkLst>
-        <pc:spChg chg="add">
-          <ac:chgData name="Nathan, Lucas (DNR)" userId="96837891-6aae-41c1-b905-2f597761f76b" providerId="ADAL" clId="{F64F8652-B73F-49BC-A105-17EA9971C31A}" dt="2026-08-21T19:14:14.143" v="893" actId="22"/>
-          <ac:spMkLst>
-            <pc:docMk/>
-            <pc:sldMk cId="26251068" sldId="264"/>
-            <ac:spMk id="3" creationId="{17396744-5A55-9118-5178-28CB01129175}"/>
-          </ac:spMkLst>
-        </pc:spChg>
-      </pc:sldChg>
-      <pc:sldChg chg="new del">
-        <pc:chgData name="Nathan, Lucas (DNR)" userId="96837891-6aae-41c1-b905-2f597761f76b" providerId="ADAL" clId="{F64F8652-B73F-49BC-A105-17EA9971C31A}" dt="2026-08-20T18:57:47.114" v="621" actId="47"/>
-        <pc:sldMkLst>
-          <pc:docMk/>
-          <pc:sldMk cId="1830833992" sldId="265"/>
-        </pc:sldMkLst>
-      </pc:sldChg>
-      <pc:sldChg chg="modSp add del mod">
-        <pc:chgData name="Nathan, Lucas (DNR)" userId="96837891-6aae-41c1-b905-2f597761f76b" providerId="ADAL" clId="{F64F8652-B73F-49BC-A105-17EA9971C31A}" dt="2026-08-20T18:58:25.079" v="644" actId="47"/>
-        <pc:sldMkLst>
-          <pc:docMk/>
-          <pc:sldMk cId="3682069085" sldId="266"/>
-        </pc:sldMkLst>
-        <pc:spChg chg="mod">
-          <ac:chgData name="Nathan, Lucas (DNR)" userId="96837891-6aae-41c1-b905-2f597761f76b" providerId="ADAL" clId="{F64F8652-B73F-49BC-A105-17EA9971C31A}" dt="2026-08-20T18:57:57.334" v="641" actId="20577"/>
-          <ac:spMkLst>
-            <pc:docMk/>
-            <pc:sldMk cId="3682069085" sldId="266"/>
-            <ac:spMk id="4" creationId="{08866912-E5BA-9807-9452-B225735480EE}"/>
           </ac:spMkLst>
         </pc:spChg>
       </pc:sldChg>
@@ -379,22 +327,6 @@
             <pc:docMk/>
             <pc:sldMk cId="1454144528" sldId="267"/>
             <ac:spMk id="4" creationId="{94F933C4-A647-0DA0-5236-83D00C7AC93A}"/>
-          </ac:spMkLst>
-        </pc:spChg>
-        <pc:spChg chg="del">
-          <ac:chgData name="Nathan, Lucas (DNR)" userId="96837891-6aae-41c1-b905-2f597761f76b" providerId="ADAL" clId="{F64F8652-B73F-49BC-A105-17EA9971C31A}" dt="2026-08-20T18:58:26.814" v="645" actId="478"/>
-          <ac:spMkLst>
-            <pc:docMk/>
-            <pc:sldMk cId="1454144528" sldId="267"/>
-            <ac:spMk id="5" creationId="{6A356268-4562-647A-FBBC-74631ADD2549}"/>
-          </ac:spMkLst>
-        </pc:spChg>
-        <pc:spChg chg="del">
-          <ac:chgData name="Nathan, Lucas (DNR)" userId="96837891-6aae-41c1-b905-2f597761f76b" providerId="ADAL" clId="{F64F8652-B73F-49BC-A105-17EA9971C31A}" dt="2026-08-20T18:58:29.974" v="648" actId="478"/>
-          <ac:spMkLst>
-            <pc:docMk/>
-            <pc:sldMk cId="1454144528" sldId="267"/>
-            <ac:spMk id="12" creationId="{D1C4419D-EE87-1A4A-6F47-B3A5BF0A523B}"/>
           </ac:spMkLst>
         </pc:spChg>
         <pc:spChg chg="mod">
@@ -413,30 +345,6 @@
             <ac:spMk id="74" creationId="{2FA0CD76-DB46-C196-D4C5-340484EE2E9D}"/>
           </ac:spMkLst>
         </pc:spChg>
-        <pc:cxnChg chg="del mod">
-          <ac:chgData name="Nathan, Lucas (DNR)" userId="96837891-6aae-41c1-b905-2f597761f76b" providerId="ADAL" clId="{F64F8652-B73F-49BC-A105-17EA9971C31A}" dt="2026-08-20T18:58:27.734" v="646" actId="478"/>
-          <ac:cxnSpMkLst>
-            <pc:docMk/>
-            <pc:sldMk cId="1454144528" sldId="267"/>
-            <ac:cxnSpMk id="8" creationId="{3830FE5E-72A3-EF3A-2CD6-3F4A83B03528}"/>
-          </ac:cxnSpMkLst>
-        </pc:cxnChg>
-        <pc:cxnChg chg="del mod">
-          <ac:chgData name="Nathan, Lucas (DNR)" userId="96837891-6aae-41c1-b905-2f597761f76b" providerId="ADAL" clId="{F64F8652-B73F-49BC-A105-17EA9971C31A}" dt="2026-08-20T18:58:28.324" v="647" actId="478"/>
-          <ac:cxnSpMkLst>
-            <pc:docMk/>
-            <pc:sldMk cId="1454144528" sldId="267"/>
-            <ac:cxnSpMk id="14" creationId="{1D86613C-B5CD-789F-B350-CB022CFB9AAC}"/>
-          </ac:cxnSpMkLst>
-        </pc:cxnChg>
-        <pc:cxnChg chg="del mod">
-          <ac:chgData name="Nathan, Lucas (DNR)" userId="96837891-6aae-41c1-b905-2f597761f76b" providerId="ADAL" clId="{F64F8652-B73F-49BC-A105-17EA9971C31A}" dt="2026-08-20T18:58:30.574" v="649" actId="478"/>
-          <ac:cxnSpMkLst>
-            <pc:docMk/>
-            <pc:sldMk cId="1454144528" sldId="267"/>
-            <ac:cxnSpMk id="15" creationId="{7F29F53F-61B8-09AC-0D51-C9865DE4FD46}"/>
-          </ac:cxnSpMkLst>
-        </pc:cxnChg>
       </pc:sldChg>
       <pc:sldChg chg="delSp modSp add mod">
         <pc:chgData name="Nathan, Lucas (DNR)" userId="96837891-6aae-41c1-b905-2f597761f76b" providerId="ADAL" clId="{F64F8652-B73F-49BC-A105-17EA9971C31A}" dt="2026-08-21T18:43:26.124" v="796" actId="1076"/>
@@ -450,22 +358,6 @@
             <pc:docMk/>
             <pc:sldMk cId="158936071" sldId="268"/>
             <ac:spMk id="4" creationId="{6CADB27A-A354-2A95-0493-8B923E5DBA81}"/>
-          </ac:spMkLst>
-        </pc:spChg>
-        <pc:spChg chg="del">
-          <ac:chgData name="Nathan, Lucas (DNR)" userId="96837891-6aae-41c1-b905-2f597761f76b" providerId="ADAL" clId="{F64F8652-B73F-49BC-A105-17EA9971C31A}" dt="2026-08-21T18:42:00.621" v="685" actId="478"/>
-          <ac:spMkLst>
-            <pc:docMk/>
-            <pc:sldMk cId="158936071" sldId="268"/>
-            <ac:spMk id="7" creationId="{5EB89ACF-4455-C393-F521-238F3CA0EF4E}"/>
-          </ac:spMkLst>
-        </pc:spChg>
-        <pc:spChg chg="del">
-          <ac:chgData name="Nathan, Lucas (DNR)" userId="96837891-6aae-41c1-b905-2f597761f76b" providerId="ADAL" clId="{F64F8652-B73F-49BC-A105-17EA9971C31A}" dt="2026-08-21T18:43:21.828" v="795" actId="478"/>
-          <ac:spMkLst>
-            <pc:docMk/>
-            <pc:sldMk cId="158936071" sldId="268"/>
-            <ac:spMk id="11" creationId="{A3F364C1-357B-65BE-6FBC-1D8A9431288D}"/>
           </ac:spMkLst>
         </pc:spChg>
         <pc:spChg chg="mod">
@@ -484,38 +376,6 @@
             <ac:spMk id="19" creationId="{03579F9D-D5C9-CD07-D7FB-4B0CB3BA039D}"/>
           </ac:spMkLst>
         </pc:spChg>
-        <pc:spChg chg="del">
-          <ac:chgData name="Nathan, Lucas (DNR)" userId="96837891-6aae-41c1-b905-2f597761f76b" providerId="ADAL" clId="{F64F8652-B73F-49BC-A105-17EA9971C31A}" dt="2026-08-21T18:41:37.255" v="664" actId="478"/>
-          <ac:spMkLst>
-            <pc:docMk/>
-            <pc:sldMk cId="158936071" sldId="268"/>
-            <ac:spMk id="38" creationId="{6534C19D-47CE-60FF-A968-A9CB256A61D9}"/>
-          </ac:spMkLst>
-        </pc:spChg>
-        <pc:spChg chg="del">
-          <ac:chgData name="Nathan, Lucas (DNR)" userId="96837891-6aae-41c1-b905-2f597761f76b" providerId="ADAL" clId="{F64F8652-B73F-49BC-A105-17EA9971C31A}" dt="2026-08-21T18:41:38.292" v="665" actId="478"/>
-          <ac:spMkLst>
-            <pc:docMk/>
-            <pc:sldMk cId="158936071" sldId="268"/>
-            <ac:spMk id="74" creationId="{A2885D8F-AB6F-E6B6-6DCA-77E9EB1DA027}"/>
-          </ac:spMkLst>
-        </pc:spChg>
-        <pc:cxnChg chg="del mod">
-          <ac:chgData name="Nathan, Lucas (DNR)" userId="96837891-6aae-41c1-b905-2f597761f76b" providerId="ADAL" clId="{F64F8652-B73F-49BC-A105-17EA9971C31A}" dt="2026-08-21T18:43:21.125" v="794" actId="478"/>
-          <ac:cxnSpMkLst>
-            <pc:docMk/>
-            <pc:sldMk cId="158936071" sldId="268"/>
-            <ac:cxnSpMk id="20" creationId="{D0C04736-052D-0E77-AC33-129B3EA833AF}"/>
-          </ac:cxnSpMkLst>
-        </pc:cxnChg>
-        <pc:cxnChg chg="del mod">
-          <ac:chgData name="Nathan, Lucas (DNR)" userId="96837891-6aae-41c1-b905-2f597761f76b" providerId="ADAL" clId="{F64F8652-B73F-49BC-A105-17EA9971C31A}" dt="2026-08-21T18:42:03.122" v="688" actId="478"/>
-          <ac:cxnSpMkLst>
-            <pc:docMk/>
-            <pc:sldMk cId="158936071" sldId="268"/>
-            <ac:cxnSpMk id="41" creationId="{5CE21E72-8B27-4C98-F075-B547C295B6AB}"/>
-          </ac:cxnSpMkLst>
-        </pc:cxnChg>
         <pc:cxnChg chg="mod">
           <ac:chgData name="Nathan, Lucas (DNR)" userId="96837891-6aae-41c1-b905-2f597761f76b" providerId="ADAL" clId="{F64F8652-B73F-49BC-A105-17EA9971C31A}" dt="2026-08-21T18:43:26.124" v="796" actId="1076"/>
           <ac:cxnSpMkLst>
@@ -524,45 +384,6 @@
             <ac:cxnSpMk id="44" creationId="{263CA7C3-AE98-69BE-AC0A-6A4141EBCDEA}"/>
           </ac:cxnSpMkLst>
         </pc:cxnChg>
-        <pc:cxnChg chg="del mod">
-          <ac:chgData name="Nathan, Lucas (DNR)" userId="96837891-6aae-41c1-b905-2f597761f76b" providerId="ADAL" clId="{F64F8652-B73F-49BC-A105-17EA9971C31A}" dt="2026-08-21T18:42:02.692" v="687" actId="478"/>
-          <ac:cxnSpMkLst>
-            <pc:docMk/>
-            <pc:sldMk cId="158936071" sldId="268"/>
-            <ac:cxnSpMk id="78" creationId="{F9212A6A-2CDE-7B08-9C4B-9AB5EA408455}"/>
-          </ac:cxnSpMkLst>
-        </pc:cxnChg>
-        <pc:cxnChg chg="del mod">
-          <ac:chgData name="Nathan, Lucas (DNR)" userId="96837891-6aae-41c1-b905-2f597761f76b" providerId="ADAL" clId="{F64F8652-B73F-49BC-A105-17EA9971C31A}" dt="2026-08-21T18:42:02.262" v="686" actId="478"/>
-          <ac:cxnSpMkLst>
-            <pc:docMk/>
-            <pc:sldMk cId="158936071" sldId="268"/>
-            <ac:cxnSpMk id="93" creationId="{6BE08011-8016-4EC8-8E6A-4F9E2E2CD86E}"/>
-          </ac:cxnSpMkLst>
-        </pc:cxnChg>
-      </pc:sldChg>
-      <pc:sldChg chg="addSp modSp add del mod">
-        <pc:chgData name="Nathan, Lucas (DNR)" userId="96837891-6aae-41c1-b905-2f597761f76b" providerId="ADAL" clId="{F64F8652-B73F-49BC-A105-17EA9971C31A}" dt="2026-08-21T19:14:46.905" v="896" actId="47"/>
-        <pc:sldMkLst>
-          <pc:docMk/>
-          <pc:sldMk cId="3276788366" sldId="269"/>
-        </pc:sldMkLst>
-        <pc:spChg chg="add mod">
-          <ac:chgData name="Nathan, Lucas (DNR)" userId="96837891-6aae-41c1-b905-2f597761f76b" providerId="ADAL" clId="{F64F8652-B73F-49BC-A105-17EA9971C31A}" dt="2026-08-21T18:59:50.084" v="873" actId="1076"/>
-          <ac:spMkLst>
-            <pc:docMk/>
-            <pc:sldMk cId="3276788366" sldId="269"/>
-            <ac:spMk id="3" creationId="{A976EF1F-E925-4E9F-C8C9-62BD18B6F7C1}"/>
-          </ac:spMkLst>
-        </pc:spChg>
-        <pc:spChg chg="mod">
-          <ac:chgData name="Nathan, Lucas (DNR)" userId="96837891-6aae-41c1-b905-2f597761f76b" providerId="ADAL" clId="{F64F8652-B73F-49BC-A105-17EA9971C31A}" dt="2026-08-21T18:44:28.701" v="813" actId="20577"/>
-          <ac:spMkLst>
-            <pc:docMk/>
-            <pc:sldMk cId="3276788366" sldId="269"/>
-            <ac:spMk id="4" creationId="{0059EC47-C72C-6265-645E-0CDB99C5EA14}"/>
-          </ac:spMkLst>
-        </pc:spChg>
       </pc:sldChg>
     </pc:docChg>
   </pc:docChgLst>
@@ -716,7 +537,7 @@
           <a:p>
             <a:fld id="{179C5205-C240-4C15-BC7A-8B28C81B6976}" type="datetimeFigureOut">
               <a:rPr lang="en-US" smtClean="0"/>
-              <a:t>08/21/2026</a:t>
+              <a:t>08/24/2026</a:t>
             </a:fld>
             <a:endParaRPr lang="en-US"/>
           </a:p>
@@ -914,7 +735,7 @@
           <a:p>
             <a:fld id="{179C5205-C240-4C15-BC7A-8B28C81B6976}" type="datetimeFigureOut">
               <a:rPr lang="en-US" smtClean="0"/>
-              <a:t>08/21/2026</a:t>
+              <a:t>08/24/2026</a:t>
             </a:fld>
             <a:endParaRPr lang="en-US"/>
           </a:p>
@@ -1122,7 +943,7 @@
           <a:p>
             <a:fld id="{179C5205-C240-4C15-BC7A-8B28C81B6976}" type="datetimeFigureOut">
               <a:rPr lang="en-US" smtClean="0"/>
-              <a:t>08/21/2026</a:t>
+              <a:t>08/24/2026</a:t>
             </a:fld>
             <a:endParaRPr lang="en-US"/>
           </a:p>
@@ -1320,7 +1141,7 @@
           <a:p>
             <a:fld id="{179C5205-C240-4C15-BC7A-8B28C81B6976}" type="datetimeFigureOut">
               <a:rPr lang="en-US" smtClean="0"/>
-              <a:t>08/21/2026</a:t>
+              <a:t>08/24/2026</a:t>
             </a:fld>
             <a:endParaRPr lang="en-US"/>
           </a:p>
@@ -1595,7 +1416,7 @@
           <a:p>
             <a:fld id="{179C5205-C240-4C15-BC7A-8B28C81B6976}" type="datetimeFigureOut">
               <a:rPr lang="en-US" smtClean="0"/>
-              <a:t>08/21/2026</a:t>
+              <a:t>08/24/2026</a:t>
             </a:fld>
             <a:endParaRPr lang="en-US"/>
           </a:p>
@@ -1860,7 +1681,7 @@
           <a:p>
             <a:fld id="{179C5205-C240-4C15-BC7A-8B28C81B6976}" type="datetimeFigureOut">
               <a:rPr lang="en-US" smtClean="0"/>
-              <a:t>08/21/2026</a:t>
+              <a:t>08/24/2026</a:t>
             </a:fld>
             <a:endParaRPr lang="en-US"/>
           </a:p>
@@ -2272,7 +2093,7 @@
           <a:p>
             <a:fld id="{179C5205-C240-4C15-BC7A-8B28C81B6976}" type="datetimeFigureOut">
               <a:rPr lang="en-US" smtClean="0"/>
-              <a:t>08/21/2026</a:t>
+              <a:t>08/24/2026</a:t>
             </a:fld>
             <a:endParaRPr lang="en-US"/>
           </a:p>
@@ -2413,7 +2234,7 @@
           <a:p>
             <a:fld id="{179C5205-C240-4C15-BC7A-8B28C81B6976}" type="datetimeFigureOut">
               <a:rPr lang="en-US" smtClean="0"/>
-              <a:t>08/21/2026</a:t>
+              <a:t>08/24/2026</a:t>
             </a:fld>
             <a:endParaRPr lang="en-US"/>
           </a:p>
@@ -2526,7 +2347,7 @@
           <a:p>
             <a:fld id="{179C5205-C240-4C15-BC7A-8B28C81B6976}" type="datetimeFigureOut">
               <a:rPr lang="en-US" smtClean="0"/>
-              <a:t>08/21/2026</a:t>
+              <a:t>08/24/2026</a:t>
             </a:fld>
             <a:endParaRPr lang="en-US"/>
           </a:p>
@@ -2837,7 +2658,7 @@
           <a:p>
             <a:fld id="{179C5205-C240-4C15-BC7A-8B28C81B6976}" type="datetimeFigureOut">
               <a:rPr lang="en-US" smtClean="0"/>
-              <a:t>08/21/2026</a:t>
+              <a:t>08/24/2026</a:t>
             </a:fld>
             <a:endParaRPr lang="en-US"/>
           </a:p>
@@ -3125,7 +2946,7 @@
           <a:p>
             <a:fld id="{179C5205-C240-4C15-BC7A-8B28C81B6976}" type="datetimeFigureOut">
               <a:rPr lang="en-US" smtClean="0"/>
-              <a:t>08/21/2026</a:t>
+              <a:t>08/24/2026</a:t>
             </a:fld>
             <a:endParaRPr lang="en-US"/>
           </a:p>
@@ -3366,7 +3187,7 @@
           <a:p>
             <a:fld id="{179C5205-C240-4C15-BC7A-8B28C81B6976}" type="datetimeFigureOut">
               <a:rPr lang="en-US" smtClean="0"/>
-              <a:t>08/21/2026</a:t>
+              <a:t>08/24/2026</a:t>
             </a:fld>
             <a:endParaRPr lang="en-US"/>
           </a:p>
@@ -4087,7 +3908,7 @@
           <a:p>
             <a:pPr algn="ctr"/>
             <a:r>
-              <a:rPr lang="en-US" sz="1200" b="1" u="sng" kern="100" dirty="0" err="1">
+              <a:rPr lang="en-US" sz="1200" b="1" u="sng" kern="100">
                 <a:solidFill>
                   <a:srgbClr val="000000"/>
                 </a:solidFill>
@@ -4162,7 +3983,7 @@
                 <a:ea typeface="Aptos" panose="020B0004020202020204" pitchFamily="34" charset="0"/>
                 <a:cs typeface="Times New Roman" panose="02020603050405020304" pitchFamily="18" charset="0"/>
               </a:rPr>
-              <a:t>age_length_summary</a:t>
+              <a:t>ageLengthSummary</a:t>
             </a:r>
             <a:endParaRPr lang="en-US" sz="1200" u="sng" kern="100" dirty="0">
               <a:effectLst/>
@@ -4680,6 +4501,118 @@
           </a:p>
         </p:txBody>
       </p:sp>
+      <p:sp>
+        <p:nvSpPr>
+          <p:cNvPr id="5" name="Oval 1">
+            <a:extLst>
+              <a:ext uri="{FF2B5EF4-FFF2-40B4-BE49-F238E27FC236}">
+                <a16:creationId xmlns:a16="http://schemas.microsoft.com/office/drawing/2014/main" id="{5CB56F00-E8BD-EC94-645A-FEECDB529A91}"/>
+              </a:ext>
+            </a:extLst>
+          </p:cNvPr>
+          <p:cNvSpPr/>
+          <p:nvPr/>
+        </p:nvSpPr>
+        <p:spPr>
+          <a:xfrm>
+            <a:off x="9592696" y="3047462"/>
+            <a:ext cx="2532065" cy="1179512"/>
+          </a:xfrm>
+          <a:prstGeom prst="ellipse">
+            <a:avLst/>
+          </a:prstGeom>
+          <a:solidFill>
+            <a:schemeClr val="accent2"/>
+          </a:solidFill>
+        </p:spPr>
+        <p:style>
+          <a:lnRef idx="2">
+            <a:schemeClr val="accent1">
+              <a:shade val="15000"/>
+            </a:schemeClr>
+          </a:lnRef>
+          <a:fillRef idx="1">
+            <a:schemeClr val="accent1"/>
+          </a:fillRef>
+          <a:effectRef idx="0">
+            <a:schemeClr val="accent1"/>
+          </a:effectRef>
+          <a:fontRef idx="minor">
+            <a:schemeClr val="lt1"/>
+          </a:fontRef>
+        </p:style>
+        <p:txBody>
+          <a:bodyPr rot="0" spcFirstLastPara="0" vert="horz" wrap="square" lIns="91440" tIns="45720" rIns="91440" bIns="45720" numCol="1" spcCol="0" rtlCol="0" fromWordArt="0" anchor="ctr" anchorCtr="0" forceAA="0" compatLnSpc="1">
+            <a:prstTxWarp prst="textNoShape">
+              <a:avLst/>
+            </a:prstTxWarp>
+            <a:noAutofit/>
+          </a:bodyPr>
+          <a:lstStyle/>
+          <a:p>
+            <a:pPr algn="ctr"/>
+            <a:r>
+              <a:rPr lang="en-US" sz="1200" b="1" u="sng" kern="100" dirty="0" err="1">
+                <a:solidFill>
+                  <a:srgbClr val="000000"/>
+                </a:solidFill>
+                <a:effectLst/>
+                <a:ea typeface="Aptos" panose="020B0004020202020204" pitchFamily="34" charset="0"/>
+                <a:cs typeface="Times New Roman" panose="02020603050405020304" pitchFamily="18" charset="0"/>
+              </a:rPr>
+              <a:t>detectionByYear</a:t>
+            </a:r>
+            <a:endParaRPr lang="en-US" sz="1200" u="sng" kern="100" dirty="0">
+              <a:effectLst/>
+              <a:ea typeface="Aptos" panose="020B0004020202020204" pitchFamily="34" charset="0"/>
+              <a:cs typeface="Times New Roman" panose="02020603050405020304" pitchFamily="18" charset="0"/>
+            </a:endParaRPr>
+          </a:p>
+        </p:txBody>
+      </p:sp>
+      <p:cxnSp>
+        <p:nvCxnSpPr>
+          <p:cNvPr id="8" name="Straight Arrow Connector 7">
+            <a:extLst>
+              <a:ext uri="{FF2B5EF4-FFF2-40B4-BE49-F238E27FC236}">
+                <a16:creationId xmlns:a16="http://schemas.microsoft.com/office/drawing/2014/main" id="{CE6E467D-E8AF-C9DD-AC7F-04E2A3F21B8F}"/>
+              </a:ext>
+            </a:extLst>
+          </p:cNvPr>
+          <p:cNvCxnSpPr>
+            <a:cxnSpLocks/>
+            <a:stCxn id="114" idx="6"/>
+            <a:endCxn id="5" idx="1"/>
+          </p:cNvCxnSpPr>
+          <p:nvPr/>
+        </p:nvCxnSpPr>
+        <p:spPr>
+          <a:xfrm>
+            <a:off x="6096000" y="2457706"/>
+            <a:ext cx="3867508" cy="762492"/>
+          </a:xfrm>
+          <a:prstGeom prst="straightConnector1">
+            <a:avLst/>
+          </a:prstGeom>
+          <a:ln>
+            <a:tailEnd type="triangle"/>
+          </a:ln>
+        </p:spPr>
+        <p:style>
+          <a:lnRef idx="2">
+            <a:schemeClr val="dk1"/>
+          </a:lnRef>
+          <a:fillRef idx="0">
+            <a:schemeClr val="dk1"/>
+          </a:fillRef>
+          <a:effectRef idx="1">
+            <a:schemeClr val="dk1"/>
+          </a:effectRef>
+          <a:fontRef idx="minor">
+            <a:schemeClr val="tx1"/>
+          </a:fontRef>
+        </p:style>
+      </p:cxnSp>
     </p:spTree>
     <p:extLst>
       <p:ext uri="{BB962C8B-B14F-4D97-AF65-F5344CB8AC3E}">
@@ -9034,7 +8967,7 @@
           <a:p>
             <a:r>
               <a:rPr lang="en-US" dirty="0" err="1"/>
-              <a:t>Age_length_summary</a:t>
+              <a:t>ageLengthSummary</a:t>
             </a:r>
             <a:endParaRPr lang="en-US" dirty="0"/>
           </a:p>

</xml_diff>

<commit_message>
updated after FISH_query/catchByEffort updates
</commit_message>
<xml_diff>
--- a/dev/MFA_table_joins.pptx
+++ b/dev/MFA_table_joins.pptx
@@ -120,7 +120,7 @@
 <file path=ppt/revisionInfo.xml><?xml version="1.0" encoding="utf-8"?>
 <p1510:revInfo xmlns:a="http://schemas.openxmlformats.org/drawingml/2006/main" xmlns:r="http://schemas.openxmlformats.org/officeDocument/2006/relationships" xmlns:p1510="http://schemas.microsoft.com/office/powerpoint/2015/10/main">
   <p1510:revLst>
-    <p1510:client id="{EEFF3537-259B-4121-BEBA-A217C3B649A0}" v="2" dt="2026-08-24T20:22:37.767"/>
+    <p1510:client id="{AC5AC92B-2308-4395-BD5A-764B9D49FDF5}" v="3" dt="2026-09-29T19:41:01.256"/>
   </p1510:revLst>
 </p1510:revInfo>
 </file>
@@ -130,260 +130,63 @@
   <pc:docChgLst>
     <pc:chgData name="Nathan, Lucas (DNR)" userId="96837891-6aae-41c1-b905-2f597761f76b" providerId="ADAL" clId="{F64F8652-B73F-49BC-A105-17EA9971C31A}"/>
     <pc:docChg chg="undo custSel addSld delSld modSld sldOrd">
-      <pc:chgData name="Nathan, Lucas (DNR)" userId="96837891-6aae-41c1-b905-2f597761f76b" providerId="ADAL" clId="{F64F8652-B73F-49BC-A105-17EA9971C31A}" dt="2026-08-24T20:23:14.881" v="1070" actId="20577"/>
+      <pc:chgData name="Nathan, Lucas (DNR)" userId="96837891-6aae-41c1-b905-2f597761f76b" providerId="ADAL" clId="{F64F8652-B73F-49BC-A105-17EA9971C31A}" dt="2026-09-29T19:41:26.794" v="1089" actId="1076"/>
       <pc:docMkLst>
         <pc:docMk/>
       </pc:docMkLst>
       <pc:sldChg chg="addSp delSp modSp mod">
-        <pc:chgData name="Nathan, Lucas (DNR)" userId="96837891-6aae-41c1-b905-2f597761f76b" providerId="ADAL" clId="{F64F8652-B73F-49BC-A105-17EA9971C31A}" dt="2026-08-24T20:23:01.755" v="1062" actId="20577"/>
+        <pc:chgData name="Nathan, Lucas (DNR)" userId="96837891-6aae-41c1-b905-2f597761f76b" providerId="ADAL" clId="{F64F8652-B73F-49BC-A105-17EA9971C31A}" dt="2026-09-29T19:41:12.424" v="1087" actId="478"/>
         <pc:sldMkLst>
           <pc:docMk/>
           <pc:sldMk cId="4018073164" sldId="256"/>
         </pc:sldMkLst>
         <pc:spChg chg="add mod">
-          <ac:chgData name="Nathan, Lucas (DNR)" userId="96837891-6aae-41c1-b905-2f597761f76b" providerId="ADAL" clId="{F64F8652-B73F-49BC-A105-17EA9971C31A}" dt="2026-08-21T19:13:01.470" v="890" actId="1076"/>
+          <ac:chgData name="Nathan, Lucas (DNR)" userId="96837891-6aae-41c1-b905-2f597761f76b" providerId="ADAL" clId="{F64F8652-B73F-49BC-A105-17EA9971C31A}" dt="2026-09-29T19:41:10.244" v="1086" actId="1076"/>
           <ac:spMkLst>
             <pc:docMk/>
             <pc:sldMk cId="4018073164" sldId="256"/>
-            <ac:spMk id="3" creationId="{C83F8609-4D7A-AA38-F086-9E85B47A8159}"/>
+            <ac:spMk id="11" creationId="{BB7CA647-AE2A-13CD-C36F-8D1D8DAC0349}"/>
           </ac:spMkLst>
         </pc:spChg>
-        <pc:spChg chg="add mod">
-          <ac:chgData name="Nathan, Lucas (DNR)" userId="96837891-6aae-41c1-b905-2f597761f76b" providerId="ADAL" clId="{F64F8652-B73F-49BC-A105-17EA9971C31A}" dt="2026-08-24T20:22:42.600" v="1054" actId="1076"/>
-          <ac:spMkLst>
-            <pc:docMk/>
-            <pc:sldMk cId="4018073164" sldId="256"/>
-            <ac:spMk id="5" creationId="{5CB56F00-E8BD-EC94-645A-FEECDB529A91}"/>
-          </ac:spMkLst>
-        </pc:spChg>
-        <pc:spChg chg="mod">
-          <ac:chgData name="Nathan, Lucas (DNR)" userId="96837891-6aae-41c1-b905-2f597761f76b" providerId="ADAL" clId="{F64F8652-B73F-49BC-A105-17EA9971C31A}" dt="2026-08-21T19:12:44.737" v="883" actId="1076"/>
-          <ac:spMkLst>
-            <pc:docMk/>
-            <pc:sldMk cId="4018073164" sldId="256"/>
-            <ac:spMk id="7" creationId="{4FE9BE98-0136-BEEC-A5C5-767111FEA440}"/>
-          </ac:spMkLst>
-        </pc:spChg>
-        <pc:spChg chg="add mod">
-          <ac:chgData name="Nathan, Lucas (DNR)" userId="96837891-6aae-41c1-b905-2f597761f76b" providerId="ADAL" clId="{F64F8652-B73F-49BC-A105-17EA9971C31A}" dt="2026-08-21T19:15:31.781" v="928" actId="20577"/>
-          <ac:spMkLst>
-            <pc:docMk/>
-            <pc:sldMk cId="4018073164" sldId="256"/>
-            <ac:spMk id="35" creationId="{8B85A523-01A2-1DA7-72C4-D28D66DEECBB}"/>
-          </ac:spMkLst>
-        </pc:spChg>
-        <pc:spChg chg="add mod">
-          <ac:chgData name="Nathan, Lucas (DNR)" userId="96837891-6aae-41c1-b905-2f597761f76b" providerId="ADAL" clId="{F64F8652-B73F-49BC-A105-17EA9971C31A}" dt="2026-08-21T19:15:49.776" v="947" actId="207"/>
-          <ac:spMkLst>
-            <pc:docMk/>
-            <pc:sldMk cId="4018073164" sldId="256"/>
-            <ac:spMk id="37" creationId="{4F3D3F9A-BD58-A8B4-D609-BC9D6BE92DE4}"/>
-          </ac:spMkLst>
-        </pc:spChg>
-        <pc:spChg chg="mod">
-          <ac:chgData name="Nathan, Lucas (DNR)" userId="96837891-6aae-41c1-b905-2f597761f76b" providerId="ADAL" clId="{F64F8652-B73F-49BC-A105-17EA9971C31A}" dt="2026-08-21T19:12:36.084" v="879" actId="1076"/>
-          <ac:spMkLst>
-            <pc:docMk/>
-            <pc:sldMk cId="4018073164" sldId="256"/>
-            <ac:spMk id="114" creationId="{22A466D5-AAD0-3071-6965-5C1B6750E217}"/>
-          </ac:spMkLst>
-        </pc:spChg>
-        <pc:spChg chg="mod">
-          <ac:chgData name="Nathan, Lucas (DNR)" userId="96837891-6aae-41c1-b905-2f597761f76b" providerId="ADAL" clId="{F64F8652-B73F-49BC-A105-17EA9971C31A}" dt="2026-08-21T19:41:26.489" v="1027"/>
-          <ac:spMkLst>
-            <pc:docMk/>
-            <pc:sldMk cId="4018073164" sldId="256"/>
-            <ac:spMk id="115" creationId="{35491D12-1809-8137-CC33-DAD53068DEB8}"/>
-          </ac:spMkLst>
-        </pc:spChg>
-        <pc:spChg chg="mod">
-          <ac:chgData name="Nathan, Lucas (DNR)" userId="96837891-6aae-41c1-b905-2f597761f76b" providerId="ADAL" clId="{F64F8652-B73F-49BC-A105-17EA9971C31A}" dt="2026-08-24T20:22:20.847" v="1030"/>
-          <ac:spMkLst>
-            <pc:docMk/>
-            <pc:sldMk cId="4018073164" sldId="256"/>
-            <ac:spMk id="131" creationId="{0F4BA67F-0E14-F6A5-745D-BF7DA8036AB2}"/>
-          </ac:spMkLst>
-        </pc:spChg>
-        <pc:spChg chg="mod">
-          <ac:chgData name="Nathan, Lucas (DNR)" userId="96837891-6aae-41c1-b905-2f597761f76b" providerId="ADAL" clId="{F64F8652-B73F-49BC-A105-17EA9971C31A}" dt="2026-08-24T20:23:01.755" v="1062" actId="20577"/>
-          <ac:spMkLst>
-            <pc:docMk/>
-            <pc:sldMk cId="4018073164" sldId="256"/>
-            <ac:spMk id="134" creationId="{71B0AA02-42DC-A02A-5D95-F1E49F6BBBB7}"/>
-          </ac:spMkLst>
-        </pc:spChg>
-        <pc:spChg chg="mod">
-          <ac:chgData name="Nathan, Lucas (DNR)" userId="96837891-6aae-41c1-b905-2f597761f76b" providerId="ADAL" clId="{F64F8652-B73F-49BC-A105-17EA9971C31A}" dt="2026-08-21T19:13:02.732" v="891" actId="1076"/>
-          <ac:spMkLst>
-            <pc:docMk/>
-            <pc:sldMk cId="4018073164" sldId="256"/>
-            <ac:spMk id="146" creationId="{243A9D08-314D-3FF0-8773-EA0BED2236E8}"/>
-          </ac:spMkLst>
-        </pc:spChg>
-        <pc:cxnChg chg="add mod">
-          <ac:chgData name="Nathan, Lucas (DNR)" userId="96837891-6aae-41c1-b905-2f597761f76b" providerId="ADAL" clId="{F64F8652-B73F-49BC-A105-17EA9971C31A}" dt="2026-08-21T19:13:02.732" v="891" actId="1076"/>
+        <pc:cxnChg chg="add del mod">
+          <ac:chgData name="Nathan, Lucas (DNR)" userId="96837891-6aae-41c1-b905-2f597761f76b" providerId="ADAL" clId="{F64F8652-B73F-49BC-A105-17EA9971C31A}" dt="2026-09-29T19:41:12.424" v="1087" actId="478"/>
           <ac:cxnSpMkLst>
             <pc:docMk/>
             <pc:sldMk cId="4018073164" sldId="256"/>
-            <ac:cxnSpMk id="6" creationId="{6E5E4102-F999-0B05-BBF4-9FFA54A5074E}"/>
+            <ac:cxnSpMk id="2" creationId="{14617A0D-EB9F-2B33-822A-7FA2DEBB957C}"/>
           </ac:cxnSpMkLst>
         </pc:cxnChg>
-        <pc:cxnChg chg="add mod">
-          <ac:chgData name="Nathan, Lucas (DNR)" userId="96837891-6aae-41c1-b905-2f597761f76b" providerId="ADAL" clId="{F64F8652-B73F-49BC-A105-17EA9971C31A}" dt="2026-08-24T20:22:42.600" v="1054" actId="1076"/>
+        <pc:cxnChg chg="add del mod">
+          <ac:chgData name="Nathan, Lucas (DNR)" userId="96837891-6aae-41c1-b905-2f597761f76b" providerId="ADAL" clId="{F64F8652-B73F-49BC-A105-17EA9971C31A}" dt="2026-09-29T19:40:48.294" v="1078" actId="478"/>
           <ac:cxnSpMkLst>
             <pc:docMk/>
             <pc:sldMk cId="4018073164" sldId="256"/>
-            <ac:cxnSpMk id="8" creationId="{CE6E467D-E8AF-C9DD-AC7F-04E2A3F21B8F}"/>
+            <ac:cxnSpMk id="10" creationId="{669BFF34-9D1C-78DB-4BAB-183AEF5AA4F4}"/>
           </ac:cxnSpMkLst>
         </pc:cxnChg>
         <pc:cxnChg chg="mod">
-          <ac:chgData name="Nathan, Lucas (DNR)" userId="96837891-6aae-41c1-b905-2f597761f76b" providerId="ADAL" clId="{F64F8652-B73F-49BC-A105-17EA9971C31A}" dt="2026-08-21T19:12:44.737" v="883" actId="1076"/>
+          <ac:chgData name="Nathan, Lucas (DNR)" userId="96837891-6aae-41c1-b905-2f597761f76b" providerId="ADAL" clId="{F64F8652-B73F-49BC-A105-17EA9971C31A}" dt="2026-09-29T19:40:24.330" v="1071" actId="17032"/>
           <ac:cxnSpMkLst>
             <pc:docMk/>
             <pc:sldMk cId="4018073164" sldId="256"/>
             <ac:cxnSpMk id="12" creationId="{81A26EC5-D573-533A-BC0E-C461C4C8848C}"/>
           </ac:cxnSpMkLst>
         </pc:cxnChg>
-        <pc:cxnChg chg="mod">
-          <ac:chgData name="Nathan, Lucas (DNR)" userId="96837891-6aae-41c1-b905-2f597761f76b" providerId="ADAL" clId="{F64F8652-B73F-49BC-A105-17EA9971C31A}" dt="2026-08-21T19:12:44.737" v="883" actId="1076"/>
-          <ac:cxnSpMkLst>
-            <pc:docMk/>
-            <pc:sldMk cId="4018073164" sldId="256"/>
-            <ac:cxnSpMk id="119" creationId="{E5FC0A42-AE9F-0B0B-485B-29F8C0298083}"/>
-          </ac:cxnSpMkLst>
-        </pc:cxnChg>
-        <pc:cxnChg chg="mod">
-          <ac:chgData name="Nathan, Lucas (DNR)" userId="96837891-6aae-41c1-b905-2f597761f76b" providerId="ADAL" clId="{F64F8652-B73F-49BC-A105-17EA9971C31A}" dt="2026-08-21T19:12:44.737" v="883" actId="1076"/>
-          <ac:cxnSpMkLst>
-            <pc:docMk/>
-            <pc:sldMk cId="4018073164" sldId="256"/>
-            <ac:cxnSpMk id="127" creationId="{4523B275-7E03-2157-6D4C-DDEFFA1D55B1}"/>
-          </ac:cxnSpMkLst>
-        </pc:cxnChg>
-        <pc:cxnChg chg="mod">
-          <ac:chgData name="Nathan, Lucas (DNR)" userId="96837891-6aae-41c1-b905-2f597761f76b" providerId="ADAL" clId="{F64F8652-B73F-49BC-A105-17EA9971C31A}" dt="2026-08-21T19:13:04.405" v="892" actId="1076"/>
-          <ac:cxnSpMkLst>
-            <pc:docMk/>
-            <pc:sldMk cId="4018073164" sldId="256"/>
-            <ac:cxnSpMk id="137" creationId="{72489654-A647-3A7F-4431-D5E48C7D81F8}"/>
-          </ac:cxnSpMkLst>
-        </pc:cxnChg>
-        <pc:cxnChg chg="mod">
-          <ac:chgData name="Nathan, Lucas (DNR)" userId="96837891-6aae-41c1-b905-2f597761f76b" providerId="ADAL" clId="{F64F8652-B73F-49BC-A105-17EA9971C31A}" dt="2026-08-21T19:13:01.470" v="890" actId="1076"/>
-          <ac:cxnSpMkLst>
-            <pc:docMk/>
-            <pc:sldMk cId="4018073164" sldId="256"/>
-            <ac:cxnSpMk id="143" creationId="{BF46648B-8EDA-6C28-B5D0-4CED0A3094C8}"/>
-          </ac:cxnSpMkLst>
-        </pc:cxnChg>
       </pc:sldChg>
-      <pc:sldChg chg="modSp mod">
-        <pc:chgData name="Nathan, Lucas (DNR)" userId="96837891-6aae-41c1-b905-2f597761f76b" providerId="ADAL" clId="{F64F8652-B73F-49BC-A105-17EA9971C31A}" dt="2026-08-24T20:23:14.881" v="1070" actId="20577"/>
-        <pc:sldMkLst>
-          <pc:docMk/>
-          <pc:sldMk cId="3824178543" sldId="258"/>
-        </pc:sldMkLst>
-        <pc:spChg chg="mod">
-          <ac:chgData name="Nathan, Lucas (DNR)" userId="96837891-6aae-41c1-b905-2f597761f76b" providerId="ADAL" clId="{F64F8652-B73F-49BC-A105-17EA9971C31A}" dt="2026-08-20T18:59:17.783" v="653"/>
-          <ac:spMkLst>
-            <pc:docMk/>
-            <pc:sldMk cId="3824178543" sldId="258"/>
-            <ac:spMk id="2" creationId="{1036EC3D-1D78-C254-2687-3311AA086CE2}"/>
-          </ac:spMkLst>
-        </pc:spChg>
-        <pc:spChg chg="mod">
-          <ac:chgData name="Nathan, Lucas (DNR)" userId="96837891-6aae-41c1-b905-2f597761f76b" providerId="ADAL" clId="{F64F8652-B73F-49BC-A105-17EA9971C31A}" dt="2026-08-24T20:23:14.881" v="1070" actId="20577"/>
-          <ac:spMkLst>
-            <pc:docMk/>
-            <pc:sldMk cId="3824178543" sldId="258"/>
-            <ac:spMk id="4" creationId="{254CB11E-5E2E-302D-3DB2-2779B0D21CF0}"/>
-          </ac:spMkLst>
-        </pc:spChg>
-      </pc:sldChg>
-      <pc:sldChg chg="addSp delSp modSp mod">
-        <pc:chgData name="Nathan, Lucas (DNR)" userId="96837891-6aae-41c1-b905-2f597761f76b" providerId="ADAL" clId="{F64F8652-B73F-49BC-A105-17EA9971C31A}" dt="2026-08-21T19:17:42.158" v="1025" actId="478"/>
+      <pc:sldChg chg="addSp modSp mod">
+        <pc:chgData name="Nathan, Lucas (DNR)" userId="96837891-6aae-41c1-b905-2f597761f76b" providerId="ADAL" clId="{F64F8652-B73F-49BC-A105-17EA9971C31A}" dt="2026-09-29T19:41:26.794" v="1089" actId="1076"/>
         <pc:sldMkLst>
           <pc:docMk/>
           <pc:sldMk cId="3322492765" sldId="261"/>
         </pc:sldMkLst>
-        <pc:spChg chg="mod">
-          <ac:chgData name="Nathan, Lucas (DNR)" userId="96837891-6aae-41c1-b905-2f597761f76b" providerId="ADAL" clId="{F64F8652-B73F-49BC-A105-17EA9971C31A}" dt="2026-08-20T18:59:01.779" v="651"/>
+        <pc:spChg chg="add mod">
+          <ac:chgData name="Nathan, Lucas (DNR)" userId="96837891-6aae-41c1-b905-2f597761f76b" providerId="ADAL" clId="{F64F8652-B73F-49BC-A105-17EA9971C31A}" dt="2026-09-29T19:41:26.794" v="1089" actId="1076"/>
           <ac:spMkLst>
             <pc:docMk/>
             <pc:sldMk cId="3322492765" sldId="261"/>
-            <ac:spMk id="74" creationId="{8794BFCB-0CD3-D62F-28BE-79835CCFE93C}"/>
+            <ac:spMk id="3" creationId="{CAF8DB76-DF0D-6DA6-0FC9-4A9E564AFA44}"/>
           </ac:spMkLst>
         </pc:spChg>
-      </pc:sldChg>
-      <pc:sldChg chg="delSp modSp add mod ord">
-        <pc:chgData name="Nathan, Lucas (DNR)" userId="96837891-6aae-41c1-b905-2f597761f76b" providerId="ADAL" clId="{F64F8652-B73F-49BC-A105-17EA9971C31A}" dt="2026-08-21T18:43:53.668" v="797" actId="115"/>
-        <pc:sldMkLst>
-          <pc:docMk/>
-          <pc:sldMk cId="1454144528" sldId="267"/>
-        </pc:sldMkLst>
-        <pc:spChg chg="mod">
-          <ac:chgData name="Nathan, Lucas (DNR)" userId="96837891-6aae-41c1-b905-2f597761f76b" providerId="ADAL" clId="{F64F8652-B73F-49BC-A105-17EA9971C31A}" dt="2026-08-20T18:59:51.633" v="655" actId="20577"/>
-          <ac:spMkLst>
-            <pc:docMk/>
-            <pc:sldMk cId="1454144528" sldId="267"/>
-            <ac:spMk id="4" creationId="{94F933C4-A647-0DA0-5236-83D00C7AC93A}"/>
-          </ac:spMkLst>
-        </pc:spChg>
-        <pc:spChg chg="mod">
-          <ac:chgData name="Nathan, Lucas (DNR)" userId="96837891-6aae-41c1-b905-2f597761f76b" providerId="ADAL" clId="{F64F8652-B73F-49BC-A105-17EA9971C31A}" dt="2026-08-21T18:43:53.668" v="797" actId="115"/>
-          <ac:spMkLst>
-            <pc:docMk/>
-            <pc:sldMk cId="1454144528" sldId="267"/>
-            <ac:spMk id="13" creationId="{5739946C-9A4D-7611-F89B-0C4B17EA0446}"/>
-          </ac:spMkLst>
-        </pc:spChg>
-        <pc:spChg chg="mod">
-          <ac:chgData name="Nathan, Lucas (DNR)" userId="96837891-6aae-41c1-b905-2f597761f76b" providerId="ADAL" clId="{F64F8652-B73F-49BC-A105-17EA9971C31A}" dt="2026-08-20T18:58:57.064" v="650"/>
-          <ac:spMkLst>
-            <pc:docMk/>
-            <pc:sldMk cId="1454144528" sldId="267"/>
-            <ac:spMk id="74" creationId="{2FA0CD76-DB46-C196-D4C5-340484EE2E9D}"/>
-          </ac:spMkLst>
-        </pc:spChg>
-      </pc:sldChg>
-      <pc:sldChg chg="delSp modSp add mod">
-        <pc:chgData name="Nathan, Lucas (DNR)" userId="96837891-6aae-41c1-b905-2f597761f76b" providerId="ADAL" clId="{F64F8652-B73F-49BC-A105-17EA9971C31A}" dt="2026-08-21T18:43:26.124" v="796" actId="1076"/>
-        <pc:sldMkLst>
-          <pc:docMk/>
-          <pc:sldMk cId="158936071" sldId="268"/>
-        </pc:sldMkLst>
-        <pc:spChg chg="mod">
-          <ac:chgData name="Nathan, Lucas (DNR)" userId="96837891-6aae-41c1-b905-2f597761f76b" providerId="ADAL" clId="{F64F8652-B73F-49BC-A105-17EA9971C31A}" dt="2026-08-21T18:41:24.432" v="663" actId="20577"/>
-          <ac:spMkLst>
-            <pc:docMk/>
-            <pc:sldMk cId="158936071" sldId="268"/>
-            <ac:spMk id="4" creationId="{6CADB27A-A354-2A95-0493-8B923E5DBA81}"/>
-          </ac:spMkLst>
-        </pc:spChg>
-        <pc:spChg chg="mod">
-          <ac:chgData name="Nathan, Lucas (DNR)" userId="96837891-6aae-41c1-b905-2f597761f76b" providerId="ADAL" clId="{F64F8652-B73F-49BC-A105-17EA9971C31A}" dt="2026-08-21T18:43:26.124" v="796" actId="1076"/>
-          <ac:spMkLst>
-            <pc:docMk/>
-            <pc:sldMk cId="158936071" sldId="268"/>
-            <ac:spMk id="13" creationId="{2079E76D-952B-11A9-1116-CD85142B68BB}"/>
-          </ac:spMkLst>
-        </pc:spChg>
-        <pc:spChg chg="mod">
-          <ac:chgData name="Nathan, Lucas (DNR)" userId="96837891-6aae-41c1-b905-2f597761f76b" providerId="ADAL" clId="{F64F8652-B73F-49BC-A105-17EA9971C31A}" dt="2026-08-21T18:42:05.475" v="689" actId="1076"/>
-          <ac:spMkLst>
-            <pc:docMk/>
-            <pc:sldMk cId="158936071" sldId="268"/>
-            <ac:spMk id="19" creationId="{03579F9D-D5C9-CD07-D7FB-4B0CB3BA039D}"/>
-          </ac:spMkLst>
-        </pc:spChg>
-        <pc:cxnChg chg="mod">
-          <ac:chgData name="Nathan, Lucas (DNR)" userId="96837891-6aae-41c1-b905-2f597761f76b" providerId="ADAL" clId="{F64F8652-B73F-49BC-A105-17EA9971C31A}" dt="2026-08-21T18:43:26.124" v="796" actId="1076"/>
-          <ac:cxnSpMkLst>
-            <pc:docMk/>
-            <pc:sldMk cId="158936071" sldId="268"/>
-            <ac:cxnSpMk id="44" creationId="{263CA7C3-AE98-69BE-AC0A-6A4141EBCDEA}"/>
-          </ac:cxnSpMkLst>
-        </pc:cxnChg>
       </pc:sldChg>
     </pc:docChg>
   </pc:docChgLst>
@@ -537,7 +340,7 @@
           <a:p>
             <a:fld id="{179C5205-C240-4C15-BC7A-8B28C81B6976}" type="datetimeFigureOut">
               <a:rPr lang="en-US" smtClean="0"/>
-              <a:t>08/24/2026</a:t>
+              <a:t>09/29/2026</a:t>
             </a:fld>
             <a:endParaRPr lang="en-US"/>
           </a:p>
@@ -735,7 +538,7 @@
           <a:p>
             <a:fld id="{179C5205-C240-4C15-BC7A-8B28C81B6976}" type="datetimeFigureOut">
               <a:rPr lang="en-US" smtClean="0"/>
-              <a:t>08/24/2026</a:t>
+              <a:t>09/29/2026</a:t>
             </a:fld>
             <a:endParaRPr lang="en-US"/>
           </a:p>
@@ -943,7 +746,7 @@
           <a:p>
             <a:fld id="{179C5205-C240-4C15-BC7A-8B28C81B6976}" type="datetimeFigureOut">
               <a:rPr lang="en-US" smtClean="0"/>
-              <a:t>08/24/2026</a:t>
+              <a:t>09/29/2026</a:t>
             </a:fld>
             <a:endParaRPr lang="en-US"/>
           </a:p>
@@ -1141,7 +944,7 @@
           <a:p>
             <a:fld id="{179C5205-C240-4C15-BC7A-8B28C81B6976}" type="datetimeFigureOut">
               <a:rPr lang="en-US" smtClean="0"/>
-              <a:t>08/24/2026</a:t>
+              <a:t>09/29/2026</a:t>
             </a:fld>
             <a:endParaRPr lang="en-US"/>
           </a:p>
@@ -1416,7 +1219,7 @@
           <a:p>
             <a:fld id="{179C5205-C240-4C15-BC7A-8B28C81B6976}" type="datetimeFigureOut">
               <a:rPr lang="en-US" smtClean="0"/>
-              <a:t>08/24/2026</a:t>
+              <a:t>09/29/2026</a:t>
             </a:fld>
             <a:endParaRPr lang="en-US"/>
           </a:p>
@@ -1681,7 +1484,7 @@
           <a:p>
             <a:fld id="{179C5205-C240-4C15-BC7A-8B28C81B6976}" type="datetimeFigureOut">
               <a:rPr lang="en-US" smtClean="0"/>
-              <a:t>08/24/2026</a:t>
+              <a:t>09/29/2026</a:t>
             </a:fld>
             <a:endParaRPr lang="en-US"/>
           </a:p>
@@ -2093,7 +1896,7 @@
           <a:p>
             <a:fld id="{179C5205-C240-4C15-BC7A-8B28C81B6976}" type="datetimeFigureOut">
               <a:rPr lang="en-US" smtClean="0"/>
-              <a:t>08/24/2026</a:t>
+              <a:t>09/29/2026</a:t>
             </a:fld>
             <a:endParaRPr lang="en-US"/>
           </a:p>
@@ -2234,7 +2037,7 @@
           <a:p>
             <a:fld id="{179C5205-C240-4C15-BC7A-8B28C81B6976}" type="datetimeFigureOut">
               <a:rPr lang="en-US" smtClean="0"/>
-              <a:t>08/24/2026</a:t>
+              <a:t>09/29/2026</a:t>
             </a:fld>
             <a:endParaRPr lang="en-US"/>
           </a:p>
@@ -2347,7 +2150,7 @@
           <a:p>
             <a:fld id="{179C5205-C240-4C15-BC7A-8B28C81B6976}" type="datetimeFigureOut">
               <a:rPr lang="en-US" smtClean="0"/>
-              <a:t>08/24/2026</a:t>
+              <a:t>09/29/2026</a:t>
             </a:fld>
             <a:endParaRPr lang="en-US"/>
           </a:p>
@@ -2658,7 +2461,7 @@
           <a:p>
             <a:fld id="{179C5205-C240-4C15-BC7A-8B28C81B6976}" type="datetimeFigureOut">
               <a:rPr lang="en-US" smtClean="0"/>
-              <a:t>08/24/2026</a:t>
+              <a:t>09/29/2026</a:t>
             </a:fld>
             <a:endParaRPr lang="en-US"/>
           </a:p>
@@ -2946,7 +2749,7 @@
           <a:p>
             <a:fld id="{179C5205-C240-4C15-BC7A-8B28C81B6976}" type="datetimeFigureOut">
               <a:rPr lang="en-US" smtClean="0"/>
-              <a:t>08/24/2026</a:t>
+              <a:t>09/29/2026</a:t>
             </a:fld>
             <a:endParaRPr lang="en-US"/>
           </a:p>
@@ -3187,7 +2990,7 @@
           <a:p>
             <a:fld id="{179C5205-C240-4C15-BC7A-8B28C81B6976}" type="datetimeFigureOut">
               <a:rPr lang="en-US" smtClean="0"/>
-              <a:t>08/24/2026</a:t>
+              <a:t>09/29/2026</a:t>
             </a:fld>
             <a:endParaRPr lang="en-US"/>
           </a:p>
@@ -4241,19 +4044,25 @@
           <a:prstGeom prst="straightConnector1">
             <a:avLst/>
           </a:prstGeom>
-          <a:ln>
-            <a:tailEnd type="triangle"/>
+          <a:ln w="19050" cap="flat" cmpd="sng" algn="ctr">
+            <a:solidFill>
+              <a:schemeClr val="dk1"/>
+            </a:solidFill>
+            <a:prstDash val="dash"/>
+            <a:round/>
+            <a:headEnd type="none" w="med" len="med"/>
+            <a:tailEnd type="none" w="med" len="med"/>
           </a:ln>
         </p:spPr>
         <p:style>
-          <a:lnRef idx="2">
-            <a:schemeClr val="dk1"/>
+          <a:lnRef idx="0">
+            <a:scrgbClr r="0" g="0" b="0"/>
           </a:lnRef>
           <a:fillRef idx="0">
-            <a:schemeClr val="dk1"/>
+            <a:scrgbClr r="0" g="0" b="0"/>
           </a:fillRef>
-          <a:effectRef idx="1">
-            <a:schemeClr val="dk1"/>
+          <a:effectRef idx="0">
+            <a:scrgbClr r="0" g="0" b="0"/>
           </a:effectRef>
           <a:fontRef idx="minor">
             <a:schemeClr val="tx1"/>
@@ -4613,6 +4422,41 @@
           </a:fontRef>
         </p:style>
       </p:cxnSp>
+      <p:sp>
+        <p:nvSpPr>
+          <p:cNvPr id="11" name="TextBox 10">
+            <a:extLst>
+              <a:ext uri="{FF2B5EF4-FFF2-40B4-BE49-F238E27FC236}">
+                <a16:creationId xmlns:a16="http://schemas.microsoft.com/office/drawing/2014/main" id="{BB7CA647-AE2A-13CD-C36F-8D1D8DAC0349}"/>
+              </a:ext>
+            </a:extLst>
+          </p:cNvPr>
+          <p:cNvSpPr txBox="1"/>
+          <p:nvPr/>
+        </p:nvSpPr>
+        <p:spPr>
+          <a:xfrm>
+            <a:off x="3377970" y="2717042"/>
+            <a:ext cx="598241" cy="369332"/>
+          </a:xfrm>
+          <a:prstGeom prst="rect">
+            <a:avLst/>
+          </a:prstGeom>
+          <a:noFill/>
+        </p:spPr>
+        <p:txBody>
+          <a:bodyPr wrap="none" rtlCol="0">
+            <a:spAutoFit/>
+          </a:bodyPr>
+          <a:lstStyle/>
+          <a:p>
+            <a:r>
+              <a:rPr lang="en-US" dirty="0"/>
+              <a:t>SQL</a:t>
+            </a:r>
+          </a:p>
+        </p:txBody>
+      </p:sp>
     </p:spTree>
     <p:extLst>
       <p:ext uri="{BB962C8B-B14F-4D97-AF65-F5344CB8AC3E}">
@@ -7582,6 +7426,41 @@
           </a:fontRef>
         </p:style>
       </p:cxnSp>
+      <p:sp>
+        <p:nvSpPr>
+          <p:cNvPr id="3" name="TextBox 2">
+            <a:extLst>
+              <a:ext uri="{FF2B5EF4-FFF2-40B4-BE49-F238E27FC236}">
+                <a16:creationId xmlns:a16="http://schemas.microsoft.com/office/drawing/2014/main" id="{CAF8DB76-DF0D-6DA6-0FC9-4A9E564AFA44}"/>
+              </a:ext>
+            </a:extLst>
+          </p:cNvPr>
+          <p:cNvSpPr txBox="1"/>
+          <p:nvPr/>
+        </p:nvSpPr>
+        <p:spPr>
+          <a:xfrm>
+            <a:off x="6528044" y="4937400"/>
+            <a:ext cx="598241" cy="369332"/>
+          </a:xfrm>
+          <a:prstGeom prst="rect">
+            <a:avLst/>
+          </a:prstGeom>
+          <a:noFill/>
+        </p:spPr>
+        <p:txBody>
+          <a:bodyPr wrap="none" rtlCol="0">
+            <a:spAutoFit/>
+          </a:bodyPr>
+          <a:lstStyle/>
+          <a:p>
+            <a:r>
+              <a:rPr lang="en-US" dirty="0"/>
+              <a:t>SQL</a:t>
+            </a:r>
+          </a:p>
+        </p:txBody>
+      </p:sp>
     </p:spTree>
     <p:extLst>
       <p:ext uri="{BB962C8B-B14F-4D97-AF65-F5344CB8AC3E}">

</xml_diff>

<commit_message>
added FMU and WaterTypeAbbr as filters #30
</commit_message>
<xml_diff>
--- a/dev/MFA_table_joins.pptx
+++ b/dev/MFA_table_joins.pptx
@@ -120,7 +120,7 @@
 <file path=ppt/revisionInfo.xml><?xml version="1.0" encoding="utf-8"?>
 <p1510:revInfo xmlns:a="http://schemas.openxmlformats.org/drawingml/2006/main" xmlns:r="http://schemas.openxmlformats.org/officeDocument/2006/relationships" xmlns:p1510="http://schemas.microsoft.com/office/powerpoint/2015/10/main">
   <p1510:revLst>
-    <p1510:client id="{AC5AC92B-2308-4395-BD5A-764B9D49FDF5}" v="3" dt="2026-09-29T19:41:01.256"/>
+    <p1510:client id="{AC5AC92B-2308-4395-BD5A-764B9D49FDF5}" v="16" dt="2026-10-05T14:43:19.608"/>
   </p1510:revLst>
 </p1510:revInfo>
 </file>
@@ -130,7 +130,7 @@
   <pc:docChgLst>
     <pc:chgData name="Nathan, Lucas (DNR)" userId="96837891-6aae-41c1-b905-2f597761f76b" providerId="ADAL" clId="{F64F8652-B73F-49BC-A105-17EA9971C31A}"/>
     <pc:docChg chg="undo custSel addSld delSld modSld sldOrd">
-      <pc:chgData name="Nathan, Lucas (DNR)" userId="96837891-6aae-41c1-b905-2f597761f76b" providerId="ADAL" clId="{F64F8652-B73F-49BC-A105-17EA9971C31A}" dt="2026-09-29T19:41:26.794" v="1089" actId="1076"/>
+      <pc:chgData name="Nathan, Lucas (DNR)" userId="96837891-6aae-41c1-b905-2f597761f76b" providerId="ADAL" clId="{F64F8652-B73F-49BC-A105-17EA9971C31A}" dt="2026-10-05T14:43:23.309" v="1154" actId="14100"/>
       <pc:docMkLst>
         <pc:docMk/>
       </pc:docMkLst>
@@ -148,28 +148,139 @@
             <ac:spMk id="11" creationId="{BB7CA647-AE2A-13CD-C36F-8D1D8DAC0349}"/>
           </ac:spMkLst>
         </pc:spChg>
-        <pc:cxnChg chg="add del mod">
-          <ac:chgData name="Nathan, Lucas (DNR)" userId="96837891-6aae-41c1-b905-2f597761f76b" providerId="ADAL" clId="{F64F8652-B73F-49BC-A105-17EA9971C31A}" dt="2026-09-29T19:41:12.424" v="1087" actId="478"/>
-          <ac:cxnSpMkLst>
-            <pc:docMk/>
-            <pc:sldMk cId="4018073164" sldId="256"/>
-            <ac:cxnSpMk id="2" creationId="{14617A0D-EB9F-2B33-822A-7FA2DEBB957C}"/>
-          </ac:cxnSpMkLst>
-        </pc:cxnChg>
-        <pc:cxnChg chg="add del mod">
-          <ac:chgData name="Nathan, Lucas (DNR)" userId="96837891-6aae-41c1-b905-2f597761f76b" providerId="ADAL" clId="{F64F8652-B73F-49BC-A105-17EA9971C31A}" dt="2026-09-29T19:40:48.294" v="1078" actId="478"/>
-          <ac:cxnSpMkLst>
-            <pc:docMk/>
-            <pc:sldMk cId="4018073164" sldId="256"/>
-            <ac:cxnSpMk id="10" creationId="{669BFF34-9D1C-78DB-4BAB-183AEF5AA4F4}"/>
-          </ac:cxnSpMkLst>
-        </pc:cxnChg>
         <pc:cxnChg chg="mod">
           <ac:chgData name="Nathan, Lucas (DNR)" userId="96837891-6aae-41c1-b905-2f597761f76b" providerId="ADAL" clId="{F64F8652-B73F-49BC-A105-17EA9971C31A}" dt="2026-09-29T19:40:24.330" v="1071" actId="17032"/>
           <ac:cxnSpMkLst>
             <pc:docMk/>
             <pc:sldMk cId="4018073164" sldId="256"/>
             <ac:cxnSpMk id="12" creationId="{81A26EC5-D573-533A-BC0E-C461C4C8848C}"/>
+          </ac:cxnSpMkLst>
+        </pc:cxnChg>
+      </pc:sldChg>
+      <pc:sldChg chg="addSp modSp mod">
+        <pc:chgData name="Nathan, Lucas (DNR)" userId="96837891-6aae-41c1-b905-2f597761f76b" providerId="ADAL" clId="{F64F8652-B73F-49BC-A105-17EA9971C31A}" dt="2026-10-05T14:43:23.309" v="1154" actId="14100"/>
+        <pc:sldMkLst>
+          <pc:docMk/>
+          <pc:sldMk cId="736430854" sldId="259"/>
+        </pc:sldMkLst>
+        <pc:spChg chg="mod">
+          <ac:chgData name="Nathan, Lucas (DNR)" userId="96837891-6aae-41c1-b905-2f597761f76b" providerId="ADAL" clId="{F64F8652-B73F-49BC-A105-17EA9971C31A}" dt="2026-10-05T14:42:34.666" v="1129" actId="115"/>
+          <ac:spMkLst>
+            <pc:docMk/>
+            <pc:sldMk cId="736430854" sldId="259"/>
+            <ac:spMk id="5" creationId="{E4341F77-F201-7337-BB6D-ACA54CA290C4}"/>
+          </ac:spMkLst>
+        </pc:spChg>
+        <pc:spChg chg="add mod">
+          <ac:chgData name="Nathan, Lucas (DNR)" userId="96837891-6aae-41c1-b905-2f597761f76b" providerId="ADAL" clId="{F64F8652-B73F-49BC-A105-17EA9971C31A}" dt="2026-10-05T14:42:11.859" v="1119" actId="1076"/>
+          <ac:spMkLst>
+            <pc:docMk/>
+            <pc:sldMk cId="736430854" sldId="259"/>
+            <ac:spMk id="8" creationId="{A956516C-0AE2-0D7C-CF0D-42EA3E415DAA}"/>
+          </ac:spMkLst>
+        </pc:spChg>
+        <pc:spChg chg="add mod">
+          <ac:chgData name="Nathan, Lucas (DNR)" userId="96837891-6aae-41c1-b905-2f597761f76b" providerId="ADAL" clId="{F64F8652-B73F-49BC-A105-17EA9971C31A}" dt="2026-10-05T14:42:44.616" v="1132" actId="115"/>
+          <ac:spMkLst>
+            <pc:docMk/>
+            <pc:sldMk cId="736430854" sldId="259"/>
+            <ac:spMk id="27" creationId="{D3C113A9-AEAE-269F-7C2B-35FAC55A3275}"/>
+          </ac:spMkLst>
+        </pc:spChg>
+        <pc:spChg chg="add mod">
+          <ac:chgData name="Nathan, Lucas (DNR)" userId="96837891-6aae-41c1-b905-2f597761f76b" providerId="ADAL" clId="{F64F8652-B73F-49BC-A105-17EA9971C31A}" dt="2026-10-05T14:43:13.808" v="1148" actId="115"/>
+          <ac:spMkLst>
+            <pc:docMk/>
+            <pc:sldMk cId="736430854" sldId="259"/>
+            <ac:spMk id="29" creationId="{59E3B0BF-E3CC-F8B0-415B-E5FD6FB50001}"/>
+          </ac:spMkLst>
+        </pc:spChg>
+        <pc:spChg chg="mod">
+          <ac:chgData name="Nathan, Lucas (DNR)" userId="96837891-6aae-41c1-b905-2f597761f76b" providerId="ADAL" clId="{F64F8652-B73F-49BC-A105-17EA9971C31A}" dt="2026-10-05T14:41:57.357" v="1115" actId="1076"/>
+          <ac:spMkLst>
+            <pc:docMk/>
+            <pc:sldMk cId="736430854" sldId="259"/>
+            <ac:spMk id="55" creationId="{E5F2DEB9-D5FF-822A-EC32-801F1E718A91}"/>
+          </ac:spMkLst>
+        </pc:spChg>
+        <pc:spChg chg="mod">
+          <ac:chgData name="Nathan, Lucas (DNR)" userId="96837891-6aae-41c1-b905-2f597761f76b" providerId="ADAL" clId="{F64F8652-B73F-49BC-A105-17EA9971C31A}" dt="2026-10-05T14:41:55.554" v="1114" actId="1076"/>
+          <ac:spMkLst>
+            <pc:docMk/>
+            <pc:sldMk cId="736430854" sldId="259"/>
+            <ac:spMk id="56" creationId="{804BC60D-A7DB-B0DC-873E-C88966E8B6E5}"/>
+          </ac:spMkLst>
+        </pc:spChg>
+        <pc:spChg chg="mod">
+          <ac:chgData name="Nathan, Lucas (DNR)" userId="96837891-6aae-41c1-b905-2f597761f76b" providerId="ADAL" clId="{F64F8652-B73F-49BC-A105-17EA9971C31A}" dt="2026-10-05T14:42:04.090" v="1117" actId="1076"/>
+          <ac:spMkLst>
+            <pc:docMk/>
+            <pc:sldMk cId="736430854" sldId="259"/>
+            <ac:spMk id="57" creationId="{9E41CA45-5A62-0DC2-D3E3-DB5565A92737}"/>
+          </ac:spMkLst>
+        </pc:spChg>
+        <pc:cxnChg chg="add mod">
+          <ac:chgData name="Nathan, Lucas (DNR)" userId="96837891-6aae-41c1-b905-2f597761f76b" providerId="ADAL" clId="{F64F8652-B73F-49BC-A105-17EA9971C31A}" dt="2026-10-05T14:42:11.859" v="1119" actId="1076"/>
+          <ac:cxnSpMkLst>
+            <pc:docMk/>
+            <pc:sldMk cId="736430854" sldId="259"/>
+            <ac:cxnSpMk id="10" creationId="{E00B45E2-8CCA-CD70-AD7F-0C8A39070315}"/>
+          </ac:cxnSpMkLst>
+        </pc:cxnChg>
+        <pc:cxnChg chg="mod">
+          <ac:chgData name="Nathan, Lucas (DNR)" userId="96837891-6aae-41c1-b905-2f597761f76b" providerId="ADAL" clId="{F64F8652-B73F-49BC-A105-17EA9971C31A}" dt="2026-10-05T14:41:57.357" v="1115" actId="1076"/>
+          <ac:cxnSpMkLst>
+            <pc:docMk/>
+            <pc:sldMk cId="736430854" sldId="259"/>
+            <ac:cxnSpMk id="23" creationId="{8B2C970B-DFB2-ABD9-17B5-8C09DD3A1C63}"/>
+          </ac:cxnSpMkLst>
+        </pc:cxnChg>
+        <pc:cxnChg chg="add mod">
+          <ac:chgData name="Nathan, Lucas (DNR)" userId="96837891-6aae-41c1-b905-2f597761f76b" providerId="ADAL" clId="{F64F8652-B73F-49BC-A105-17EA9971C31A}" dt="2026-10-05T14:43:18.919" v="1151" actId="14100"/>
+          <ac:cxnSpMkLst>
+            <pc:docMk/>
+            <pc:sldMk cId="736430854" sldId="259"/>
+            <ac:cxnSpMk id="30" creationId="{E3D00D13-90FF-FA76-A1CC-14955AF313F2}"/>
+          </ac:cxnSpMkLst>
+        </pc:cxnChg>
+        <pc:cxnChg chg="add mod">
+          <ac:chgData name="Nathan, Lucas (DNR)" userId="96837891-6aae-41c1-b905-2f597761f76b" providerId="ADAL" clId="{F64F8652-B73F-49BC-A105-17EA9971C31A}" dt="2026-10-05T14:43:23.309" v="1154" actId="14100"/>
+          <ac:cxnSpMkLst>
+            <pc:docMk/>
+            <pc:sldMk cId="736430854" sldId="259"/>
+            <ac:cxnSpMk id="34" creationId="{386E51CF-14D7-F7A1-2A14-3C0AC73759B8}"/>
+          </ac:cxnSpMkLst>
+        </pc:cxnChg>
+        <pc:cxnChg chg="mod">
+          <ac:chgData name="Nathan, Lucas (DNR)" userId="96837891-6aae-41c1-b905-2f597761f76b" providerId="ADAL" clId="{F64F8652-B73F-49BC-A105-17EA9971C31A}" dt="2026-10-05T14:36:53.066" v="1094" actId="1076"/>
+          <ac:cxnSpMkLst>
+            <pc:docMk/>
+            <pc:sldMk cId="736430854" sldId="259"/>
+            <ac:cxnSpMk id="52" creationId="{6D1009BD-12C6-C04E-B63A-A7D9B2D7872E}"/>
+          </ac:cxnSpMkLst>
+        </pc:cxnChg>
+        <pc:cxnChg chg="mod">
+          <ac:chgData name="Nathan, Lucas (DNR)" userId="96837891-6aae-41c1-b905-2f597761f76b" providerId="ADAL" clId="{F64F8652-B73F-49BC-A105-17EA9971C31A}" dt="2026-10-05T14:41:57.357" v="1115" actId="1076"/>
+          <ac:cxnSpMkLst>
+            <pc:docMk/>
+            <pc:sldMk cId="736430854" sldId="259"/>
+            <ac:cxnSpMk id="60" creationId="{1AEE35A2-74F7-EC18-C0F9-6FA2948E2BD5}"/>
+          </ac:cxnSpMkLst>
+        </pc:cxnChg>
+        <pc:cxnChg chg="mod">
+          <ac:chgData name="Nathan, Lucas (DNR)" userId="96837891-6aae-41c1-b905-2f597761f76b" providerId="ADAL" clId="{F64F8652-B73F-49BC-A105-17EA9971C31A}" dt="2026-10-05T14:42:06.742" v="1118" actId="14100"/>
+          <ac:cxnSpMkLst>
+            <pc:docMk/>
+            <pc:sldMk cId="736430854" sldId="259"/>
+            <ac:cxnSpMk id="64" creationId="{1DFF9741-0F70-B9A9-9AEB-498E31BECBF6}"/>
+          </ac:cxnSpMkLst>
+        </pc:cxnChg>
+        <pc:cxnChg chg="mod">
+          <ac:chgData name="Nathan, Lucas (DNR)" userId="96837891-6aae-41c1-b905-2f597761f76b" providerId="ADAL" clId="{F64F8652-B73F-49BC-A105-17EA9971C31A}" dt="2026-10-05T14:42:04.090" v="1117" actId="1076"/>
+          <ac:cxnSpMkLst>
+            <pc:docMk/>
+            <pc:sldMk cId="736430854" sldId="259"/>
+            <ac:cxnSpMk id="97" creationId="{F71000F1-93EA-247E-8A84-87318AB40F95}"/>
           </ac:cxnSpMkLst>
         </pc:cxnChg>
       </pc:sldChg>
@@ -340,7 +451,7 @@
           <a:p>
             <a:fld id="{179C5205-C240-4C15-BC7A-8B28C81B6976}" type="datetimeFigureOut">
               <a:rPr lang="en-US" smtClean="0"/>
-              <a:t>09/29/2026</a:t>
+              <a:t>10/05/2026</a:t>
             </a:fld>
             <a:endParaRPr lang="en-US"/>
           </a:p>
@@ -538,7 +649,7 @@
           <a:p>
             <a:fld id="{179C5205-C240-4C15-BC7A-8B28C81B6976}" type="datetimeFigureOut">
               <a:rPr lang="en-US" smtClean="0"/>
-              <a:t>09/29/2026</a:t>
+              <a:t>10/05/2026</a:t>
             </a:fld>
             <a:endParaRPr lang="en-US"/>
           </a:p>
@@ -746,7 +857,7 @@
           <a:p>
             <a:fld id="{179C5205-C240-4C15-BC7A-8B28C81B6976}" type="datetimeFigureOut">
               <a:rPr lang="en-US" smtClean="0"/>
-              <a:t>09/29/2026</a:t>
+              <a:t>10/05/2026</a:t>
             </a:fld>
             <a:endParaRPr lang="en-US"/>
           </a:p>
@@ -944,7 +1055,7 @@
           <a:p>
             <a:fld id="{179C5205-C240-4C15-BC7A-8B28C81B6976}" type="datetimeFigureOut">
               <a:rPr lang="en-US" smtClean="0"/>
-              <a:t>09/29/2026</a:t>
+              <a:t>10/05/2026</a:t>
             </a:fld>
             <a:endParaRPr lang="en-US"/>
           </a:p>
@@ -1219,7 +1330,7 @@
           <a:p>
             <a:fld id="{179C5205-C240-4C15-BC7A-8B28C81B6976}" type="datetimeFigureOut">
               <a:rPr lang="en-US" smtClean="0"/>
-              <a:t>09/29/2026</a:t>
+              <a:t>10/05/2026</a:t>
             </a:fld>
             <a:endParaRPr lang="en-US"/>
           </a:p>
@@ -1484,7 +1595,7 @@
           <a:p>
             <a:fld id="{179C5205-C240-4C15-BC7A-8B28C81B6976}" type="datetimeFigureOut">
               <a:rPr lang="en-US" smtClean="0"/>
-              <a:t>09/29/2026</a:t>
+              <a:t>10/05/2026</a:t>
             </a:fld>
             <a:endParaRPr lang="en-US"/>
           </a:p>
@@ -1896,7 +2007,7 @@
           <a:p>
             <a:fld id="{179C5205-C240-4C15-BC7A-8B28C81B6976}" type="datetimeFigureOut">
               <a:rPr lang="en-US" smtClean="0"/>
-              <a:t>09/29/2026</a:t>
+              <a:t>10/05/2026</a:t>
             </a:fld>
             <a:endParaRPr lang="en-US"/>
           </a:p>
@@ -2037,7 +2148,7 @@
           <a:p>
             <a:fld id="{179C5205-C240-4C15-BC7A-8B28C81B6976}" type="datetimeFigureOut">
               <a:rPr lang="en-US" smtClean="0"/>
-              <a:t>09/29/2026</a:t>
+              <a:t>10/05/2026</a:t>
             </a:fld>
             <a:endParaRPr lang="en-US"/>
           </a:p>
@@ -2150,7 +2261,7 @@
           <a:p>
             <a:fld id="{179C5205-C240-4C15-BC7A-8B28C81B6976}" type="datetimeFigureOut">
               <a:rPr lang="en-US" smtClean="0"/>
-              <a:t>09/29/2026</a:t>
+              <a:t>10/05/2026</a:t>
             </a:fld>
             <a:endParaRPr lang="en-US"/>
           </a:p>
@@ -2461,7 +2572,7 @@
           <a:p>
             <a:fld id="{179C5205-C240-4C15-BC7A-8B28C81B6976}" type="datetimeFigureOut">
               <a:rPr lang="en-US" smtClean="0"/>
-              <a:t>09/29/2026</a:t>
+              <a:t>10/05/2026</a:t>
             </a:fld>
             <a:endParaRPr lang="en-US"/>
           </a:p>
@@ -2749,7 +2860,7 @@
           <a:p>
             <a:fld id="{179C5205-C240-4C15-BC7A-8B28C81B6976}" type="datetimeFigureOut">
               <a:rPr lang="en-US" smtClean="0"/>
-              <a:t>09/29/2026</a:t>
+              <a:t>10/05/2026</a:t>
             </a:fld>
             <a:endParaRPr lang="en-US"/>
           </a:p>
@@ -2990,7 +3101,7 @@
           <a:p>
             <a:fld id="{179C5205-C240-4C15-BC7A-8B28C81B6976}" type="datetimeFigureOut">
               <a:rPr lang="en-US" smtClean="0"/>
-              <a:t>09/29/2026</a:t>
+              <a:t>10/05/2026</a:t>
             </a:fld>
             <a:endParaRPr lang="en-US"/>
           </a:p>
@@ -4536,8 +4647,8 @@
         </p:nvSpPr>
         <p:spPr>
           <a:xfrm>
-            <a:off x="592136" y="1600994"/>
-            <a:ext cx="1519237" cy="958850"/>
+            <a:off x="267769" y="1580376"/>
+            <a:ext cx="2167972" cy="958850"/>
           </a:xfrm>
           <a:prstGeom prst="rect">
             <a:avLst/>
@@ -4575,7 +4686,7 @@
             <a:r>
               <a:rPr lang="en-US" sz="1200" b="1" kern="100" dirty="0" err="1">
                 <a:solidFill>
-                  <a:srgbClr val="000000"/>
+                  <a:schemeClr val="tx1"/>
                 </a:solidFill>
                 <a:effectLst/>
                 <a:ea typeface="Aptos" panose="020B0004020202020204" pitchFamily="34" charset="0"/>
@@ -4584,6 +4695,9 @@
               <a:t>WaterBody</a:t>
             </a:r>
             <a:endParaRPr lang="en-US" sz="1200" kern="100" dirty="0">
+              <a:solidFill>
+                <a:schemeClr val="tx1"/>
+              </a:solidFill>
               <a:effectLst/>
               <a:ea typeface="Aptos" panose="020B0004020202020204" pitchFamily="34" charset="0"/>
               <a:cs typeface="Times New Roman" panose="02020603050405020304" pitchFamily="18" charset="0"/>
@@ -4596,7 +4710,7 @@
             <a:r>
               <a:rPr lang="en-US" sz="1200" u="sng" kern="100" dirty="0">
                 <a:solidFill>
-                  <a:srgbClr val="000000"/>
+                  <a:schemeClr val="tx1"/>
                 </a:solidFill>
                 <a:effectLst/>
                 <a:ea typeface="Aptos" panose="020B0004020202020204" pitchFamily="34" charset="0"/>
@@ -4604,11 +4718,6 @@
               </a:rPr>
               <a:t>MDNRID</a:t>
             </a:r>
-            <a:endParaRPr lang="en-US" sz="1200" u="sng" kern="100" dirty="0">
-              <a:effectLst/>
-              <a:ea typeface="Aptos" panose="020B0004020202020204" pitchFamily="34" charset="0"/>
-              <a:cs typeface="Times New Roman" panose="02020603050405020304" pitchFamily="18" charset="0"/>
-            </a:endParaRPr>
           </a:p>
           <a:p>
             <a:pPr marL="0" marR="0" algn="ctr">
@@ -4617,7 +4726,7 @@
             <a:r>
               <a:rPr lang="en-US" sz="1200" kern="100" dirty="0" err="1">
                 <a:solidFill>
-                  <a:srgbClr val="000000"/>
+                  <a:schemeClr val="tx1"/>
                 </a:solidFill>
                 <a:effectLst/>
                 <a:ea typeface="Aptos" panose="020B0004020202020204" pitchFamily="34" charset="0"/>
@@ -4626,6 +4735,51 @@
               <a:t>WaterBodyName</a:t>
             </a:r>
             <a:endParaRPr lang="en-US" sz="1200" kern="100" dirty="0">
+              <a:solidFill>
+                <a:schemeClr val="tx1"/>
+              </a:solidFill>
+              <a:effectLst/>
+              <a:ea typeface="Aptos" panose="020B0004020202020204" pitchFamily="34" charset="0"/>
+              <a:cs typeface="Times New Roman" panose="02020603050405020304" pitchFamily="18" charset="0"/>
+            </a:endParaRPr>
+          </a:p>
+          <a:p>
+            <a:pPr algn="ctr"/>
+            <a:r>
+              <a:rPr lang="en-US" sz="1200" u="sng" kern="100" dirty="0" err="1">
+                <a:solidFill>
+                  <a:schemeClr val="tx1"/>
+                </a:solidFill>
+                <a:ea typeface="Aptos" panose="020B0004020202020204" pitchFamily="34" charset="0"/>
+                <a:cs typeface="Times New Roman" panose="02020603050405020304" pitchFamily="18" charset="0"/>
+              </a:rPr>
+              <a:t>WaterId</a:t>
+            </a:r>
+            <a:endParaRPr lang="en-US" sz="1200" u="sng" kern="100" dirty="0">
+              <a:solidFill>
+                <a:schemeClr val="tx1"/>
+              </a:solidFill>
+              <a:effectLst/>
+              <a:ea typeface="Aptos" panose="020B0004020202020204" pitchFamily="34" charset="0"/>
+              <a:cs typeface="Times New Roman" panose="02020603050405020304" pitchFamily="18" charset="0"/>
+            </a:endParaRPr>
+          </a:p>
+          <a:p>
+            <a:pPr algn="ctr"/>
+            <a:r>
+              <a:rPr lang="en-US" sz="1200" u="sng" kern="100" dirty="0" err="1">
+                <a:solidFill>
+                  <a:schemeClr val="tx1"/>
+                </a:solidFill>
+                <a:ea typeface="Aptos" panose="020B0004020202020204" pitchFamily="34" charset="0"/>
+                <a:cs typeface="Times New Roman" panose="02020603050405020304" pitchFamily="18" charset="0"/>
+              </a:rPr>
+              <a:t>AgencyOrganizationalUnitId</a:t>
+            </a:r>
+            <a:endParaRPr lang="en-US" sz="1200" u="sng" kern="100" dirty="0">
+              <a:solidFill>
+                <a:schemeClr val="tx1"/>
+              </a:solidFill>
               <a:effectLst/>
               <a:ea typeface="Aptos" panose="020B0004020202020204" pitchFamily="34" charset="0"/>
               <a:cs typeface="Times New Roman" panose="02020603050405020304" pitchFamily="18" charset="0"/>
@@ -5212,8 +5366,8 @@
         </p:nvCxnSpPr>
         <p:spPr>
           <a:xfrm>
-            <a:off x="1351755" y="2559844"/>
-            <a:ext cx="0" cy="464819"/>
+            <a:off x="1351755" y="2539226"/>
+            <a:ext cx="0" cy="485437"/>
           </a:xfrm>
           <a:prstGeom prst="straightConnector1">
             <a:avLst/>
@@ -5251,7 +5405,7 @@
         </p:nvSpPr>
         <p:spPr>
           <a:xfrm>
-            <a:off x="5131595" y="1856255"/>
+            <a:off x="4304013" y="3591717"/>
             <a:ext cx="1600991" cy="958851"/>
           </a:xfrm>
           <a:prstGeom prst="rect">
@@ -5403,7 +5557,7 @@
         </p:nvSpPr>
         <p:spPr>
           <a:xfrm>
-            <a:off x="4584245" y="3186732"/>
+            <a:off x="7004824" y="3745532"/>
             <a:ext cx="2695692" cy="2234407"/>
           </a:xfrm>
           <a:prstGeom prst="rect">
@@ -5665,7 +5819,7 @@
         </p:nvSpPr>
         <p:spPr>
           <a:xfrm>
-            <a:off x="5425326" y="6129337"/>
+            <a:off x="7845906" y="6175375"/>
             <a:ext cx="1013527" cy="682625"/>
           </a:xfrm>
           <a:prstGeom prst="rect">
@@ -5775,9 +5929,9 @@
           <p:nvPr/>
         </p:nvCxnSpPr>
         <p:spPr>
-          <a:xfrm flipV="1">
-            <a:off x="2362675" y="2335681"/>
-            <a:ext cx="2768920" cy="1735462"/>
+          <a:xfrm>
+            <a:off x="2362675" y="4071143"/>
+            <a:ext cx="1941338" cy="0"/>
           </a:xfrm>
           <a:prstGeom prst="straightConnector1">
             <a:avLst/>
@@ -5812,15 +5966,15 @@
           </p:cNvPr>
           <p:cNvCxnSpPr>
             <a:cxnSpLocks/>
-            <a:stCxn id="55" idx="2"/>
-            <a:endCxn id="56" idx="0"/>
+            <a:stCxn id="55" idx="3"/>
+            <a:endCxn id="56" idx="1"/>
           </p:cNvCxnSpPr>
           <p:nvPr/>
         </p:nvCxnSpPr>
         <p:spPr>
           <a:xfrm>
-            <a:off x="5932091" y="2815106"/>
-            <a:ext cx="0" cy="371626"/>
+            <a:off x="5905004" y="4071143"/>
+            <a:ext cx="1099820" cy="791593"/>
           </a:xfrm>
           <a:prstGeom prst="straightConnector1">
             <a:avLst/>
@@ -5861,9 +6015,9 @@
           <p:nvPr/>
         </p:nvCxnSpPr>
         <p:spPr>
-          <a:xfrm flipH="1">
-            <a:off x="5932090" y="5421139"/>
-            <a:ext cx="1" cy="708198"/>
+          <a:xfrm>
+            <a:off x="8352670" y="5979939"/>
+            <a:ext cx="0" cy="195436"/>
           </a:xfrm>
           <a:prstGeom prst="straightConnector1">
             <a:avLst/>
@@ -5974,9 +6128,497 @@
           <p:nvPr/>
         </p:nvCxnSpPr>
         <p:spPr>
+          <a:xfrm flipV="1">
+            <a:off x="5905004" y="2357675"/>
+            <a:ext cx="3199069" cy="1713468"/>
+          </a:xfrm>
+          <a:prstGeom prst="straightConnector1">
+            <a:avLst/>
+          </a:prstGeom>
+          <a:ln>
+            <a:tailEnd type="triangle"/>
+          </a:ln>
+        </p:spPr>
+        <p:style>
+          <a:lnRef idx="2">
+            <a:schemeClr val="dk1"/>
+          </a:lnRef>
+          <a:fillRef idx="0">
+            <a:schemeClr val="dk1"/>
+          </a:fillRef>
+          <a:effectRef idx="1">
+            <a:schemeClr val="dk1"/>
+          </a:effectRef>
+          <a:fontRef idx="minor">
+            <a:schemeClr val="tx1"/>
+          </a:fontRef>
+        </p:style>
+      </p:cxnSp>
+      <p:sp>
+        <p:nvSpPr>
+          <p:cNvPr id="8" name="Oval 1">
+            <a:extLst>
+              <a:ext uri="{FF2B5EF4-FFF2-40B4-BE49-F238E27FC236}">
+                <a16:creationId xmlns:a16="http://schemas.microsoft.com/office/drawing/2014/main" id="{A956516C-0AE2-0D7C-CF0D-42EA3E415DAA}"/>
+              </a:ext>
+            </a:extLst>
+          </p:cNvPr>
+          <p:cNvSpPr/>
+          <p:nvPr/>
+        </p:nvSpPr>
+        <p:spPr>
           <a:xfrm>
-            <a:off x="6732586" y="2335681"/>
-            <a:ext cx="2371487" cy="21994"/>
+            <a:off x="2936536" y="2350405"/>
+            <a:ext cx="2167972" cy="958850"/>
+          </a:xfrm>
+          <a:prstGeom prst="rect">
+            <a:avLst/>
+          </a:prstGeom>
+          <a:noFill/>
+        </p:spPr>
+        <p:style>
+          <a:lnRef idx="2">
+            <a:schemeClr val="accent1">
+              <a:shade val="15000"/>
+            </a:schemeClr>
+          </a:lnRef>
+          <a:fillRef idx="1">
+            <a:schemeClr val="accent1"/>
+          </a:fillRef>
+          <a:effectRef idx="0">
+            <a:schemeClr val="accent1"/>
+          </a:effectRef>
+          <a:fontRef idx="minor">
+            <a:schemeClr val="lt1"/>
+          </a:fontRef>
+        </p:style>
+        <p:txBody>
+          <a:bodyPr rot="0" spcFirstLastPara="0" vert="horz" wrap="square" lIns="91440" tIns="45720" rIns="91440" bIns="45720" numCol="1" spcCol="0" rtlCol="0" fromWordArt="0" anchor="ctr" anchorCtr="0" forceAA="0" compatLnSpc="1">
+            <a:prstTxWarp prst="textNoShape">
+              <a:avLst/>
+            </a:prstTxWarp>
+            <a:noAutofit/>
+          </a:bodyPr>
+          <a:lstStyle/>
+          <a:p>
+            <a:pPr algn="ctr"/>
+            <a:r>
+              <a:rPr lang="en-US" sz="1200" b="1" kern="100" dirty="0" err="1">
+                <a:solidFill>
+                  <a:schemeClr val="tx1"/>
+                </a:solidFill>
+                <a:ea typeface="Aptos" panose="020B0004020202020204" pitchFamily="34" charset="0"/>
+                <a:cs typeface="Times New Roman" panose="02020603050405020304" pitchFamily="18" charset="0"/>
+              </a:rPr>
+              <a:t>AgencyOrganizationalUnit</a:t>
+            </a:r>
+            <a:endParaRPr lang="en-US" sz="1200" kern="100" dirty="0">
+              <a:solidFill>
+                <a:schemeClr val="tx1"/>
+              </a:solidFill>
+              <a:effectLst/>
+              <a:ea typeface="Aptos" panose="020B0004020202020204" pitchFamily="34" charset="0"/>
+              <a:cs typeface="Times New Roman" panose="02020603050405020304" pitchFamily="18" charset="0"/>
+            </a:endParaRPr>
+          </a:p>
+          <a:p>
+            <a:pPr algn="ctr"/>
+            <a:r>
+              <a:rPr lang="en-US" sz="1200" u="sng" kern="100" dirty="0" err="1">
+                <a:solidFill>
+                  <a:schemeClr val="tx1"/>
+                </a:solidFill>
+                <a:ea typeface="Aptos" panose="020B0004020202020204" pitchFamily="34" charset="0"/>
+                <a:cs typeface="Times New Roman" panose="02020603050405020304" pitchFamily="18" charset="0"/>
+              </a:rPr>
+              <a:t>AgencyOrganizationalUnitId</a:t>
+            </a:r>
+            <a:endParaRPr lang="en-US" sz="1200" u="sng" kern="100" dirty="0">
+              <a:solidFill>
+                <a:schemeClr val="tx1"/>
+              </a:solidFill>
+              <a:ea typeface="Aptos" panose="020B0004020202020204" pitchFamily="34" charset="0"/>
+              <a:cs typeface="Times New Roman" panose="02020603050405020304" pitchFamily="18" charset="0"/>
+            </a:endParaRPr>
+          </a:p>
+          <a:p>
+            <a:pPr algn="ctr"/>
+            <a:r>
+              <a:rPr lang="en-US" sz="1200" kern="100" dirty="0" err="1">
+                <a:solidFill>
+                  <a:schemeClr val="tx1"/>
+                </a:solidFill>
+                <a:ea typeface="Aptos" panose="020B0004020202020204" pitchFamily="34" charset="0"/>
+                <a:cs typeface="Times New Roman" panose="02020603050405020304" pitchFamily="18" charset="0"/>
+              </a:rPr>
+              <a:t>UnitReportId</a:t>
+            </a:r>
+            <a:r>
+              <a:rPr lang="en-US" sz="1200" kern="100" dirty="0">
+                <a:solidFill>
+                  <a:schemeClr val="tx1"/>
+                </a:solidFill>
+                <a:ea typeface="Aptos" panose="020B0004020202020204" pitchFamily="34" charset="0"/>
+                <a:cs typeface="Times New Roman" panose="02020603050405020304" pitchFamily="18" charset="0"/>
+              </a:rPr>
+              <a:t> (FMU)</a:t>
+            </a:r>
+            <a:endParaRPr lang="en-US" sz="1200" kern="100" dirty="0">
+              <a:solidFill>
+                <a:schemeClr val="tx1"/>
+              </a:solidFill>
+              <a:effectLst/>
+              <a:ea typeface="Aptos" panose="020B0004020202020204" pitchFamily="34" charset="0"/>
+              <a:cs typeface="Times New Roman" panose="02020603050405020304" pitchFamily="18" charset="0"/>
+            </a:endParaRPr>
+          </a:p>
+        </p:txBody>
+      </p:sp>
+      <p:cxnSp>
+        <p:nvCxnSpPr>
+          <p:cNvPr id="10" name="Straight Arrow Connector 9">
+            <a:extLst>
+              <a:ext uri="{FF2B5EF4-FFF2-40B4-BE49-F238E27FC236}">
+                <a16:creationId xmlns:a16="http://schemas.microsoft.com/office/drawing/2014/main" id="{E00B45E2-8CCA-CD70-AD7F-0C8A39070315}"/>
+              </a:ext>
+            </a:extLst>
+          </p:cNvPr>
+          <p:cNvCxnSpPr>
+            <a:cxnSpLocks/>
+            <a:stCxn id="8" idx="1"/>
+            <a:endCxn id="5" idx="3"/>
+          </p:cNvCxnSpPr>
+          <p:nvPr/>
+        </p:nvCxnSpPr>
+        <p:spPr>
+          <a:xfrm flipH="1" flipV="1">
+            <a:off x="2435741" y="2059801"/>
+            <a:ext cx="500795" cy="770029"/>
+          </a:xfrm>
+          <a:prstGeom prst="straightConnector1">
+            <a:avLst/>
+          </a:prstGeom>
+          <a:ln>
+            <a:tailEnd type="triangle"/>
+          </a:ln>
+        </p:spPr>
+        <p:style>
+          <a:lnRef idx="2">
+            <a:schemeClr val="dk1"/>
+          </a:lnRef>
+          <a:fillRef idx="0">
+            <a:schemeClr val="dk1"/>
+          </a:fillRef>
+          <a:effectRef idx="1">
+            <a:schemeClr val="dk1"/>
+          </a:effectRef>
+          <a:fontRef idx="minor">
+            <a:schemeClr val="tx1"/>
+          </a:fontRef>
+        </p:style>
+      </p:cxnSp>
+      <p:sp>
+        <p:nvSpPr>
+          <p:cNvPr id="27" name="Oval 1">
+            <a:extLst>
+              <a:ext uri="{FF2B5EF4-FFF2-40B4-BE49-F238E27FC236}">
+                <a16:creationId xmlns:a16="http://schemas.microsoft.com/office/drawing/2014/main" id="{D3C113A9-AEAE-269F-7C2B-35FAC55A3275}"/>
+              </a:ext>
+            </a:extLst>
+          </p:cNvPr>
+          <p:cNvSpPr/>
+          <p:nvPr/>
+        </p:nvSpPr>
+        <p:spPr>
+          <a:xfrm>
+            <a:off x="2936536" y="1326758"/>
+            <a:ext cx="2167972" cy="958850"/>
+          </a:xfrm>
+          <a:prstGeom prst="rect">
+            <a:avLst/>
+          </a:prstGeom>
+          <a:noFill/>
+        </p:spPr>
+        <p:style>
+          <a:lnRef idx="2">
+            <a:schemeClr val="accent1">
+              <a:shade val="15000"/>
+            </a:schemeClr>
+          </a:lnRef>
+          <a:fillRef idx="1">
+            <a:schemeClr val="accent1"/>
+          </a:fillRef>
+          <a:effectRef idx="0">
+            <a:schemeClr val="accent1"/>
+          </a:effectRef>
+          <a:fontRef idx="minor">
+            <a:schemeClr val="lt1"/>
+          </a:fontRef>
+        </p:style>
+        <p:txBody>
+          <a:bodyPr rot="0" spcFirstLastPara="0" vert="horz" wrap="square" lIns="91440" tIns="45720" rIns="91440" bIns="45720" numCol="1" spcCol="0" rtlCol="0" fromWordArt="0" anchor="ctr" anchorCtr="0" forceAA="0" compatLnSpc="1">
+            <a:prstTxWarp prst="textNoShape">
+              <a:avLst/>
+            </a:prstTxWarp>
+            <a:noAutofit/>
+          </a:bodyPr>
+          <a:lstStyle/>
+          <a:p>
+            <a:pPr algn="ctr"/>
+            <a:r>
+              <a:rPr lang="en-US" sz="1200" b="1" kern="100" dirty="0">
+                <a:solidFill>
+                  <a:schemeClr val="tx1"/>
+                </a:solidFill>
+                <a:ea typeface="Aptos" panose="020B0004020202020204" pitchFamily="34" charset="0"/>
+                <a:cs typeface="Times New Roman" panose="02020603050405020304" pitchFamily="18" charset="0"/>
+              </a:rPr>
+              <a:t>Water</a:t>
+            </a:r>
+            <a:endParaRPr lang="en-US" sz="1200" kern="100" dirty="0">
+              <a:solidFill>
+                <a:schemeClr val="tx1"/>
+              </a:solidFill>
+              <a:effectLst/>
+              <a:ea typeface="Aptos" panose="020B0004020202020204" pitchFamily="34" charset="0"/>
+              <a:cs typeface="Times New Roman" panose="02020603050405020304" pitchFamily="18" charset="0"/>
+            </a:endParaRPr>
+          </a:p>
+          <a:p>
+            <a:pPr algn="ctr"/>
+            <a:r>
+              <a:rPr lang="en-US" sz="1200" u="sng" kern="100" dirty="0" err="1">
+                <a:solidFill>
+                  <a:schemeClr val="tx1"/>
+                </a:solidFill>
+                <a:ea typeface="Aptos" panose="020B0004020202020204" pitchFamily="34" charset="0"/>
+                <a:cs typeface="Times New Roman" panose="02020603050405020304" pitchFamily="18" charset="0"/>
+              </a:rPr>
+              <a:t>WaterId</a:t>
+            </a:r>
+            <a:endParaRPr lang="en-US" sz="1200" u="sng" kern="100" dirty="0">
+              <a:solidFill>
+                <a:schemeClr val="tx1"/>
+              </a:solidFill>
+              <a:ea typeface="Aptos" panose="020B0004020202020204" pitchFamily="34" charset="0"/>
+              <a:cs typeface="Times New Roman" panose="02020603050405020304" pitchFamily="18" charset="0"/>
+            </a:endParaRPr>
+          </a:p>
+          <a:p>
+            <a:pPr algn="ctr"/>
+            <a:r>
+              <a:rPr lang="en-US" sz="1200" u="sng" kern="100" dirty="0" err="1">
+                <a:solidFill>
+                  <a:schemeClr val="tx1"/>
+                </a:solidFill>
+                <a:ea typeface="Aptos" panose="020B0004020202020204" pitchFamily="34" charset="0"/>
+                <a:cs typeface="Times New Roman" panose="02020603050405020304" pitchFamily="18" charset="0"/>
+              </a:rPr>
+              <a:t>WaterTypeId</a:t>
+            </a:r>
+            <a:endParaRPr lang="en-US" sz="1200" u="sng" kern="100" dirty="0">
+              <a:solidFill>
+                <a:schemeClr val="tx1"/>
+              </a:solidFill>
+              <a:effectLst/>
+              <a:ea typeface="Aptos" panose="020B0004020202020204" pitchFamily="34" charset="0"/>
+              <a:cs typeface="Times New Roman" panose="02020603050405020304" pitchFamily="18" charset="0"/>
+            </a:endParaRPr>
+          </a:p>
+        </p:txBody>
+      </p:sp>
+      <p:sp>
+        <p:nvSpPr>
+          <p:cNvPr id="29" name="Oval 1">
+            <a:extLst>
+              <a:ext uri="{FF2B5EF4-FFF2-40B4-BE49-F238E27FC236}">
+                <a16:creationId xmlns:a16="http://schemas.microsoft.com/office/drawing/2014/main" id="{59E3B0BF-E3CC-F8B0-415B-E5FD6FB50001}"/>
+              </a:ext>
+            </a:extLst>
+          </p:cNvPr>
+          <p:cNvSpPr/>
+          <p:nvPr/>
+        </p:nvSpPr>
+        <p:spPr>
+          <a:xfrm>
+            <a:off x="5370928" y="1321594"/>
+            <a:ext cx="2167972" cy="958850"/>
+          </a:xfrm>
+          <a:prstGeom prst="rect">
+            <a:avLst/>
+          </a:prstGeom>
+          <a:noFill/>
+        </p:spPr>
+        <p:style>
+          <a:lnRef idx="2">
+            <a:schemeClr val="accent1">
+              <a:shade val="15000"/>
+            </a:schemeClr>
+          </a:lnRef>
+          <a:fillRef idx="1">
+            <a:schemeClr val="accent1"/>
+          </a:fillRef>
+          <a:effectRef idx="0">
+            <a:schemeClr val="accent1"/>
+          </a:effectRef>
+          <a:fontRef idx="minor">
+            <a:schemeClr val="lt1"/>
+          </a:fontRef>
+        </p:style>
+        <p:txBody>
+          <a:bodyPr rot="0" spcFirstLastPara="0" vert="horz" wrap="square" lIns="91440" tIns="45720" rIns="91440" bIns="45720" numCol="1" spcCol="0" rtlCol="0" fromWordArt="0" anchor="ctr" anchorCtr="0" forceAA="0" compatLnSpc="1">
+            <a:prstTxWarp prst="textNoShape">
+              <a:avLst/>
+            </a:prstTxWarp>
+            <a:noAutofit/>
+          </a:bodyPr>
+          <a:lstStyle/>
+          <a:p>
+            <a:pPr algn="ctr"/>
+            <a:r>
+              <a:rPr lang="en-US" sz="1200" b="1" kern="100" dirty="0" err="1">
+                <a:solidFill>
+                  <a:schemeClr val="tx1"/>
+                </a:solidFill>
+                <a:ea typeface="Aptos" panose="020B0004020202020204" pitchFamily="34" charset="0"/>
+                <a:cs typeface="Times New Roman" panose="02020603050405020304" pitchFamily="18" charset="0"/>
+              </a:rPr>
+              <a:t>WaterType</a:t>
+            </a:r>
+            <a:endParaRPr lang="en-US" sz="1200" u="sng" kern="100" dirty="0">
+              <a:solidFill>
+                <a:schemeClr val="tx1"/>
+              </a:solidFill>
+              <a:ea typeface="Aptos" panose="020B0004020202020204" pitchFamily="34" charset="0"/>
+              <a:cs typeface="Times New Roman" panose="02020603050405020304" pitchFamily="18" charset="0"/>
+            </a:endParaRPr>
+          </a:p>
+          <a:p>
+            <a:pPr algn="ctr"/>
+            <a:r>
+              <a:rPr lang="en-US" sz="1200" u="sng" kern="100" dirty="0" err="1">
+                <a:solidFill>
+                  <a:schemeClr val="tx1"/>
+                </a:solidFill>
+                <a:ea typeface="Aptos" panose="020B0004020202020204" pitchFamily="34" charset="0"/>
+                <a:cs typeface="Times New Roman" panose="02020603050405020304" pitchFamily="18" charset="0"/>
+              </a:rPr>
+              <a:t>WaterTypeId</a:t>
+            </a:r>
+            <a:endParaRPr lang="en-US" sz="1200" u="sng" kern="100" dirty="0">
+              <a:solidFill>
+                <a:schemeClr val="tx1"/>
+              </a:solidFill>
+              <a:ea typeface="Aptos" panose="020B0004020202020204" pitchFamily="34" charset="0"/>
+              <a:cs typeface="Times New Roman" panose="02020603050405020304" pitchFamily="18" charset="0"/>
+            </a:endParaRPr>
+          </a:p>
+          <a:p>
+            <a:pPr algn="ctr"/>
+            <a:r>
+              <a:rPr lang="en-US" sz="1200" kern="100" dirty="0">
+                <a:solidFill>
+                  <a:schemeClr val="tx1"/>
+                </a:solidFill>
+                <a:ea typeface="Aptos" panose="020B0004020202020204" pitchFamily="34" charset="0"/>
+                <a:cs typeface="Times New Roman" panose="02020603050405020304" pitchFamily="18" charset="0"/>
+              </a:rPr>
+              <a:t>Name (</a:t>
+            </a:r>
+            <a:r>
+              <a:rPr lang="en-US" sz="1200" kern="100" dirty="0" err="1">
+                <a:solidFill>
+                  <a:schemeClr val="tx1"/>
+                </a:solidFill>
+                <a:ea typeface="Aptos" panose="020B0004020202020204" pitchFamily="34" charset="0"/>
+                <a:cs typeface="Times New Roman" panose="02020603050405020304" pitchFamily="18" charset="0"/>
+              </a:rPr>
+              <a:t>WaterTypeAbbr</a:t>
+            </a:r>
+            <a:r>
+              <a:rPr lang="en-US" sz="1200" kern="100" dirty="0">
+                <a:solidFill>
+                  <a:schemeClr val="tx1"/>
+                </a:solidFill>
+                <a:ea typeface="Aptos" panose="020B0004020202020204" pitchFamily="34" charset="0"/>
+                <a:cs typeface="Times New Roman" panose="02020603050405020304" pitchFamily="18" charset="0"/>
+              </a:rPr>
+              <a:t>)</a:t>
+            </a:r>
+            <a:endParaRPr lang="en-US" sz="1200" kern="100" dirty="0">
+              <a:solidFill>
+                <a:schemeClr val="tx1"/>
+              </a:solidFill>
+              <a:effectLst/>
+              <a:ea typeface="Aptos" panose="020B0004020202020204" pitchFamily="34" charset="0"/>
+              <a:cs typeface="Times New Roman" panose="02020603050405020304" pitchFamily="18" charset="0"/>
+            </a:endParaRPr>
+          </a:p>
+        </p:txBody>
+      </p:sp>
+      <p:cxnSp>
+        <p:nvCxnSpPr>
+          <p:cNvPr id="30" name="Straight Arrow Connector 29">
+            <a:extLst>
+              <a:ext uri="{FF2B5EF4-FFF2-40B4-BE49-F238E27FC236}">
+                <a16:creationId xmlns:a16="http://schemas.microsoft.com/office/drawing/2014/main" id="{E3D00D13-90FF-FA76-A1CC-14955AF313F2}"/>
+              </a:ext>
+            </a:extLst>
+          </p:cNvPr>
+          <p:cNvCxnSpPr>
+            <a:cxnSpLocks/>
+            <a:stCxn id="27" idx="1"/>
+            <a:endCxn id="5" idx="3"/>
+          </p:cNvCxnSpPr>
+          <p:nvPr/>
+        </p:nvCxnSpPr>
+        <p:spPr>
+          <a:xfrm flipH="1">
+            <a:off x="2435741" y="1806183"/>
+            <a:ext cx="500795" cy="253618"/>
+          </a:xfrm>
+          <a:prstGeom prst="straightConnector1">
+            <a:avLst/>
+          </a:prstGeom>
+          <a:ln>
+            <a:tailEnd type="triangle"/>
+          </a:ln>
+        </p:spPr>
+        <p:style>
+          <a:lnRef idx="2">
+            <a:schemeClr val="dk1"/>
+          </a:lnRef>
+          <a:fillRef idx="0">
+            <a:schemeClr val="dk1"/>
+          </a:fillRef>
+          <a:effectRef idx="1">
+            <a:schemeClr val="dk1"/>
+          </a:effectRef>
+          <a:fontRef idx="minor">
+            <a:schemeClr val="tx1"/>
+          </a:fontRef>
+        </p:style>
+      </p:cxnSp>
+      <p:cxnSp>
+        <p:nvCxnSpPr>
+          <p:cNvPr id="34" name="Straight Arrow Connector 33">
+            <a:extLst>
+              <a:ext uri="{FF2B5EF4-FFF2-40B4-BE49-F238E27FC236}">
+                <a16:creationId xmlns:a16="http://schemas.microsoft.com/office/drawing/2014/main" id="{386E51CF-14D7-F7A1-2A14-3C0AC73759B8}"/>
+              </a:ext>
+            </a:extLst>
+          </p:cNvPr>
+          <p:cNvCxnSpPr>
+            <a:cxnSpLocks/>
+            <a:stCxn id="29" idx="1"/>
+            <a:endCxn id="27" idx="3"/>
+          </p:cNvCxnSpPr>
+          <p:nvPr/>
+        </p:nvCxnSpPr>
+        <p:spPr>
+          <a:xfrm flipH="1">
+            <a:off x="5104508" y="1801019"/>
+            <a:ext cx="266420" cy="5164"/>
           </a:xfrm>
           <a:prstGeom prst="straightConnector1">
             <a:avLst/>

</xml_diff>